<commit_message>
Name the evaluation-set owners and speakers; mark Ruby absent
</commit_message>
<xml_diff>
--- a/docs/slides/Presentation_Group11_Sprint2.pptx
+++ b/docs/slides/Presentation_Group11_Sprint2.pptx
@@ -877,10 +877,10 @@
           <a:p>
             <a:r>
               <a:rPr lang="en-US" dirty="0"/>
-              <a:t>SLIDE 5 - Progress (0:18)
+              <a:t>SLIDE 5 - Progress (Saadhvika, 0:18)
 Here is every feature with its owner. The assistant, memory, the four-objective scorer, the desk
-redesign and the AWS deployment are done. Clarification reliability and the live inbox
-benchmark are in progress. Next: independent labels, a held-out set, and a usability test.</a:t>
+redesign and the AWS deployment are done. In progress: clarification reliability, and our
+evaluation set of 50 new requests with independent labels. Next: a live run and a usability test.</a:t>
             </a:r>
             <a:endParaRPr lang="en-US" dirty="0"/>
           </a:p>
@@ -968,12 +968,12 @@
           <a:p>
             <a:r>
               <a:rPr lang="en-US" dirty="0"/>
-              <a:t>SLIDE 6 - Validation plan (0:33)
+              <a:t>SLIDE 6 - Validation plan (Niyanthri, 0:35)
 For allocation we measure late batches and late days in the course simulator, normal and with a
 closure, against the three baselines and earliest finish, choosing settings on separate seeds
 first. Our default is 1.4 percent late against 1.7, with 68 percent fewer late days. For
-language: all 30 inbox requests by kind, plus held-out rewordings, labelled by two teammates
-separately. Hard cases: impossible dates, ineligible workshops, misheard orders. We give
+language: all 30 inbox requests by kind, plus 50 new held-out requests that we are writing and
+labelling separately. Hard cases: impossible dates, ineligible workshops, misheard orders. We give
 options, refuse with a reason, and read the order back before booking.</a:t>
             </a:r>
             <a:endParaRPr lang="en-US" dirty="0"/>
@@ -1170,6 +1170,9 @@
               <a:t>SLIDE 8 - Thank you (0:05)
 Thank you. The code and the video link are on the first slide.
 Q&amp;A PREPARATION (not read aloud)
+- Ruby (Duong Thanh Nhan) cannot attend: she emails Salman and Jack with her reason before the
+  session, and slide 1 shows "Absent" with that reason. Any member may be asked about her desk
+  redesign: one answer at a time, objective panel, saved plan, Show working.
 - Why voice? The track's bonus asks how a dispatcher would really use it: on the floor, on a
   phone. Typing still works everywhere, and the course inbox is still evaluated as text.
 - Can a misheard "yes" book something? No. "Book it" only opens the sheet. Saving needs a
@@ -2229,7 +2232,7 @@
                 <a:ea typeface="Arial" pitchFamily="34" charset="-122"/>
                 <a:cs typeface="Arial" pitchFamily="34" charset="-120"/>
               </a:rPr>
-              <a:t>Present (in person)</a:t>
+              <a:t>Absent: [reason]</a:t>
             </a:r>
             <a:endParaRPr lang="en-US" sz="700" dirty="0"/>
           </a:p>
@@ -8508,7 +8511,293 @@
                           <a:ea typeface="Arial" pitchFamily="34" charset="-122"/>
                           <a:cs typeface="Arial" pitchFamily="34" charset="-120"/>
                         </a:rPr>
-                        <a:t>Live run on all 30 inbox requests, two independent labellers</a:t>
+                        <a:t>Evaluation set: 50 new held-out requests, written and labelled</a:t>
+                      </a:r>
+                      <a:endParaRPr lang="en-US" sz="900" dirty="0">
+                        <a:latin typeface="Arial" charset="0"/>
+                        <a:ea typeface="Arial" charset="0"/>
+                        <a:cs typeface="Arial" charset="0"/>
+                      </a:endParaRPr>
+                    </a:p>
+                  </a:txBody>
+                  <a:tcPr marL="0" marR="50800" marT="25400" marB="25400" anchor="ctr">
+                    <a:lnL w="0" cap="flat" cmpd="sng" algn="ctr">
+                      <a:noFill/>
+                    </a:lnL>
+                    <a:lnR w="0" cap="flat" cmpd="sng" algn="ctr">
+                      <a:noFill/>
+                    </a:lnR>
+                    <a:lnT w="0" cap="flat" cmpd="sng" algn="ctr">
+                      <a:noFill/>
+                    </a:lnT>
+                    <a:lnB w="9525" cap="flat" cmpd="sng" algn="ctr">
+                      <a:solidFill>
+                        <a:srgbClr val="E4DDD0"/>
+                      </a:solidFill>
+                      <a:prstDash val="solid"/>
+                      <a:round/>
+                      <a:headEnd type="none" w="med" len="med"/>
+                      <a:tailEnd type="none" w="med" len="med"/>
+                    </a:lnB>
+                  </a:tcPr>
+                </a:tc>
+                <a:tc>
+                  <a:txBody>
+                    <a:bodyPr/>
+                    <a:lstStyle/>
+                    <a:p>
+                      <a:pPr indent="0" marL="0">
+                        <a:buNone/>
+                      </a:pPr>
+                      <a:r>
+                        <a:rPr lang="en-US" sz="900" dirty="0">
+                          <a:solidFill>
+                            <a:srgbClr val="4A463F"/>
+                          </a:solidFill>
+                          <a:latin typeface="Arial" pitchFamily="34" charset="0"/>
+                          <a:ea typeface="Arial" pitchFamily="34" charset="-122"/>
+                          <a:cs typeface="Arial" pitchFamily="34" charset="-120"/>
+                        </a:rPr>
+                        <a:t>Saadhvika and Niyanthri</a:t>
+                      </a:r>
+                      <a:endParaRPr lang="en-US" sz="900" dirty="0">
+                        <a:latin typeface="Arial" charset="0"/>
+                        <a:ea typeface="Arial" charset="0"/>
+                        <a:cs typeface="Arial" charset="0"/>
+                      </a:endParaRPr>
+                    </a:p>
+                  </a:txBody>
+                  <a:tcPr marL="0" marR="50800" marT="25400" marB="25400" anchor="ctr">
+                    <a:lnL w="0" cap="flat" cmpd="sng" algn="ctr">
+                      <a:noFill/>
+                    </a:lnL>
+                    <a:lnR w="0" cap="flat" cmpd="sng" algn="ctr">
+                      <a:noFill/>
+                    </a:lnR>
+                    <a:lnT w="0" cap="flat" cmpd="sng" algn="ctr">
+                      <a:noFill/>
+                    </a:lnT>
+                    <a:lnB w="9525" cap="flat" cmpd="sng" algn="ctr">
+                      <a:solidFill>
+                        <a:srgbClr val="E4DDD0"/>
+                      </a:solidFill>
+                      <a:prstDash val="solid"/>
+                      <a:round/>
+                      <a:headEnd type="none" w="med" len="med"/>
+                      <a:tailEnd type="none" w="med" len="med"/>
+                    </a:lnB>
+                  </a:tcPr>
+                </a:tc>
+                <a:tc>
+                  <a:txBody>
+                    <a:bodyPr/>
+                    <a:lstStyle/>
+                    <a:p>
+                      <a:pPr indent="0" marL="0">
+                        <a:buNone/>
+                      </a:pPr>
+                      <a:r>
+                        <a:rPr lang="en-US" sz="900" b="1" dirty="0">
+                          <a:solidFill>
+                            <a:srgbClr val="9A6A12"/>
+                          </a:solidFill>
+                          <a:latin typeface="Arial" pitchFamily="34" charset="0"/>
+                          <a:ea typeface="Arial" pitchFamily="34" charset="-122"/>
+                          <a:cs typeface="Arial" pitchFamily="34" charset="-120"/>
+                        </a:rPr>
+                        <a:t>In progress</a:t>
+                      </a:r>
+                      <a:endParaRPr lang="en-US" sz="900" dirty="0">
+                        <a:latin typeface="Arial" charset="0"/>
+                        <a:ea typeface="Arial" charset="0"/>
+                        <a:cs typeface="Arial" charset="0"/>
+                      </a:endParaRPr>
+                    </a:p>
+                  </a:txBody>
+                  <a:tcPr marL="0" marR="50800" marT="25400" marB="25400" anchor="ctr">
+                    <a:lnL w="0" cap="flat" cmpd="sng" algn="ctr">
+                      <a:noFill/>
+                    </a:lnL>
+                    <a:lnR w="0" cap="flat" cmpd="sng" algn="ctr">
+                      <a:noFill/>
+                    </a:lnR>
+                    <a:lnT w="0" cap="flat" cmpd="sng" algn="ctr">
+                      <a:noFill/>
+                    </a:lnT>
+                    <a:lnB w="9525" cap="flat" cmpd="sng" algn="ctr">
+                      <a:solidFill>
+                        <a:srgbClr val="E4DDD0"/>
+                      </a:solidFill>
+                      <a:prstDash val="solid"/>
+                      <a:round/>
+                      <a:headEnd type="none" w="med" len="med"/>
+                      <a:tailEnd type="none" w="med" len="med"/>
+                    </a:lnB>
+                  </a:tcPr>
+                </a:tc>
+              </a:tr>
+              <a:tr h="283464">
+                <a:tc>
+                  <a:txBody>
+                    <a:bodyPr/>
+                    <a:lstStyle/>
+                    <a:p>
+                      <a:pPr indent="0" marL="0">
+                        <a:buNone/>
+                      </a:pPr>
+                      <a:r>
+                        <a:rPr lang="en-US" sz="900" dirty="0">
+                          <a:solidFill>
+                            <a:srgbClr val="1D1B18"/>
+                          </a:solidFill>
+                          <a:latin typeface="Arial" pitchFamily="34" charset="0"/>
+                          <a:ea typeface="Arial" pitchFamily="34" charset="-122"/>
+                          <a:cs typeface="Arial" pitchFamily="34" charset="-120"/>
+                        </a:rPr>
+                        <a:t>Independent labels for the 30 inbox requests</a:t>
+                      </a:r>
+                      <a:endParaRPr lang="en-US" sz="900" dirty="0">
+                        <a:latin typeface="Arial" charset="0"/>
+                        <a:ea typeface="Arial" charset="0"/>
+                        <a:cs typeface="Arial" charset="0"/>
+                      </a:endParaRPr>
+                    </a:p>
+                  </a:txBody>
+                  <a:tcPr marL="0" marR="50800" marT="25400" marB="25400" anchor="ctr">
+                    <a:lnL w="0" cap="flat" cmpd="sng" algn="ctr">
+                      <a:noFill/>
+                    </a:lnL>
+                    <a:lnR w="0" cap="flat" cmpd="sng" algn="ctr">
+                      <a:noFill/>
+                    </a:lnR>
+                    <a:lnT w="0" cap="flat" cmpd="sng" algn="ctr">
+                      <a:noFill/>
+                    </a:lnT>
+                    <a:lnB w="9525" cap="flat" cmpd="sng" algn="ctr">
+                      <a:solidFill>
+                        <a:srgbClr val="E4DDD0"/>
+                      </a:solidFill>
+                      <a:prstDash val="solid"/>
+                      <a:round/>
+                      <a:headEnd type="none" w="med" len="med"/>
+                      <a:tailEnd type="none" w="med" len="med"/>
+                    </a:lnB>
+                  </a:tcPr>
+                </a:tc>
+                <a:tc>
+                  <a:txBody>
+                    <a:bodyPr/>
+                    <a:lstStyle/>
+                    <a:p>
+                      <a:pPr indent="0" marL="0">
+                        <a:buNone/>
+                      </a:pPr>
+                      <a:r>
+                        <a:rPr lang="en-US" sz="900" dirty="0">
+                          <a:solidFill>
+                            <a:srgbClr val="4A463F"/>
+                          </a:solidFill>
+                          <a:latin typeface="Arial" pitchFamily="34" charset="0"/>
+                          <a:ea typeface="Arial" pitchFamily="34" charset="-122"/>
+                          <a:cs typeface="Arial" pitchFamily="34" charset="-120"/>
+                        </a:rPr>
+                        <a:t>Saadhvika and Niyanthri</a:t>
+                      </a:r>
+                      <a:endParaRPr lang="en-US" sz="900" dirty="0">
+                        <a:latin typeface="Arial" charset="0"/>
+                        <a:ea typeface="Arial" charset="0"/>
+                        <a:cs typeface="Arial" charset="0"/>
+                      </a:endParaRPr>
+                    </a:p>
+                  </a:txBody>
+                  <a:tcPr marL="0" marR="50800" marT="25400" marB="25400" anchor="ctr">
+                    <a:lnL w="0" cap="flat" cmpd="sng" algn="ctr">
+                      <a:noFill/>
+                    </a:lnL>
+                    <a:lnR w="0" cap="flat" cmpd="sng" algn="ctr">
+                      <a:noFill/>
+                    </a:lnR>
+                    <a:lnT w="0" cap="flat" cmpd="sng" algn="ctr">
+                      <a:noFill/>
+                    </a:lnT>
+                    <a:lnB w="9525" cap="flat" cmpd="sng" algn="ctr">
+                      <a:solidFill>
+                        <a:srgbClr val="E4DDD0"/>
+                      </a:solidFill>
+                      <a:prstDash val="solid"/>
+                      <a:round/>
+                      <a:headEnd type="none" w="med" len="med"/>
+                      <a:tailEnd type="none" w="med" len="med"/>
+                    </a:lnB>
+                  </a:tcPr>
+                </a:tc>
+                <a:tc>
+                  <a:txBody>
+                    <a:bodyPr/>
+                    <a:lstStyle/>
+                    <a:p>
+                      <a:pPr indent="0" marL="0">
+                        <a:buNone/>
+                      </a:pPr>
+                      <a:r>
+                        <a:rPr lang="en-US" sz="900" b="1" dirty="0">
+                          <a:solidFill>
+                            <a:srgbClr val="9A6A12"/>
+                          </a:solidFill>
+                          <a:latin typeface="Arial" pitchFamily="34" charset="0"/>
+                          <a:ea typeface="Arial" pitchFamily="34" charset="-122"/>
+                          <a:cs typeface="Arial" pitchFamily="34" charset="-120"/>
+                        </a:rPr>
+                        <a:t>In progress</a:t>
+                      </a:r>
+                      <a:endParaRPr lang="en-US" sz="900" dirty="0">
+                        <a:latin typeface="Arial" charset="0"/>
+                        <a:ea typeface="Arial" charset="0"/>
+                        <a:cs typeface="Arial" charset="0"/>
+                      </a:endParaRPr>
+                    </a:p>
+                  </a:txBody>
+                  <a:tcPr marL="0" marR="50800" marT="25400" marB="25400" anchor="ctr">
+                    <a:lnL w="0" cap="flat" cmpd="sng" algn="ctr">
+                      <a:noFill/>
+                    </a:lnL>
+                    <a:lnR w="0" cap="flat" cmpd="sng" algn="ctr">
+                      <a:noFill/>
+                    </a:lnR>
+                    <a:lnT w="0" cap="flat" cmpd="sng" algn="ctr">
+                      <a:noFill/>
+                    </a:lnT>
+                    <a:lnB w="9525" cap="flat" cmpd="sng" algn="ctr">
+                      <a:solidFill>
+                        <a:srgbClr val="E4DDD0"/>
+                      </a:solidFill>
+                      <a:prstDash val="solid"/>
+                      <a:round/>
+                      <a:headEnd type="none" w="med" len="med"/>
+                      <a:tailEnd type="none" w="med" len="med"/>
+                    </a:lnB>
+                  </a:tcPr>
+                </a:tc>
+              </a:tr>
+              <a:tr h="283464">
+                <a:tc>
+                  <a:txBody>
+                    <a:bodyPr/>
+                    <a:lstStyle/>
+                    <a:p>
+                      <a:pPr indent="0" marL="0">
+                        <a:buNone/>
+                      </a:pPr>
+                      <a:r>
+                        <a:rPr lang="en-US" sz="900" dirty="0">
+                          <a:solidFill>
+                            <a:srgbClr val="1D1B18"/>
+                          </a:solidFill>
+                          <a:latin typeface="Arial" pitchFamily="34" charset="0"/>
+                          <a:ea typeface="Arial" pitchFamily="34" charset="-122"/>
+                          <a:cs typeface="Arial" pitchFamily="34" charset="-120"/>
+                        </a:rPr>
+                        <a:t>Live run on the full evaluation set; usability test</a:t>
                       </a:r>
                       <a:endParaRPr lang="en-US" sz="900" dirty="0">
                         <a:latin typeface="Arial" charset="0"/>
@@ -8596,292 +8885,6 @@
                       <a:r>
                         <a:rPr lang="en-US" sz="900" b="1" dirty="0">
                           <a:solidFill>
-                            <a:srgbClr val="9A6A12"/>
-                          </a:solidFill>
-                          <a:latin typeface="Arial" pitchFamily="34" charset="0"/>
-                          <a:ea typeface="Arial" pitchFamily="34" charset="-122"/>
-                          <a:cs typeface="Arial" pitchFamily="34" charset="-120"/>
-                        </a:rPr>
-                        <a:t>In progress</a:t>
-                      </a:r>
-                      <a:endParaRPr lang="en-US" sz="900" dirty="0">
-                        <a:latin typeface="Arial" charset="0"/>
-                        <a:ea typeface="Arial" charset="0"/>
-                        <a:cs typeface="Arial" charset="0"/>
-                      </a:endParaRPr>
-                    </a:p>
-                  </a:txBody>
-                  <a:tcPr marL="0" marR="50800" marT="25400" marB="25400" anchor="ctr">
-                    <a:lnL w="0" cap="flat" cmpd="sng" algn="ctr">
-                      <a:noFill/>
-                    </a:lnL>
-                    <a:lnR w="0" cap="flat" cmpd="sng" algn="ctr">
-                      <a:noFill/>
-                    </a:lnR>
-                    <a:lnT w="0" cap="flat" cmpd="sng" algn="ctr">
-                      <a:noFill/>
-                    </a:lnT>
-                    <a:lnB w="9525" cap="flat" cmpd="sng" algn="ctr">
-                      <a:solidFill>
-                        <a:srgbClr val="E4DDD0"/>
-                      </a:solidFill>
-                      <a:prstDash val="solid"/>
-                      <a:round/>
-                      <a:headEnd type="none" w="med" len="med"/>
-                      <a:tailEnd type="none" w="med" len="med"/>
-                    </a:lnB>
-                  </a:tcPr>
-                </a:tc>
-              </a:tr>
-              <a:tr h="283464">
-                <a:tc>
-                  <a:txBody>
-                    <a:bodyPr/>
-                    <a:lstStyle/>
-                    <a:p>
-                      <a:pPr indent="0" marL="0">
-                        <a:buNone/>
-                      </a:pPr>
-                      <a:r>
-                        <a:rPr lang="en-US" sz="900" dirty="0">
-                          <a:solidFill>
-                            <a:srgbClr val="1D1B18"/>
-                          </a:solidFill>
-                          <a:latin typeface="Arial" pitchFamily="34" charset="0"/>
-                          <a:ea typeface="Arial" pitchFamily="34" charset="-122"/>
-                          <a:cs typeface="Arial" pitchFamily="34" charset="-120"/>
-                        </a:rPr>
-                        <a:t>Held-out rewordings and prompt-injection items</a:t>
-                      </a:r>
-                      <a:endParaRPr lang="en-US" sz="900" dirty="0">
-                        <a:latin typeface="Arial" charset="0"/>
-                        <a:ea typeface="Arial" charset="0"/>
-                        <a:cs typeface="Arial" charset="0"/>
-                      </a:endParaRPr>
-                    </a:p>
-                  </a:txBody>
-                  <a:tcPr marL="0" marR="50800" marT="25400" marB="25400" anchor="ctr">
-                    <a:lnL w="0" cap="flat" cmpd="sng" algn="ctr">
-                      <a:noFill/>
-                    </a:lnL>
-                    <a:lnR w="0" cap="flat" cmpd="sng" algn="ctr">
-                      <a:noFill/>
-                    </a:lnR>
-                    <a:lnT w="0" cap="flat" cmpd="sng" algn="ctr">
-                      <a:noFill/>
-                    </a:lnT>
-                    <a:lnB w="9525" cap="flat" cmpd="sng" algn="ctr">
-                      <a:solidFill>
-                        <a:srgbClr val="E4DDD0"/>
-                      </a:solidFill>
-                      <a:prstDash val="solid"/>
-                      <a:round/>
-                      <a:headEnd type="none" w="med" len="med"/>
-                      <a:tailEnd type="none" w="med" len="med"/>
-                    </a:lnB>
-                  </a:tcPr>
-                </a:tc>
-                <a:tc>
-                  <a:txBody>
-                    <a:bodyPr/>
-                    <a:lstStyle/>
-                    <a:p>
-                      <a:pPr indent="0" marL="0">
-                        <a:buNone/>
-                      </a:pPr>
-                      <a:r>
-                        <a:rPr lang="en-US" sz="900" dirty="0">
-                          <a:solidFill>
-                            <a:srgbClr val="8A2C35"/>
-                          </a:solidFill>
-                          <a:latin typeface="Arial" pitchFamily="34" charset="0"/>
-                          <a:ea typeface="Arial" pitchFamily="34" charset="-122"/>
-                          <a:cs typeface="Arial" pitchFamily="34" charset="-120"/>
-                        </a:rPr>
-                        <a:t>[TBD]</a:t>
-                      </a:r>
-                      <a:endParaRPr lang="en-US" sz="900" dirty="0">
-                        <a:latin typeface="Arial" charset="0"/>
-                        <a:ea typeface="Arial" charset="0"/>
-                        <a:cs typeface="Arial" charset="0"/>
-                      </a:endParaRPr>
-                    </a:p>
-                  </a:txBody>
-                  <a:tcPr marL="0" marR="50800" marT="25400" marB="25400" anchor="ctr">
-                    <a:lnL w="0" cap="flat" cmpd="sng" algn="ctr">
-                      <a:noFill/>
-                    </a:lnL>
-                    <a:lnR w="0" cap="flat" cmpd="sng" algn="ctr">
-                      <a:noFill/>
-                    </a:lnR>
-                    <a:lnT w="0" cap="flat" cmpd="sng" algn="ctr">
-                      <a:noFill/>
-                    </a:lnT>
-                    <a:lnB w="9525" cap="flat" cmpd="sng" algn="ctr">
-                      <a:solidFill>
-                        <a:srgbClr val="E4DDD0"/>
-                      </a:solidFill>
-                      <a:prstDash val="solid"/>
-                      <a:round/>
-                      <a:headEnd type="none" w="med" len="med"/>
-                      <a:tailEnd type="none" w="med" len="med"/>
-                    </a:lnB>
-                  </a:tcPr>
-                </a:tc>
-                <a:tc>
-                  <a:txBody>
-                    <a:bodyPr/>
-                    <a:lstStyle/>
-                    <a:p>
-                      <a:pPr indent="0" marL="0">
-                        <a:buNone/>
-                      </a:pPr>
-                      <a:r>
-                        <a:rPr lang="en-US" sz="900" b="1" dirty="0">
-                          <a:solidFill>
-                            <a:srgbClr val="6B665D"/>
-                          </a:solidFill>
-                          <a:latin typeface="Arial" pitchFamily="34" charset="0"/>
-                          <a:ea typeface="Arial" pitchFamily="34" charset="-122"/>
-                          <a:cs typeface="Arial" pitchFamily="34" charset="-120"/>
-                        </a:rPr>
-                        <a:t>Planned</a:t>
-                      </a:r>
-                      <a:endParaRPr lang="en-US" sz="900" dirty="0">
-                        <a:latin typeface="Arial" charset="0"/>
-                        <a:ea typeface="Arial" charset="0"/>
-                        <a:cs typeface="Arial" charset="0"/>
-                      </a:endParaRPr>
-                    </a:p>
-                  </a:txBody>
-                  <a:tcPr marL="0" marR="50800" marT="25400" marB="25400" anchor="ctr">
-                    <a:lnL w="0" cap="flat" cmpd="sng" algn="ctr">
-                      <a:noFill/>
-                    </a:lnL>
-                    <a:lnR w="0" cap="flat" cmpd="sng" algn="ctr">
-                      <a:noFill/>
-                    </a:lnR>
-                    <a:lnT w="0" cap="flat" cmpd="sng" algn="ctr">
-                      <a:noFill/>
-                    </a:lnT>
-                    <a:lnB w="9525" cap="flat" cmpd="sng" algn="ctr">
-                      <a:solidFill>
-                        <a:srgbClr val="E4DDD0"/>
-                      </a:solidFill>
-                      <a:prstDash val="solid"/>
-                      <a:round/>
-                      <a:headEnd type="none" w="med" len="med"/>
-                      <a:tailEnd type="none" w="med" len="med"/>
-                    </a:lnB>
-                  </a:tcPr>
-                </a:tc>
-              </a:tr>
-              <a:tr h="283464">
-                <a:tc>
-                  <a:txBody>
-                    <a:bodyPr/>
-                    <a:lstStyle/>
-                    <a:p>
-                      <a:pPr indent="0" marL="0">
-                        <a:buNone/>
-                      </a:pPr>
-                      <a:r>
-                        <a:rPr lang="en-US" sz="900" dirty="0">
-                          <a:solidFill>
-                            <a:srgbClr val="1D1B18"/>
-                          </a:solidFill>
-                          <a:latin typeface="Arial" pitchFamily="34" charset="0"/>
-                          <a:ea typeface="Arial" pitchFamily="34" charset="-122"/>
-                          <a:cs typeface="Arial" pitchFamily="34" charset="-120"/>
-                        </a:rPr>
-                        <a:t>Usability test: two people acting as dispatchers, four tasks</a:t>
-                      </a:r>
-                      <a:endParaRPr lang="en-US" sz="900" dirty="0">
-                        <a:latin typeface="Arial" charset="0"/>
-                        <a:ea typeface="Arial" charset="0"/>
-                        <a:cs typeface="Arial" charset="0"/>
-                      </a:endParaRPr>
-                    </a:p>
-                  </a:txBody>
-                  <a:tcPr marL="0" marR="50800" marT="25400" marB="25400" anchor="ctr">
-                    <a:lnL w="0" cap="flat" cmpd="sng" algn="ctr">
-                      <a:noFill/>
-                    </a:lnL>
-                    <a:lnR w="0" cap="flat" cmpd="sng" algn="ctr">
-                      <a:noFill/>
-                    </a:lnR>
-                    <a:lnT w="0" cap="flat" cmpd="sng" algn="ctr">
-                      <a:noFill/>
-                    </a:lnT>
-                    <a:lnB w="9525" cap="flat" cmpd="sng" algn="ctr">
-                      <a:solidFill>
-                        <a:srgbClr val="E4DDD0"/>
-                      </a:solidFill>
-                      <a:prstDash val="solid"/>
-                      <a:round/>
-                      <a:headEnd type="none" w="med" len="med"/>
-                      <a:tailEnd type="none" w="med" len="med"/>
-                    </a:lnB>
-                  </a:tcPr>
-                </a:tc>
-                <a:tc>
-                  <a:txBody>
-                    <a:bodyPr/>
-                    <a:lstStyle/>
-                    <a:p>
-                      <a:pPr indent="0" marL="0">
-                        <a:buNone/>
-                      </a:pPr>
-                      <a:r>
-                        <a:rPr lang="en-US" sz="900" dirty="0">
-                          <a:solidFill>
-                            <a:srgbClr val="8A2C35"/>
-                          </a:solidFill>
-                          <a:latin typeface="Arial" pitchFamily="34" charset="0"/>
-                          <a:ea typeface="Arial" pitchFamily="34" charset="-122"/>
-                          <a:cs typeface="Arial" pitchFamily="34" charset="-120"/>
-                        </a:rPr>
-                        <a:t>[TBD]</a:t>
-                      </a:r>
-                      <a:endParaRPr lang="en-US" sz="900" dirty="0">
-                        <a:latin typeface="Arial" charset="0"/>
-                        <a:ea typeface="Arial" charset="0"/>
-                        <a:cs typeface="Arial" charset="0"/>
-                      </a:endParaRPr>
-                    </a:p>
-                  </a:txBody>
-                  <a:tcPr marL="0" marR="50800" marT="25400" marB="25400" anchor="ctr">
-                    <a:lnL w="0" cap="flat" cmpd="sng" algn="ctr">
-                      <a:noFill/>
-                    </a:lnL>
-                    <a:lnR w="0" cap="flat" cmpd="sng" algn="ctr">
-                      <a:noFill/>
-                    </a:lnR>
-                    <a:lnT w="0" cap="flat" cmpd="sng" algn="ctr">
-                      <a:noFill/>
-                    </a:lnT>
-                    <a:lnB w="9525" cap="flat" cmpd="sng" algn="ctr">
-                      <a:solidFill>
-                        <a:srgbClr val="E4DDD0"/>
-                      </a:solidFill>
-                      <a:prstDash val="solid"/>
-                      <a:round/>
-                      <a:headEnd type="none" w="med" len="med"/>
-                      <a:tailEnd type="none" w="med" len="med"/>
-                    </a:lnB>
-                  </a:tcPr>
-                </a:tc>
-                <a:tc>
-                  <a:txBody>
-                    <a:bodyPr/>
-                    <a:lstStyle/>
-                    <a:p>
-                      <a:pPr indent="0" marL="0">
-                        <a:buNone/>
-                      </a:pPr>
-                      <a:r>
-                        <a:rPr lang="en-US" sz="900" b="1" dirty="0">
-                          <a:solidFill>
                             <a:srgbClr val="6B665D"/>
                           </a:solidFill>
                           <a:latin typeface="Arial" pitchFamily="34" charset="0"/>
@@ -9263,7 +9266,7 @@
                 <a:ea typeface="Arial" pitchFamily="34" charset="-122"/>
                 <a:cs typeface="Arial" pitchFamily="34" charset="-120"/>
               </a:rPr>
-              <a:t>All 30 inbox requests, grouped by the 7 kinds in the data dictionary; held-out rewordings and bait items; two teammates label separately, then agree. A model judge is used only where it agrees with them.</a:t>
+              <a:t>All 30 inbox requests, grouped by the 7 kinds in the data dictionary, plus 50 new held-out requests (rewordings, bait items) written and labelled by Saadhvika and Niyanthri. Labels are made separately, then agreed; a model judge counts only where it matches them.</a:t>
             </a:r>
             <a:endParaRPr lang="en-US" sz="850" dirty="0"/>
           </a:p>

</xml_diff>

<commit_message>
Give Lynn the live model run; add Ruby's absence reason
</commit_message>
<xml_diff>
--- a/docs/slides/Presentation_Group11_Sprint2.pptx
+++ b/docs/slides/Presentation_Group11_Sprint2.pptx
@@ -880,7 +880,8 @@
               <a:t>SLIDE 5 - Progress (Saadhvika, 0:18)
 Here is every feature with its owner. The assistant, memory, the four-objective scorer, the desk
 redesign and the AWS deployment are done. In progress: clarification reliability, and our
-evaluation set of 50 new requests with independent labels. Next: a live run and a usability test.</a:t>
+evaluation set of 50 new requests with independent labels. Next: Lynn's live run on the full
+set, and a usability test.</a:t>
             </a:r>
             <a:endParaRPr lang="en-US" dirty="0"/>
           </a:p>
@@ -2232,7 +2233,7 @@
                 <a:ea typeface="Arial" pitchFamily="34" charset="-122"/>
                 <a:cs typeface="Arial" pitchFamily="34" charset="-120"/>
               </a:rPr>
-              <a:t>Absent: [reason]</a:t>
+              <a:t>Absent: business trip to China</a:t>
             </a:r>
             <a:endParaRPr lang="en-US" sz="700" dirty="0"/>
           </a:p>
@@ -7492,7 +7493,7 @@
                   </a:tcPr>
                 </a:tc>
               </a:tr>
-              <a:tr h="283464">
+              <a:tr h="265176">
                 <a:tc>
                   <a:txBody>
                     <a:bodyPr/>
@@ -7635,7 +7636,7 @@
                   </a:tcPr>
                 </a:tc>
               </a:tr>
-              <a:tr h="283464">
+              <a:tr h="265176">
                 <a:tc>
                   <a:txBody>
                     <a:bodyPr/>
@@ -7778,7 +7779,7 @@
                   </a:tcPr>
                 </a:tc>
               </a:tr>
-              <a:tr h="283464">
+              <a:tr h="265176">
                 <a:tc>
                   <a:txBody>
                     <a:bodyPr/>
@@ -7921,7 +7922,7 @@
                   </a:tcPr>
                 </a:tc>
               </a:tr>
-              <a:tr h="283464">
+              <a:tr h="265176">
                 <a:tc>
                   <a:txBody>
                     <a:bodyPr/>
@@ -8064,7 +8065,7 @@
                   </a:tcPr>
                 </a:tc>
               </a:tr>
-              <a:tr h="283464">
+              <a:tr h="265176">
                 <a:tc>
                   <a:txBody>
                     <a:bodyPr/>
@@ -8207,7 +8208,7 @@
                   </a:tcPr>
                 </a:tc>
               </a:tr>
-              <a:tr h="283464">
+              <a:tr h="265176">
                 <a:tc>
                   <a:txBody>
                     <a:bodyPr/>
@@ -8350,7 +8351,7 @@
                   </a:tcPr>
                 </a:tc>
               </a:tr>
-              <a:tr h="283464">
+              <a:tr h="265176">
                 <a:tc>
                   <a:txBody>
                     <a:bodyPr/>
@@ -8493,7 +8494,7 @@
                   </a:tcPr>
                 </a:tc>
               </a:tr>
-              <a:tr h="283464">
+              <a:tr h="265176">
                 <a:tc>
                   <a:txBody>
                     <a:bodyPr/>
@@ -8636,7 +8637,7 @@
                   </a:tcPr>
                 </a:tc>
               </a:tr>
-              <a:tr h="283464">
+              <a:tr h="265176">
                 <a:tc>
                   <a:txBody>
                     <a:bodyPr/>
@@ -8779,7 +8780,7 @@
                   </a:tcPr>
                 </a:tc>
               </a:tr>
-              <a:tr h="283464">
+              <a:tr h="265176">
                 <a:tc>
                   <a:txBody>
                     <a:bodyPr/>
@@ -8797,7 +8798,150 @@
                           <a:ea typeface="Arial" pitchFamily="34" charset="-122"/>
                           <a:cs typeface="Arial" pitchFamily="34" charset="-120"/>
                         </a:rPr>
-                        <a:t>Live run on the full evaluation set; usability test</a:t>
+                        <a:t>Live model run on the full evaluation set (30 inbox + 50 new)</a:t>
+                      </a:r>
+                      <a:endParaRPr lang="en-US" sz="900" dirty="0">
+                        <a:latin typeface="Arial" charset="0"/>
+                        <a:ea typeface="Arial" charset="0"/>
+                        <a:cs typeface="Arial" charset="0"/>
+                      </a:endParaRPr>
+                    </a:p>
+                  </a:txBody>
+                  <a:tcPr marL="0" marR="50800" marT="25400" marB="25400" anchor="ctr">
+                    <a:lnL w="0" cap="flat" cmpd="sng" algn="ctr">
+                      <a:noFill/>
+                    </a:lnL>
+                    <a:lnR w="0" cap="flat" cmpd="sng" algn="ctr">
+                      <a:noFill/>
+                    </a:lnR>
+                    <a:lnT w="0" cap="flat" cmpd="sng" algn="ctr">
+                      <a:noFill/>
+                    </a:lnT>
+                    <a:lnB w="9525" cap="flat" cmpd="sng" algn="ctr">
+                      <a:solidFill>
+                        <a:srgbClr val="E4DDD0"/>
+                      </a:solidFill>
+                      <a:prstDash val="solid"/>
+                      <a:round/>
+                      <a:headEnd type="none" w="med" len="med"/>
+                      <a:tailEnd type="none" w="med" len="med"/>
+                    </a:lnB>
+                  </a:tcPr>
+                </a:tc>
+                <a:tc>
+                  <a:txBody>
+                    <a:bodyPr/>
+                    <a:lstStyle/>
+                    <a:p>
+                      <a:pPr indent="0" marL="0">
+                        <a:buNone/>
+                      </a:pPr>
+                      <a:r>
+                        <a:rPr lang="en-US" sz="900" dirty="0">
+                          <a:solidFill>
+                            <a:srgbClr val="4A463F"/>
+                          </a:solidFill>
+                          <a:latin typeface="Arial" pitchFamily="34" charset="0"/>
+                          <a:ea typeface="Arial" pitchFamily="34" charset="-122"/>
+                          <a:cs typeface="Arial" pitchFamily="34" charset="-120"/>
+                        </a:rPr>
+                        <a:t>Tang Zheling</a:t>
+                      </a:r>
+                      <a:endParaRPr lang="en-US" sz="900" dirty="0">
+                        <a:latin typeface="Arial" charset="0"/>
+                        <a:ea typeface="Arial" charset="0"/>
+                        <a:cs typeface="Arial" charset="0"/>
+                      </a:endParaRPr>
+                    </a:p>
+                  </a:txBody>
+                  <a:tcPr marL="0" marR="50800" marT="25400" marB="25400" anchor="ctr">
+                    <a:lnL w="0" cap="flat" cmpd="sng" algn="ctr">
+                      <a:noFill/>
+                    </a:lnL>
+                    <a:lnR w="0" cap="flat" cmpd="sng" algn="ctr">
+                      <a:noFill/>
+                    </a:lnR>
+                    <a:lnT w="0" cap="flat" cmpd="sng" algn="ctr">
+                      <a:noFill/>
+                    </a:lnT>
+                    <a:lnB w="9525" cap="flat" cmpd="sng" algn="ctr">
+                      <a:solidFill>
+                        <a:srgbClr val="E4DDD0"/>
+                      </a:solidFill>
+                      <a:prstDash val="solid"/>
+                      <a:round/>
+                      <a:headEnd type="none" w="med" len="med"/>
+                      <a:tailEnd type="none" w="med" len="med"/>
+                    </a:lnB>
+                  </a:tcPr>
+                </a:tc>
+                <a:tc>
+                  <a:txBody>
+                    <a:bodyPr/>
+                    <a:lstStyle/>
+                    <a:p>
+                      <a:pPr indent="0" marL="0">
+                        <a:buNone/>
+                      </a:pPr>
+                      <a:r>
+                        <a:rPr lang="en-US" sz="900" b="1" dirty="0">
+                          <a:solidFill>
+                            <a:srgbClr val="6B665D"/>
+                          </a:solidFill>
+                          <a:latin typeface="Arial" pitchFamily="34" charset="0"/>
+                          <a:ea typeface="Arial" pitchFamily="34" charset="-122"/>
+                          <a:cs typeface="Arial" pitchFamily="34" charset="-120"/>
+                        </a:rPr>
+                        <a:t>Planned</a:t>
+                      </a:r>
+                      <a:endParaRPr lang="en-US" sz="900" dirty="0">
+                        <a:latin typeface="Arial" charset="0"/>
+                        <a:ea typeface="Arial" charset="0"/>
+                        <a:cs typeface="Arial" charset="0"/>
+                      </a:endParaRPr>
+                    </a:p>
+                  </a:txBody>
+                  <a:tcPr marL="0" marR="50800" marT="25400" marB="25400" anchor="ctr">
+                    <a:lnL w="0" cap="flat" cmpd="sng" algn="ctr">
+                      <a:noFill/>
+                    </a:lnL>
+                    <a:lnR w="0" cap="flat" cmpd="sng" algn="ctr">
+                      <a:noFill/>
+                    </a:lnR>
+                    <a:lnT w="0" cap="flat" cmpd="sng" algn="ctr">
+                      <a:noFill/>
+                    </a:lnT>
+                    <a:lnB w="9525" cap="flat" cmpd="sng" algn="ctr">
+                      <a:solidFill>
+                        <a:srgbClr val="E4DDD0"/>
+                      </a:solidFill>
+                      <a:prstDash val="solid"/>
+                      <a:round/>
+                      <a:headEnd type="none" w="med" len="med"/>
+                      <a:tailEnd type="none" w="med" len="med"/>
+                    </a:lnB>
+                  </a:tcPr>
+                </a:tc>
+              </a:tr>
+              <a:tr h="265176">
+                <a:tc>
+                  <a:txBody>
+                    <a:bodyPr/>
+                    <a:lstStyle/>
+                    <a:p>
+                      <a:pPr indent="0" marL="0">
+                        <a:buNone/>
+                      </a:pPr>
+                      <a:r>
+                        <a:rPr lang="en-US" sz="900" dirty="0">
+                          <a:solidFill>
+                            <a:srgbClr val="1D1B18"/>
+                          </a:solidFill>
+                          <a:latin typeface="Arial" pitchFamily="34" charset="0"/>
+                          <a:ea typeface="Arial" pitchFamily="34" charset="-122"/>
+                          <a:cs typeface="Arial" pitchFamily="34" charset="-120"/>
+                        </a:rPr>
+                        <a:t>Usability test: two people acting as dispatchers, four tasks</a:t>
                       </a:r>
                       <a:endParaRPr lang="en-US" sz="900" dirty="0">
                         <a:latin typeface="Arial" charset="0"/>
@@ -8959,7 +9103,7 @@
                 <a:ea typeface="Arial" pitchFamily="34" charset="-122"/>
                 <a:cs typeface="Arial" pitchFamily="34" charset="-120"/>
               </a:rPr>
-              <a:t>6 of 10 done. Code: github.com/JoshuaGloor/dss5105-capstone-project (PR #15 for this sprint, PR #14 for clarification reliability).</a:t>
+              <a:t>6 of 11 done. Code: github.com/JoshuaGloor/dss5105-capstone-project (PR #15 for this sprint, PR #14 for clarification reliability).</a:t>
             </a:r>
             <a:endParaRPr lang="en-US" sz="700" dirty="0"/>
           </a:p>

</xml_diff>

<commit_message>
Rewrite the Sprint 2 recording script as a launch film
</commit_message>
<xml_diff>
--- a/docs/slides/Presentation_Group11_Sprint2.pptx
+++ b/docs/slides/Presentation_Group11_Sprint2.pptx
@@ -509,9 +509,22 @@
           <a:p>
             <a:r>
               <a:rPr lang="en-US" dirty="0"/>
-              <a:t>SLIDE 1 - Cover (0:12)
-Hi, we are Group 11, Track 2: the Quick-Response Subcontracting Desk for SweaterCo.
-Our primary objective is to minimise lateness. Our secondary objective is to minimise defects.</a:t>
+              <a:t>SLIDE 1 - Cold open and cover (0:00-0:22)  VOICE: NARRATOR, plus the app
+[0:00] TC1 on black, no music, faint room tone: "07:53. The first request arrives."
+[0:02] TC2: "By 10:18, there are thirty."
+       (Both times are R01 and R30 in track2/data/dispatch_requests.txt.)
+[0:04] APP, tight on the phone's microphone button. The thumb holds it; the live transcript writes
+       itself across the screen.
+       AT THE MIC (BUILDER, natural, not performed): "ORD-109, 500 vests for Harbor Knits, due
+       April 13. Keep it away from BudgetWorks."
+[0:10] The answer card lands. LET IT PLAY: "GiantWeave can deliver order 109..." Cut out
+       mid-sentence.
+[0:12] Hard cut to black on the first beat of the music.
+       TC3: "Introducing Dispatch." Second line, smaller, camel: "The Quick-Response Subcontracting
+       Desk, by voice."
+[0:15] SLIDE 1. Slow push-in. Hold at least 6 seconds so every name and status can be read.
+       NARRATOR: "We're Group 11, Track 2. Our primary objective: minimise lateness. Our
+       secondary objective: minimise defects."</a:t>
             </a:r>
             <a:endParaRPr lang="en-US" dirty="0"/>
           </a:p>
@@ -599,11 +612,14 @@
           <a:p>
             <a:r>
               <a:rPr lang="en-US" dirty="0"/>
-              <a:t>SLIDE 2 - The user, and what changed since Sprint 1 (0:24)
-Our user is Ravi, the production dispatcher. He is on the factory floor, and requests arrive in
-a group chat. He needs a safe answer in seconds, with a record of why.
-Since Sprint 1, we beat the earliest-finish rule that tied us, our defects and fairness settings
-beat their baselines, and Ravi can now talk to the desk, which remembers what he confirms.</a:t>
+              <a:t>SLIDE 2 - Objective and focus (0:22-0:51)  VOICE: NARRATOR
+[0:22] SLIDE 2. Push in on THE USER and the inbox quote.
+       NARRATOR: "Our user is Ravi, a dispatcher at SweaterCo, on the floor with a phone. Requests
+       land in a group chat, and most are messy. Ravi needs a safe answer in seconds, and a record
+       of why."
+[0:38] PUNCH IN on WHAT CHANGED SINCE SPRINT 1. Step down the rows as they are named.
+       NARRATOR: "Since Sprint 1, we beat the earliest-finish rule that tied us. Our defects and
+       fairness settings beat their baselines. And Ravi can now talk to the desk, which remembers."</a:t>
             </a:r>
             <a:endParaRPr lang="en-US" dirty="0"/>
           </a:p>
@@ -691,11 +707,12 @@
           <a:p>
             <a:r>
               <a:rPr lang="en-US" dirty="0"/>
-              <a:t>SLIDE 3 - The user journey (0:25)
-Here is his journey. He holds the microphone and says the order, the date and any constraint.
-The assistant answers on screen and out loud: the best workshop, when it arrives, and why.
-He says "book it" and slides to confirm. It offers to remember his constraint, and applies it
-to that customer's next order. Voice can propose. Only the slide commits.</a:t>
+              <a:t>SLIDE 3 - The user journey (0:51-1:13)  VOICE: BUILDER
+[0:51] TC4: "Say it. See why. Slide to book."
+[0:53] SLIDE 3. Track left to right across the five phones; punch in on each one as it is named.
+       BUILDER: "Ravi holds the mic and says it. The desk answers out loud: the best workshop, when
+       it arrives, and why. 'Book it' opens one sheet; one slide commits. It offers to remember
+       the constraint, and applies it next time. Voice proposes. Only the slide commits."</a:t>
             </a:r>
             <a:endParaRPr lang="en-US" dirty="0"/>
           </a:p>
@@ -783,13 +800,19 @@
           <a:p>
             <a:r>
               <a:rPr lang="en-US" dirty="0"/>
-              <a:t>SLIDE 4 - Architecture and key choices (0:36)
-It is one workflow, not a ReAct loop, because every request needs the same checks in order.
-Speech becomes text in the browser. Python handles commands like "book it" itself. Everything
-else is one structured-output call, and every field must quote the message or Python rejects it.
-Deterministic tools then find the order, apply remembered rules, check eligibility, estimate and
-rank. Replies are Python templates, so the model never does arithmetic. A person confirms, and
-SQLite keeps the record and the memory, as exact rules rather than a vector store.</a:t>
+              <a:t>SLIDE 4 - Architecture and key choices (1:13-1:58)  VOICE: BUILDER
+[1:13] SLIDE 4. Wide on the six boxes, then a slow track left to right with the voice.
+       BUILDER: "Under the hood: one fixed workflow, not a ReAct agent, because every request
+       needs the same checks, in order. Speech becomes text in the browser. Python handles 'book
+       it' on its own. Everything else is one structured-output call, and every field must quote
+       the message, or Python rejects it."
+[1:35] PUNCH IN on the dark TOOLS box.
+       BUILDER: "Then deterministic tools: exact order lookup, remembered rules, the course's own
+       eligibility check, estimates and ranking. Replies are templates, so the model never does
+       arithmetic."
+[1:46] Tilt down to the KEY CHOICES table.
+       BUILDER: "Memory is exact rules in SQLite, not a vector store: a constraint must match
+       exactly, with who said it. And only a slide books, never a spoken yes."</a:t>
             </a:r>
             <a:endParaRPr lang="en-US" dirty="0"/>
           </a:p>
@@ -877,11 +900,12 @@
           <a:p>
             <a:r>
               <a:rPr lang="en-US" dirty="0"/>
-              <a:t>SLIDE 5 - Progress (Saadhvika, 0:18)
-Here is every feature with its owner. The assistant, memory, the four-objective scorer, the desk
-redesign and the AWS deployment are done. In progress: clarification reliability, and our
-evaluation set of 50 new requests with independent labels. Next: Lynn's live run on the full
-set, and a usability test.</a:t>
+              <a:t>SLIDE 5 - Progress (1:58-2:17)  VOICE: SAADHVIKA
+[1:58] SLIDE 5. Slow push-in. Light the green Done rows, then amber, then grey, as they are named.
+       SAADHVIKA: "Here's every feature with its owner. Done: the voice assistant, memory, capacity
+       questions, the four-objective scorer, the desk redesign and the AWS deployment. In
+       progress: clarification reliability, and our evaluation set. Planned: Lynn's live run on
+       the full set, and a usability test."</a:t>
             </a:r>
             <a:endParaRPr lang="en-US" dirty="0"/>
           </a:p>
@@ -969,13 +993,19 @@
           <a:p>
             <a:r>
               <a:rPr lang="en-US" dirty="0"/>
-              <a:t>SLIDE 6 - Validation plan (Niyanthri, 0:35)
-For allocation we measure late batches and late days in the course simulator, normal and with a
-closure, against the three baselines and earliest finish, choosing settings on separate seeds
-first. Our default is 1.4 percent late against 1.7, with 68 percent fewer late days. For
-language: all 30 inbox requests by kind, plus 50 new held-out requests that we are writing and
-labelling separately. Hard cases: impossible dates, ineligible workshops, misheard orders. We give
-options, refuse with a reason, and read the order back before booking.</a:t>
+              <a:t>SLIDE 6 - Validation plan (2:17-3:02)  VOICE: NIYANTHRI
+[2:17] SLIDE 6. Push in on the left column.
+       NIYANTHRI: "For allocation we measure our objective: late batches and late days, in the
+       course simulator, with and without a closure. Baselines: random, biggest capacity and
+       cheapest, plus earliest finish, with settings chosen on separate seeds first. The minimum:
+       beat all three, and handle all 30 inbox requests."
+[2:38] PUNCH IN on the TODAY table, first row.
+       NIYANTHRI: "Today: 1.4 percent late against 1.7, and 68 percent fewer late days. For
+       language: the 30 inbox requests, plus 50 new held-out ones, labelled separately, then
+       agreed."
+[2:51] PUNCH IN on HARD CASES.
+       NIYANTHRI: "Hard cases: an impossible date, a workshop that can't take it, a misheard order.
+       We give options, refuse with a reason, and read the order back."</a:t>
             </a:r>
             <a:endParaRPr lang="en-US" dirty="0"/>
           </a:p>
@@ -1063,24 +1093,42 @@
           <a:p>
             <a:r>
               <a:rPr lang="en-US" dirty="0"/>
-              <a:t>SLIDE 7 - Demo (2:00)
-[0:00] Show slide 7 for two seconds, then switch to the app.
-Now the demo. This is Ravi's phone. The rings show how busy each workshop is, and OldMill is
-greyed out because it is suspended.
-[0:10] Hold the microphone and say: "ORD-109, 500 vests for Harbor Knits, due April 13.
-Keep it away from BudgetWorks." Let the reply play.
-He just says it. GiantWeave delivers on Thursday, 9 April, 3.71 days early. BudgetWorks is
-excluded, and the card says Ravi asked.
-[0:35] Open "Compare 4 workshops", then "Can't take it". Close them.
-[0:45] Say "book it". On the sheet, slide to confirm. Tap "Remember" on the offer.
-One slide, and the booking is saved with his name. The rule goes into memory.
-[1:05] Say: "ORD-081 for Harbor Knits needs to go out, due April 20."
-A new order for the same customer: the rule is applied, and the card says it came from memory.
-[1:20] Hard case. Say: "QuickStitch for the scarves on ORD-103?"
-QuickStitch cannot make scarves, and no workshop can meet the 4 April date. The desk says so,
-gives the earliest option, 13.44 days late, and a two-shop split. Nothing is booked.
-[1:40] Point at the "Behind the answer" panel.
-Every answer shows what the model extracted, with its quotes, and what Python computed.</a:t>
+              <a:t>SLIDE 7 - Demo (3:02-4:37)  VOICES: BUILDER (journey), LYNN (hard case)
+[3:02] SLIDE 7 for two seconds, then hard cut to the app.
+       Small caption, top left, for the next minute: "The journey".
+[3:04] Phone, full height. The welcome card: "Hi Ravi, what needs to go out today?"
+       BUILDER: "This is Ravi's phone. The rings show how busy each workshop is. OldMill is
+       greyed out: it's suspended."
+[3:12] Hold the microphone. Caption: "Based on request R25 in the course inbox".
+       AT THE MIC: "ORD-109, 500 vests for Harbor Knits, due April 13. Keep it away from
+       BudgetWorks."
+[3:19] The answer lands; slow zoom to the delivery timeline. LET IT PLAY: "GiantWeave can deliver
+       order 109 by Thursday 9 April, 3.71 days early. Cost 550, defect risk 6.0%. Say book it,
+       or tap book, to confirm."
+[3:28] Zoom to the excluded list.
+       BUILDER: "BudgetWorks is out, and the card says Ravi asked."
+[3:32] Tap "Compare 4 workshops", then "Can't take it". Close them.
+       BUILDER: "Every other option, and why the rest can't take it."
+[3:38] AT THE MIC: "Book it." The sheet rises. Slide to confirm.
+       BUILDER: "'Book it' only opens the sheet. One slide saves it, with Ravi's name."
+[3:46] Tap "Remember" on the offer.
+       BUILDER: "And it offers to keep that rule."
+[3:49] AT THE MIC: "ORD-081 for Harbor Knits needs to go out, due April 20."
+[3:54] The card lands; zoom to the memory chip.
+       BUILDER: "A new order, same customer. The rule is applied, and the card says it came from
+       memory."
+[4:02] TC5: "Now, a hard one." Caption, top left, from here: "Hard case".
+[4:04] AT THE MIC: "QuickStitch for the scarves on ORD-103?" Caption: "Request R14 in the course
+       inbox, word for word".
+[4:08] The refusal lands. LET IT PLAY through the reason, then fade it under LYNN. Zoom to the
+       reason, then to the alternatives.
+[4:13] LYNN: "QuickStitch can't make scarves, and no workshop can meet the date. So the desk
+       refuses, gives the earliest option and a two-shop split, and books nothing."
+[4:25] Open the "Behind the answer" panel. Slow zoom to the quotes, then to the computed numbers.
+       LYNN: "And every answer shows its working: what the model read, with its quotes, and what
+       Python computed."
+[4:33] Hard cut to black. TC6: "Dispatch." Second line, camel: "Ravi talks. Python checks. A
+       person commits."</a:t>
             </a:r>
             <a:endParaRPr lang="en-US" dirty="0"/>
           </a:p>
@@ -1168,12 +1216,27 @@
           <a:p>
             <a:r>
               <a:rPr lang="en-US" dirty="0"/>
-              <a:t>SLIDE 8 - Thank you (0:05)
-Thank you. The code and the video link are on the first slide.
+              <a:t>SLIDE 8 - Thank you (4:37-4:46)  VOICE: NARRATOR
+[4:37] Dissolve to SLIDE 8. The music resolves.
+       NARRATOR: "Thank you. The code and the video link are on the first slide."
+[4:43] Hold in silence, then end. Check the export runs under 4:55.
+AFTER RECORDING
+- Export H.264, 1920 x 1080, as Presentation_Group11_Sprint2.mp4. Watch it once end to end.
+- Upload to YouTube as unlisted, then open the link in a private window.
+- Put the link on slides 1 and 8:
+    DEMO_LINK=https://youtu.be/... node scripts/build_sprint2_deck.mjs
+  then export the PDF again, and open the GitHub link in a private window too.
+- One member uploads the .mp4 and the .pptx (or .pdf) to Canvas by 15:00.
 Q&amp;A PREPARATION (not read aloud)
-- Ruby (Duong Thanh Nhan) cannot attend: she emails Salman and Jack with her reason before the
-  session, and slide 1 shows "Absent" with that reason. Any member may be asked about her desk
+- Ruby (Duong Thanh Nhan) cannot attend: Ruby emails Salman and Jack with the reason before the
+  session, and slide 1 shows "Absent" with that reason. Any member may be asked about Ruby's desk
   redesign: one answer at a time, objective panel, saved plan, Show working.
+- Who is Ravi? One of the five people in the course's dispatch chat (R02, R07, R12, R17, R22,
+  R27). We made the person who posts requests our user and gave them the phone, as the bonus
+  suggests. In the demo, Ravi says other people's requests out loud too: Mei's R25 and the boss's
+  R14.
+- Is the film sped up? Only the model's wait is trimmed, and the film says so on screen. Our
+  real wait on the take: [time it on the take]. No answer was edited.
 - Why voice? The track's bonus asks how a dispatcher would really use it: on the floor, on a
   phone. Typing still works everywhere, and the course inbox is still evaluated as text.
 - Can a misheard "yes" book something? No. "Book it" only opens the sheet. Saving needs a
@@ -3077,7 +3140,7 @@
                 <a:ea typeface="Arial" pitchFamily="34" charset="-122"/>
                 <a:cs typeface="Arial" pitchFamily="34" charset="-120"/>
               </a:rPr>
-              <a:t>WHAT HE NEEDS</a:t>
+              <a:t>WHAT RAVI NEEDS</a:t>
             </a:r>
             <a:endParaRPr lang="en-US" sz="750" dirty="0"/>
           </a:p>
@@ -4037,7 +4100,7 @@
       </p:sp>
       <p:pic>
         <p:nvPicPr>
-          <p:cNvPr id="4" name="Image 0" descr="Ask: Hold the mic: order, date and any constraint, in his words.">    </p:cNvPr>
+          <p:cNvPr id="4" name="Image 0" descr="Ask: Hold the mic: order, date and any constraint, in plain words.">    </p:cNvPr>
           <p:cNvPicPr>
             <a:picLocks noChangeAspect="1"/>
           </p:cNvPicPr>
@@ -4177,7 +4240,7 @@
                 <a:ea typeface="Arial" pitchFamily="34" charset="-122"/>
                 <a:cs typeface="Arial" pitchFamily="34" charset="-120"/>
               </a:rPr>
-              <a:t>Hold the mic: order, date and any constraint, in his words.</a:t>
+              <a:t>Hold the mic: order, date and any constraint, in plain words.</a:t>
             </a:r>
             <a:endParaRPr lang="en-US" sz="750" dirty="0"/>
           </a:p>
@@ -4333,7 +4396,7 @@
       </p:sp>
       <p:pic>
         <p:nvPicPr>
-          <p:cNvPr id="12" name="Image 2" descr="Confirm: &quot;Book it&quot; opens one sheet. He slides, with his name on it.">    </p:cNvPr>
+          <p:cNvPr id="12" name="Image 2" descr="Confirm: &quot;Book it&quot; opens one sheet. One slide books it, with a name on it.">    </p:cNvPr>
           <p:cNvPicPr>
             <a:picLocks noChangeAspect="1"/>
           </p:cNvPicPr>
@@ -4473,7 +4536,7 @@
                 <a:ea typeface="Arial" pitchFamily="34" charset="-122"/>
                 <a:cs typeface="Arial" pitchFamily="34" charset="-120"/>
               </a:rPr>
-              <a:t>"Book it" opens one sheet. He slides, with his name on it.</a:t>
+              <a:t>"Book it" opens one sheet. One slide books it, with a name on it.</a:t>
             </a:r>
             <a:endParaRPr lang="en-US" sz="750" dirty="0"/>
           </a:p>
@@ -4481,7 +4544,7 @@
       </p:sp>
       <p:pic>
         <p:nvPicPr>
-          <p:cNvPr id="16" name="Image 3" descr="Remember: It offers to keep his constraint for this customer.">    </p:cNvPr>
+          <p:cNvPr id="16" name="Image 3" descr="Remember: It offers to keep the constraint for this customer.">    </p:cNvPr>
           <p:cNvPicPr>
             <a:picLocks noChangeAspect="1"/>
           </p:cNvPicPr>
@@ -4621,7 +4684,7 @@
                 <a:ea typeface="Arial" pitchFamily="34" charset="-122"/>
                 <a:cs typeface="Arial" pitchFamily="34" charset="-120"/>
               </a:rPr>
-              <a:t>It offers to keep his constraint for this customer.</a:t>
+              <a:t>It offers to keep the constraint for this customer.</a:t>
             </a:r>
             <a:endParaRPr lang="en-US" sz="750" dirty="0"/>
           </a:p>
@@ -6708,7 +6771,7 @@
                           <a:ea typeface="Arial" pitchFamily="34" charset="-122"/>
                           <a:cs typeface="Arial" pitchFamily="34" charset="-120"/>
                         </a:rPr>
-                        <a:t>Free, live words as he speaks, no extra key; typing always works</a:t>
+                        <a:t>Free, live words while speaking, no extra key; typing always works</a:t>
                       </a:r>
                       <a:endParaRPr lang="en-US" sz="900" dirty="0">
                         <a:latin typeface="Arial" charset="0"/>

</xml_diff>

<commit_message>
Simplify the recording script to two takes with no editing
</commit_message>
<xml_diff>
--- a/docs/slides/Presentation_Group11_Sprint2.pptx
+++ b/docs/slides/Presentation_Group11_Sprint2.pptx
@@ -509,22 +509,9 @@
           <a:p>
             <a:r>
               <a:rPr lang="en-US" dirty="0"/>
-              <a:t>SLIDE 1 - Cold open and cover (0:00-0:22)  VOICE: NARRATOR, plus the app
-[0:00] TC1 on black, no music, faint room tone: "07:53. The first request arrives."
-[0:02] TC2: "By 10:18, there are thirty."
-       (Both times are R01 and R30 in track2/data/dispatch_requests.txt.)
-[0:04] APP, tight on the phone's microphone button. The thumb holds it; the live transcript writes
-       itself across the screen.
-       AT THE MIC (BUILDER, natural, not performed): "ORD-109, 500 vests for Harbor Knits, due
-       April 13. Keep it away from BudgetWorks."
-[0:10] The answer card lands. LET IT PLAY: "GiantWeave can deliver order 109..." Cut out
-       mid-sentence.
-[0:12] Hard cut to black on the first beat of the music.
-       TC3: "Introducing Dispatch." Second line, smaller, camel: "The Quick-Response Subcontracting
-       Desk, by voice."
-[0:15] SLIDE 1. Slow push-in. Hold at least 6 seconds so every name and status can be read.
-       NARRATOR: "We're Group 11, Track 2. Our primary objective: minimise lateness. Our
-       secondary objective: minimise defects."</a:t>
+              <a:t>SLIDE 1 - Cover (0:00-0:10)  Joshua
+"Hi, we're Group 11, Track 2: the Quick-Response Subcontracting Desk. Our primary objective is
+minimising lateness, and our secondary is minimising defects."</a:t>
             </a:r>
             <a:endParaRPr lang="en-US" dirty="0"/>
           </a:p>
@@ -612,14 +599,12 @@
           <a:p>
             <a:r>
               <a:rPr lang="en-US" dirty="0"/>
-              <a:t>SLIDE 2 - Objective and focus (0:22-0:51)  VOICE: NARRATOR
-[0:22] SLIDE 2. Push in on THE USER and the inbox quote.
-       NARRATOR: "Our user is Ravi, a dispatcher at SweaterCo, on the floor with a phone. Requests
-       land in a group chat, and most are messy. Ravi needs a safe answer in seconds, and a record
-       of why."
-[0:38] PUNCH IN on WHAT CHANGED SINCE SPRINT 1. Step down the rows as they are named.
-       NARRATOR: "Since Sprint 1, we beat the earliest-finish rule that tied us. Our defects and
-       fairness settings beat their baselines. And Ravi can now talk to the desk, which remembers."</a:t>
+              <a:t>SLIDE 2 - Objective and focus (0:10-0:41)  Joshua
+"Our user is Ravi, a dispatcher at SweaterCo, on the factory floor with a phone. Requests arrive
+in a group chat. A wrong pick means a late order or a bad batch, so Ravi needs a safe answer in
+seconds, with a record of why. That one job is our scope.
+Since Sprint 1, we beat earliest finish, which tied us, our defects and fairness settings beat
+their baselines, and Ravi can now talk to the desk."</a:t>
             </a:r>
             <a:endParaRPr lang="en-US" dirty="0"/>
           </a:p>
@@ -707,12 +692,10 @@
           <a:p>
             <a:r>
               <a:rPr lang="en-US" dirty="0"/>
-              <a:t>SLIDE 3 - The user journey (0:51-1:13)  VOICE: BUILDER
-[0:51] TC4: "Say it. See why. Slide to book."
-[0:53] SLIDE 3. Track left to right across the five phones; punch in on each one as it is named.
-       BUILDER: "Ravi holds the mic and says it. The desk answers out loud: the best workshop, when
-       it arrives, and why. 'Book it' opens one sheet; one slide commits. It offers to remember
-       the constraint, and applies it next time. Voice proposes. Only the slide commits."</a:t>
+              <a:t>SLIDE 3 - The user journey (0:41-1:04)  Zepeng
+"We designed the journey for the floor. Ravi holds the mic and says the order. The desk answers
+on screen and out loud: the best workshop, when it arrives, and why. 'Book it' opens a sheet, and
+a slide confirms. It offers to remember the constraint, and uses it on the next order."</a:t>
             </a:r>
             <a:endParaRPr lang="en-US" dirty="0"/>
           </a:p>
@@ -800,19 +783,14 @@
           <a:p>
             <a:r>
               <a:rPr lang="en-US" dirty="0"/>
-              <a:t>SLIDE 4 - Architecture and key choices (1:13-1:58)  VOICE: BUILDER
-[1:13] SLIDE 4. Wide on the six boxes, then a slow track left to right with the voice.
-       BUILDER: "Under the hood: one fixed workflow, not a ReAct agent, because every request
-       needs the same checks, in order. Speech becomes text in the browser. Python handles 'book
-       it' on its own. Everything else is one structured-output call, and every field must quote
-       the message, or Python rejects it."
-[1:35] PUNCH IN on the dark TOOLS box.
-       BUILDER: "Then deterministic tools: exact order lookup, remembered rules, the course's own
-       eligibility check, estimates and ranking. Replies are templates, so the model never does
-       arithmetic."
-[1:46] Tilt down to the KEY CHOICES table.
-       BUILDER: "Memory is exact rules in SQLite, not a vector store: a constraint must match
-       exactly, with who said it. And only a slide books, never a spoken yes."</a:t>
+              <a:t>SLIDE 4 - Architecture and key choices (1:04-1:48)  Zepeng
+"This diagram is what we built. Speech becomes text in the browser: free and live, instead of a
+server speech model. Python handles commands like 'book it' without a model. Everything else is
+one structured-output call, not a ReAct agent, because every request needs the same checks in
+order, and every field must quote the message. Deterministic tools then look up the order, apply
+remembered rules, check eligibility and rank. Replies are
+templates, so the model never does arithmetic. Memory is exact rules in SQLite, not a vector
+store, because a rule must match exactly. And only a slide books, never a spoken yes."</a:t>
             </a:r>
             <a:endParaRPr lang="en-US" dirty="0"/>
           </a:p>
@@ -900,12 +878,11 @@
           <a:p>
             <a:r>
               <a:rPr lang="en-US" dirty="0"/>
-              <a:t>SLIDE 5 - Progress (1:58-2:17)  VOICE: SAADHVIKA
-[1:58] SLIDE 5. Slow push-in. Light the green Done rows, then amber, then grey, as they are named.
-       SAADHVIKA: "Here's every feature with its owner. Done: the voice assistant, memory, capacity
-       questions, the four-objective scorer, the desk redesign and the AWS deployment. In
-       progress: clarification reliability, and our evaluation set. Planned: Lynn's live run on
-       the full set, and a usability test."</a:t>
+              <a:t>SLIDE 5 - Progress (1:48-2:08)  Saadhvika
+"This is every feature with its owner and status. Done: the voice assistant, memory, capacity
+questions, the four-objective scorer, the desk redesign and the AWS deployment. In progress:
+clarification fixes, and our evaluation set. Planned: Lynn's live run on the full set, and a
+usability test."</a:t>
             </a:r>
             <a:endParaRPr lang="en-US" dirty="0"/>
           </a:p>
@@ -993,19 +970,14 @@
           <a:p>
             <a:r>
               <a:rPr lang="en-US" dirty="0"/>
-              <a:t>SLIDE 6 - Validation plan (2:17-3:02)  VOICE: NIYANTHRI
-[2:17] SLIDE 6. Push in on the left column.
-       NIYANTHRI: "For allocation we measure our objective: late batches and late days, in the
-       course simulator, with and without a closure. Baselines: random, biggest capacity and
-       cheapest, plus earliest finish, with settings chosen on separate seeds first. The minimum:
-       beat all three, and handle all 30 inbox requests."
-[2:38] PUNCH IN on the TODAY table, first row.
-       NIYANTHRI: "Today: 1.4 percent late against 1.7, and 68 percent fewer late days. For
-       language: the 30 inbox requests, plus 50 new held-out ones, labelled separately, then
-       agreed."
-[2:51] PUNCH IN on HARD CASES.
-       NIYANTHRI: "Hard cases: an impossible date, a workshop that can't take it, a misheard order.
-       We give options, refuse with a reason, and read the order back."</a:t>
+              <a:t>SLIDE 6 - Validation plan (2:08-2:51)  Niyanthri
+"We measure late batches and late days, our primary objective, in the course simulator, with and
+without a closure. Baselines are random, biggest capacity and cheapest, plus earliest
+finish, and settings were chosen on separate seeds first. The minimum is to beat all three
+baselines, and handle all 30 inbox requests. Today: 1.4 percent late against 1.7, and 68 percent
+fewer late days. For language, the 30 inbox requests plus 50 new held-out ones, labelled
+separately, then agreed. Hard cases: an impossible date, a workshop that can't take it, and a
+misheard order. We give options, refuse with a reason, and read the order back."</a:t>
             </a:r>
             <a:endParaRPr lang="en-US" dirty="0"/>
           </a:p>
@@ -1093,42 +1065,34 @@
           <a:p>
             <a:r>
               <a:rPr lang="en-US" dirty="0"/>
-              <a:t>SLIDE 7 - Demo (3:02-4:37)  VOICES: BUILDER (journey), LYNN (hard case)
-[3:02] SLIDE 7 for two seconds, then hard cut to the app.
-       Small caption, top left, for the next minute: "The journey".
-[3:04] Phone, full height. The welcome card: "Hi Ravi, what needs to go out today?"
-       BUILDER: "This is Ravi's phone. The rings show how busy each workshop is. OldMill is
-       greyed out: it's suspended."
-[3:12] Hold the microphone. Caption: "Based on request R25 in the course inbox".
-       AT THE MIC: "ORD-109, 500 vests for Harbor Knits, due April 13. Keep it away from
-       BudgetWorks."
-[3:19] The answer lands; slow zoom to the delivery timeline. LET IT PLAY: "GiantWeave can deliver
-       order 109 by Thursday 9 April, 3.71 days early. Cost 550, defect risk 6.0%. Say book it,
-       or tap book, to confirm."
-[3:28] Zoom to the excluded list.
-       BUILDER: "BudgetWorks is out, and the card says Ravi asked."
-[3:32] Tap "Compare 4 workshops", then "Can't take it". Close them.
-       BUILDER: "Every other option, and why the rest can't take it."
-[3:38] AT THE MIC: "Book it." The sheet rises. Slide to confirm.
-       BUILDER: "'Book it' only opens the sheet. One slide saves it, with Ravi's name."
-[3:46] Tap "Remember" on the offer.
-       BUILDER: "And it offers to keep that rule."
-[3:49] AT THE MIC: "ORD-081 for Harbor Knits needs to go out, due April 20."
-[3:54] The card lands; zoom to the memory chip.
-       BUILDER: "A new order, same customer. The rule is applied, and the card says it came from
-       memory."
-[4:02] TC5: "Now, a hard one." Caption, top left, from here: "Hard case".
-[4:04] AT THE MIC: "QuickStitch for the scarves on ORD-103?" Caption: "Request R14 in the course
-       inbox, word for word".
-[4:08] The refusal lands. LET IT PLAY through the reason, then fade it under LYNN. Zoom to the
-       reason, then to the alternatives.
-[4:13] LYNN: "QuickStitch can't make scarves, and no workshop can meet the date. So the desk
-       refuses, gives the earliest option and a two-shop split, and books nothing."
-[4:25] Open the "Behind the answer" panel. Slow zoom to the quotes, then to the computed numbers.
-       LYNN: "And every answer shows its working: what the model read, with its quotes, and what
-       Python computed."
-[4:33] Hard cut to black. TC6: "Dispatch." Second line, camel: "Ravi talks. Python checks. A
-       person commits."</a:t>
+              <a:t>SLIDE 7 - Demo (2:51-4:50)  Zepeng, then Lynn
+Take A ends here:
+  Zepeng: "Now the demo."
+Take B, in the app. Times are from the start of Take B. Speak only when the app is quiet.
+[0:00] Zepeng: "This is Ravi's phone. The rings show how busy each workshop is, and OldMill is
+       grey because it's suspended."
+[0:08] Hold the mic and say: "ORD-109, 500 vests for Harbor Knits, due April 13. Keep it away
+       from BudgetWorks."
+       Let the answer play: "GiantWeave can deliver order 109 by Thursday 9 April, 3.71 days
+       early. Cost 550, defect risk 6.0%. Say book it, or tap book, to confirm."
+[0:30] Tap "Compare 4 workshops", then "Can't take it", then close them. (optional)
+       Zepeng: "Here are the other options, and why the rest can't take it. BudgetWorks is out
+       because Ravi asked."
+[0:40] Hold the mic and say: "Book it." The sheet opens.
+       Zepeng: "Nothing is saved until I slide." Slide to confirm.
+[0:52] On the receipt, tap "Remember".
+       Zepeng: "And it offers to remember that rule."
+[0:58] Hold the mic and say: "ORD-081 for Harbor Knits needs to go out, due April 20."
+       Let the answer play, then point at the memory note on the card.
+       Zepeng: "Same customer, so the rule is applied, and the card says it came from memory."
+[1:22] Lynn: "Now a hard case, straight from the inbox."
+       Zepeng holds the mic and says: "QuickStitch for the scarves on ORD-103?"
+       Let the answer play: QuickStitch cannot make scarves, no workshop meets 4 April, and the
+       best alternative is 13.44 days late.
+[1:45] Lynn: "It refuses, gives the earliest option and a two-shop split, and books nothing."
+[1:52] Open "Behind the answer". (optional)
+       Lynn: "This panel shows what the model read, with quotes, and what Python computed."
+[1:59] Stop recording.</a:t>
             </a:r>
             <a:endParaRPr lang="en-US" dirty="0"/>
           </a:p>
@@ -1216,13 +1180,10 @@
           <a:p>
             <a:r>
               <a:rPr lang="en-US" dirty="0"/>
-              <a:t>SLIDE 8 - Thank you (4:37-4:46)  VOICE: NARRATOR
-[4:37] Dissolve to SLIDE 8. The music resolves.
-       NARRATOR: "Thank you. The code and the video link are on the first slide."
-[4:43] Hold in silence, then end. Check the export runs under 4:55.
+              <a:t>SLIDE 8 - Thank you (not recorded)
+The video ends on the demo, so this slide stays in the deck for the Q&amp;A only.
 AFTER RECORDING
-- Export H.264, 1920 x 1080, as Presentation_Group11_Sprint2.mp4. Watch it once end to end.
-- Upload to YouTube as unlisted, then open the link in a private window.
+- Upload the .mp4 to YouTube as unlisted, then open the link in a private window.
 - Put the link on slides 1 and 8:
     DEMO_LINK=https://youtu.be/... node scripts/build_sprint2_deck.mjs
   then export the PDF again, and open the GitHub link in a private window too.
@@ -1235,8 +1196,7 @@
   R27). We made the person who posts requests our user and gave them the phone, as the bonus
   suggests. In the demo, Ravi says other people's requests out loud too: Mei's R25 and the boss's
   R14.
-- Is the film sped up? Only the model's wait is trimmed, and the film says so on screen. Our
-  real wait on the take: [time it on the take]. No answer was edited.
+- Is the demo real time? Yes. It is one take with no cuts; only the start and end are trimmed.
 - Why voice? The track's bonus asks how a dispatcher would really use it: on the floor, on a
   phone. Typing still works everywhere, and the course inbox is still evaluated as text.
 - Can a misheard "yes" book something? No. "Book it" only opens the sheet. Saving needs a

</xml_diff>

<commit_message>
Name the app StitchFlow; Charles plays the dispatcher in the demo
</commit_message>
<xml_diff>
--- a/docs/slides/Presentation_Group11_Sprint2.pptx
+++ b/docs/slides/Presentation_Group11_Sprint2.pptx
@@ -509,9 +509,9 @@
           <a:p>
             <a:r>
               <a:rPr lang="en-US" dirty="0"/>
-              <a:t>SLIDE 1 - Cover (0:00-0:10)  Joshua
-"Hi, we're Group 11, Track 2: the Quick-Response Subcontracting Desk. Our primary objective is
-minimising lateness, and our secondary is minimising defects."</a:t>
+              <a:t>SLIDE 1 - Cover (0:00-0:13)  Joshua
+"Hi, we're Group 11, Track 2. This is StitchFlow: say an order, and it finds the right workshop.
+Our primary objective is minimising lateness, and our secondary is minimising defects."</a:t>
             </a:r>
             <a:endParaRPr lang="en-US" dirty="0"/>
           </a:p>
@@ -599,12 +599,12 @@
           <a:p>
             <a:r>
               <a:rPr lang="en-US" dirty="0"/>
-              <a:t>SLIDE 2 - Objective and focus (0:10-0:41)  Joshua
-"Our user is Ravi, a dispatcher at SweaterCo, on the factory floor with a phone. Requests arrive
-in a group chat. A wrong pick means a late order or a bad batch, so Ravi needs a safe answer in
+              <a:t>SLIDE 2 - Objective and focus (0:13-0:45)  Joshua
+"Our user is SweaterCo's dispatcher, out on the factory floor. Requests arrive in a group chat.
+A wrong pick means a late order or a bad batch, so the dispatcher needs a safe answer in
 seconds, with a record of why. That one job is our scope.
 Since Sprint 1, we beat earliest finish, which tied us, our defects and fairness settings beat
-their baselines, and Ravi can now talk to the desk."</a:t>
+their baselines, and the dispatcher can now talk to the desk."</a:t>
             </a:r>
             <a:endParaRPr lang="en-US" dirty="0"/>
           </a:p>
@@ -692,8 +692,8 @@
           <a:p>
             <a:r>
               <a:rPr lang="en-US" dirty="0"/>
-              <a:t>SLIDE 3 - The user journey (0:41-1:04)  Zepeng
-"We designed the journey for the floor. Ravi holds the mic and says the order. The desk answers
+              <a:t>SLIDE 3 - The user journey (0:45-1:08)  Zepeng
+"We designed the journey for the floor. The dispatcher holds the mic and says the order. The desk answers
 on screen and out loud: the best workshop, when it arrives, and why. 'Book it' opens a sheet, and
 a slide confirms. It offers to remember the constraint, and uses it on the next order."</a:t>
             </a:r>
@@ -783,7 +783,7 @@
           <a:p>
             <a:r>
               <a:rPr lang="en-US" dirty="0"/>
-              <a:t>SLIDE 4 - Architecture and key choices (1:04-1:48)  Zepeng
+              <a:t>SLIDE 4 - Architecture and key choices (1:08-1:53)  Zepeng
 "This diagram is what we built. Speech becomes text in the browser: free and live, instead of a
 server speech model. Python handles commands like 'book it' without a model. Everything else is
 one structured-output call, not a ReAct agent, because every request needs the same checks in
@@ -878,7 +878,7 @@
           <a:p>
             <a:r>
               <a:rPr lang="en-US" dirty="0"/>
-              <a:t>SLIDE 5 - Progress (1:48-2:08)  Saadhvika
+              <a:t>SLIDE 5 - Progress (1:53-2:13)  Saadhvika
 "This is every feature with its owner and status. Done: the voice assistant, memory, capacity
 questions, the four-objective scorer, the desk redesign and the AWS deployment. In progress:
 clarification fixes, and our evaluation set. Planned: Lynn's live run on the full set, and a
@@ -970,10 +970,10 @@
           <a:p>
             <a:r>
               <a:rPr lang="en-US" dirty="0"/>
-              <a:t>SLIDE 6 - Validation plan (2:08-2:51)  Niyanthri
+              <a:t>SLIDE 6 - Validation plan (2:13-2:55)  Niyanthri
 "We measure late batches and late days, our primary objective, in the course simulator, with and
 without a closure. Baselines are random, biggest capacity and cheapest, plus earliest
-finish, and settings were chosen on separate seeds first. The minimum is to beat all three
+finish. The minimum is to beat all three
 baselines, and handle all 30 inbox requests. Today: 1.4 percent late against 1.7, and 68 percent
 fewer late days. For language, the 30 inbox requests plus 50 new held-out ones, labelled
 separately, then agreed. Hard cases: an impossible date, a workshop that can't take it, and a
@@ -1065,19 +1065,19 @@
           <a:p>
             <a:r>
               <a:rPr lang="en-US" dirty="0"/>
-              <a:t>SLIDE 7 - Demo (2:51-4:50)  Zepeng, then Lynn
+              <a:t>SLIDE 7 - Demo (2:55-4:50)  Zepeng, then Lynn
 Take A ends here:
   Zepeng: "Now the demo."
 Take B, in the app. Times are from the start of Take B. Speak only when the app is quiet.
-[0:00] Zepeng: "This is Ravi's phone. The rings show how busy each workshop is, and OldMill is
-       grey because it's suspended."
+[0:00] Zepeng: "I'm Charles, playing the dispatcher. The rings show how busy each workshop is,
+       and OldMill is grey because it's suspended."
 [0:08] Hold the mic and say: "ORD-109, 500 vests for Harbor Knits, due April 13. Keep it away
        from BudgetWorks."
        Let the answer play: "GiantWeave can deliver order 109 by Thursday 9 April, 3.71 days
        early. Cost 550, defect risk 6.0%. Say book it, or tap book, to confirm."
 [0:30] Tap "Compare 4 workshops", then "Can't take it", then close them. (optional)
        Zepeng: "Here are the other options, and why the rest can't take it. BudgetWorks is out
-       because Ravi asked."
+       because I asked."
 [0:40] Hold the mic and say: "Book it." The sheet opens.
        Zepeng: "Nothing is saved until I slide." Slide to confirm.
 [0:52] On the receipt, tap "Remember".
@@ -1192,10 +1192,11 @@
 - Ruby (Duong Thanh Nhan) cannot attend: Ruby emails Salman and Jack with the reason before the
   session, and slide 1 shows "Absent" with that reason. Any member may be asked about Ruby's desk
   redesign: one answer at a time, objective panel, saved plan, Show working.
-- Who is Ravi? One of the five people in the course's dispatch chat (R02, R07, R12, R17, R22,
-  R27). We made the person who posts requests our user and gave them the phone, as the bonus
-  suggests. In the demo, Ravi says other people's requests out loud too: Mei's R25 and the boss's
-  R14.
+- Who is the user? SweaterCo's dispatcher, the person who handles the dispatch chat. Five
+  people post requests there (Ravi, Priya, Mei, Chen and the boss). In the demo Charles plays
+  the dispatcher and says requests from the chat out loud: Mei's R25 and the boss's R14.
+- Why "StitchFlow"? Stitch for garments, flow for orders moving to the right workshop.
+  QuickStitch is one of the eight workshops, not us.
 - Is the demo real time? Yes. It is one take with no cuts; only the start and end are trimmed.
 - Why voice? The track's bonus asks how a dispatcher would really use it: on the floor, on a
   phone. Typing still works everywhere, and the course inbox is still evaluated as text.
@@ -1341,7 +1342,7 @@
                 <a:ea typeface="Arial" pitchFamily="34" charset="-122"/>
                 <a:cs typeface="Arial" pitchFamily="34" charset="-120"/>
               </a:rPr>
-              <a:t>SWEATERCO  /  QUICK-RESPONSE SUBCONTRACTING DESK  /  GROUP 11  /  SPRINT 2</a:t>
+              <a:t>STITCHFLOW  /  QUICK-RESPONSE SUBCONTRACTING DESK  /  GROUP 11  /  SPRINT 2</a:t>
             </a:r>
             <a:endParaRPr lang="en-US" sz="700" dirty="0"/>
           </a:p>
@@ -1866,7 +1867,7 @@
         <p:spPr>
           <a:xfrm>
             <a:off x="548640" y="1143000"/>
-            <a:ext cx="5669280" cy="1143000"/>
+            <a:ext cx="5669280" cy="731520"/>
           </a:xfrm>
           <a:prstGeom prst="rect">
             <a:avLst/>
@@ -1882,7 +1883,7 @@
               <a:buNone/>
             </a:pPr>
             <a:r>
-              <a:rPr lang="en-US" sz="3400" dirty="0">
+              <a:rPr lang="en-US" sz="4400" dirty="0">
                 <a:solidFill>
                   <a:srgbClr val="F4EFE6"/>
                 </a:solidFill>
@@ -1890,16 +1891,38 @@
                 <a:ea typeface="Georgia" pitchFamily="34" charset="-122"/>
                 <a:cs typeface="Georgia" pitchFamily="34" charset="-120"/>
               </a:rPr>
-              <a:t>The Quick-Response</a:t>
-            </a:r>
-            <a:endParaRPr lang="en-US" sz="3400" dirty="0"/>
-          </a:p>
-          <a:p>
-            <a:pPr indent="0" marL="0">
-              <a:buNone/>
-            </a:pPr>
-            <a:r>
-              <a:rPr lang="en-US" sz="3400" dirty="0">
+              <a:t>StitchFlow</a:t>
+            </a:r>
+            <a:endParaRPr lang="en-US" sz="4400" dirty="0"/>
+          </a:p>
+        </p:txBody>
+      </p:sp>
+      <p:sp>
+        <p:nvSpPr>
+          <p:cNvPr id="5" name="Text 3"/>
+          <p:cNvSpPr txBox="1"/>
+          <p:nvPr/>
+        </p:nvSpPr>
+        <p:spPr>
+          <a:xfrm>
+            <a:off x="548640" y="1874520"/>
+            <a:ext cx="5669280" cy="329184"/>
+          </a:xfrm>
+          <a:prstGeom prst="rect">
+            <a:avLst/>
+          </a:prstGeom>
+          <a:noFill/>
+          <a:ln/>
+        </p:spPr>
+        <p:txBody>
+          <a:bodyPr wrap="square" lIns="0" tIns="0" rIns="0" bIns="0" rtlCol="0" anchor="ctr"/>
+          <a:lstStyle/>
+          <a:p>
+            <a:pPr indent="0" marL="0">
+              <a:buNone/>
+            </a:pPr>
+            <a:r>
+              <a:rPr lang="en-US" sz="1700" dirty="0">
                 <a:solidFill>
                   <a:srgbClr val="F4EFE6"/>
                 </a:solidFill>
@@ -1907,38 +1930,38 @@
                 <a:ea typeface="Georgia" pitchFamily="34" charset="-122"/>
                 <a:cs typeface="Georgia" pitchFamily="34" charset="-120"/>
               </a:rPr>
-              <a:t>Subcontracting Desk</a:t>
-            </a:r>
-            <a:endParaRPr lang="en-US" sz="3400" dirty="0"/>
-          </a:p>
-        </p:txBody>
-      </p:sp>
-      <p:sp>
-        <p:nvSpPr>
-          <p:cNvPr id="5" name="Text 3"/>
-          <p:cNvSpPr txBox="1"/>
-          <p:nvPr/>
-        </p:nvSpPr>
-        <p:spPr>
-          <a:xfrm>
-            <a:off x="548640" y="2304288"/>
-            <a:ext cx="5486400" cy="365760"/>
-          </a:xfrm>
-          <a:prstGeom prst="rect">
-            <a:avLst/>
-          </a:prstGeom>
-          <a:noFill/>
-          <a:ln/>
-        </p:spPr>
-        <p:txBody>
-          <a:bodyPr wrap="square" lIns="0" tIns="0" rIns="0" bIns="0" rtlCol="0" anchor="t"/>
-          <a:lstStyle/>
-          <a:p>
-            <a:pPr indent="0" marL="0">
-              <a:buNone/>
-            </a:pPr>
-            <a:r>
-              <a:rPr lang="en-US" sz="1500" i="1" dirty="0">
+              <a:t>The Quick-Response Subcontracting Desk</a:t>
+            </a:r>
+            <a:endParaRPr lang="en-US" sz="1700" dirty="0"/>
+          </a:p>
+        </p:txBody>
+      </p:sp>
+      <p:sp>
+        <p:nvSpPr>
+          <p:cNvPr id="6" name="Text 4"/>
+          <p:cNvSpPr txBox="1"/>
+          <p:nvPr/>
+        </p:nvSpPr>
+        <p:spPr>
+          <a:xfrm>
+            <a:off x="548640" y="2231136"/>
+            <a:ext cx="5669280" cy="329184"/>
+          </a:xfrm>
+          <a:prstGeom prst="rect">
+            <a:avLst/>
+          </a:prstGeom>
+          <a:noFill/>
+          <a:ln/>
+        </p:spPr>
+        <p:txBody>
+          <a:bodyPr wrap="square" lIns="0" tIns="0" rIns="0" bIns="0" rtlCol="0" anchor="ctr"/>
+          <a:lstStyle/>
+          <a:p>
+            <a:pPr indent="0" marL="0">
+              <a:buNone/>
+            </a:pPr>
+            <a:r>
+              <a:rPr lang="en-US" sz="1300" i="1" dirty="0">
                 <a:solidFill>
                   <a:srgbClr val="B9AF9F"/>
                 </a:solidFill>
@@ -1946,15 +1969,15 @@
                 <a:ea typeface="Georgia" pitchFamily="34" charset="-122"/>
                 <a:cs typeface="Georgia" pitchFamily="34" charset="-120"/>
               </a:rPr>
-              <a:t>Ravi talks. Python checks. A person commits.</a:t>
-            </a:r>
-            <a:endParaRPr lang="en-US" sz="1500" dirty="0"/>
-          </a:p>
-        </p:txBody>
-      </p:sp>
-      <p:sp>
-        <p:nvSpPr>
-          <p:cNvPr id="6" name="Shape 4"/>
+              <a:t>Say the order. StitchFlow finds the right workshop.</a:t>
+            </a:r>
+            <a:endParaRPr lang="en-US" sz="1300" dirty="0"/>
+          </a:p>
+        </p:txBody>
+      </p:sp>
+      <p:sp>
+        <p:nvSpPr>
+          <p:cNvPr id="7" name="Shape 5"/>
           <p:cNvSpPr/>
           <p:nvPr/>
         </p:nvSpPr>
@@ -1981,7 +2004,7 @@
       </p:sp>
       <p:sp>
         <p:nvSpPr>
-          <p:cNvPr id="7" name="Text 5"/>
+          <p:cNvPr id="8" name="Text 6"/>
           <p:cNvSpPr txBox="1"/>
           <p:nvPr/>
         </p:nvSpPr>
@@ -2031,7 +2054,7 @@
       </p:sp>
       <p:sp>
         <p:nvSpPr>
-          <p:cNvPr id="8" name="Shape 6"/>
+          <p:cNvPr id="9" name="Shape 7"/>
           <p:cNvSpPr/>
           <p:nvPr/>
         </p:nvSpPr>
@@ -2058,7 +2081,7 @@
       </p:sp>
       <p:sp>
         <p:nvSpPr>
-          <p:cNvPr id="9" name="Text 7"/>
+          <p:cNvPr id="10" name="Text 8"/>
           <p:cNvSpPr txBox="1"/>
           <p:nvPr/>
         </p:nvSpPr>
@@ -2108,7 +2131,7 @@
       </p:sp>
       <p:sp>
         <p:nvSpPr>
-          <p:cNvPr id="10" name="Text 8"/>
+          <p:cNvPr id="11" name="Text 9"/>
           <p:cNvSpPr txBox="1"/>
           <p:nvPr/>
         </p:nvSpPr>
@@ -2147,7 +2170,7 @@
       </p:sp>
       <p:sp>
         <p:nvSpPr>
-          <p:cNvPr id="11" name="Text 9"/>
+          <p:cNvPr id="12" name="Text 10"/>
           <p:cNvSpPr txBox="1"/>
           <p:nvPr/>
         </p:nvSpPr>
@@ -2186,7 +2209,7 @@
       </p:sp>
       <p:sp>
         <p:nvSpPr>
-          <p:cNvPr id="12" name="Text 10"/>
+          <p:cNvPr id="13" name="Text 11"/>
           <p:cNvSpPr txBox="1"/>
           <p:nvPr/>
         </p:nvSpPr>
@@ -2225,7 +2248,7 @@
       </p:sp>
       <p:sp>
         <p:nvSpPr>
-          <p:cNvPr id="13" name="Text 11"/>
+          <p:cNvPr id="14" name="Text 12"/>
           <p:cNvSpPr txBox="1"/>
           <p:nvPr/>
         </p:nvSpPr>
@@ -2264,7 +2287,7 @@
       </p:sp>
       <p:sp>
         <p:nvSpPr>
-          <p:cNvPr id="14" name="Text 12"/>
+          <p:cNvPr id="15" name="Text 13"/>
           <p:cNvSpPr txBox="1"/>
           <p:nvPr/>
         </p:nvSpPr>
@@ -2303,7 +2326,7 @@
       </p:sp>
       <p:sp>
         <p:nvSpPr>
-          <p:cNvPr id="15" name="Text 13"/>
+          <p:cNvPr id="16" name="Text 14"/>
           <p:cNvSpPr txBox="1"/>
           <p:nvPr/>
         </p:nvSpPr>
@@ -2342,7 +2365,7 @@
       </p:sp>
       <p:sp>
         <p:nvSpPr>
-          <p:cNvPr id="16" name="Text 14"/>
+          <p:cNvPr id="17" name="Text 15"/>
           <p:cNvSpPr txBox="1"/>
           <p:nvPr/>
         </p:nvSpPr>
@@ -2381,7 +2404,7 @@
       </p:sp>
       <p:sp>
         <p:nvSpPr>
-          <p:cNvPr id="17" name="Text 15"/>
+          <p:cNvPr id="18" name="Text 16"/>
           <p:cNvSpPr txBox="1"/>
           <p:nvPr/>
         </p:nvSpPr>
@@ -2420,7 +2443,7 @@
       </p:sp>
       <p:sp>
         <p:nvSpPr>
-          <p:cNvPr id="18" name="Text 16"/>
+          <p:cNvPr id="19" name="Text 17"/>
           <p:cNvSpPr txBox="1"/>
           <p:nvPr/>
         </p:nvSpPr>
@@ -2459,7 +2482,7 @@
       </p:sp>
       <p:sp>
         <p:nvSpPr>
-          <p:cNvPr id="19" name="Text 17"/>
+          <p:cNvPr id="20" name="Text 18"/>
           <p:cNvSpPr txBox="1"/>
           <p:nvPr/>
         </p:nvSpPr>
@@ -2498,7 +2521,7 @@
       </p:sp>
       <p:sp>
         <p:nvSpPr>
-          <p:cNvPr id="20" name="Text 18"/>
+          <p:cNvPr id="21" name="Text 19"/>
           <p:cNvSpPr txBox="1"/>
           <p:nvPr/>
         </p:nvSpPr>
@@ -2537,7 +2560,7 @@
       </p:sp>
       <p:sp>
         <p:nvSpPr>
-          <p:cNvPr id="21" name="Text 19"/>
+          <p:cNvPr id="22" name="Text 20"/>
           <p:cNvSpPr txBox="1"/>
           <p:nvPr/>
         </p:nvSpPr>
@@ -2576,7 +2599,7 @@
       </p:sp>
       <p:sp>
         <p:nvSpPr>
-          <p:cNvPr id="22" name="Text 20"/>
+          <p:cNvPr id="23" name="Text 21"/>
           <p:cNvSpPr txBox="1"/>
           <p:nvPr/>
         </p:nvSpPr>
@@ -2626,7 +2649,7 @@
       </p:sp>
       <p:sp>
         <p:nvSpPr>
-          <p:cNvPr id="23" name="Text 21"/>
+          <p:cNvPr id="24" name="Text 22"/>
           <p:cNvSpPr txBox="1"/>
           <p:nvPr/>
         </p:nvSpPr>
@@ -2676,7 +2699,7 @@
       </p:sp>
       <p:sp>
         <p:nvSpPr>
-          <p:cNvPr id="24" name="Text 22"/>
+          <p:cNvPr id="25" name="Text 23"/>
           <p:cNvSpPr txBox="1"/>
           <p:nvPr/>
         </p:nvSpPr>
@@ -2715,7 +2738,7 @@
       </p:sp>
       <p:pic>
         <p:nvPicPr>
-          <p:cNvPr id="25" name="Image 0" descr="The dispatch assistant on a phone: a greeting, the eight workshops with their queue rings, and example requests">    </p:cNvPr>
+          <p:cNvPr id="26" name="Image 0" descr="The dispatch assistant on a phone: a greeting, the eight workshops with their queue rings, and example requests">    </p:cNvPr>
           <p:cNvPicPr>
             <a:picLocks noChangeAspect="1"/>
           </p:cNvPicPr>
@@ -2841,7 +2864,7 @@
                 <a:ea typeface="Georgia" pitchFamily="34" charset="-122"/>
                 <a:cs typeface="Georgia" pitchFamily="34" charset="-120"/>
               </a:rPr>
-              <a:t>Ravi decides on the factory floor, in seconds</a:t>
+              <a:t>The dispatcher decides on the factory floor, in seconds</a:t>
             </a:r>
             <a:endParaRPr lang="en-US" sz="2300" dirty="0"/>
           </a:p>
@@ -2944,7 +2967,7 @@
                 <a:ea typeface="Georgia" pitchFamily="34" charset="-122"/>
                 <a:cs typeface="Georgia" pitchFamily="34" charset="-120"/>
               </a:rPr>
-              <a:t>Ravi, production dispatcher at SweaterCo</a:t>
+              <a:t>The production dispatcher at SweaterCo</a:t>
             </a:r>
             <a:endParaRPr lang="en-US" sz="1350" dirty="0"/>
           </a:p>
@@ -3100,7 +3123,7 @@
                 <a:ea typeface="Arial" pitchFamily="34" charset="-122"/>
                 <a:cs typeface="Arial" pitchFamily="34" charset="-120"/>
               </a:rPr>
-              <a:t>WHAT RAVI NEEDS</a:t>
+              <a:t>WHAT THE DISPATCHER NEEDS</a:t>
             </a:r>
             <a:endParaRPr lang="en-US" sz="750" dirty="0"/>
           </a:p>
@@ -11101,7 +11124,7 @@
                 <a:ea typeface="Georgia" pitchFamily="34" charset="-122"/>
                 <a:cs typeface="Georgia" pitchFamily="34" charset="-120"/>
               </a:rPr>
-              <a:t>Ravi, on the floor</a:t>
+              <a:t>Charles, as the dispatcher</a:t>
             </a:r>
             <a:endParaRPr lang="en-US" sz="2800" dirty="0"/>
           </a:p>
@@ -11742,7 +11765,7 @@
                 <a:ea typeface="Georgia" pitchFamily="34" charset="-122"/>
                 <a:cs typeface="Georgia" pitchFamily="34" charset="-120"/>
               </a:rPr>
-              <a:t>SWEATERCO</a:t>
+              <a:t>STITCHFLOW</a:t>
             </a:r>
             <a:endParaRPr lang="en-US" sz="1300" dirty="0"/>
           </a:p>
@@ -11959,7 +11982,7 @@
                 <a:ea typeface="Arial" pitchFamily="34" charset="-122"/>
                 <a:cs typeface="Arial" pitchFamily="34" charset="-120"/>
               </a:rPr>
-              <a:t>RAVI TALKS  /  PYTHON CHECKS  /  A PERSON COMMITS</a:t>
+              <a:t>SAY THE ORDER  /  PYTHON CHECKS  /  A PERSON COMMITS</a:t>
             </a:r>
             <a:endParaRPr lang="en-US" sz="850" dirty="0"/>
           </a:p>

</xml_diff>

<commit_message>
Add section numbers and a progress count to the deck, after Niyanthri's redesign
</commit_message>
<xml_diff>
--- a/docs/slides/Presentation_Group11_Sprint2.pptx
+++ b/docs/slides/Presentation_Group11_Sprint2.pptx
@@ -879,7 +879,7 @@
             <a:r>
               <a:rPr lang="en-US" dirty="0"/>
               <a:t>SLIDE 5 - Progress (1:53-2:13)  Saadhvika
-"This is every feature with its owner and status. Done: the voice assistant, memory, capacity
+"Every feature has an owner. Six of eleven are done: the voice assistant, memory, capacity
 questions, the four-objective scorer, the desk redesign and the AWS deployment. In progress:
 clarification fixes, and our evaluation set. Planned: Lynn's live run on the full set, and a
 usability test."</a:t>
@@ -2819,6 +2819,17 @@
             <a:r>
               <a:rPr lang="en-US" sz="850" b="1" spc="300" kern="0" dirty="0">
                 <a:solidFill>
+                  <a:srgbClr val="1D1B18"/>
+                </a:solidFill>
+                <a:latin typeface="Arial" pitchFamily="34" charset="0"/>
+                <a:ea typeface="Arial" pitchFamily="34" charset="-122"/>
+                <a:cs typeface="Arial" pitchFamily="34" charset="-120"/>
+              </a:rPr>
+              <a:t>02   </a:t>
+            </a:r>
+            <a:r>
+              <a:rPr lang="en-US" sz="850" b="1" spc="300" kern="0" dirty="0">
+                <a:solidFill>
                   <a:srgbClr val="7D5E30"/>
                 </a:solidFill>
                 <a:latin typeface="Arial" pitchFamily="34" charset="0"/>
@@ -4030,6 +4041,17 @@
             <a:r>
               <a:rPr lang="en-US" sz="850" b="1" spc="300" kern="0" dirty="0">
                 <a:solidFill>
+                  <a:srgbClr val="1D1B18"/>
+                </a:solidFill>
+                <a:latin typeface="Arial" pitchFamily="34" charset="0"/>
+                <a:ea typeface="Arial" pitchFamily="34" charset="-122"/>
+                <a:cs typeface="Arial" pitchFamily="34" charset="-120"/>
+              </a:rPr>
+              <a:t>03   </a:t>
+            </a:r>
+            <a:r>
+              <a:rPr lang="en-US" sz="850" b="1" spc="300" kern="0" dirty="0">
+                <a:solidFill>
                   <a:srgbClr val="7D5E30"/>
                 </a:solidFill>
                 <a:latin typeface="Arial" pitchFamily="34" charset="0"/>
@@ -4957,6 +4979,17 @@
             <a:pPr indent="0" marL="0">
               <a:buNone/>
             </a:pPr>
+            <a:r>
+              <a:rPr lang="en-US" sz="850" b="1" spc="300" kern="0" dirty="0">
+                <a:solidFill>
+                  <a:srgbClr val="1D1B18"/>
+                </a:solidFill>
+                <a:latin typeface="Arial" pitchFamily="34" charset="0"/>
+                <a:ea typeface="Arial" pitchFamily="34" charset="-122"/>
+                <a:cs typeface="Arial" pitchFamily="34" charset="-120"/>
+              </a:rPr>
+              <a:t>04   </a:t>
+            </a:r>
             <a:r>
               <a:rPr lang="en-US" sz="850" b="1" spc="300" kern="0" dirty="0">
                 <a:solidFill>
@@ -7318,12 +7351,23 @@
             <a:r>
               <a:rPr lang="en-US" sz="850" b="1" spc="300" kern="0" dirty="0">
                 <a:solidFill>
-                  <a:srgbClr val="7D5E30"/>
+                  <a:srgbClr val="1D1B18"/>
                 </a:solidFill>
                 <a:latin typeface="Arial" pitchFamily="34" charset="0"/>
                 <a:ea typeface="Arial" pitchFamily="34" charset="-122"/>
                 <a:cs typeface="Arial" pitchFamily="34" charset="-120"/>
               </a:rPr>
+              <a:t>05   </a:t>
+            </a:r>
+            <a:r>
+              <a:rPr lang="en-US" sz="850" b="1" spc="300" kern="0" dirty="0">
+                <a:solidFill>
+                  <a:srgbClr val="7D5E30"/>
+                </a:solidFill>
+                <a:latin typeface="Arial" pitchFamily="34" charset="0"/>
+                <a:ea typeface="Arial" pitchFamily="34" charset="-122"/>
+                <a:cs typeface="Arial" pitchFamily="34" charset="-120"/>
+              </a:rPr>
               <a:t>PROGRESS SINCE THE SPRINT 1 ROADMAP</a:t>
             </a:r>
             <a:endParaRPr lang="en-US" sz="850" dirty="0"/>
@@ -7366,6 +7410,227 @@
               <a:t>Every feature, its owner and its status</a:t>
             </a:r>
             <a:endParaRPr lang="en-US" sz="2300" dirty="0"/>
+          </a:p>
+        </p:txBody>
+      </p:sp>
+      <p:sp>
+        <p:nvSpPr>
+          <p:cNvPr id="4" name="Text 2"/>
+          <p:cNvSpPr txBox="1"/>
+          <p:nvPr/>
+        </p:nvSpPr>
+        <p:spPr>
+          <a:xfrm>
+            <a:off x="548640" y="1234440"/>
+            <a:ext cx="2011680" cy="914400"/>
+          </a:xfrm>
+          <a:prstGeom prst="rect">
+            <a:avLst/>
+          </a:prstGeom>
+          <a:noFill/>
+          <a:ln/>
+        </p:spPr>
+        <p:txBody>
+          <a:bodyPr wrap="square" lIns="0" tIns="0" rIns="0" bIns="0" rtlCol="0" anchor="ctr"/>
+          <a:lstStyle/>
+          <a:p>
+            <a:pPr indent="0" marL="0">
+              <a:buNone/>
+            </a:pPr>
+            <a:r>
+              <a:rPr lang="en-US" sz="6000" dirty="0">
+                <a:solidFill>
+                  <a:srgbClr val="2F5D46"/>
+                </a:solidFill>
+                <a:latin typeface="Georgia" pitchFamily="34" charset="0"/>
+                <a:ea typeface="Georgia" pitchFamily="34" charset="-122"/>
+                <a:cs typeface="Georgia" pitchFamily="34" charset="-120"/>
+              </a:rPr>
+              <a:t>6</a:t>
+            </a:r>
+            <a:r>
+              <a:rPr lang="en-US" sz="6000" dirty="0">
+                <a:solidFill>
+                  <a:srgbClr val="1D1B18"/>
+                </a:solidFill>
+                <a:latin typeface="Georgia" pitchFamily="34" charset="0"/>
+                <a:ea typeface="Georgia" pitchFamily="34" charset="-122"/>
+                <a:cs typeface="Georgia" pitchFamily="34" charset="-120"/>
+              </a:rPr>
+              <a:t>/11</a:t>
+            </a:r>
+            <a:endParaRPr lang="en-US" sz="6000" dirty="0"/>
+          </a:p>
+        </p:txBody>
+      </p:sp>
+      <p:sp>
+        <p:nvSpPr>
+          <p:cNvPr id="5" name="Text 3"/>
+          <p:cNvSpPr txBox="1"/>
+          <p:nvPr/>
+        </p:nvSpPr>
+        <p:spPr>
+          <a:xfrm>
+            <a:off x="548640" y="2194560"/>
+            <a:ext cx="2011680" cy="256032"/>
+          </a:xfrm>
+          <a:prstGeom prst="rect">
+            <a:avLst/>
+          </a:prstGeom>
+          <a:noFill/>
+          <a:ln/>
+        </p:spPr>
+        <p:txBody>
+          <a:bodyPr wrap="square" lIns="0" tIns="0" rIns="0" bIns="0" rtlCol="0" anchor="t"/>
+          <a:lstStyle/>
+          <a:p>
+            <a:pPr indent="0" marL="0">
+              <a:buNone/>
+            </a:pPr>
+            <a:r>
+              <a:rPr lang="en-US" sz="1100" b="1" dirty="0">
+                <a:solidFill>
+                  <a:srgbClr val="1D1B18"/>
+                </a:solidFill>
+                <a:latin typeface="Arial" pitchFamily="34" charset="0"/>
+                <a:ea typeface="Arial" pitchFamily="34" charset="-122"/>
+                <a:cs typeface="Arial" pitchFamily="34" charset="-120"/>
+              </a:rPr>
+              <a:t>features done this sprint</a:t>
+            </a:r>
+            <a:endParaRPr lang="en-US" sz="1100" dirty="0"/>
+          </a:p>
+        </p:txBody>
+      </p:sp>
+      <p:sp>
+        <p:nvSpPr>
+          <p:cNvPr id="6" name="Shape 4"/>
+          <p:cNvSpPr/>
+          <p:nvPr/>
+        </p:nvSpPr>
+        <p:spPr>
+          <a:xfrm>
+            <a:off x="548640" y="2615184"/>
+            <a:ext cx="1463040" cy="292608"/>
+          </a:xfrm>
+          <a:prstGeom prst="roundRect">
+            <a:avLst>
+              <a:gd name="adj" fmla="val 50000"/>
+            </a:avLst>
+          </a:prstGeom>
+          <a:solidFill>
+            <a:srgbClr val="9A6A12"/>
+          </a:solidFill>
+          <a:ln w="12700">
+            <a:solidFill>
+              <a:srgbClr val="9A6A12"/>
+            </a:solidFill>
+            <a:prstDash val="solid"/>
+          </a:ln>
+        </p:spPr>
+      </p:sp>
+      <p:sp>
+        <p:nvSpPr>
+          <p:cNvPr id="7" name="Text 5"/>
+          <p:cNvSpPr txBox="1"/>
+          <p:nvPr/>
+        </p:nvSpPr>
+        <p:spPr>
+          <a:xfrm>
+            <a:off x="548640" y="2615184"/>
+            <a:ext cx="1463040" cy="292608"/>
+          </a:xfrm>
+          <a:prstGeom prst="rect">
+            <a:avLst/>
+          </a:prstGeom>
+          <a:noFill/>
+          <a:ln/>
+        </p:spPr>
+        <p:txBody>
+          <a:bodyPr wrap="square" lIns="0" tIns="0" rIns="0" bIns="0" rtlCol="0" anchor="ctr"/>
+          <a:lstStyle/>
+          <a:p>
+            <a:pPr algn="ctr" indent="0" marL="0">
+              <a:buNone/>
+            </a:pPr>
+            <a:r>
+              <a:rPr lang="en-US" sz="900" b="1" dirty="0">
+                <a:solidFill>
+                  <a:srgbClr val="FFFFFF"/>
+                </a:solidFill>
+                <a:latin typeface="Arial" pitchFamily="34" charset="0"/>
+                <a:ea typeface="Arial" pitchFamily="34" charset="-122"/>
+                <a:cs typeface="Arial" pitchFamily="34" charset="-120"/>
+              </a:rPr>
+              <a:t>3 in progress</a:t>
+            </a:r>
+            <a:endParaRPr lang="en-US" sz="900" dirty="0"/>
+          </a:p>
+        </p:txBody>
+      </p:sp>
+      <p:sp>
+        <p:nvSpPr>
+          <p:cNvPr id="8" name="Shape 6"/>
+          <p:cNvSpPr/>
+          <p:nvPr/>
+        </p:nvSpPr>
+        <p:spPr>
+          <a:xfrm>
+            <a:off x="548640" y="3017520"/>
+            <a:ext cx="1463040" cy="292608"/>
+          </a:xfrm>
+          <a:prstGeom prst="roundRect">
+            <a:avLst>
+              <a:gd name="adj" fmla="val 50000"/>
+            </a:avLst>
+          </a:prstGeom>
+          <a:solidFill>
+            <a:srgbClr val="FAF8F4"/>
+          </a:solidFill>
+          <a:ln w="12700">
+            <a:solidFill>
+              <a:srgbClr val="6B665D"/>
+            </a:solidFill>
+            <a:prstDash val="solid"/>
+          </a:ln>
+        </p:spPr>
+      </p:sp>
+      <p:sp>
+        <p:nvSpPr>
+          <p:cNvPr id="9" name="Text 7"/>
+          <p:cNvSpPr txBox="1"/>
+          <p:nvPr/>
+        </p:nvSpPr>
+        <p:spPr>
+          <a:xfrm>
+            <a:off x="548640" y="3017520"/>
+            <a:ext cx="1463040" cy="292608"/>
+          </a:xfrm>
+          <a:prstGeom prst="rect">
+            <a:avLst/>
+          </a:prstGeom>
+          <a:noFill/>
+          <a:ln/>
+        </p:spPr>
+        <p:txBody>
+          <a:bodyPr wrap="square" lIns="0" tIns="0" rIns="0" bIns="0" rtlCol="0" anchor="ctr"/>
+          <a:lstStyle/>
+          <a:p>
+            <a:pPr algn="ctr" indent="0" marL="0">
+              <a:buNone/>
+            </a:pPr>
+            <a:r>
+              <a:rPr lang="en-US" sz="900" b="1" dirty="0">
+                <a:solidFill>
+                  <a:srgbClr val="6B665D"/>
+                </a:solidFill>
+                <a:latin typeface="Arial" pitchFamily="34" charset="0"/>
+                <a:ea typeface="Arial" pitchFamily="34" charset="-122"/>
+                <a:cs typeface="Arial" pitchFamily="34" charset="-120"/>
+              </a:rPr>
+              <a:t>2 planned</a:t>
+            </a:r>
+            <a:endParaRPr lang="en-US" sz="900" dirty="0"/>
           </a:p>
         </p:txBody>
       </p:sp>
@@ -7384,17 +7649,17 @@
           </p:nvPr>
         </p:nvGraphicFramePr>
         <p:xfrm>
-          <a:off x="548640" y="1207008"/>
-          <a:ext cx="8046720" cy="914400"/>
+          <a:off x="2743200" y="1207008"/>
+          <a:ext cx="5852160" cy="914400"/>
         </p:xfrm>
         <a:graphic>
           <a:graphicData uri="http://schemas.openxmlformats.org/drawingml/2006/table">
             <a:tbl>
               <a:tblPr/>
               <a:tblGrid>
-                <a:gridCol w="5120640"/>
-                <a:gridCol w="1828800"/>
-                <a:gridCol w="1097280"/>
+                <a:gridCol w="3520440"/>
+                <a:gridCol w="1508760"/>
+                <a:gridCol w="822960"/>
               </a:tblGrid>
               <a:tr h="219456">
                 <a:tc>
@@ -7549,7 +7814,7 @@
                         <a:buNone/>
                       </a:pPr>
                       <a:r>
-                        <a:rPr lang="en-US" sz="900" dirty="0">
+                        <a:rPr lang="en-US" sz="850" dirty="0">
                           <a:solidFill>
                             <a:srgbClr val="1D1B18"/>
                           </a:solidFill>
@@ -7559,7 +7824,7 @@
                         </a:rPr>
                         <a:t>Voice assistant: phone UI, speech in and out, slide to book</a:t>
                       </a:r>
-                      <a:endParaRPr lang="en-US" sz="900" dirty="0">
+                      <a:endParaRPr lang="en-US" sz="850" dirty="0">
                         <a:latin typeface="Arial" charset="0"/>
                         <a:ea typeface="Arial" charset="0"/>
                         <a:cs typeface="Arial" charset="0"/>
@@ -7596,7 +7861,7 @@
                         <a:buNone/>
                       </a:pPr>
                       <a:r>
-                        <a:rPr lang="en-US" sz="900" dirty="0">
+                        <a:rPr lang="en-US" sz="850" dirty="0">
                           <a:solidFill>
                             <a:srgbClr val="4A463F"/>
                           </a:solidFill>
@@ -7606,7 +7871,7 @@
                         </a:rPr>
                         <a:t>Chen Zepeng</a:t>
                       </a:r>
-                      <a:endParaRPr lang="en-US" sz="900" dirty="0">
+                      <a:endParaRPr lang="en-US" sz="850" dirty="0">
                         <a:latin typeface="Arial" charset="0"/>
                         <a:ea typeface="Arial" charset="0"/>
                         <a:cs typeface="Arial" charset="0"/>
@@ -7643,7 +7908,7 @@
                         <a:buNone/>
                       </a:pPr>
                       <a:r>
-                        <a:rPr lang="en-US" sz="900" b="1" dirty="0">
+                        <a:rPr lang="en-US" sz="850" b="1" dirty="0">
                           <a:solidFill>
                             <a:srgbClr val="2F5D46"/>
                           </a:solidFill>
@@ -7653,7 +7918,7 @@
                         </a:rPr>
                         <a:t>Done</a:t>
                       </a:r>
-                      <a:endParaRPr lang="en-US" sz="900" dirty="0">
+                      <a:endParaRPr lang="en-US" sz="850" dirty="0">
                         <a:latin typeface="Arial" charset="0"/>
                         <a:ea typeface="Arial" charset="0"/>
                         <a:cs typeface="Arial" charset="0"/>
@@ -7692,7 +7957,7 @@
                         <a:buNone/>
                       </a:pPr>
                       <a:r>
-                        <a:rPr lang="en-US" sz="900" dirty="0">
+                        <a:rPr lang="en-US" sz="850" dirty="0">
                           <a:solidFill>
                             <a:srgbClr val="1D1B18"/>
                           </a:solidFill>
@@ -7702,7 +7967,7 @@
                         </a:rPr>
                         <a:t>Long-term memory: rules from confirmed bookings, log, profile</a:t>
                       </a:r>
-                      <a:endParaRPr lang="en-US" sz="900" dirty="0">
+                      <a:endParaRPr lang="en-US" sz="850" dirty="0">
                         <a:latin typeface="Arial" charset="0"/>
                         <a:ea typeface="Arial" charset="0"/>
                         <a:cs typeface="Arial" charset="0"/>
@@ -7739,7 +8004,7 @@
                         <a:buNone/>
                       </a:pPr>
                       <a:r>
-                        <a:rPr lang="en-US" sz="900" dirty="0">
+                        <a:rPr lang="en-US" sz="850" dirty="0">
                           <a:solidFill>
                             <a:srgbClr val="4A463F"/>
                           </a:solidFill>
@@ -7749,7 +8014,7 @@
                         </a:rPr>
                         <a:t>Chen Zepeng</a:t>
                       </a:r>
-                      <a:endParaRPr lang="en-US" sz="900" dirty="0">
+                      <a:endParaRPr lang="en-US" sz="850" dirty="0">
                         <a:latin typeface="Arial" charset="0"/>
                         <a:ea typeface="Arial" charset="0"/>
                         <a:cs typeface="Arial" charset="0"/>
@@ -7786,7 +8051,7 @@
                         <a:buNone/>
                       </a:pPr>
                       <a:r>
-                        <a:rPr lang="en-US" sz="900" b="1" dirty="0">
+                        <a:rPr lang="en-US" sz="850" b="1" dirty="0">
                           <a:solidFill>
                             <a:srgbClr val="2F5D46"/>
                           </a:solidFill>
@@ -7796,7 +8061,7 @@
                         </a:rPr>
                         <a:t>Done</a:t>
                       </a:r>
-                      <a:endParaRPr lang="en-US" sz="900" dirty="0">
+                      <a:endParaRPr lang="en-US" sz="850" dirty="0">
                         <a:latin typeface="Arial" charset="0"/>
                         <a:ea typeface="Arial" charset="0"/>
                         <a:cs typeface="Arial" charset="0"/>
@@ -7835,7 +8100,7 @@
                         <a:buNone/>
                       </a:pPr>
                       <a:r>
-                        <a:rPr lang="en-US" sz="900" dirty="0">
+                        <a:rPr lang="en-US" sz="850" dirty="0">
                           <a:solidFill>
                             <a:srgbClr val="1D1B18"/>
                           </a:solidFill>
@@ -7845,7 +8110,7 @@
                         </a:rPr>
                         <a:t>Four-objective scorer, frozen presets, objective lab</a:t>
                       </a:r>
-                      <a:endParaRPr lang="en-US" sz="900" dirty="0">
+                      <a:endParaRPr lang="en-US" sz="850" dirty="0">
                         <a:latin typeface="Arial" charset="0"/>
                         <a:ea typeface="Arial" charset="0"/>
                         <a:cs typeface="Arial" charset="0"/>
@@ -7882,7 +8147,7 @@
                         <a:buNone/>
                       </a:pPr>
                       <a:r>
-                        <a:rPr lang="en-US" sz="900" dirty="0">
+                        <a:rPr lang="en-US" sz="850" dirty="0">
                           <a:solidFill>
                             <a:srgbClr val="4A463F"/>
                           </a:solidFill>
@@ -7892,7 +8157,7 @@
                         </a:rPr>
                         <a:t>Chen Zepeng</a:t>
                       </a:r>
-                      <a:endParaRPr lang="en-US" sz="900" dirty="0">
+                      <a:endParaRPr lang="en-US" sz="850" dirty="0">
                         <a:latin typeface="Arial" charset="0"/>
                         <a:ea typeface="Arial" charset="0"/>
                         <a:cs typeface="Arial" charset="0"/>
@@ -7929,7 +8194,7 @@
                         <a:buNone/>
                       </a:pPr>
                       <a:r>
-                        <a:rPr lang="en-US" sz="900" b="1" dirty="0">
+                        <a:rPr lang="en-US" sz="850" b="1" dirty="0">
                           <a:solidFill>
                             <a:srgbClr val="2F5D46"/>
                           </a:solidFill>
@@ -7939,7 +8204,7 @@
                         </a:rPr>
                         <a:t>Done</a:t>
                       </a:r>
-                      <a:endParaRPr lang="en-US" sz="900" dirty="0">
+                      <a:endParaRPr lang="en-US" sz="850" dirty="0">
                         <a:latin typeface="Arial" charset="0"/>
                         <a:ea typeface="Arial" charset="0"/>
                         <a:cs typeface="Arial" charset="0"/>
@@ -7978,7 +8243,7 @@
                         <a:buNone/>
                       </a:pPr>
                       <a:r>
-                        <a:rPr lang="en-US" sz="900" dirty="0">
+                        <a:rPr lang="en-US" sz="850" dirty="0">
                           <a:solidFill>
                             <a:srgbClr val="1D1B18"/>
                           </a:solidFill>
@@ -7988,7 +8253,7 @@
                         </a:rPr>
                         <a:t>Capacity questions and workshop checks from chat</a:t>
                       </a:r>
-                      <a:endParaRPr lang="en-US" sz="900" dirty="0">
+                      <a:endParaRPr lang="en-US" sz="850" dirty="0">
                         <a:latin typeface="Arial" charset="0"/>
                         <a:ea typeface="Arial" charset="0"/>
                         <a:cs typeface="Arial" charset="0"/>
@@ -8025,7 +8290,7 @@
                         <a:buNone/>
                       </a:pPr>
                       <a:r>
-                        <a:rPr lang="en-US" sz="900" dirty="0">
+                        <a:rPr lang="en-US" sz="850" dirty="0">
                           <a:solidFill>
                             <a:srgbClr val="4A463F"/>
                           </a:solidFill>
@@ -8035,7 +8300,7 @@
                         </a:rPr>
                         <a:t>Chen Zepeng</a:t>
                       </a:r>
-                      <a:endParaRPr lang="en-US" sz="900" dirty="0">
+                      <a:endParaRPr lang="en-US" sz="850" dirty="0">
                         <a:latin typeface="Arial" charset="0"/>
                         <a:ea typeface="Arial" charset="0"/>
                         <a:cs typeface="Arial" charset="0"/>
@@ -8072,7 +8337,7 @@
                         <a:buNone/>
                       </a:pPr>
                       <a:r>
-                        <a:rPr lang="en-US" sz="900" b="1" dirty="0">
+                        <a:rPr lang="en-US" sz="850" b="1" dirty="0">
                           <a:solidFill>
                             <a:srgbClr val="2F5D46"/>
                           </a:solidFill>
@@ -8082,7 +8347,7 @@
                         </a:rPr>
                         <a:t>Done</a:t>
                       </a:r>
-                      <a:endParaRPr lang="en-US" sz="900" dirty="0">
+                      <a:endParaRPr lang="en-US" sz="850" dirty="0">
                         <a:latin typeface="Arial" charset="0"/>
                         <a:ea typeface="Arial" charset="0"/>
                         <a:cs typeface="Arial" charset="0"/>
@@ -8121,7 +8386,7 @@
                         <a:buNone/>
                       </a:pPr>
                       <a:r>
-                        <a:rPr lang="en-US" sz="900" dirty="0">
+                        <a:rPr lang="en-US" sz="850" dirty="0">
                           <a:solidFill>
                             <a:srgbClr val="1D1B18"/>
                           </a:solidFill>
@@ -8131,7 +8396,7 @@
                         </a:rPr>
                         <a:t>Chat-first desk redesign</a:t>
                       </a:r>
-                      <a:endParaRPr lang="en-US" sz="900" dirty="0">
+                      <a:endParaRPr lang="en-US" sz="850" dirty="0">
                         <a:latin typeface="Arial" charset="0"/>
                         <a:ea typeface="Arial" charset="0"/>
                         <a:cs typeface="Arial" charset="0"/>
@@ -8168,7 +8433,7 @@
                         <a:buNone/>
                       </a:pPr>
                       <a:r>
-                        <a:rPr lang="en-US" sz="900" dirty="0">
+                        <a:rPr lang="en-US" sz="850" dirty="0">
                           <a:solidFill>
                             <a:srgbClr val="4A463F"/>
                           </a:solidFill>
@@ -8178,7 +8443,7 @@
                         </a:rPr>
                         <a:t>Duong Thanh Nhan</a:t>
                       </a:r>
-                      <a:endParaRPr lang="en-US" sz="900" dirty="0">
+                      <a:endParaRPr lang="en-US" sz="850" dirty="0">
                         <a:latin typeface="Arial" charset="0"/>
                         <a:ea typeface="Arial" charset="0"/>
                         <a:cs typeface="Arial" charset="0"/>
@@ -8215,7 +8480,7 @@
                         <a:buNone/>
                       </a:pPr>
                       <a:r>
-                        <a:rPr lang="en-US" sz="900" b="1" dirty="0">
+                        <a:rPr lang="en-US" sz="850" b="1" dirty="0">
                           <a:solidFill>
                             <a:srgbClr val="2F5D46"/>
                           </a:solidFill>
@@ -8225,7 +8490,7 @@
                         </a:rPr>
                         <a:t>Done</a:t>
                       </a:r>
-                      <a:endParaRPr lang="en-US" sz="900" dirty="0">
+                      <a:endParaRPr lang="en-US" sz="850" dirty="0">
                         <a:latin typeface="Arial" charset="0"/>
                         <a:ea typeface="Arial" charset="0"/>
                         <a:cs typeface="Arial" charset="0"/>
@@ -8264,7 +8529,7 @@
                         <a:buNone/>
                       </a:pPr>
                       <a:r>
-                        <a:rPr lang="en-US" sz="900" dirty="0">
+                        <a:rPr lang="en-US" sz="850" dirty="0">
                           <a:solidFill>
                             <a:srgbClr val="1D1B18"/>
                           </a:solidFill>
@@ -8274,7 +8539,7 @@
                         </a:rPr>
                         <a:t>AWS deployment behind HTTPS (demo site)</a:t>
                       </a:r>
-                      <a:endParaRPr lang="en-US" sz="900" dirty="0">
+                      <a:endParaRPr lang="en-US" sz="850" dirty="0">
                         <a:latin typeface="Arial" charset="0"/>
                         <a:ea typeface="Arial" charset="0"/>
                         <a:cs typeface="Arial" charset="0"/>
@@ -8311,7 +8576,7 @@
                         <a:buNone/>
                       </a:pPr>
                       <a:r>
-                        <a:rPr lang="en-US" sz="900" dirty="0">
+                        <a:rPr lang="en-US" sz="850" dirty="0">
                           <a:solidFill>
                             <a:srgbClr val="4A463F"/>
                           </a:solidFill>
@@ -8321,7 +8586,7 @@
                         </a:rPr>
                         <a:t>Joshua Wesley Gloor</a:t>
                       </a:r>
-                      <a:endParaRPr lang="en-US" sz="900" dirty="0">
+                      <a:endParaRPr lang="en-US" sz="850" dirty="0">
                         <a:latin typeface="Arial" charset="0"/>
                         <a:ea typeface="Arial" charset="0"/>
                         <a:cs typeface="Arial" charset="0"/>
@@ -8358,7 +8623,7 @@
                         <a:buNone/>
                       </a:pPr>
                       <a:r>
-                        <a:rPr lang="en-US" sz="900" b="1" dirty="0">
+                        <a:rPr lang="en-US" sz="850" b="1" dirty="0">
                           <a:solidFill>
                             <a:srgbClr val="2F5D46"/>
                           </a:solidFill>
@@ -8368,7 +8633,7 @@
                         </a:rPr>
                         <a:t>Done</a:t>
                       </a:r>
-                      <a:endParaRPr lang="en-US" sz="900" dirty="0">
+                      <a:endParaRPr lang="en-US" sz="850" dirty="0">
                         <a:latin typeface="Arial" charset="0"/>
                         <a:ea typeface="Arial" charset="0"/>
                         <a:cs typeface="Arial" charset="0"/>
@@ -8407,7 +8672,7 @@
                         <a:buNone/>
                       </a:pPr>
                       <a:r>
-                        <a:rPr lang="en-US" sz="900" dirty="0">
+                        <a:rPr lang="en-US" sz="850" dirty="0">
                           <a:solidFill>
                             <a:srgbClr val="1D1B18"/>
                           </a:solidFill>
@@ -8417,7 +8682,7 @@
                         </a:rPr>
                         <a:t>Clarification reliability fixes and 247-assertion benchmark</a:t>
                       </a:r>
-                      <a:endParaRPr lang="en-US" sz="900" dirty="0">
+                      <a:endParaRPr lang="en-US" sz="850" dirty="0">
                         <a:latin typeface="Arial" charset="0"/>
                         <a:ea typeface="Arial" charset="0"/>
                         <a:cs typeface="Arial" charset="0"/>
@@ -8454,7 +8719,7 @@
                         <a:buNone/>
                       </a:pPr>
                       <a:r>
-                        <a:rPr lang="en-US" sz="900" dirty="0">
+                        <a:rPr lang="en-US" sz="850" dirty="0">
                           <a:solidFill>
                             <a:srgbClr val="4A463F"/>
                           </a:solidFill>
@@ -8464,7 +8729,7 @@
                         </a:rPr>
                         <a:t>Tang Zheling</a:t>
                       </a:r>
-                      <a:endParaRPr lang="en-US" sz="900" dirty="0">
+                      <a:endParaRPr lang="en-US" sz="850" dirty="0">
                         <a:latin typeface="Arial" charset="0"/>
                         <a:ea typeface="Arial" charset="0"/>
                         <a:cs typeface="Arial" charset="0"/>
@@ -8501,7 +8766,7 @@
                         <a:buNone/>
                       </a:pPr>
                       <a:r>
-                        <a:rPr lang="en-US" sz="900" b="1" dirty="0">
+                        <a:rPr lang="en-US" sz="850" b="1" dirty="0">
                           <a:solidFill>
                             <a:srgbClr val="9A6A12"/>
                           </a:solidFill>
@@ -8511,7 +8776,7 @@
                         </a:rPr>
                         <a:t>In progress</a:t>
                       </a:r>
-                      <a:endParaRPr lang="en-US" sz="900" dirty="0">
+                      <a:endParaRPr lang="en-US" sz="850" dirty="0">
                         <a:latin typeface="Arial" charset="0"/>
                         <a:ea typeface="Arial" charset="0"/>
                         <a:cs typeface="Arial" charset="0"/>
@@ -8550,7 +8815,7 @@
                         <a:buNone/>
                       </a:pPr>
                       <a:r>
-                        <a:rPr lang="en-US" sz="900" dirty="0">
+                        <a:rPr lang="en-US" sz="850" dirty="0">
                           <a:solidFill>
                             <a:srgbClr val="1D1B18"/>
                           </a:solidFill>
@@ -8560,7 +8825,7 @@
                         </a:rPr>
                         <a:t>Evaluation set: 50 new held-out requests, written and labelled</a:t>
                       </a:r>
-                      <a:endParaRPr lang="en-US" sz="900" dirty="0">
+                      <a:endParaRPr lang="en-US" sz="850" dirty="0">
                         <a:latin typeface="Arial" charset="0"/>
                         <a:ea typeface="Arial" charset="0"/>
                         <a:cs typeface="Arial" charset="0"/>
@@ -8597,7 +8862,7 @@
                         <a:buNone/>
                       </a:pPr>
                       <a:r>
-                        <a:rPr lang="en-US" sz="900" dirty="0">
+                        <a:rPr lang="en-US" sz="850" dirty="0">
                           <a:solidFill>
                             <a:srgbClr val="4A463F"/>
                           </a:solidFill>
@@ -8607,7 +8872,7 @@
                         </a:rPr>
                         <a:t>Saadhvika and Niyanthri</a:t>
                       </a:r>
-                      <a:endParaRPr lang="en-US" sz="900" dirty="0">
+                      <a:endParaRPr lang="en-US" sz="850" dirty="0">
                         <a:latin typeface="Arial" charset="0"/>
                         <a:ea typeface="Arial" charset="0"/>
                         <a:cs typeface="Arial" charset="0"/>
@@ -8644,7 +8909,7 @@
                         <a:buNone/>
                       </a:pPr>
                       <a:r>
-                        <a:rPr lang="en-US" sz="900" b="1" dirty="0">
+                        <a:rPr lang="en-US" sz="850" b="1" dirty="0">
                           <a:solidFill>
                             <a:srgbClr val="9A6A12"/>
                           </a:solidFill>
@@ -8654,7 +8919,7 @@
                         </a:rPr>
                         <a:t>In progress</a:t>
                       </a:r>
-                      <a:endParaRPr lang="en-US" sz="900" dirty="0">
+                      <a:endParaRPr lang="en-US" sz="850" dirty="0">
                         <a:latin typeface="Arial" charset="0"/>
                         <a:ea typeface="Arial" charset="0"/>
                         <a:cs typeface="Arial" charset="0"/>
@@ -8693,7 +8958,7 @@
                         <a:buNone/>
                       </a:pPr>
                       <a:r>
-                        <a:rPr lang="en-US" sz="900" dirty="0">
+                        <a:rPr lang="en-US" sz="850" dirty="0">
                           <a:solidFill>
                             <a:srgbClr val="1D1B18"/>
                           </a:solidFill>
@@ -8703,7 +8968,7 @@
                         </a:rPr>
                         <a:t>Independent labels for the 30 inbox requests</a:t>
                       </a:r>
-                      <a:endParaRPr lang="en-US" sz="900" dirty="0">
+                      <a:endParaRPr lang="en-US" sz="850" dirty="0">
                         <a:latin typeface="Arial" charset="0"/>
                         <a:ea typeface="Arial" charset="0"/>
                         <a:cs typeface="Arial" charset="0"/>
@@ -8740,7 +9005,7 @@
                         <a:buNone/>
                       </a:pPr>
                       <a:r>
-                        <a:rPr lang="en-US" sz="900" dirty="0">
+                        <a:rPr lang="en-US" sz="850" dirty="0">
                           <a:solidFill>
                             <a:srgbClr val="4A463F"/>
                           </a:solidFill>
@@ -8750,7 +9015,7 @@
                         </a:rPr>
                         <a:t>Saadhvika and Niyanthri</a:t>
                       </a:r>
-                      <a:endParaRPr lang="en-US" sz="900" dirty="0">
+                      <a:endParaRPr lang="en-US" sz="850" dirty="0">
                         <a:latin typeface="Arial" charset="0"/>
                         <a:ea typeface="Arial" charset="0"/>
                         <a:cs typeface="Arial" charset="0"/>
@@ -8787,7 +9052,7 @@
                         <a:buNone/>
                       </a:pPr>
                       <a:r>
-                        <a:rPr lang="en-US" sz="900" b="1" dirty="0">
+                        <a:rPr lang="en-US" sz="850" b="1" dirty="0">
                           <a:solidFill>
                             <a:srgbClr val="9A6A12"/>
                           </a:solidFill>
@@ -8797,7 +9062,7 @@
                         </a:rPr>
                         <a:t>In progress</a:t>
                       </a:r>
-                      <a:endParaRPr lang="en-US" sz="900" dirty="0">
+                      <a:endParaRPr lang="en-US" sz="850" dirty="0">
                         <a:latin typeface="Arial" charset="0"/>
                         <a:ea typeface="Arial" charset="0"/>
                         <a:cs typeface="Arial" charset="0"/>
@@ -8836,7 +9101,7 @@
                         <a:buNone/>
                       </a:pPr>
                       <a:r>
-                        <a:rPr lang="en-US" sz="900" dirty="0">
+                        <a:rPr lang="en-US" sz="850" dirty="0">
                           <a:solidFill>
                             <a:srgbClr val="1D1B18"/>
                           </a:solidFill>
@@ -8846,7 +9111,7 @@
                         </a:rPr>
                         <a:t>Live model run on the full evaluation set (30 inbox + 50 new)</a:t>
                       </a:r>
-                      <a:endParaRPr lang="en-US" sz="900" dirty="0">
+                      <a:endParaRPr lang="en-US" sz="850" dirty="0">
                         <a:latin typeface="Arial" charset="0"/>
                         <a:ea typeface="Arial" charset="0"/>
                         <a:cs typeface="Arial" charset="0"/>
@@ -8883,7 +9148,7 @@
                         <a:buNone/>
                       </a:pPr>
                       <a:r>
-                        <a:rPr lang="en-US" sz="900" dirty="0">
+                        <a:rPr lang="en-US" sz="850" dirty="0">
                           <a:solidFill>
                             <a:srgbClr val="4A463F"/>
                           </a:solidFill>
@@ -8893,7 +9158,7 @@
                         </a:rPr>
                         <a:t>Tang Zheling</a:t>
                       </a:r>
-                      <a:endParaRPr lang="en-US" sz="900" dirty="0">
+                      <a:endParaRPr lang="en-US" sz="850" dirty="0">
                         <a:latin typeface="Arial" charset="0"/>
                         <a:ea typeface="Arial" charset="0"/>
                         <a:cs typeface="Arial" charset="0"/>
@@ -8930,7 +9195,7 @@
                         <a:buNone/>
                       </a:pPr>
                       <a:r>
-                        <a:rPr lang="en-US" sz="900" b="1" dirty="0">
+                        <a:rPr lang="en-US" sz="850" b="1" dirty="0">
                           <a:solidFill>
                             <a:srgbClr val="6B665D"/>
                           </a:solidFill>
@@ -8940,7 +9205,7 @@
                         </a:rPr>
                         <a:t>Planned</a:t>
                       </a:r>
-                      <a:endParaRPr lang="en-US" sz="900" dirty="0">
+                      <a:endParaRPr lang="en-US" sz="850" dirty="0">
                         <a:latin typeface="Arial" charset="0"/>
                         <a:ea typeface="Arial" charset="0"/>
                         <a:cs typeface="Arial" charset="0"/>
@@ -8979,7 +9244,7 @@
                         <a:buNone/>
                       </a:pPr>
                       <a:r>
-                        <a:rPr lang="en-US" sz="900" dirty="0">
+                        <a:rPr lang="en-US" sz="850" dirty="0">
                           <a:solidFill>
                             <a:srgbClr val="1D1B18"/>
                           </a:solidFill>
@@ -8989,7 +9254,7 @@
                         </a:rPr>
                         <a:t>Usability test: two people acting as dispatchers, four tasks</a:t>
                       </a:r>
-                      <a:endParaRPr lang="en-US" sz="900" dirty="0">
+                      <a:endParaRPr lang="en-US" sz="850" dirty="0">
                         <a:latin typeface="Arial" charset="0"/>
                         <a:ea typeface="Arial" charset="0"/>
                         <a:cs typeface="Arial" charset="0"/>
@@ -9026,7 +9291,7 @@
                         <a:buNone/>
                       </a:pPr>
                       <a:r>
-                        <a:rPr lang="en-US" sz="900" dirty="0">
+                        <a:rPr lang="en-US" sz="850" dirty="0">
                           <a:solidFill>
                             <a:srgbClr val="8A2C35"/>
                           </a:solidFill>
@@ -9036,7 +9301,7 @@
                         </a:rPr>
                         <a:t>[TBD]</a:t>
                       </a:r>
-                      <a:endParaRPr lang="en-US" sz="900" dirty="0">
+                      <a:endParaRPr lang="en-US" sz="850" dirty="0">
                         <a:latin typeface="Arial" charset="0"/>
                         <a:ea typeface="Arial" charset="0"/>
                         <a:cs typeface="Arial" charset="0"/>
@@ -9073,7 +9338,7 @@
                         <a:buNone/>
                       </a:pPr>
                       <a:r>
-                        <a:rPr lang="en-US" sz="900" b="1" dirty="0">
+                        <a:rPr lang="en-US" sz="850" b="1" dirty="0">
                           <a:solidFill>
                             <a:srgbClr val="6B665D"/>
                           </a:solidFill>
@@ -9083,7 +9348,7 @@
                         </a:rPr>
                         <a:t>Planned</a:t>
                       </a:r>
-                      <a:endParaRPr lang="en-US" sz="900" dirty="0">
+                      <a:endParaRPr lang="en-US" sz="850" dirty="0">
                         <a:latin typeface="Arial" charset="0"/>
                         <a:ea typeface="Arial" charset="0"/>
                         <a:cs typeface="Arial" charset="0"/>
@@ -9118,7 +9383,7 @@
       </p:graphicFrame>
       <p:sp>
         <p:nvSpPr>
-          <p:cNvPr id="5" name="Text 2"/>
+          <p:cNvPr id="11" name="Text 8"/>
           <p:cNvSpPr txBox="1"/>
           <p:nvPr/>
         </p:nvSpPr>
@@ -9149,7 +9414,7 @@
                 <a:ea typeface="Arial" pitchFamily="34" charset="-122"/>
                 <a:cs typeface="Arial" pitchFamily="34" charset="-120"/>
               </a:rPr>
-              <a:t>6 of 11 done. Code: github.com/JoshuaGloor/dss5105-capstone-project (PR #15 for this sprint, PR #14 for clarification reliability).</a:t>
+              <a:t>Code: github.com/JoshuaGloor/dss5105-capstone-project (PRs #15 and #18 for this sprint, PR #14 for clarification reliability).</a:t>
             </a:r>
             <a:endParaRPr lang="en-US" sz="700" dirty="0"/>
           </a:p>
@@ -9252,6 +9517,17 @@
             <a:pPr indent="0" marL="0">
               <a:buNone/>
             </a:pPr>
+            <a:r>
+              <a:rPr lang="en-US" sz="850" b="1" spc="300" kern="0" dirty="0">
+                <a:solidFill>
+                  <a:srgbClr val="1D1B18"/>
+                </a:solidFill>
+                <a:latin typeface="Arial" pitchFamily="34" charset="0"/>
+                <a:ea typeface="Arial" pitchFamily="34" charset="-122"/>
+                <a:cs typeface="Arial" pitchFamily="34" charset="-120"/>
+              </a:rPr>
+              <a:t>06   </a:t>
+            </a:r>
             <a:r>
               <a:rPr lang="en-US" sz="850" b="1" spc="300" kern="0" dirty="0">
                 <a:solidFill>
@@ -11076,6 +11352,17 @@
             <a:pPr indent="0" marL="0">
               <a:buNone/>
             </a:pPr>
+            <a:r>
+              <a:rPr lang="en-US" sz="850" b="1" spc="300" kern="0" dirty="0">
+                <a:solidFill>
+                  <a:srgbClr val="F4EFE6"/>
+                </a:solidFill>
+                <a:latin typeface="Arial" pitchFamily="34" charset="0"/>
+                <a:ea typeface="Arial" pitchFamily="34" charset="-122"/>
+                <a:cs typeface="Arial" pitchFamily="34" charset="-120"/>
+              </a:rPr>
+              <a:t>07   </a:t>
+            </a:r>
             <a:r>
               <a:rPr lang="en-US" sz="850" b="1" spc="300" kern="0" dirty="0">
                 <a:solidFill>

</xml_diff>

<commit_message>
Hand-drawn architecture diagram; key choices get their own slide
</commit_message>
<xml_diff>
--- a/docs/slides/Presentation_Group11_Sprint2.pptx
+++ b/docs/slides/Presentation_Group11_Sprint2.pptx
@@ -13,9 +13,10 @@
     <p:sldId id="261" r:id="rId7"/>
     <p:sldId id="262" r:id="rId8"/>
     <p:sldId id="263" r:id="rId9"/>
+    <p:sldId id="264" r:id="rId10"/>
   </p:sldIdLst>
   <p:notesMasterIdLst>
-    <p:notesMasterId r:id="rId10"/>
+    <p:notesMasterId r:id="rId11"/>
   </p:notesMasterIdLst>
   <p:sldSz cx="9144000" cy="5143500"/>
   <p:notesSz cx="5143500" cy="9144000"/>
@@ -692,7 +693,7 @@
           <a:p>
             <a:r>
               <a:rPr lang="en-US" dirty="0"/>
-              <a:t>SLIDE 3 - The user journey (0:45-1:08)  Zepeng
+              <a:t>SLIDE 3 - The user journey (0:45-1:08)  Charles
 "We designed the journey for the floor. The dispatcher holds the mic and says the order. The desk answers
 on screen and out loud: the best workshop, when it arrives, and why. 'Book it' opens a sheet, and
 a slide confirms. It offers to remember the constraint, and uses it on the next order."</a:t>
@@ -783,14 +784,12 @@
           <a:p>
             <a:r>
               <a:rPr lang="en-US" dirty="0"/>
-              <a:t>SLIDE 4 - Architecture and key choices (1:08-1:53)  Zepeng
-"This diagram is what we built. Speech becomes text in the browser: free and live, instead of a
-server speech model. Python handles commands like 'book it' without a model. Everything else is
-one structured-output call, not a ReAct agent, because every request needs the same checks in
-order, and every field must quote the message. Deterministic tools then look up the order, apply
-remembered rules, check eligibility and rank. Replies are
-templates, so the model never does arithmetic. Memory is exact rules in SQLite, not a vector
-store, because a rule must match exactly. And only a slide books, never a spoken yes."</a:t>
+              <a:t>SLIDE 4 - Architecture (1:08-1:35)  Charles
+"This is what we built. Speech becomes text in the browser, and Python answers commands like
+'book it' itself. Everything else is one structured-output call, and every field must quote the
+message. Deterministic tools then look up the order, apply remembered rules, check eligibility
+and rank, so the model never does arithmetic. A slide confirms, and SQLite keeps the booking and
+the rule."</a:t>
             </a:r>
             <a:endParaRPr lang="en-US" dirty="0"/>
           </a:p>
@@ -878,11 +877,10 @@
           <a:p>
             <a:r>
               <a:rPr lang="en-US" dirty="0"/>
-              <a:t>SLIDE 5 - Progress (1:53-2:13)  Saadhvika
-"Every feature has an owner. Six of eleven are done: the voice assistant, memory, capacity
-questions, the four-objective scorer, the desk redesign and the AWS deployment. In progress:
-clarification fixes, and our evaluation set. Planned: Lynn's live run on the full set, and a
-usability test."</a:t>
+              <a:t>SLIDE 5 - Key choices (1:35-1:53)  Charles
+"We chose a fixed workflow over a ReAct agent, because every request needs the same checks;
+exact lookups over embeddings, so we never fetch the wrong order; exact rules in SQLite over a
+vector store; and a slide, never a spoken yes."</a:t>
             </a:r>
             <a:endParaRPr lang="en-US" dirty="0"/>
           </a:p>
@@ -970,14 +968,11 @@
           <a:p>
             <a:r>
               <a:rPr lang="en-US" dirty="0"/>
-              <a:t>SLIDE 6 - Validation plan (2:13-2:55)  Niyanthri
-"We measure late batches and late days, our primary objective, in the course simulator, with and
-without a closure. Baselines are random, biggest capacity and cheapest, plus earliest
-finish. The minimum is to beat all three
-baselines, and handle all 30 inbox requests. Today: 1.4 percent late against 1.7, and 68 percent
-fewer late days. For language, the 30 inbox requests plus 50 new held-out ones, labelled
-separately, then agreed. Hard cases: an impossible date, a workshop that can't take it, and a
-misheard order. We give options, refuse with a reason, and read the order back."</a:t>
+              <a:t>SLIDE 6 - Progress (1:53-2:13)  Saadhvika
+"Every feature has an owner. Six of eleven are done: the voice assistant, memory, capacity
+questions, the four-objective scorer, the desk redesign and the AWS deployment. In progress:
+clarification fixes, and our evaluation set. Planned: Lynn's live run on the full set, and a
+usability test."</a:t>
             </a:r>
             <a:endParaRPr lang="en-US" dirty="0"/>
           </a:p>
@@ -1065,34 +1060,14 @@
           <a:p>
             <a:r>
               <a:rPr lang="en-US" dirty="0"/>
-              <a:t>SLIDE 7 - Demo (2:55-4:50)  Zepeng, then Lynn
-Take A ends here:
-  Zepeng: "Now the demo."
-Take B, in the app. Times are from the start of Take B. Speak only when the app is quiet.
-[0:00] Zepeng: "I'm Charles, playing the dispatcher. The rings show how busy each workshop is,
-       and OldMill is grey because it's suspended."
-[0:08] Hold the mic and say: "ORD-109, 500 vests for Harbor Knits, due April 13. Keep it away
-       from BudgetWorks."
-       Let the answer play: "GiantWeave can deliver order 109 by Thursday 9 April, 3.71 days
-       early. Cost 550, defect risk 6.0%. Say book it, or tap book, to confirm."
-[0:30] Tap "Compare 4 workshops", then "Can't take it", then close them. (optional)
-       Zepeng: "Here are the other options, and why the rest can't take it. BudgetWorks is out
-       because I asked."
-[0:40] Hold the mic and say: "Book it." The sheet opens.
-       Zepeng: "Nothing is saved until I slide." Slide to confirm.
-[0:52] On the receipt, tap "Remember".
-       Zepeng: "And it offers to remember that rule."
-[0:58] Hold the mic and say: "ORD-081 for Harbor Knits needs to go out, due April 20."
-       Let the answer play, then point at the memory note on the card.
-       Zepeng: "Same customer, so the rule is applied, and the card says it came from memory."
-[1:22] Lynn: "Now a hard case, straight from the inbox."
-       Zepeng holds the mic and says: "QuickStitch for the scarves on ORD-103?"
-       Let the answer play: QuickStitch cannot make scarves, no workshop meets 4 April, and the
-       best alternative is 13.44 days late.
-[1:45] Lynn: "It refuses, gives the earliest option and a two-shop split, and books nothing."
-[1:52] Open "Behind the answer". (optional)
-       Lynn: "This panel shows what the model read, with quotes, and what Python computed."
-[1:59] Stop recording.</a:t>
+              <a:t>SLIDE 7 - Validation plan (2:13-2:55)  Niyanthri
+"We measure late batches and late days, our primary objective, in the course simulator, with and
+without a closure. Baselines are random, biggest capacity and cheapest, plus earliest
+finish. The minimum is to beat all three
+baselines, and handle all 30 inbox requests. Today: 1.4 percent late against 1.7, and 68 percent
+fewer late days. For language, the 30 inbox requests plus 50 new held-out ones, labelled
+separately, then agreed. Hard cases: an impossible date, a workshop that can't take it, and a
+misheard order. We give options, refuse with a reason, and read the order back."</a:t>
             </a:r>
             <a:endParaRPr lang="en-US" dirty="0"/>
           </a:p>
@@ -1180,11 +1155,126 @@
           <a:p>
             <a:r>
               <a:rPr lang="en-US" dirty="0"/>
-              <a:t>SLIDE 8 - Thank you (not recorded)
+              <a:t>SLIDE 8 - Demo (2:55-4:50)  Charles, then Lynn
+Take A ends here:
+  Charles: "Now the demo."
+Take B, in the app. Times are from the start of Take B. Speak only when the app is quiet.
+[0:00] Charles: "I'm Charles, playing the dispatcher. The rings show how busy each workshop is,
+       and OldMill is grey because it's suspended."
+[0:08] Hold the mic and say: "ORD-109, 500 vests for Harbor Knits, due April 13. Keep it away
+       from BudgetWorks."
+       Let the answer play: "GiantWeave can deliver order 109 by Thursday 9 April, 3.71 days
+       early. Cost 550, defect risk 6.0%. Say book it, or tap book, to confirm."
+[0:30] Tap "Compare 4 workshops", then "Can't take it", then close them. (optional)
+       Charles: "Here are the other options, and why the rest can't take it. BudgetWorks is out
+       because I asked."
+[0:40] Hold the mic and say: "Book it." The sheet opens.
+       Charles: "Nothing is saved until I slide." Slide to confirm.
+[0:52] On the receipt, tap "Remember".
+       Charles: "And it offers to remember that rule."
+[0:58] Hold the mic and say: "ORD-081 for Harbor Knits needs to go out, due April 20."
+       Let the answer play, then point at the memory note on the card.
+       Charles: "Same customer, so the rule is applied, and the card says it came from memory."
+[1:22] Lynn: "Now a hard case, straight from the inbox."
+       Charles holds the mic and says: "QuickStitch for the scarves on ORD-103?"
+       Let the answer play: QuickStitch cannot make scarves, no workshop meets 4 April, and the
+       best alternative is 13.44 days late.
+[1:45] Lynn: "It refuses, gives the earliest option and a two-shop split, and books nothing."
+[1:52] Open "Behind the answer". (optional)
+       Lynn: "This panel shows what the model read, with quotes, and what Python computed."
+[1:59] Stop recording.</a:t>
+            </a:r>
+            <a:endParaRPr lang="en-US" dirty="0"/>
+          </a:p>
+        </p:txBody>
+      </p:sp>
+      <p:sp>
+        <p:nvSpPr>
+          <p:cNvPr id="4" name="Slide Number Placeholder 3"/>
+          <p:cNvSpPr>
+            <a:spLocks noGrp="1"/>
+          </p:cNvSpPr>
+          <p:nvPr>
+            <p:ph type="sldNum" sz="quarter" idx="10"/>
+          </p:nvPr>
+        </p:nvSpPr>
+        <p:spPr/>
+        <p:txBody>
+          <a:bodyPr/>
+          <a:lstStyle/>
+          <a:p>
+            <a:fld id="{F7021451-1387-4CA6-816F-3879F97B5CBC}" type="slidenum">
+              <a:rPr lang="en-US"/>
+              <a:t>8</a:t>
+            </a:fld>
+            <a:endParaRPr lang="en-US"/>
+          </a:p>
+        </p:txBody>
+      </p:sp>
+    </p:spTree>
+    <p:extLst>
+      <p:ext uri="{BB962C8B-B14F-4D97-AF65-F5344CB8AC3E}">
+        <p14:creationId xmlns:p14="http://schemas.microsoft.com/office/powerpoint/2010/main" val="1024086991"/>
+      </p:ext>
+    </p:extLst>
+  </p:cSld>
+  <p:clrMapOvr>
+    <a:masterClrMapping/>
+  </p:clrMapOvr>
+</p:notes>
+</file>
+
+<file path=ppt/notesSlides/notesSlide9.xml><?xml version="1.0" encoding="utf-8"?>
+<p:notes xmlns:a="http://schemas.openxmlformats.org/drawingml/2006/main" xmlns:r="http://schemas.openxmlformats.org/officeDocument/2006/relationships" xmlns:p="http://schemas.openxmlformats.org/presentationml/2006/main">
+  <p:cSld>
+    <p:spTree>
+      <p:nvGrpSpPr>
+        <p:cNvPr id="1" name=""/>
+        <p:cNvGrpSpPr/>
+        <p:nvPr/>
+      </p:nvGrpSpPr>
+      <p:grpSpPr>
+        <a:xfrm>
+          <a:off x="0" y="0"/>
+          <a:ext cx="0" cy="0"/>
+          <a:chOff x="0" y="0"/>
+          <a:chExt cx="0" cy="0"/>
+        </a:xfrm>
+      </p:grpSpPr>
+      <p:sp>
+        <p:nvSpPr>
+          <p:cNvPr id="2" name="Slide Image Placeholder 1"/>
+          <p:cNvSpPr>
+            <a:spLocks noGrp="1" noRot="1" noChangeAspect="1"/>
+          </p:cNvSpPr>
+          <p:nvPr>
+            <p:ph type="sldImg"/>
+          </p:nvPr>
+        </p:nvSpPr>
+        <p:spPr/>
+      </p:sp>
+      <p:sp>
+        <p:nvSpPr>
+          <p:cNvPr id="3" name="Notes Placeholder 2"/>
+          <p:cNvSpPr>
+            <a:spLocks noGrp="1"/>
+          </p:cNvSpPr>
+          <p:nvPr>
+            <p:ph type="body" idx="1"/>
+          </p:nvPr>
+        </p:nvSpPr>
+        <p:spPr/>
+        <p:txBody>
+          <a:bodyPr/>
+          <a:lstStyle/>
+          <a:p>
+            <a:r>
+              <a:rPr lang="en-US" dirty="0"/>
+              <a:t>SLIDE 9 - Thank you (not recorded)
 The video ends on the demo, so this slide stays in the deck for the Q&amp;A only.
 AFTER RECORDING
 - Upload the .mp4 to YouTube as unlisted, then open the link in a private window.
-- Put the link on slides 1 and 8:
+- Put the link on slides 1 and 9:
     DEMO_LINK=https://youtu.be/... node scripts/build_sprint2_deck.mjs
   then export the PDF again, and open the GitHub link in a private window too.
 - One member uploads the .mp4 and the .pptx (or .pdf) to Canvas by 15:00.
@@ -1236,7 +1326,7 @@
           <a:p>
             <a:fld id="{F7021451-1387-4CA6-816F-3879F97B5CBC}" type="slidenum">
               <a:rPr lang="en-US"/>
-              <a:t>8</a:t>
+              <a:t>9</a:t>
             </a:fld>
             <a:endParaRPr lang="en-US"/>
           </a:p>
@@ -4999,7 +5089,7 @@
                 <a:ea typeface="Arial" pitchFamily="34" charset="-122"/>
                 <a:cs typeface="Arial" pitchFamily="34" charset="-120"/>
               </a:rPr>
-              <a:t>ARCHITECTURE AS BUILT  /  KEY CHOICES</a:t>
+              <a:t>ARCHITECTURE AS BUILT</a:t>
             </a:r>
             <a:endParaRPr lang="en-US" sz="850" dirty="0"/>
           </a:p>
@@ -5044,41 +5134,113 @@
           </a:p>
         </p:txBody>
       </p:sp>
-      <p:sp>
-        <p:nvSpPr>
-          <p:cNvPr id="4" name="Shape 2"/>
-          <p:cNvSpPr/>
+      <p:pic>
+        <p:nvPicPr>
+          <p:cNvPr id="4" name="Image 0" descr="Architecture: phone app and router, LLM intake and quote check, deterministic tools, reply card, slide to confirm, plan ledger, memory store and course data, with the simulator and inbox evaluation">    </p:cNvPr>
+          <p:cNvPicPr>
+            <a:picLocks noChangeAspect="1"/>
+          </p:cNvPicPr>
           <p:nvPr/>
-        </p:nvSpPr>
-        <p:spPr>
-          <a:xfrm>
-            <a:off x="548640" y="1298448"/>
-            <a:ext cx="1216152" cy="1207008"/>
-          </a:xfrm>
-          <a:prstGeom prst="rect">
-            <a:avLst/>
-          </a:prstGeom>
-          <a:solidFill>
-            <a:srgbClr val="FFFFFF"/>
-          </a:solidFill>
-          <a:ln w="9525">
-            <a:solidFill>
-              <a:srgbClr val="E4DDD0"/>
-            </a:solidFill>
-            <a:prstDash val="solid"/>
-          </a:ln>
-        </p:spPr>
-      </p:sp>
-      <p:sp>
-        <p:nvSpPr>
-          <p:cNvPr id="5" name="Text 3"/>
+        </p:nvPicPr>
+        <p:blipFill>
+          <a:blip r:embed="rId1"/>
+          <a:stretch>
+            <a:fillRect/>
+          </a:stretch>
+        </p:blipFill>
+        <p:spPr>
+          <a:xfrm>
+            <a:off x="592658" y="1097280"/>
+            <a:ext cx="7958683" cy="3611880"/>
+          </a:xfrm>
+          <a:prstGeom prst="rect">
+            <a:avLst/>
+          </a:prstGeom>
+        </p:spPr>
+      </p:pic>
+      <p:sp>
+        <p:nvSpPr>
+          <p:cNvPr id="25" name="Slide Number Placeholder 0"/>
+          <p:cNvSpPr>
+            <a:spLocks noGrp="1"/>
+          </p:cNvSpPr>
+          <p:nvPr>
+            <p:ph type="sldNum" sz="quarter" idx="4294967295"/>
+          </p:nvPr>
+        </p:nvSpPr>
+        <p:spPr>
+          <a:xfrm>
+            <a:off x="8138160" y="4800600"/>
+            <a:ext cx="457200" cy="201168"/>
+          </a:xfrm>
+          <a:prstGeom prst="rect">
+            <a:avLst/>
+          </a:prstGeom>
+          <a:extLst>
+            <a:ext uri="{C572A759-6A51-4108-AA02-DFA0A04FC94B}">
+              <ma14:wrappingTextBoxFlag xmlns:ma14="http://schemas.microsoft.com/office/mac/drawingml/2011/main" val="0"/>
+            </a:ext>
+          </a:extLst>
+        </p:spPr>
+        <p:txBody>
+          <a:bodyPr/>
+          <a:lstStyle>
+            <a:lvl1pPr>
+              <a:defRPr sz="700">
+                <a:solidFill>
+                  <a:srgbClr val="6B665D"/>
+                </a:solidFill>
+                <a:latin typeface="Arial"/>
+                <a:ea typeface="Arial"/>
+                <a:cs typeface="Arial"/>
+              </a:defRPr>
+            </a:lvl1pPr>
+          </a:lstStyle>
+          <a:p>
+            <a:pPr algn="r"/>
+            <a:fld id="{F7021451-1387-4CA6-816F-3879F97B5CBC}" type="slidenum">
+              <a:rPr b="0" lang="en-US"/>
+              <a:t>4</a:t>
+            </a:fld>
+            <a:endParaRPr lang="en-US"/>
+          </a:p>
+        </p:txBody>
+      </p:sp>
+    </p:spTree>
+  </p:cSld>
+  <p:clrMapOvr>
+    <a:masterClrMapping/>
+  </p:clrMapOvr>
+</p:sld>
+</file>
+
+<file path=ppt/slides/slide5.xml><?xml version="1.0" encoding="utf-8"?>
+<p:sld xmlns:a="http://schemas.openxmlformats.org/drawingml/2006/main" xmlns:r="http://schemas.openxmlformats.org/officeDocument/2006/relationships" xmlns:p="http://schemas.openxmlformats.org/presentationml/2006/main">
+  <p:cSld name="Slide 5">
+    <p:spTree>
+      <p:nvGrpSpPr>
+        <p:cNvPr id="1" name=""/>
+        <p:cNvGrpSpPr/>
+        <p:nvPr/>
+      </p:nvGrpSpPr>
+      <p:grpSpPr>
+        <a:xfrm>
+          <a:off x="0" y="0"/>
+          <a:ext cx="0" cy="0"/>
+          <a:chOff x="0" y="0"/>
+          <a:chExt cx="0" cy="0"/>
+        </a:xfrm>
+      </p:grpSpPr>
+      <p:sp>
+        <p:nvSpPr>
+          <p:cNvPr id="2" name="Text 0"/>
           <p:cNvSpPr txBox="1"/>
           <p:nvPr/>
         </p:nvSpPr>
         <p:spPr>
           <a:xfrm>
-            <a:off x="630936" y="1371600"/>
-            <a:ext cx="1051560" cy="146304"/>
+            <a:off x="548640" y="310896"/>
+            <a:ext cx="8046720" cy="201168"/>
           </a:xfrm>
           <a:prstGeom prst="rect">
             <a:avLst/>
@@ -5094,30 +5256,41 @@
               <a:buNone/>
             </a:pPr>
             <a:r>
-              <a:rPr lang="en-US" sz="700" b="1" spc="120" kern="0" dirty="0">
-                <a:solidFill>
-                  <a:srgbClr val="7D5E30"/>
+              <a:rPr lang="en-US" sz="850" b="1" spc="300" kern="0" dirty="0">
+                <a:solidFill>
+                  <a:srgbClr val="1D1B18"/>
                 </a:solidFill>
                 <a:latin typeface="Arial" pitchFamily="34" charset="0"/>
                 <a:ea typeface="Arial" pitchFamily="34" charset="-122"/>
                 <a:cs typeface="Arial" pitchFamily="34" charset="-120"/>
               </a:rPr>
-              <a:t>PHONE APP</a:t>
-            </a:r>
-            <a:endParaRPr lang="en-US" sz="700" dirty="0"/>
-          </a:p>
-        </p:txBody>
-      </p:sp>
-      <p:sp>
-        <p:nvSpPr>
-          <p:cNvPr id="6" name="Text 4"/>
+              <a:t>05   </a:t>
+            </a:r>
+            <a:r>
+              <a:rPr lang="en-US" sz="850" b="1" spc="300" kern="0" dirty="0">
+                <a:solidFill>
+                  <a:srgbClr val="7D5E30"/>
+                </a:solidFill>
+                <a:latin typeface="Arial" pitchFamily="34" charset="0"/>
+                <a:ea typeface="Arial" pitchFamily="34" charset="-122"/>
+                <a:cs typeface="Arial" pitchFamily="34" charset="-120"/>
+              </a:rPr>
+              <a:t>KEY CHOICES</a:t>
+            </a:r>
+            <a:endParaRPr lang="en-US" sz="850" dirty="0"/>
+          </a:p>
+        </p:txBody>
+      </p:sp>
+      <p:sp>
+        <p:nvSpPr>
+          <p:cNvPr id="3" name="Text 1"/>
           <p:cNvSpPr txBox="1"/>
           <p:nvPr/>
         </p:nvSpPr>
         <p:spPr>
           <a:xfrm>
-            <a:off x="630936" y="1527048"/>
-            <a:ext cx="1051560" cy="182880"/>
+            <a:off x="548640" y="530352"/>
+            <a:ext cx="8046720" cy="548640"/>
           </a:xfrm>
           <a:prstGeom prst="rect">
             <a:avLst/>
@@ -5126,14 +5299,14 @@
           <a:ln/>
         </p:spPr>
         <p:txBody>
-          <a:bodyPr wrap="square" lIns="0" tIns="0" rIns="0" bIns="0" rtlCol="0" anchor="t"/>
+          <a:bodyPr wrap="square" lIns="0" tIns="0" rIns="0" bIns="0" rtlCol="0" anchor="ctr"/>
           <a:lstStyle/>
           <a:p>
             <a:pPr indent="0" marL="0">
               <a:buNone/>
             </a:pPr>
             <a:r>
-              <a:rPr lang="en-US" sz="1050" dirty="0">
+              <a:rPr lang="en-US" sz="2300" dirty="0">
                 <a:solidFill>
                   <a:srgbClr val="1D1B18"/>
                 </a:solidFill>
@@ -5141,1230 +5314,15 @@
                 <a:ea typeface="Georgia" pitchFamily="34" charset="-122"/>
                 <a:cs typeface="Georgia" pitchFamily="34" charset="-120"/>
               </a:rPr>
-              <a:t>Browser</a:t>
-            </a:r>
-            <a:endParaRPr lang="en-US" sz="1050" dirty="0"/>
-          </a:p>
-        </p:txBody>
-      </p:sp>
-      <p:sp>
-        <p:nvSpPr>
-          <p:cNvPr id="7" name="Text 5"/>
-          <p:cNvSpPr txBox="1"/>
-          <p:nvPr/>
-        </p:nvSpPr>
-        <p:spPr>
-          <a:xfrm>
-            <a:off x="630936" y="1737360"/>
-            <a:ext cx="1051560" cy="548640"/>
-          </a:xfrm>
-          <a:prstGeom prst="rect">
-            <a:avLst/>
-          </a:prstGeom>
-          <a:noFill/>
-          <a:ln/>
-        </p:spPr>
-        <p:txBody>
-          <a:bodyPr wrap="square" lIns="0" tIns="0" rIns="0" bIns="0" rtlCol="0" anchor="t"/>
-          <a:lstStyle/>
-          <a:p>
-            <a:pPr indent="0" marL="0">
-              <a:buNone/>
-            </a:pPr>
-            <a:r>
-              <a:rPr lang="en-US" sz="750" dirty="0">
-                <a:solidFill>
-                  <a:srgbClr val="4A463F"/>
-                </a:solidFill>
-                <a:latin typeface="Arial" pitchFamily="34" charset="0"/>
-                <a:ea typeface="Arial" pitchFamily="34" charset="-122"/>
-                <a:cs typeface="Arial" pitchFamily="34" charset="-120"/>
-              </a:rPr>
-              <a:t>Speech to text, cards, voice, slide to book</a:t>
-            </a:r>
-            <a:endParaRPr lang="en-US" sz="750" dirty="0"/>
-          </a:p>
-        </p:txBody>
-      </p:sp>
-      <p:sp>
-        <p:nvSpPr>
-          <p:cNvPr id="8" name="Text 6"/>
-          <p:cNvSpPr txBox="1"/>
-          <p:nvPr/>
-        </p:nvSpPr>
-        <p:spPr>
-          <a:xfrm>
-            <a:off x="630936" y="2231136"/>
-            <a:ext cx="1051560" cy="237744"/>
-          </a:xfrm>
-          <a:prstGeom prst="rect">
-            <a:avLst/>
-          </a:prstGeom>
-          <a:noFill/>
-          <a:ln/>
-        </p:spPr>
-        <p:txBody>
-          <a:bodyPr wrap="square" lIns="0" tIns="0" rIns="0" bIns="0" rtlCol="0" anchor="b"/>
-          <a:lstStyle/>
-          <a:p>
-            <a:pPr indent="0" marL="0">
-              <a:buNone/>
-            </a:pPr>
-            <a:r>
-              <a:rPr lang="en-US" sz="650" dirty="0">
-                <a:solidFill>
-                  <a:srgbClr val="7D5E30"/>
-                </a:solidFill>
-                <a:latin typeface="Courier New" pitchFamily="34" charset="0"/>
-                <a:ea typeface="Courier New" pitchFamily="34" charset="-122"/>
-                <a:cs typeface="Courier New" pitchFamily="34" charset="-120"/>
-              </a:rPr>
-              <a:t>assets/assistant</a:t>
-            </a:r>
-            <a:endParaRPr lang="en-US" sz="650" dirty="0"/>
-          </a:p>
-        </p:txBody>
-      </p:sp>
-      <p:sp>
-        <p:nvSpPr>
-          <p:cNvPr id="9" name="Shape 7"/>
-          <p:cNvSpPr/>
-          <p:nvPr/>
-        </p:nvSpPr>
-        <p:spPr>
-          <a:xfrm>
-            <a:off x="1783080" y="1901952"/>
-            <a:ext cx="113386" cy="0"/>
-          </a:xfrm>
-          <a:prstGeom prst="line">
-            <a:avLst/>
-          </a:prstGeom>
-          <a:noFill/>
-          <a:ln w="12700">
-            <a:solidFill>
-              <a:srgbClr val="1D1B18"/>
-            </a:solidFill>
-            <a:prstDash val="solid"/>
-            <a:tailEnd type="triangle"/>
-          </a:ln>
-        </p:spPr>
-      </p:sp>
-      <p:sp>
-        <p:nvSpPr>
-          <p:cNvPr id="10" name="Shape 8"/>
-          <p:cNvSpPr/>
-          <p:nvPr/>
-        </p:nvSpPr>
-        <p:spPr>
-          <a:xfrm>
-            <a:off x="1914754" y="1298448"/>
-            <a:ext cx="1216152" cy="1207008"/>
-          </a:xfrm>
-          <a:prstGeom prst="rect">
-            <a:avLst/>
-          </a:prstGeom>
-          <a:solidFill>
-            <a:srgbClr val="FFFFFF"/>
-          </a:solidFill>
-          <a:ln w="9525">
-            <a:solidFill>
-              <a:srgbClr val="E4DDD0"/>
-            </a:solidFill>
-            <a:prstDash val="solid"/>
-          </a:ln>
-        </p:spPr>
-      </p:sp>
-      <p:sp>
-        <p:nvSpPr>
-          <p:cNvPr id="11" name="Text 9"/>
-          <p:cNvSpPr txBox="1"/>
-          <p:nvPr/>
-        </p:nvSpPr>
-        <p:spPr>
-          <a:xfrm>
-            <a:off x="1997050" y="1371600"/>
-            <a:ext cx="1051560" cy="146304"/>
-          </a:xfrm>
-          <a:prstGeom prst="rect">
-            <a:avLst/>
-          </a:prstGeom>
-          <a:noFill/>
-          <a:ln/>
-        </p:spPr>
-        <p:txBody>
-          <a:bodyPr wrap="square" lIns="0" tIns="0" rIns="0" bIns="0" rtlCol="0" anchor="t"/>
-          <a:lstStyle/>
-          <a:p>
-            <a:pPr indent="0" marL="0">
-              <a:buNone/>
-            </a:pPr>
-            <a:r>
-              <a:rPr lang="en-US" sz="700" b="1" spc="120" kern="0" dirty="0">
-                <a:solidFill>
-                  <a:srgbClr val="7D5E30"/>
-                </a:solidFill>
-                <a:latin typeface="Arial" pitchFamily="34" charset="0"/>
-                <a:ea typeface="Arial" pitchFamily="34" charset="-122"/>
-                <a:cs typeface="Arial" pitchFamily="34" charset="-120"/>
-              </a:rPr>
-              <a:t>ROUTER</a:t>
-            </a:r>
-            <a:endParaRPr lang="en-US" sz="700" dirty="0"/>
-          </a:p>
-        </p:txBody>
-      </p:sp>
-      <p:sp>
-        <p:nvSpPr>
-          <p:cNvPr id="12" name="Text 10"/>
-          <p:cNvSpPr txBox="1"/>
-          <p:nvPr/>
-        </p:nvSpPr>
-        <p:spPr>
-          <a:xfrm>
-            <a:off x="1997050" y="1527048"/>
-            <a:ext cx="1051560" cy="182880"/>
-          </a:xfrm>
-          <a:prstGeom prst="rect">
-            <a:avLst/>
-          </a:prstGeom>
-          <a:noFill/>
-          <a:ln/>
-        </p:spPr>
-        <p:txBody>
-          <a:bodyPr wrap="square" lIns="0" tIns="0" rIns="0" bIns="0" rtlCol="0" anchor="t"/>
-          <a:lstStyle/>
-          <a:p>
-            <a:pPr indent="0" marL="0">
-              <a:buNone/>
-            </a:pPr>
-            <a:r>
-              <a:rPr lang="en-US" sz="1050" dirty="0">
-                <a:solidFill>
-                  <a:srgbClr val="1D1B18"/>
-                </a:solidFill>
-                <a:latin typeface="Georgia" pitchFamily="34" charset="0"/>
-                <a:ea typeface="Georgia" pitchFamily="34" charset="-122"/>
-                <a:cs typeface="Georgia" pitchFamily="34" charset="-120"/>
-              </a:rPr>
-              <a:t>Python</a:t>
-            </a:r>
-            <a:endParaRPr lang="en-US" sz="1050" dirty="0"/>
-          </a:p>
-        </p:txBody>
-      </p:sp>
-      <p:sp>
-        <p:nvSpPr>
-          <p:cNvPr id="13" name="Text 11"/>
-          <p:cNvSpPr txBox="1"/>
-          <p:nvPr/>
-        </p:nvSpPr>
-        <p:spPr>
-          <a:xfrm>
-            <a:off x="1997050" y="1737360"/>
-            <a:ext cx="1051560" cy="548640"/>
-          </a:xfrm>
-          <a:prstGeom prst="rect">
-            <a:avLst/>
-          </a:prstGeom>
-          <a:noFill/>
-          <a:ln/>
-        </p:spPr>
-        <p:txBody>
-          <a:bodyPr wrap="square" lIns="0" tIns="0" rIns="0" bIns="0" rtlCol="0" anchor="t"/>
-          <a:lstStyle/>
-          <a:p>
-            <a:pPr indent="0" marL="0">
-              <a:buNone/>
-            </a:pPr>
-            <a:r>
-              <a:rPr lang="en-US" sz="750" dirty="0">
-                <a:solidFill>
-                  <a:srgbClr val="4A463F"/>
-                </a:solidFill>
-                <a:latin typeface="Arial" pitchFamily="34" charset="0"/>
-                <a:ea typeface="Arial" pitchFamily="34" charset="-122"/>
-                <a:cs typeface="Arial" pitchFamily="34" charset="-120"/>
-              </a:rPr>
-              <a:t>"book it", memory and workshop questions: no model</a:t>
-            </a:r>
-            <a:endParaRPr lang="en-US" sz="750" dirty="0"/>
-          </a:p>
-        </p:txBody>
-      </p:sp>
-      <p:sp>
-        <p:nvSpPr>
-          <p:cNvPr id="14" name="Text 12"/>
-          <p:cNvSpPr txBox="1"/>
-          <p:nvPr/>
-        </p:nvSpPr>
-        <p:spPr>
-          <a:xfrm>
-            <a:off x="1997050" y="2231136"/>
-            <a:ext cx="1051560" cy="237744"/>
-          </a:xfrm>
-          <a:prstGeom prst="rect">
-            <a:avLst/>
-          </a:prstGeom>
-          <a:noFill/>
-          <a:ln/>
-        </p:spPr>
-        <p:txBody>
-          <a:bodyPr wrap="square" lIns="0" tIns="0" rIns="0" bIns="0" rtlCol="0" anchor="b"/>
-          <a:lstStyle/>
-          <a:p>
-            <a:pPr indent="0" marL="0">
-              <a:buNone/>
-            </a:pPr>
-            <a:r>
-              <a:rPr lang="en-US" sz="650" dirty="0">
-                <a:solidFill>
-                  <a:srgbClr val="7D5E30"/>
-                </a:solidFill>
-                <a:latin typeface="Courier New" pitchFamily="34" charset="0"/>
-                <a:ea typeface="Courier New" pitchFamily="34" charset="-122"/>
-                <a:cs typeface="Courier New" pitchFamily="34" charset="-120"/>
-              </a:rPr>
-              <a:t>assistant.py</a:t>
-            </a:r>
-            <a:endParaRPr lang="en-US" sz="650" dirty="0"/>
-          </a:p>
-        </p:txBody>
-      </p:sp>
-      <p:sp>
-        <p:nvSpPr>
-          <p:cNvPr id="15" name="Shape 13"/>
-          <p:cNvSpPr/>
-          <p:nvPr/>
-        </p:nvSpPr>
-        <p:spPr>
-          <a:xfrm>
-            <a:off x="3149194" y="1901952"/>
-            <a:ext cx="113386" cy="0"/>
-          </a:xfrm>
-          <a:prstGeom prst="line">
-            <a:avLst/>
-          </a:prstGeom>
-          <a:noFill/>
-          <a:ln w="12700">
-            <a:solidFill>
-              <a:srgbClr val="1D1B18"/>
-            </a:solidFill>
-            <a:prstDash val="solid"/>
-            <a:tailEnd type="triangle"/>
-          </a:ln>
-        </p:spPr>
-      </p:sp>
-      <p:sp>
-        <p:nvSpPr>
-          <p:cNvPr id="16" name="Shape 14"/>
-          <p:cNvSpPr/>
-          <p:nvPr/>
-        </p:nvSpPr>
-        <p:spPr>
-          <a:xfrm>
-            <a:off x="3280867" y="1298448"/>
-            <a:ext cx="1216152" cy="1207008"/>
-          </a:xfrm>
-          <a:prstGeom prst="rect">
-            <a:avLst/>
-          </a:prstGeom>
-          <a:solidFill>
-            <a:srgbClr val="F3EFE7"/>
-          </a:solidFill>
-          <a:ln w="9525">
-            <a:solidFill>
-              <a:srgbClr val="6B665D"/>
-            </a:solidFill>
-            <a:prstDash val="dash"/>
-          </a:ln>
-        </p:spPr>
-      </p:sp>
-      <p:sp>
-        <p:nvSpPr>
-          <p:cNvPr id="17" name="Text 15"/>
-          <p:cNvSpPr txBox="1"/>
-          <p:nvPr/>
-        </p:nvSpPr>
-        <p:spPr>
-          <a:xfrm>
-            <a:off x="3363163" y="1371600"/>
-            <a:ext cx="1051560" cy="146304"/>
-          </a:xfrm>
-          <a:prstGeom prst="rect">
-            <a:avLst/>
-          </a:prstGeom>
-          <a:noFill/>
-          <a:ln/>
-        </p:spPr>
-        <p:txBody>
-          <a:bodyPr wrap="square" lIns="0" tIns="0" rIns="0" bIns="0" rtlCol="0" anchor="t"/>
-          <a:lstStyle/>
-          <a:p>
-            <a:pPr indent="0" marL="0">
-              <a:buNone/>
-            </a:pPr>
-            <a:r>
-              <a:rPr lang="en-US" sz="700" b="1" spc="120" kern="0" dirty="0">
-                <a:solidFill>
-                  <a:srgbClr val="7D5E30"/>
-                </a:solidFill>
-                <a:latin typeface="Arial" pitchFamily="34" charset="0"/>
-                <a:ea typeface="Arial" pitchFamily="34" charset="-122"/>
-                <a:cs typeface="Arial" pitchFamily="34" charset="-120"/>
-              </a:rPr>
-              <a:t>LLM</a:t>
-            </a:r>
-            <a:endParaRPr lang="en-US" sz="700" dirty="0"/>
-          </a:p>
-        </p:txBody>
-      </p:sp>
-      <p:sp>
-        <p:nvSpPr>
-          <p:cNvPr id="18" name="Text 16"/>
-          <p:cNvSpPr txBox="1"/>
-          <p:nvPr/>
-        </p:nvSpPr>
-        <p:spPr>
-          <a:xfrm>
-            <a:off x="3363163" y="1527048"/>
-            <a:ext cx="1051560" cy="182880"/>
-          </a:xfrm>
-          <a:prstGeom prst="rect">
-            <a:avLst/>
-          </a:prstGeom>
-          <a:noFill/>
-          <a:ln/>
-        </p:spPr>
-        <p:txBody>
-          <a:bodyPr wrap="square" lIns="0" tIns="0" rIns="0" bIns="0" rtlCol="0" anchor="t"/>
-          <a:lstStyle/>
-          <a:p>
-            <a:pPr indent="0" marL="0">
-              <a:buNone/>
-            </a:pPr>
-            <a:r>
-              <a:rPr lang="en-US" sz="1050" dirty="0">
-                <a:solidFill>
-                  <a:srgbClr val="1D1B18"/>
-                </a:solidFill>
-                <a:latin typeface="Georgia" pitchFamily="34" charset="0"/>
-                <a:ea typeface="Georgia" pitchFamily="34" charset="-122"/>
-                <a:cs typeface="Georgia" pitchFamily="34" charset="-120"/>
-              </a:rPr>
-              <a:t>Structured output</a:t>
-            </a:r>
-            <a:endParaRPr lang="en-US" sz="1050" dirty="0"/>
-          </a:p>
-        </p:txBody>
-      </p:sp>
-      <p:sp>
-        <p:nvSpPr>
-          <p:cNvPr id="19" name="Text 17"/>
-          <p:cNvSpPr txBox="1"/>
-          <p:nvPr/>
-        </p:nvSpPr>
-        <p:spPr>
-          <a:xfrm>
-            <a:off x="3363163" y="1737360"/>
-            <a:ext cx="1051560" cy="548640"/>
-          </a:xfrm>
-          <a:prstGeom prst="rect">
-            <a:avLst/>
-          </a:prstGeom>
-          <a:noFill/>
-          <a:ln/>
-        </p:spPr>
-        <p:txBody>
-          <a:bodyPr wrap="square" lIns="0" tIns="0" rIns="0" bIns="0" rtlCol="0" anchor="t"/>
-          <a:lstStyle/>
-          <a:p>
-            <a:pPr indent="0" marL="0">
-              <a:buNone/>
-            </a:pPr>
-            <a:r>
-              <a:rPr lang="en-US" sz="750" dirty="0">
-                <a:solidFill>
-                  <a:srgbClr val="4A463F"/>
-                </a:solidFill>
-                <a:latin typeface="Arial" pitchFamily="34" charset="0"/>
-                <a:ea typeface="Arial" pitchFamily="34" charset="-122"/>
-                <a:cs typeface="Arial" pitchFamily="34" charset="-120"/>
-              </a:rPr>
-              <a:t>Typed patch; every field must quote the message</a:t>
-            </a:r>
-            <a:endParaRPr lang="en-US" sz="750" dirty="0"/>
-          </a:p>
-        </p:txBody>
-      </p:sp>
-      <p:sp>
-        <p:nvSpPr>
-          <p:cNvPr id="20" name="Text 18"/>
-          <p:cNvSpPr txBox="1"/>
-          <p:nvPr/>
-        </p:nvSpPr>
-        <p:spPr>
-          <a:xfrm>
-            <a:off x="3363163" y="2231136"/>
-            <a:ext cx="1051560" cy="237744"/>
-          </a:xfrm>
-          <a:prstGeom prst="rect">
-            <a:avLst/>
-          </a:prstGeom>
-          <a:noFill/>
-          <a:ln/>
-        </p:spPr>
-        <p:txBody>
-          <a:bodyPr wrap="square" lIns="0" tIns="0" rIns="0" bIns="0" rtlCol="0" anchor="b"/>
-          <a:lstStyle/>
-          <a:p>
-            <a:pPr indent="0" marL="0">
-              <a:buNone/>
-            </a:pPr>
-            <a:r>
-              <a:rPr lang="en-US" sz="650" dirty="0">
-                <a:solidFill>
-                  <a:srgbClr val="7D5E30"/>
-                </a:solidFill>
-                <a:latin typeface="Courier New" pitchFamily="34" charset="0"/>
-                <a:ea typeface="Courier New" pitchFamily="34" charset="-122"/>
-                <a:cs typeface="Courier New" pitchFamily="34" charset="-120"/>
-              </a:rPr>
-              <a:t>intake.py</a:t>
-            </a:r>
-            <a:endParaRPr lang="en-US" sz="650" dirty="0"/>
-          </a:p>
-        </p:txBody>
-      </p:sp>
-      <p:sp>
-        <p:nvSpPr>
-          <p:cNvPr id="21" name="Shape 19"/>
-          <p:cNvSpPr/>
-          <p:nvPr/>
-        </p:nvSpPr>
-        <p:spPr>
-          <a:xfrm>
-            <a:off x="4515307" y="1901952"/>
-            <a:ext cx="113386" cy="0"/>
-          </a:xfrm>
-          <a:prstGeom prst="line">
-            <a:avLst/>
-          </a:prstGeom>
-          <a:noFill/>
-          <a:ln w="12700">
-            <a:solidFill>
-              <a:srgbClr val="1D1B18"/>
-            </a:solidFill>
-            <a:prstDash val="solid"/>
-            <a:tailEnd type="triangle"/>
-          </a:ln>
-        </p:spPr>
-      </p:sp>
-      <p:sp>
-        <p:nvSpPr>
-          <p:cNvPr id="22" name="Shape 20"/>
-          <p:cNvSpPr/>
-          <p:nvPr/>
-        </p:nvSpPr>
-        <p:spPr>
-          <a:xfrm>
-            <a:off x="4646981" y="1298448"/>
-            <a:ext cx="1216152" cy="1207008"/>
-          </a:xfrm>
-          <a:prstGeom prst="rect">
-            <a:avLst/>
-          </a:prstGeom>
-          <a:solidFill>
-            <a:srgbClr val="1D1B18"/>
-          </a:solidFill>
-          <a:ln w="9525">
-            <a:solidFill>
-              <a:srgbClr val="1D1B18"/>
-            </a:solidFill>
-            <a:prstDash val="solid"/>
-          </a:ln>
-        </p:spPr>
-      </p:sp>
-      <p:sp>
-        <p:nvSpPr>
-          <p:cNvPr id="23" name="Text 21"/>
-          <p:cNvSpPr txBox="1"/>
-          <p:nvPr/>
-        </p:nvSpPr>
-        <p:spPr>
-          <a:xfrm>
-            <a:off x="4729277" y="1371600"/>
-            <a:ext cx="1051560" cy="146304"/>
-          </a:xfrm>
-          <a:prstGeom prst="rect">
-            <a:avLst/>
-          </a:prstGeom>
-          <a:noFill/>
-          <a:ln/>
-        </p:spPr>
-        <p:txBody>
-          <a:bodyPr wrap="square" lIns="0" tIns="0" rIns="0" bIns="0" rtlCol="0" anchor="t"/>
-          <a:lstStyle/>
-          <a:p>
-            <a:pPr indent="0" marL="0">
-              <a:buNone/>
-            </a:pPr>
-            <a:r>
-              <a:rPr lang="en-US" sz="700" b="1" spc="120" kern="0" dirty="0">
-                <a:solidFill>
-                  <a:srgbClr val="CDB78F"/>
-                </a:solidFill>
-                <a:latin typeface="Arial" pitchFamily="34" charset="0"/>
-                <a:ea typeface="Arial" pitchFamily="34" charset="-122"/>
-                <a:cs typeface="Arial" pitchFamily="34" charset="-120"/>
-              </a:rPr>
-              <a:t>TOOLS</a:t>
-            </a:r>
-            <a:endParaRPr lang="en-US" sz="700" dirty="0"/>
-          </a:p>
-        </p:txBody>
-      </p:sp>
-      <p:sp>
-        <p:nvSpPr>
-          <p:cNvPr id="24" name="Text 22"/>
-          <p:cNvSpPr txBox="1"/>
-          <p:nvPr/>
-        </p:nvSpPr>
-        <p:spPr>
-          <a:xfrm>
-            <a:off x="4729277" y="1527048"/>
-            <a:ext cx="1051560" cy="182880"/>
-          </a:xfrm>
-          <a:prstGeom prst="rect">
-            <a:avLst/>
-          </a:prstGeom>
-          <a:noFill/>
-          <a:ln/>
-        </p:spPr>
-        <p:txBody>
-          <a:bodyPr wrap="square" lIns="0" tIns="0" rIns="0" bIns="0" rtlCol="0" anchor="t"/>
-          <a:lstStyle/>
-          <a:p>
-            <a:pPr indent="0" marL="0">
-              <a:buNone/>
-            </a:pPr>
-            <a:r>
-              <a:rPr lang="en-US" sz="1050" dirty="0">
-                <a:solidFill>
-                  <a:srgbClr val="F4EFE6"/>
-                </a:solidFill>
-                <a:latin typeface="Georgia" pitchFamily="34" charset="0"/>
-                <a:ea typeface="Georgia" pitchFamily="34" charset="-122"/>
-                <a:cs typeface="Georgia" pitchFamily="34" charset="-120"/>
-              </a:rPr>
-              <a:t>Deterministic</a:t>
-            </a:r>
-            <a:endParaRPr lang="en-US" sz="1050" dirty="0"/>
-          </a:p>
-        </p:txBody>
-      </p:sp>
-      <p:sp>
-        <p:nvSpPr>
-          <p:cNvPr id="25" name="Text 23"/>
-          <p:cNvSpPr txBox="1"/>
-          <p:nvPr/>
-        </p:nvSpPr>
-        <p:spPr>
-          <a:xfrm>
-            <a:off x="4729277" y="1737360"/>
-            <a:ext cx="1051560" cy="548640"/>
-          </a:xfrm>
-          <a:prstGeom prst="rect">
-            <a:avLst/>
-          </a:prstGeom>
-          <a:noFill/>
-          <a:ln/>
-        </p:spPr>
-        <p:txBody>
-          <a:bodyPr wrap="square" lIns="0" tIns="0" rIns="0" bIns="0" rtlCol="0" anchor="t"/>
-          <a:lstStyle/>
-          <a:p>
-            <a:pPr indent="0" marL="0">
-              <a:buNone/>
-            </a:pPr>
-            <a:r>
-              <a:rPr lang="en-US" sz="750" dirty="0">
-                <a:solidFill>
-                  <a:srgbClr val="F4EFE6"/>
-                </a:solidFill>
-                <a:latin typeface="Arial" pitchFamily="34" charset="0"/>
-                <a:ea typeface="Arial" pitchFamily="34" charset="-122"/>
-                <a:cs typeface="Arial" pitchFamily="34" charset="-120"/>
-              </a:rPr>
-              <a:t>Order lookup, remembered rules, eligibility, estimates, ranking</a:t>
-            </a:r>
-            <a:endParaRPr lang="en-US" sz="750" dirty="0"/>
-          </a:p>
-        </p:txBody>
-      </p:sp>
-      <p:sp>
-        <p:nvSpPr>
-          <p:cNvPr id="26" name="Text 24"/>
-          <p:cNvSpPr txBox="1"/>
-          <p:nvPr/>
-        </p:nvSpPr>
-        <p:spPr>
-          <a:xfrm>
-            <a:off x="4729277" y="2231136"/>
-            <a:ext cx="1051560" cy="237744"/>
-          </a:xfrm>
-          <a:prstGeom prst="rect">
-            <a:avLst/>
-          </a:prstGeom>
-          <a:noFill/>
-          <a:ln/>
-        </p:spPr>
-        <p:txBody>
-          <a:bodyPr wrap="square" lIns="0" tIns="0" rIns="0" bIns="0" rtlCol="0" anchor="b"/>
-          <a:lstStyle/>
-          <a:p>
-            <a:pPr indent="0" marL="0">
-              <a:buNone/>
-            </a:pPr>
-            <a:r>
-              <a:rPr lang="en-US" sz="650" dirty="0">
-                <a:solidFill>
-                  <a:srgbClr val="CDB78F"/>
-                </a:solidFill>
-                <a:latin typeface="Courier New" pitchFamily="34" charset="0"/>
-                <a:ea typeface="Courier New" pitchFamily="34" charset="-122"/>
-                <a:cs typeface="Courier New" pitchFamily="34" charset="-120"/>
-              </a:rPr>
-              <a:t>dispatch.py</a:t>
-            </a:r>
-            <a:endParaRPr lang="en-US" sz="650" dirty="0"/>
-          </a:p>
-          <a:p>
-            <a:pPr indent="0" marL="0">
-              <a:buNone/>
-            </a:pPr>
-            <a:r>
-              <a:rPr lang="en-US" sz="650" dirty="0">
-                <a:solidFill>
-                  <a:srgbClr val="CDB78F"/>
-                </a:solidFill>
-                <a:latin typeface="Courier New" pitchFamily="34" charset="0"/>
-                <a:ea typeface="Courier New" pitchFamily="34" charset="-122"/>
-                <a:cs typeface="Courier New" pitchFamily="34" charset="-120"/>
-              </a:rPr>
-              <a:t>allocator.py</a:t>
-            </a:r>
-            <a:endParaRPr lang="en-US" sz="650" dirty="0"/>
-          </a:p>
-        </p:txBody>
-      </p:sp>
-      <p:sp>
-        <p:nvSpPr>
-          <p:cNvPr id="27" name="Shape 25"/>
-          <p:cNvSpPr/>
-          <p:nvPr/>
-        </p:nvSpPr>
-        <p:spPr>
-          <a:xfrm>
-            <a:off x="5881421" y="1901952"/>
-            <a:ext cx="113386" cy="0"/>
-          </a:xfrm>
-          <a:prstGeom prst="line">
-            <a:avLst/>
-          </a:prstGeom>
-          <a:noFill/>
-          <a:ln w="12700">
-            <a:solidFill>
-              <a:srgbClr val="1D1B18"/>
-            </a:solidFill>
-            <a:prstDash val="solid"/>
-            <a:tailEnd type="triangle"/>
-          </a:ln>
-        </p:spPr>
-      </p:sp>
-      <p:sp>
-        <p:nvSpPr>
-          <p:cNvPr id="28" name="Shape 26"/>
-          <p:cNvSpPr/>
-          <p:nvPr/>
-        </p:nvSpPr>
-        <p:spPr>
-          <a:xfrm>
-            <a:off x="6013094" y="1298448"/>
-            <a:ext cx="1216152" cy="1207008"/>
-          </a:xfrm>
-          <a:prstGeom prst="rect">
-            <a:avLst/>
-          </a:prstGeom>
-          <a:solidFill>
-            <a:srgbClr val="FFFFFF"/>
-          </a:solidFill>
-          <a:ln w="9525">
-            <a:solidFill>
-              <a:srgbClr val="E4DDD0"/>
-            </a:solidFill>
-            <a:prstDash val="solid"/>
-          </a:ln>
-        </p:spPr>
-      </p:sp>
-      <p:sp>
-        <p:nvSpPr>
-          <p:cNvPr id="29" name="Text 27"/>
-          <p:cNvSpPr txBox="1"/>
-          <p:nvPr/>
-        </p:nvSpPr>
-        <p:spPr>
-          <a:xfrm>
-            <a:off x="6095390" y="1371600"/>
-            <a:ext cx="1051560" cy="146304"/>
-          </a:xfrm>
-          <a:prstGeom prst="rect">
-            <a:avLst/>
-          </a:prstGeom>
-          <a:noFill/>
-          <a:ln/>
-        </p:spPr>
-        <p:txBody>
-          <a:bodyPr wrap="square" lIns="0" tIns="0" rIns="0" bIns="0" rtlCol="0" anchor="t"/>
-          <a:lstStyle/>
-          <a:p>
-            <a:pPr indent="0" marL="0">
-              <a:buNone/>
-            </a:pPr>
-            <a:r>
-              <a:rPr lang="en-US" sz="700" b="1" spc="120" kern="0" dirty="0">
-                <a:solidFill>
-                  <a:srgbClr val="7D5E30"/>
-                </a:solidFill>
-                <a:latin typeface="Arial" pitchFamily="34" charset="0"/>
-                <a:ea typeface="Arial" pitchFamily="34" charset="-122"/>
-                <a:cs typeface="Arial" pitchFamily="34" charset="-120"/>
-              </a:rPr>
-              <a:t>REPLY</a:t>
-            </a:r>
-            <a:endParaRPr lang="en-US" sz="700" dirty="0"/>
-          </a:p>
-        </p:txBody>
-      </p:sp>
-      <p:sp>
-        <p:nvSpPr>
-          <p:cNvPr id="30" name="Text 28"/>
-          <p:cNvSpPr txBox="1"/>
-          <p:nvPr/>
-        </p:nvSpPr>
-        <p:spPr>
-          <a:xfrm>
-            <a:off x="6095390" y="1527048"/>
-            <a:ext cx="1051560" cy="182880"/>
-          </a:xfrm>
-          <a:prstGeom prst="rect">
-            <a:avLst/>
-          </a:prstGeom>
-          <a:noFill/>
-          <a:ln/>
-        </p:spPr>
-        <p:txBody>
-          <a:bodyPr wrap="square" lIns="0" tIns="0" rIns="0" bIns="0" rtlCol="0" anchor="t"/>
-          <a:lstStyle/>
-          <a:p>
-            <a:pPr indent="0" marL="0">
-              <a:buNone/>
-            </a:pPr>
-            <a:r>
-              <a:rPr lang="en-US" sz="1050" dirty="0">
-                <a:solidFill>
-                  <a:srgbClr val="1D1B18"/>
-                </a:solidFill>
-                <a:latin typeface="Georgia" pitchFamily="34" charset="0"/>
-                <a:ea typeface="Georgia" pitchFamily="34" charset="-122"/>
-                <a:cs typeface="Georgia" pitchFamily="34" charset="-120"/>
-              </a:rPr>
-              <a:t>Python template</a:t>
-            </a:r>
-            <a:endParaRPr lang="en-US" sz="1050" dirty="0"/>
-          </a:p>
-        </p:txBody>
-      </p:sp>
-      <p:sp>
-        <p:nvSpPr>
-          <p:cNvPr id="31" name="Text 29"/>
-          <p:cNvSpPr txBox="1"/>
-          <p:nvPr/>
-        </p:nvSpPr>
-        <p:spPr>
-          <a:xfrm>
-            <a:off x="6095390" y="1737360"/>
-            <a:ext cx="1051560" cy="548640"/>
-          </a:xfrm>
-          <a:prstGeom prst="rect">
-            <a:avLst/>
-          </a:prstGeom>
-          <a:noFill/>
-          <a:ln/>
-        </p:spPr>
-        <p:txBody>
-          <a:bodyPr wrap="square" lIns="0" tIns="0" rIns="0" bIns="0" rtlCol="0" anchor="t"/>
-          <a:lstStyle/>
-          <a:p>
-            <a:pPr indent="0" marL="0">
-              <a:buNone/>
-            </a:pPr>
-            <a:r>
-              <a:rPr lang="en-US" sz="750" dirty="0">
-                <a:solidFill>
-                  <a:srgbClr val="4A463F"/>
-                </a:solidFill>
-                <a:latin typeface="Arial" pitchFamily="34" charset="0"/>
-                <a:ea typeface="Arial" pitchFamily="34" charset="-122"/>
-                <a:cs typeface="Arial" pitchFamily="34" charset="-120"/>
-              </a:rPr>
-              <a:t>Card and speech from tool strings only</a:t>
-            </a:r>
-            <a:endParaRPr lang="en-US" sz="750" dirty="0"/>
-          </a:p>
-        </p:txBody>
-      </p:sp>
-      <p:sp>
-        <p:nvSpPr>
-          <p:cNvPr id="32" name="Text 30"/>
-          <p:cNvSpPr txBox="1"/>
-          <p:nvPr/>
-        </p:nvSpPr>
-        <p:spPr>
-          <a:xfrm>
-            <a:off x="6095390" y="2231136"/>
-            <a:ext cx="1051560" cy="237744"/>
-          </a:xfrm>
-          <a:prstGeom prst="rect">
-            <a:avLst/>
-          </a:prstGeom>
-          <a:noFill/>
-          <a:ln/>
-        </p:spPr>
-        <p:txBody>
-          <a:bodyPr wrap="square" lIns="0" tIns="0" rIns="0" bIns="0" rtlCol="0" anchor="b"/>
-          <a:lstStyle/>
-          <a:p>
-            <a:pPr indent="0" marL="0">
-              <a:buNone/>
-            </a:pPr>
-            <a:r>
-              <a:rPr lang="en-US" sz="650" dirty="0">
-                <a:solidFill>
-                  <a:srgbClr val="7D5E30"/>
-                </a:solidFill>
-                <a:latin typeface="Courier New" pitchFamily="34" charset="0"/>
-                <a:ea typeface="Courier New" pitchFamily="34" charset="-122"/>
-                <a:cs typeface="Courier New" pitchFamily="34" charset="-120"/>
-              </a:rPr>
-              <a:t>assistant.py</a:t>
-            </a:r>
-            <a:endParaRPr lang="en-US" sz="650" dirty="0"/>
-          </a:p>
-        </p:txBody>
-      </p:sp>
-      <p:sp>
-        <p:nvSpPr>
-          <p:cNvPr id="33" name="Shape 31"/>
-          <p:cNvSpPr/>
-          <p:nvPr/>
-        </p:nvSpPr>
-        <p:spPr>
-          <a:xfrm>
-            <a:off x="7247534" y="1901952"/>
-            <a:ext cx="113386" cy="0"/>
-          </a:xfrm>
-          <a:prstGeom prst="line">
-            <a:avLst/>
-          </a:prstGeom>
-          <a:noFill/>
-          <a:ln w="12700">
-            <a:solidFill>
-              <a:srgbClr val="1D1B18"/>
-            </a:solidFill>
-            <a:prstDash val="solid"/>
-            <a:tailEnd type="triangle"/>
-          </a:ln>
-        </p:spPr>
-      </p:sp>
-      <p:sp>
-        <p:nvSpPr>
-          <p:cNvPr id="34" name="Shape 32"/>
-          <p:cNvSpPr/>
-          <p:nvPr/>
-        </p:nvSpPr>
-        <p:spPr>
-          <a:xfrm>
-            <a:off x="7379208" y="1298448"/>
-            <a:ext cx="1216152" cy="1207008"/>
-          </a:xfrm>
-          <a:prstGeom prst="rect">
-            <a:avLst/>
-          </a:prstGeom>
-          <a:solidFill>
-            <a:srgbClr val="FFFFFF"/>
-          </a:solidFill>
-          <a:ln w="9525">
-            <a:solidFill>
-              <a:srgbClr val="E4DDD0"/>
-            </a:solidFill>
-            <a:prstDash val="solid"/>
-          </a:ln>
-        </p:spPr>
-      </p:sp>
-      <p:sp>
-        <p:nvSpPr>
-          <p:cNvPr id="35" name="Text 33"/>
-          <p:cNvSpPr txBox="1"/>
-          <p:nvPr/>
-        </p:nvSpPr>
-        <p:spPr>
-          <a:xfrm>
-            <a:off x="7461504" y="1371600"/>
-            <a:ext cx="1051560" cy="146304"/>
-          </a:xfrm>
-          <a:prstGeom prst="rect">
-            <a:avLst/>
-          </a:prstGeom>
-          <a:noFill/>
-          <a:ln/>
-        </p:spPr>
-        <p:txBody>
-          <a:bodyPr wrap="square" lIns="0" tIns="0" rIns="0" bIns="0" rtlCol="0" anchor="t"/>
-          <a:lstStyle/>
-          <a:p>
-            <a:pPr indent="0" marL="0">
-              <a:buNone/>
-            </a:pPr>
-            <a:r>
-              <a:rPr lang="en-US" sz="700" b="1" spc="120" kern="0" dirty="0">
-                <a:solidFill>
-                  <a:srgbClr val="7D5E30"/>
-                </a:solidFill>
-                <a:latin typeface="Arial" pitchFamily="34" charset="0"/>
-                <a:ea typeface="Arial" pitchFamily="34" charset="-122"/>
-                <a:cs typeface="Arial" pitchFamily="34" charset="-120"/>
-              </a:rPr>
-              <a:t>CONFIRM + STORE</a:t>
-            </a:r>
-            <a:endParaRPr lang="en-US" sz="700" dirty="0"/>
-          </a:p>
-        </p:txBody>
-      </p:sp>
-      <p:sp>
-        <p:nvSpPr>
-          <p:cNvPr id="36" name="Text 34"/>
-          <p:cNvSpPr txBox="1"/>
-          <p:nvPr/>
-        </p:nvSpPr>
-        <p:spPr>
-          <a:xfrm>
-            <a:off x="7461504" y="1527048"/>
-            <a:ext cx="1051560" cy="182880"/>
-          </a:xfrm>
-          <a:prstGeom prst="rect">
-            <a:avLst/>
-          </a:prstGeom>
-          <a:noFill/>
-          <a:ln/>
-        </p:spPr>
-        <p:txBody>
-          <a:bodyPr wrap="square" lIns="0" tIns="0" rIns="0" bIns="0" rtlCol="0" anchor="t"/>
-          <a:lstStyle/>
-          <a:p>
-            <a:pPr indent="0" marL="0">
-              <a:buNone/>
-            </a:pPr>
-            <a:r>
-              <a:rPr lang="en-US" sz="1050" dirty="0">
-                <a:solidFill>
-                  <a:srgbClr val="1D1B18"/>
-                </a:solidFill>
-                <a:latin typeface="Georgia" pitchFamily="34" charset="0"/>
-                <a:ea typeface="Georgia" pitchFamily="34" charset="-122"/>
-                <a:cs typeface="Georgia" pitchFamily="34" charset="-120"/>
-              </a:rPr>
-              <a:t>SQLite</a:t>
-            </a:r>
-            <a:endParaRPr lang="en-US" sz="1050" dirty="0"/>
-          </a:p>
-        </p:txBody>
-      </p:sp>
-      <p:sp>
-        <p:nvSpPr>
-          <p:cNvPr id="37" name="Text 35"/>
-          <p:cNvSpPr txBox="1"/>
-          <p:nvPr/>
-        </p:nvSpPr>
-        <p:spPr>
-          <a:xfrm>
-            <a:off x="7461504" y="1737360"/>
-            <a:ext cx="1051560" cy="548640"/>
-          </a:xfrm>
-          <a:prstGeom prst="rect">
-            <a:avLst/>
-          </a:prstGeom>
-          <a:noFill/>
-          <a:ln/>
-        </p:spPr>
-        <p:txBody>
-          <a:bodyPr wrap="square" lIns="0" tIns="0" rIns="0" bIns="0" rtlCol="0" anchor="t"/>
-          <a:lstStyle/>
-          <a:p>
-            <a:pPr indent="0" marL="0">
-              <a:buNone/>
-            </a:pPr>
-            <a:r>
-              <a:rPr lang="en-US" sz="750" dirty="0">
-                <a:solidFill>
-                  <a:srgbClr val="4A463F"/>
-                </a:solidFill>
-                <a:latin typeface="Arial" pitchFamily="34" charset="0"/>
-                <a:ea typeface="Arial" pitchFamily="34" charset="-122"/>
-                <a:cs typeface="Arial" pitchFamily="34" charset="-120"/>
-              </a:rPr>
-              <a:t>Recompute, save the record, learn the rule</a:t>
-            </a:r>
-            <a:endParaRPr lang="en-US" sz="750" dirty="0"/>
-          </a:p>
-        </p:txBody>
-      </p:sp>
-      <p:sp>
-        <p:nvSpPr>
-          <p:cNvPr id="38" name="Text 36"/>
-          <p:cNvSpPr txBox="1"/>
-          <p:nvPr/>
-        </p:nvSpPr>
-        <p:spPr>
-          <a:xfrm>
-            <a:off x="7461504" y="2231136"/>
-            <a:ext cx="1051560" cy="237744"/>
-          </a:xfrm>
-          <a:prstGeom prst="rect">
-            <a:avLst/>
-          </a:prstGeom>
-          <a:noFill/>
-          <a:ln/>
-        </p:spPr>
-        <p:txBody>
-          <a:bodyPr wrap="square" lIns="0" tIns="0" rIns="0" bIns="0" rtlCol="0" anchor="b"/>
-          <a:lstStyle/>
-          <a:p>
-            <a:pPr indent="0" marL="0">
-              <a:buNone/>
-            </a:pPr>
-            <a:r>
-              <a:rPr lang="en-US" sz="650" dirty="0">
-                <a:solidFill>
-                  <a:srgbClr val="7D5E30"/>
-                </a:solidFill>
-                <a:latin typeface="Courier New" pitchFamily="34" charset="0"/>
-                <a:ea typeface="Courier New" pitchFamily="34" charset="-122"/>
-                <a:cs typeface="Courier New" pitchFamily="34" charset="-120"/>
-              </a:rPr>
-              <a:t>records.py</a:t>
-            </a:r>
-            <a:endParaRPr lang="en-US" sz="650" dirty="0"/>
-          </a:p>
-          <a:p>
-            <a:pPr indent="0" marL="0">
-              <a:buNone/>
-            </a:pPr>
-            <a:r>
-              <a:rPr lang="en-US" sz="650" dirty="0">
-                <a:solidFill>
-                  <a:srgbClr val="7D5E30"/>
-                </a:solidFill>
-                <a:latin typeface="Courier New" pitchFamily="34" charset="0"/>
-                <a:ea typeface="Courier New" pitchFamily="34" charset="-122"/>
-                <a:cs typeface="Courier New" pitchFamily="34" charset="-120"/>
-              </a:rPr>
-              <a:t>memory.py</a:t>
-            </a:r>
-            <a:endParaRPr lang="en-US" sz="650" dirty="0"/>
-          </a:p>
-        </p:txBody>
-      </p:sp>
-      <p:sp>
-        <p:nvSpPr>
-          <p:cNvPr id="39" name="Text 37"/>
-          <p:cNvSpPr txBox="1"/>
-          <p:nvPr/>
-        </p:nvSpPr>
-        <p:spPr>
-          <a:xfrm>
-            <a:off x="2732227" y="2560320"/>
-            <a:ext cx="2313432" cy="274320"/>
-          </a:xfrm>
-          <a:prstGeom prst="rect">
-            <a:avLst/>
-          </a:prstGeom>
-          <a:noFill/>
-          <a:ln/>
-        </p:spPr>
-        <p:txBody>
-          <a:bodyPr wrap="square" lIns="0" tIns="0" rIns="0" bIns="0" rtlCol="0" anchor="t"/>
-          <a:lstStyle/>
-          <a:p>
-            <a:pPr algn="ctr" indent="0" marL="0">
-              <a:buNone/>
-            </a:pPr>
-            <a:r>
-              <a:rPr lang="en-US" sz="700" i="1" dirty="0">
-                <a:solidFill>
-                  <a:srgbClr val="6B665D"/>
-                </a:solidFill>
-                <a:latin typeface="Arial" pitchFamily="34" charset="0"/>
-                <a:ea typeface="Arial" pitchFamily="34" charset="-122"/>
-                <a:cs typeface="Arial" pitchFamily="34" charset="-120"/>
-              </a:rPr>
-              <a:t>Trust boundary: the model call is the only thing that leaves the machine. It never sees costs, queues or defect rates.</a:t>
-            </a:r>
-            <a:endParaRPr lang="en-US" sz="700" dirty="0"/>
-          </a:p>
-        </p:txBody>
-      </p:sp>
-      <p:sp>
-        <p:nvSpPr>
-          <p:cNvPr id="40" name="Text 38"/>
-          <p:cNvSpPr txBox="1"/>
-          <p:nvPr/>
-        </p:nvSpPr>
-        <p:spPr>
-          <a:xfrm>
-            <a:off x="548640" y="2880360"/>
-            <a:ext cx="8046720" cy="164592"/>
-          </a:xfrm>
-          <a:prstGeom prst="rect">
-            <a:avLst/>
-          </a:prstGeom>
-          <a:noFill/>
-          <a:ln/>
-        </p:spPr>
-        <p:txBody>
-          <a:bodyPr wrap="square" lIns="0" tIns="0" rIns="0" bIns="0" rtlCol="0" anchor="t"/>
-          <a:lstStyle/>
-          <a:p>
-            <a:pPr indent="0" marL="0">
-              <a:buNone/>
-            </a:pPr>
-            <a:r>
-              <a:rPr lang="en-US" sz="750" b="1" spc="180" kern="0" dirty="0">
-                <a:solidFill>
-                  <a:srgbClr val="6B665D"/>
-                </a:solidFill>
-                <a:latin typeface="Arial" pitchFamily="34" charset="0"/>
-                <a:ea typeface="Arial" pitchFamily="34" charset="-122"/>
-                <a:cs typeface="Arial" pitchFamily="34" charset="-120"/>
-              </a:rPr>
-              <a:t>KEY CHOICES, AGAINST THE ALTERNATIVE WE CONSIDERED</a:t>
-            </a:r>
-            <a:endParaRPr lang="en-US" sz="750" dirty="0"/>
+              <a:t>Each choice, against the alternative we considered</a:t>
+            </a:r>
+            <a:endParaRPr lang="en-US" sz="2300" dirty="0"/>
           </a:p>
         </p:txBody>
       </p:sp>
       <p:graphicFrame>
         <p:nvGraphicFramePr>
-          <p:cNvPr id="5" name="Table 0"/>
+          <p:cNvPr id="6" name="Table 0"/>
           <p:cNvGraphicFramePr>
             <a:graphicFrameLocks noGrp="1"/>
           </p:cNvGraphicFramePr>
@@ -6377,7 +5335,7 @@
           </p:nvPr>
         </p:nvGraphicFramePr>
         <p:xfrm>
-          <a:off x="548640" y="3072384"/>
+          <a:off x="548640" y="1243584"/>
           <a:ext cx="8046720" cy="914400"/>
         </p:xfrm>
         <a:graphic>
@@ -6385,11 +5343,59 @@
             <a:tbl>
               <a:tblPr/>
               <a:tblGrid>
-                <a:gridCol w="1828800"/>
+                <a:gridCol w="1143000"/>
+                <a:gridCol w="2148840"/>
                 <a:gridCol w="1691640"/>
-                <a:gridCol w="4526280"/>
+                <a:gridCol w="3063240"/>
               </a:tblGrid>
-              <a:tr h="219456">
+              <a:tr h="237744">
+                <a:tc>
+                  <a:txBody>
+                    <a:bodyPr/>
+                    <a:lstStyle/>
+                    <a:p>
+                      <a:pPr indent="0" marL="0">
+                        <a:buNone/>
+                      </a:pPr>
+                      <a:r>
+                        <a:rPr lang="en-US" sz="700" b="1" spc="150" kern="0" dirty="0">
+                          <a:solidFill>
+                            <a:srgbClr val="6B665D"/>
+                          </a:solidFill>
+                          <a:latin typeface="Arial" pitchFamily="34" charset="0"/>
+                          <a:ea typeface="Arial" pitchFamily="34" charset="-122"/>
+                          <a:cs typeface="Arial" pitchFamily="34" charset="-120"/>
+                        </a:rPr>
+                        <a:t>FOR</a:t>
+                      </a:r>
+                      <a:endParaRPr lang="en-US" sz="700" dirty="0">
+                        <a:latin typeface="Arial" charset="0"/>
+                        <a:ea typeface="Arial" charset="0"/>
+                        <a:cs typeface="Arial" charset="0"/>
+                      </a:endParaRPr>
+                    </a:p>
+                  </a:txBody>
+                  <a:tcPr marL="0" marR="50800" marT="25400" marB="25400" anchor="ctr">
+                    <a:lnL w="0" cap="flat" cmpd="sng" algn="ctr">
+                      <a:noFill/>
+                    </a:lnL>
+                    <a:lnR w="0" cap="flat" cmpd="sng" algn="ctr">
+                      <a:noFill/>
+                    </a:lnR>
+                    <a:lnT w="0" cap="flat" cmpd="sng" algn="ctr">
+                      <a:noFill/>
+                    </a:lnT>
+                    <a:lnB w="12700" cap="flat" cmpd="sng" algn="ctr">
+                      <a:solidFill>
+                        <a:srgbClr val="1D1B18"/>
+                      </a:solidFill>
+                      <a:prstDash val="solid"/>
+                      <a:round/>
+                      <a:headEnd type="none" w="med" len="med"/>
+                      <a:tailEnd type="none" w="med" len="med"/>
+                    </a:lnB>
+                  </a:tcPr>
+                </a:tc>
                 <a:tc>
                   <a:txBody>
                     <a:bodyPr/>
@@ -6532,7 +5538,54 @@
                   </a:tcPr>
                 </a:tc>
               </a:tr>
-              <a:tr h="246888">
+              <a:tr h="365760">
+                <a:tc>
+                  <a:txBody>
+                    <a:bodyPr/>
+                    <a:lstStyle/>
+                    <a:p>
+                      <a:pPr indent="0" marL="0">
+                        <a:buNone/>
+                      </a:pPr>
+                      <a:r>
+                        <a:rPr lang="en-US" sz="700" b="1" spc="150" kern="0" dirty="0">
+                          <a:solidFill>
+                            <a:srgbClr val="7D5E30"/>
+                          </a:solidFill>
+                          <a:latin typeface="Arial" pitchFamily="34" charset="0"/>
+                          <a:ea typeface="Arial" pitchFamily="34" charset="-122"/>
+                          <a:cs typeface="Arial" pitchFamily="34" charset="-120"/>
+                        </a:rPr>
+                        <a:t>MODEL</a:t>
+                      </a:r>
+                      <a:endParaRPr lang="en-US" sz="700" dirty="0">
+                        <a:latin typeface="Arial" charset="0"/>
+                        <a:ea typeface="Arial" charset="0"/>
+                        <a:cs typeface="Arial" charset="0"/>
+                      </a:endParaRPr>
+                    </a:p>
+                  </a:txBody>
+                  <a:tcPr marL="0" marR="50800" marT="25400" marB="25400" anchor="ctr">
+                    <a:lnL w="0" cap="flat" cmpd="sng" algn="ctr">
+                      <a:noFill/>
+                    </a:lnL>
+                    <a:lnR w="0" cap="flat" cmpd="sng" algn="ctr">
+                      <a:noFill/>
+                    </a:lnR>
+                    <a:lnT w="0" cap="flat" cmpd="sng" algn="ctr">
+                      <a:noFill/>
+                    </a:lnT>
+                    <a:lnB w="9525" cap="flat" cmpd="sng" algn="ctr">
+                      <a:solidFill>
+                        <a:srgbClr val="E4DDD0"/>
+                      </a:solidFill>
+                      <a:prstDash val="solid"/>
+                      <a:round/>
+                      <a:headEnd type="none" w="med" len="med"/>
+                      <a:tailEnd type="none" w="med" len="med"/>
+                    </a:lnB>
+                  </a:tcPr>
+                </a:tc>
                 <a:tc>
                   <a:txBody>
                     <a:bodyPr/>
@@ -6550,7 +5603,197 @@
                           <a:ea typeface="Arial" pitchFamily="34" charset="-122"/>
                           <a:cs typeface="Arial" pitchFamily="34" charset="-120"/>
                         </a:rPr>
-                        <a:t>One workflow</a:t>
+                        <a:t>One hosted model, named in .env</a:t>
+                      </a:r>
+                      <a:endParaRPr lang="en-US" sz="900" dirty="0">
+                        <a:latin typeface="Arial" charset="0"/>
+                        <a:ea typeface="Arial" charset="0"/>
+                        <a:cs typeface="Arial" charset="0"/>
+                      </a:endParaRPr>
+                    </a:p>
+                  </a:txBody>
+                  <a:tcPr marL="0" marR="50800" marT="25400" marB="25400" anchor="ctr">
+                    <a:lnL w="0" cap="flat" cmpd="sng" algn="ctr">
+                      <a:noFill/>
+                    </a:lnL>
+                    <a:lnR w="0" cap="flat" cmpd="sng" algn="ctr">
+                      <a:noFill/>
+                    </a:lnR>
+                    <a:lnT w="0" cap="flat" cmpd="sng" algn="ctr">
+                      <a:noFill/>
+                    </a:lnT>
+                    <a:lnB w="9525" cap="flat" cmpd="sng" algn="ctr">
+                      <a:solidFill>
+                        <a:srgbClr val="E4DDD0"/>
+                      </a:solidFill>
+                      <a:prstDash val="solid"/>
+                      <a:round/>
+                      <a:headEnd type="none" w="med" len="med"/>
+                      <a:tailEnd type="none" w="med" len="med"/>
+                    </a:lnB>
+                  </a:tcPr>
+                </a:tc>
+                <a:tc>
+                  <a:txBody>
+                    <a:bodyPr/>
+                    <a:lstStyle/>
+                    <a:p>
+                      <a:pPr indent="0" marL="0">
+                        <a:buNone/>
+                      </a:pPr>
+                      <a:r>
+                        <a:rPr lang="en-US" sz="900" dirty="0">
+                          <a:solidFill>
+                            <a:srgbClr val="6B665D"/>
+                          </a:solidFill>
+                          <a:latin typeface="Arial" pitchFamily="34" charset="0"/>
+                          <a:ea typeface="Arial" pitchFamily="34" charset="-122"/>
+                          <a:cs typeface="Arial" pitchFamily="34" charset="-120"/>
+                        </a:rPr>
+                        <a:t>A fine-tuned or local model</a:t>
+                      </a:r>
+                      <a:endParaRPr lang="en-US" sz="900" dirty="0">
+                        <a:latin typeface="Arial" charset="0"/>
+                        <a:ea typeface="Arial" charset="0"/>
+                        <a:cs typeface="Arial" charset="0"/>
+                      </a:endParaRPr>
+                    </a:p>
+                  </a:txBody>
+                  <a:tcPr marL="0" marR="50800" marT="25400" marB="25400" anchor="ctr">
+                    <a:lnL w="0" cap="flat" cmpd="sng" algn="ctr">
+                      <a:noFill/>
+                    </a:lnL>
+                    <a:lnR w="0" cap="flat" cmpd="sng" algn="ctr">
+                      <a:noFill/>
+                    </a:lnR>
+                    <a:lnT w="0" cap="flat" cmpd="sng" algn="ctr">
+                      <a:noFill/>
+                    </a:lnT>
+                    <a:lnB w="9525" cap="flat" cmpd="sng" algn="ctr">
+                      <a:solidFill>
+                        <a:srgbClr val="E4DDD0"/>
+                      </a:solidFill>
+                      <a:prstDash val="solid"/>
+                      <a:round/>
+                      <a:headEnd type="none" w="med" len="med"/>
+                      <a:tailEnd type="none" w="med" len="med"/>
+                    </a:lnB>
+                  </a:tcPr>
+                </a:tc>
+                <a:tc>
+                  <a:txBody>
+                    <a:bodyPr/>
+                    <a:lstStyle/>
+                    <a:p>
+                      <a:pPr indent="0" marL="0">
+                        <a:buNone/>
+                      </a:pPr>
+                      <a:r>
+                        <a:rPr lang="en-US" sz="900" dirty="0">
+                          <a:solidFill>
+                            <a:srgbClr val="4A463F"/>
+                          </a:solidFill>
+                          <a:latin typeface="Arial" pitchFamily="34" charset="0"/>
+                          <a:ea typeface="Arial" pitchFamily="34" charset="-122"/>
+                          <a:cs typeface="Arial" pitchFamily="34" charset="-120"/>
+                        </a:rPr>
+                        <a:t>It only extracts quoted fields, so no training is needed; swapping it is one line</a:t>
+                      </a:r>
+                      <a:endParaRPr lang="en-US" sz="900" dirty="0">
+                        <a:latin typeface="Arial" charset="0"/>
+                        <a:ea typeface="Arial" charset="0"/>
+                        <a:cs typeface="Arial" charset="0"/>
+                      </a:endParaRPr>
+                    </a:p>
+                  </a:txBody>
+                  <a:tcPr marL="0" marR="50800" marT="25400" marB="25400" anchor="ctr">
+                    <a:lnL w="0" cap="flat" cmpd="sng" algn="ctr">
+                      <a:noFill/>
+                    </a:lnL>
+                    <a:lnR w="0" cap="flat" cmpd="sng" algn="ctr">
+                      <a:noFill/>
+                    </a:lnR>
+                    <a:lnT w="0" cap="flat" cmpd="sng" algn="ctr">
+                      <a:noFill/>
+                    </a:lnT>
+                    <a:lnB w="9525" cap="flat" cmpd="sng" algn="ctr">
+                      <a:solidFill>
+                        <a:srgbClr val="E4DDD0"/>
+                      </a:solidFill>
+                      <a:prstDash val="solid"/>
+                      <a:round/>
+                      <a:headEnd type="none" w="med" len="med"/>
+                      <a:tailEnd type="none" w="med" len="med"/>
+                    </a:lnB>
+                  </a:tcPr>
+                </a:tc>
+              </a:tr>
+              <a:tr h="365760">
+                <a:tc>
+                  <a:txBody>
+                    <a:bodyPr/>
+                    <a:lstStyle/>
+                    <a:p>
+                      <a:pPr indent="0" marL="0">
+                        <a:buNone/>
+                      </a:pPr>
+                      <a:r>
+                        <a:rPr lang="en-US" sz="700" b="1" spc="150" kern="0" dirty="0">
+                          <a:solidFill>
+                            <a:srgbClr val="7D5E30"/>
+                          </a:solidFill>
+                          <a:latin typeface="Arial" pitchFamily="34" charset="0"/>
+                          <a:ea typeface="Arial" pitchFamily="34" charset="-122"/>
+                          <a:cs typeface="Arial" pitchFamily="34" charset="-120"/>
+                        </a:rPr>
+                        <a:t>ORCHESTRATION</a:t>
+                      </a:r>
+                      <a:endParaRPr lang="en-US" sz="700" dirty="0">
+                        <a:latin typeface="Arial" charset="0"/>
+                        <a:ea typeface="Arial" charset="0"/>
+                        <a:cs typeface="Arial" charset="0"/>
+                      </a:endParaRPr>
+                    </a:p>
+                  </a:txBody>
+                  <a:tcPr marL="0" marR="50800" marT="25400" marB="25400" anchor="ctr">
+                    <a:lnL w="0" cap="flat" cmpd="sng" algn="ctr">
+                      <a:noFill/>
+                    </a:lnL>
+                    <a:lnR w="0" cap="flat" cmpd="sng" algn="ctr">
+                      <a:noFill/>
+                    </a:lnR>
+                    <a:lnT w="0" cap="flat" cmpd="sng" algn="ctr">
+                      <a:noFill/>
+                    </a:lnT>
+                    <a:lnB w="9525" cap="flat" cmpd="sng" algn="ctr">
+                      <a:solidFill>
+                        <a:srgbClr val="E4DDD0"/>
+                      </a:solidFill>
+                      <a:prstDash val="solid"/>
+                      <a:round/>
+                      <a:headEnd type="none" w="med" len="med"/>
+                      <a:tailEnd type="none" w="med" len="med"/>
+                    </a:lnB>
+                  </a:tcPr>
+                </a:tc>
+                <a:tc>
+                  <a:txBody>
+                    <a:bodyPr/>
+                    <a:lstStyle/>
+                    <a:p>
+                      <a:pPr indent="0" marL="0">
+                        <a:buNone/>
+                      </a:pPr>
+                      <a:r>
+                        <a:rPr lang="en-US" sz="900" b="1" dirty="0">
+                          <a:solidFill>
+                            <a:srgbClr val="1D1B18"/>
+                          </a:solidFill>
+                          <a:latin typeface="Arial" pitchFamily="34" charset="0"/>
+                          <a:ea typeface="Arial" pitchFamily="34" charset="-122"/>
+                          <a:cs typeface="Arial" pitchFamily="34" charset="-120"/>
+                        </a:rPr>
+                        <a:t>One fixed workflow</a:t>
                       </a:r>
                       <a:endParaRPr lang="en-US" sz="900" dirty="0">
                         <a:latin typeface="Arial" charset="0"/>
@@ -6675,7 +5918,814 @@
                   </a:tcPr>
                 </a:tc>
               </a:tr>
-              <a:tr h="246888">
+              <a:tr h="365760">
+                <a:tc>
+                  <a:txBody>
+                    <a:bodyPr/>
+                    <a:lstStyle/>
+                    <a:p>
+                      <a:pPr indent="0" marL="0">
+                        <a:buNone/>
+                      </a:pPr>
+                      <a:r>
+                        <a:rPr lang="en-US" sz="700" b="1" spc="150" kern="0" dirty="0">
+                          <a:solidFill>
+                            <a:srgbClr val="7D5E30"/>
+                          </a:solidFill>
+                          <a:latin typeface="Arial" pitchFamily="34" charset="0"/>
+                          <a:ea typeface="Arial" pitchFamily="34" charset="-122"/>
+                          <a:cs typeface="Arial" pitchFamily="34" charset="-120"/>
+                        </a:rPr>
+                        <a:t>RETRIEVAL</a:t>
+                      </a:r>
+                      <a:endParaRPr lang="en-US" sz="700" dirty="0">
+                        <a:latin typeface="Arial" charset="0"/>
+                        <a:ea typeface="Arial" charset="0"/>
+                        <a:cs typeface="Arial" charset="0"/>
+                      </a:endParaRPr>
+                    </a:p>
+                  </a:txBody>
+                  <a:tcPr marL="0" marR="50800" marT="25400" marB="25400" anchor="ctr">
+                    <a:lnL w="0" cap="flat" cmpd="sng" algn="ctr">
+                      <a:noFill/>
+                    </a:lnL>
+                    <a:lnR w="0" cap="flat" cmpd="sng" algn="ctr">
+                      <a:noFill/>
+                    </a:lnR>
+                    <a:lnT w="0" cap="flat" cmpd="sng" algn="ctr">
+                      <a:noFill/>
+                    </a:lnT>
+                    <a:lnB w="9525" cap="flat" cmpd="sng" algn="ctr">
+                      <a:solidFill>
+                        <a:srgbClr val="E4DDD0"/>
+                      </a:solidFill>
+                      <a:prstDash val="solid"/>
+                      <a:round/>
+                      <a:headEnd type="none" w="med" len="med"/>
+                      <a:tailEnd type="none" w="med" len="med"/>
+                    </a:lnB>
+                  </a:tcPr>
+                </a:tc>
+                <a:tc>
+                  <a:txBody>
+                    <a:bodyPr/>
+                    <a:lstStyle/>
+                    <a:p>
+                      <a:pPr indent="0" marL="0">
+                        <a:buNone/>
+                      </a:pPr>
+                      <a:r>
+                        <a:rPr lang="en-US" sz="900" b="1" dirty="0">
+                          <a:solidFill>
+                            <a:srgbClr val="1D1B18"/>
+                          </a:solidFill>
+                          <a:latin typeface="Arial" pitchFamily="34" charset="0"/>
+                          <a:ea typeface="Arial" pitchFamily="34" charset="-122"/>
+                          <a:cs typeface="Arial" pitchFamily="34" charset="-120"/>
+                        </a:rPr>
+                        <a:t>Exact lookup by order ID</a:t>
+                      </a:r>
+                      <a:endParaRPr lang="en-US" sz="900" dirty="0">
+                        <a:latin typeface="Arial" charset="0"/>
+                        <a:ea typeface="Arial" charset="0"/>
+                        <a:cs typeface="Arial" charset="0"/>
+                      </a:endParaRPr>
+                    </a:p>
+                  </a:txBody>
+                  <a:tcPr marL="0" marR="50800" marT="25400" marB="25400" anchor="ctr">
+                    <a:lnL w="0" cap="flat" cmpd="sng" algn="ctr">
+                      <a:noFill/>
+                    </a:lnL>
+                    <a:lnR w="0" cap="flat" cmpd="sng" algn="ctr">
+                      <a:noFill/>
+                    </a:lnR>
+                    <a:lnT w="0" cap="flat" cmpd="sng" algn="ctr">
+                      <a:noFill/>
+                    </a:lnT>
+                    <a:lnB w="9525" cap="flat" cmpd="sng" algn="ctr">
+                      <a:solidFill>
+                        <a:srgbClr val="E4DDD0"/>
+                      </a:solidFill>
+                      <a:prstDash val="solid"/>
+                      <a:round/>
+                      <a:headEnd type="none" w="med" len="med"/>
+                      <a:tailEnd type="none" w="med" len="med"/>
+                    </a:lnB>
+                  </a:tcPr>
+                </a:tc>
+                <a:tc>
+                  <a:txBody>
+                    <a:bodyPr/>
+                    <a:lstStyle/>
+                    <a:p>
+                      <a:pPr indent="0" marL="0">
+                        <a:buNone/>
+                      </a:pPr>
+                      <a:r>
+                        <a:rPr lang="en-US" sz="900" dirty="0">
+                          <a:solidFill>
+                            <a:srgbClr val="6B665D"/>
+                          </a:solidFill>
+                          <a:latin typeface="Arial" pitchFamily="34" charset="0"/>
+                          <a:ea typeface="Arial" pitchFamily="34" charset="-122"/>
+                          <a:cs typeface="Arial" pitchFamily="34" charset="-120"/>
+                        </a:rPr>
+                        <a:t>Embedding retrieval (RAG)</a:t>
+                      </a:r>
+                      <a:endParaRPr lang="en-US" sz="900" dirty="0">
+                        <a:latin typeface="Arial" charset="0"/>
+                        <a:ea typeface="Arial" charset="0"/>
+                        <a:cs typeface="Arial" charset="0"/>
+                      </a:endParaRPr>
+                    </a:p>
+                  </a:txBody>
+                  <a:tcPr marL="0" marR="50800" marT="25400" marB="25400" anchor="ctr">
+                    <a:lnL w="0" cap="flat" cmpd="sng" algn="ctr">
+                      <a:noFill/>
+                    </a:lnL>
+                    <a:lnR w="0" cap="flat" cmpd="sng" algn="ctr">
+                      <a:noFill/>
+                    </a:lnR>
+                    <a:lnT w="0" cap="flat" cmpd="sng" algn="ctr">
+                      <a:noFill/>
+                    </a:lnT>
+                    <a:lnB w="9525" cap="flat" cmpd="sng" algn="ctr">
+                      <a:solidFill>
+                        <a:srgbClr val="E4DDD0"/>
+                      </a:solidFill>
+                      <a:prstDash val="solid"/>
+                      <a:round/>
+                      <a:headEnd type="none" w="med" len="med"/>
+                      <a:tailEnd type="none" w="med" len="med"/>
+                    </a:lnB>
+                  </a:tcPr>
+                </a:tc>
+                <a:tc>
+                  <a:txBody>
+                    <a:bodyPr/>
+                    <a:lstStyle/>
+                    <a:p>
+                      <a:pPr indent="0" marL="0">
+                        <a:buNone/>
+                      </a:pPr>
+                      <a:r>
+                        <a:rPr lang="en-US" sz="900" dirty="0">
+                          <a:solidFill>
+                            <a:srgbClr val="4A463F"/>
+                          </a:solidFill>
+                          <a:latin typeface="Arial" pitchFamily="34" charset="0"/>
+                          <a:ea typeface="Arial" pitchFamily="34" charset="-122"/>
+                          <a:cs typeface="Arial" pitchFamily="34" charset="-120"/>
+                        </a:rPr>
+                        <a:t>Orders have keys; an exact match cannot fetch the wrong order</a:t>
+                      </a:r>
+                      <a:endParaRPr lang="en-US" sz="900" dirty="0">
+                        <a:latin typeface="Arial" charset="0"/>
+                        <a:ea typeface="Arial" charset="0"/>
+                        <a:cs typeface="Arial" charset="0"/>
+                      </a:endParaRPr>
+                    </a:p>
+                  </a:txBody>
+                  <a:tcPr marL="0" marR="50800" marT="25400" marB="25400" anchor="ctr">
+                    <a:lnL w="0" cap="flat" cmpd="sng" algn="ctr">
+                      <a:noFill/>
+                    </a:lnL>
+                    <a:lnR w="0" cap="flat" cmpd="sng" algn="ctr">
+                      <a:noFill/>
+                    </a:lnR>
+                    <a:lnT w="0" cap="flat" cmpd="sng" algn="ctr">
+                      <a:noFill/>
+                    </a:lnT>
+                    <a:lnB w="9525" cap="flat" cmpd="sng" algn="ctr">
+                      <a:solidFill>
+                        <a:srgbClr val="E4DDD0"/>
+                      </a:solidFill>
+                      <a:prstDash val="solid"/>
+                      <a:round/>
+                      <a:headEnd type="none" w="med" len="med"/>
+                      <a:tailEnd type="none" w="med" len="med"/>
+                    </a:lnB>
+                  </a:tcPr>
+                </a:tc>
+              </a:tr>
+              <a:tr h="365760">
+                <a:tc>
+                  <a:txBody>
+                    <a:bodyPr/>
+                    <a:lstStyle/>
+                    <a:p>
+                      <a:pPr indent="0" marL="0">
+                        <a:buNone/>
+                      </a:pPr>
+                      <a:r>
+                        <a:rPr lang="en-US" sz="700" b="1" spc="150" kern="0" dirty="0">
+                          <a:solidFill>
+                            <a:srgbClr val="7D5E30"/>
+                          </a:solidFill>
+                          <a:latin typeface="Arial" pitchFamily="34" charset="0"/>
+                          <a:ea typeface="Arial" pitchFamily="34" charset="-122"/>
+                          <a:cs typeface="Arial" pitchFamily="34" charset="-120"/>
+                        </a:rPr>
+                        <a:t>DATA STORE</a:t>
+                      </a:r>
+                      <a:endParaRPr lang="en-US" sz="700" dirty="0">
+                        <a:latin typeface="Arial" charset="0"/>
+                        <a:ea typeface="Arial" charset="0"/>
+                        <a:cs typeface="Arial" charset="0"/>
+                      </a:endParaRPr>
+                    </a:p>
+                  </a:txBody>
+                  <a:tcPr marL="0" marR="50800" marT="25400" marB="25400" anchor="ctr">
+                    <a:lnL w="0" cap="flat" cmpd="sng" algn="ctr">
+                      <a:noFill/>
+                    </a:lnL>
+                    <a:lnR w="0" cap="flat" cmpd="sng" algn="ctr">
+                      <a:noFill/>
+                    </a:lnR>
+                    <a:lnT w="0" cap="flat" cmpd="sng" algn="ctr">
+                      <a:noFill/>
+                    </a:lnT>
+                    <a:lnB w="9525" cap="flat" cmpd="sng" algn="ctr">
+                      <a:solidFill>
+                        <a:srgbClr val="E4DDD0"/>
+                      </a:solidFill>
+                      <a:prstDash val="solid"/>
+                      <a:round/>
+                      <a:headEnd type="none" w="med" len="med"/>
+                      <a:tailEnd type="none" w="med" len="med"/>
+                    </a:lnB>
+                  </a:tcPr>
+                </a:tc>
+                <a:tc>
+                  <a:txBody>
+                    <a:bodyPr/>
+                    <a:lstStyle/>
+                    <a:p>
+                      <a:pPr indent="0" marL="0">
+                        <a:buNone/>
+                      </a:pPr>
+                      <a:r>
+                        <a:rPr lang="en-US" sz="900" b="1" dirty="0">
+                          <a:solidFill>
+                            <a:srgbClr val="1D1B18"/>
+                          </a:solidFill>
+                          <a:latin typeface="Arial" pitchFamily="34" charset="0"/>
+                          <a:ea typeface="Arial" pitchFamily="34" charset="-122"/>
+                          <a:cs typeface="Arial" pitchFamily="34" charset="-120"/>
+                        </a:rPr>
+                        <a:t>SQLite for records and memory</a:t>
+                      </a:r>
+                      <a:endParaRPr lang="en-US" sz="900" dirty="0">
+                        <a:latin typeface="Arial" charset="0"/>
+                        <a:ea typeface="Arial" charset="0"/>
+                        <a:cs typeface="Arial" charset="0"/>
+                      </a:endParaRPr>
+                    </a:p>
+                  </a:txBody>
+                  <a:tcPr marL="0" marR="50800" marT="25400" marB="25400" anchor="ctr">
+                    <a:lnL w="0" cap="flat" cmpd="sng" algn="ctr">
+                      <a:noFill/>
+                    </a:lnL>
+                    <a:lnR w="0" cap="flat" cmpd="sng" algn="ctr">
+                      <a:noFill/>
+                    </a:lnR>
+                    <a:lnT w="0" cap="flat" cmpd="sng" algn="ctr">
+                      <a:noFill/>
+                    </a:lnT>
+                    <a:lnB w="9525" cap="flat" cmpd="sng" algn="ctr">
+                      <a:solidFill>
+                        <a:srgbClr val="E4DDD0"/>
+                      </a:solidFill>
+                      <a:prstDash val="solid"/>
+                      <a:round/>
+                      <a:headEnd type="none" w="med" len="med"/>
+                      <a:tailEnd type="none" w="med" len="med"/>
+                    </a:lnB>
+                  </a:tcPr>
+                </a:tc>
+                <a:tc>
+                  <a:txBody>
+                    <a:bodyPr/>
+                    <a:lstStyle/>
+                    <a:p>
+                      <a:pPr indent="0" marL="0">
+                        <a:buNone/>
+                      </a:pPr>
+                      <a:r>
+                        <a:rPr lang="en-US" sz="900" dirty="0">
+                          <a:solidFill>
+                            <a:srgbClr val="6B665D"/>
+                          </a:solidFill>
+                          <a:latin typeface="Arial" pitchFamily="34" charset="0"/>
+                          <a:ea typeface="Arial" pitchFamily="34" charset="-122"/>
+                          <a:cs typeface="Arial" pitchFamily="34" charset="-120"/>
+                        </a:rPr>
+                        <a:t>A vector store</a:t>
+                      </a:r>
+                      <a:endParaRPr lang="en-US" sz="900" dirty="0">
+                        <a:latin typeface="Arial" charset="0"/>
+                        <a:ea typeface="Arial" charset="0"/>
+                        <a:cs typeface="Arial" charset="0"/>
+                      </a:endParaRPr>
+                    </a:p>
+                  </a:txBody>
+                  <a:tcPr marL="0" marR="50800" marT="25400" marB="25400" anchor="ctr">
+                    <a:lnL w="0" cap="flat" cmpd="sng" algn="ctr">
+                      <a:noFill/>
+                    </a:lnL>
+                    <a:lnR w="0" cap="flat" cmpd="sng" algn="ctr">
+                      <a:noFill/>
+                    </a:lnR>
+                    <a:lnT w="0" cap="flat" cmpd="sng" algn="ctr">
+                      <a:noFill/>
+                    </a:lnT>
+                    <a:lnB w="9525" cap="flat" cmpd="sng" algn="ctr">
+                      <a:solidFill>
+                        <a:srgbClr val="E4DDD0"/>
+                      </a:solidFill>
+                      <a:prstDash val="solid"/>
+                      <a:round/>
+                      <a:headEnd type="none" w="med" len="med"/>
+                      <a:tailEnd type="none" w="med" len="med"/>
+                    </a:lnB>
+                  </a:tcPr>
+                </a:tc>
+                <a:tc>
+                  <a:txBody>
+                    <a:bodyPr/>
+                    <a:lstStyle/>
+                    <a:p>
+                      <a:pPr indent="0" marL="0">
+                        <a:buNone/>
+                      </a:pPr>
+                      <a:r>
+                        <a:rPr lang="en-US" sz="900" dirty="0">
+                          <a:solidFill>
+                            <a:srgbClr val="4A463F"/>
+                          </a:solidFill>
+                          <a:latin typeface="Arial" pitchFamily="34" charset="0"/>
+                          <a:ea typeface="Arial" pitchFamily="34" charset="-122"/>
+                          <a:cs typeface="Arial" pitchFamily="34" charset="-120"/>
+                        </a:rPr>
+                        <a:t>A rule must apply exactly, with who said it, and be auditable in one local file</a:t>
+                      </a:r>
+                      <a:endParaRPr lang="en-US" sz="900" dirty="0">
+                        <a:latin typeface="Arial" charset="0"/>
+                        <a:ea typeface="Arial" charset="0"/>
+                        <a:cs typeface="Arial" charset="0"/>
+                      </a:endParaRPr>
+                    </a:p>
+                  </a:txBody>
+                  <a:tcPr marL="0" marR="50800" marT="25400" marB="25400" anchor="ctr">
+                    <a:lnL w="0" cap="flat" cmpd="sng" algn="ctr">
+                      <a:noFill/>
+                    </a:lnL>
+                    <a:lnR w="0" cap="flat" cmpd="sng" algn="ctr">
+                      <a:noFill/>
+                    </a:lnR>
+                    <a:lnT w="0" cap="flat" cmpd="sng" algn="ctr">
+                      <a:noFill/>
+                    </a:lnT>
+                    <a:lnB w="9525" cap="flat" cmpd="sng" algn="ctr">
+                      <a:solidFill>
+                        <a:srgbClr val="E4DDD0"/>
+                      </a:solidFill>
+                      <a:prstDash val="solid"/>
+                      <a:round/>
+                      <a:headEnd type="none" w="med" len="med"/>
+                      <a:tailEnd type="none" w="med" len="med"/>
+                    </a:lnB>
+                  </a:tcPr>
+                </a:tc>
+              </a:tr>
+              <a:tr h="365760">
+                <a:tc>
+                  <a:txBody>
+                    <a:bodyPr/>
+                    <a:lstStyle/>
+                    <a:p>
+                      <a:pPr indent="0" marL="0">
+                        <a:buNone/>
+                      </a:pPr>
+                      <a:r>
+                        <a:rPr lang="en-US" sz="700" b="1" spc="150" kern="0" dirty="0">
+                          <a:solidFill>
+                            <a:srgbClr val="7D5E30"/>
+                          </a:solidFill>
+                          <a:latin typeface="Arial" pitchFamily="34" charset="0"/>
+                          <a:ea typeface="Arial" pitchFamily="34" charset="-122"/>
+                          <a:cs typeface="Arial" pitchFamily="34" charset="-120"/>
+                        </a:rPr>
+                        <a:t>TOOLS</a:t>
+                      </a:r>
+                      <a:endParaRPr lang="en-US" sz="700" dirty="0">
+                        <a:latin typeface="Arial" charset="0"/>
+                        <a:ea typeface="Arial" charset="0"/>
+                        <a:cs typeface="Arial" charset="0"/>
+                      </a:endParaRPr>
+                    </a:p>
+                  </a:txBody>
+                  <a:tcPr marL="0" marR="50800" marT="25400" marB="25400" anchor="ctr">
+                    <a:lnL w="0" cap="flat" cmpd="sng" algn="ctr">
+                      <a:noFill/>
+                    </a:lnL>
+                    <a:lnR w="0" cap="flat" cmpd="sng" algn="ctr">
+                      <a:noFill/>
+                    </a:lnR>
+                    <a:lnT w="0" cap="flat" cmpd="sng" algn="ctr">
+                      <a:noFill/>
+                    </a:lnT>
+                    <a:lnB w="9525" cap="flat" cmpd="sng" algn="ctr">
+                      <a:solidFill>
+                        <a:srgbClr val="E4DDD0"/>
+                      </a:solidFill>
+                      <a:prstDash val="solid"/>
+                      <a:round/>
+                      <a:headEnd type="none" w="med" len="med"/>
+                      <a:tailEnd type="none" w="med" len="med"/>
+                    </a:lnB>
+                  </a:tcPr>
+                </a:tc>
+                <a:tc>
+                  <a:txBody>
+                    <a:bodyPr/>
+                    <a:lstStyle/>
+                    <a:p>
+                      <a:pPr indent="0" marL="0">
+                        <a:buNone/>
+                      </a:pPr>
+                      <a:r>
+                        <a:rPr lang="en-US" sz="900" b="1" dirty="0">
+                          <a:solidFill>
+                            <a:srgbClr val="1D1B18"/>
+                          </a:solidFill>
+                          <a:latin typeface="Arial" pitchFamily="34" charset="0"/>
+                          <a:ea typeface="Arial" pitchFamily="34" charset="-122"/>
+                          <a:cs typeface="Arial" pitchFamily="34" charset="-120"/>
+                        </a:rPr>
+                        <a:t>The course's eligible_workshops()</a:t>
+                      </a:r>
+                      <a:endParaRPr lang="en-US" sz="900" dirty="0">
+                        <a:latin typeface="Arial" charset="0"/>
+                        <a:ea typeface="Arial" charset="0"/>
+                        <a:cs typeface="Arial" charset="0"/>
+                      </a:endParaRPr>
+                    </a:p>
+                  </a:txBody>
+                  <a:tcPr marL="0" marR="50800" marT="25400" marB="25400" anchor="ctr">
+                    <a:lnL w="0" cap="flat" cmpd="sng" algn="ctr">
+                      <a:noFill/>
+                    </a:lnL>
+                    <a:lnR w="0" cap="flat" cmpd="sng" algn="ctr">
+                      <a:noFill/>
+                    </a:lnR>
+                    <a:lnT w="0" cap="flat" cmpd="sng" algn="ctr">
+                      <a:noFill/>
+                    </a:lnT>
+                    <a:lnB w="9525" cap="flat" cmpd="sng" algn="ctr">
+                      <a:solidFill>
+                        <a:srgbClr val="E4DDD0"/>
+                      </a:solidFill>
+                      <a:prstDash val="solid"/>
+                      <a:round/>
+                      <a:headEnd type="none" w="med" len="med"/>
+                      <a:tailEnd type="none" w="med" len="med"/>
+                    </a:lnB>
+                  </a:tcPr>
+                </a:tc>
+                <a:tc>
+                  <a:txBody>
+                    <a:bodyPr/>
+                    <a:lstStyle/>
+                    <a:p>
+                      <a:pPr indent="0" marL="0">
+                        <a:buNone/>
+                      </a:pPr>
+                      <a:r>
+                        <a:rPr lang="en-US" sz="900" dirty="0">
+                          <a:solidFill>
+                            <a:srgbClr val="6B665D"/>
+                          </a:solidFill>
+                          <a:latin typeface="Arial" pitchFamily="34" charset="0"/>
+                          <a:ea typeface="Arial" pitchFamily="34" charset="-122"/>
+                          <a:cs typeface="Arial" pitchFamily="34" charset="-120"/>
+                        </a:rPr>
+                        <a:t>Our own eligibility rule</a:t>
+                      </a:r>
+                      <a:endParaRPr lang="en-US" sz="900" dirty="0">
+                        <a:latin typeface="Arial" charset="0"/>
+                        <a:ea typeface="Arial" charset="0"/>
+                        <a:cs typeface="Arial" charset="0"/>
+                      </a:endParaRPr>
+                    </a:p>
+                  </a:txBody>
+                  <a:tcPr marL="0" marR="50800" marT="25400" marB="25400" anchor="ctr">
+                    <a:lnL w="0" cap="flat" cmpd="sng" algn="ctr">
+                      <a:noFill/>
+                    </a:lnL>
+                    <a:lnR w="0" cap="flat" cmpd="sng" algn="ctr">
+                      <a:noFill/>
+                    </a:lnR>
+                    <a:lnT w="0" cap="flat" cmpd="sng" algn="ctr">
+                      <a:noFill/>
+                    </a:lnT>
+                    <a:lnB w="9525" cap="flat" cmpd="sng" algn="ctr">
+                      <a:solidFill>
+                        <a:srgbClr val="E4DDD0"/>
+                      </a:solidFill>
+                      <a:prstDash val="solid"/>
+                      <a:round/>
+                      <a:headEnd type="none" w="med" len="med"/>
+                      <a:tailEnd type="none" w="med" len="med"/>
+                    </a:lnB>
+                  </a:tcPr>
+                </a:tc>
+                <a:tc>
+                  <a:txBody>
+                    <a:bodyPr/>
+                    <a:lstStyle/>
+                    <a:p>
+                      <a:pPr indent="0" marL="0">
+                        <a:buNone/>
+                      </a:pPr>
+                      <a:r>
+                        <a:rPr lang="en-US" sz="900" dirty="0">
+                          <a:solidFill>
+                            <a:srgbClr val="4A463F"/>
+                          </a:solidFill>
+                          <a:latin typeface="Arial" pitchFamily="34" charset="0"/>
+                          <a:ea typeface="Arial" pitchFamily="34" charset="-122"/>
+                          <a:cs typeface="Arial" pitchFamily="34" charset="-120"/>
+                        </a:rPr>
+                        <a:t>Our checks and the course simulator can never disagree</a:t>
+                      </a:r>
+                      <a:endParaRPr lang="en-US" sz="900" dirty="0">
+                        <a:latin typeface="Arial" charset="0"/>
+                        <a:ea typeface="Arial" charset="0"/>
+                        <a:cs typeface="Arial" charset="0"/>
+                      </a:endParaRPr>
+                    </a:p>
+                  </a:txBody>
+                  <a:tcPr marL="0" marR="50800" marT="25400" marB="25400" anchor="ctr">
+                    <a:lnL w="0" cap="flat" cmpd="sng" algn="ctr">
+                      <a:noFill/>
+                    </a:lnL>
+                    <a:lnR w="0" cap="flat" cmpd="sng" algn="ctr">
+                      <a:noFill/>
+                    </a:lnR>
+                    <a:lnT w="0" cap="flat" cmpd="sng" algn="ctr">
+                      <a:noFill/>
+                    </a:lnT>
+                    <a:lnB w="9525" cap="flat" cmpd="sng" algn="ctr">
+                      <a:solidFill>
+                        <a:srgbClr val="E4DDD0"/>
+                      </a:solidFill>
+                      <a:prstDash val="solid"/>
+                      <a:round/>
+                      <a:headEnd type="none" w="med" len="med"/>
+                      <a:tailEnd type="none" w="med" len="med"/>
+                    </a:lnB>
+                  </a:tcPr>
+                </a:tc>
+              </a:tr>
+              <a:tr h="365760">
+                <a:tc>
+                  <a:txBody>
+                    <a:bodyPr/>
+                    <a:lstStyle/>
+                    <a:p>
+                      <a:pPr indent="0" marL="0">
+                        <a:buNone/>
+                      </a:pPr>
+                      <a:r>
+                        <a:rPr lang="en-US" sz="700" b="1" spc="150" kern="0" dirty="0">
+                          <a:solidFill>
+                            <a:srgbClr val="7D5E30"/>
+                          </a:solidFill>
+                          <a:latin typeface="Arial" pitchFamily="34" charset="0"/>
+                          <a:ea typeface="Arial" pitchFamily="34" charset="-122"/>
+                          <a:cs typeface="Arial" pitchFamily="34" charset="-120"/>
+                        </a:rPr>
+                        <a:t>REPLIES</a:t>
+                      </a:r>
+                      <a:endParaRPr lang="en-US" sz="700" dirty="0">
+                        <a:latin typeface="Arial" charset="0"/>
+                        <a:ea typeface="Arial" charset="0"/>
+                        <a:cs typeface="Arial" charset="0"/>
+                      </a:endParaRPr>
+                    </a:p>
+                  </a:txBody>
+                  <a:tcPr marL="0" marR="50800" marT="25400" marB="25400" anchor="ctr">
+                    <a:lnL w="0" cap="flat" cmpd="sng" algn="ctr">
+                      <a:noFill/>
+                    </a:lnL>
+                    <a:lnR w="0" cap="flat" cmpd="sng" algn="ctr">
+                      <a:noFill/>
+                    </a:lnR>
+                    <a:lnT w="0" cap="flat" cmpd="sng" algn="ctr">
+                      <a:noFill/>
+                    </a:lnT>
+                    <a:lnB w="9525" cap="flat" cmpd="sng" algn="ctr">
+                      <a:solidFill>
+                        <a:srgbClr val="E4DDD0"/>
+                      </a:solidFill>
+                      <a:prstDash val="solid"/>
+                      <a:round/>
+                      <a:headEnd type="none" w="med" len="med"/>
+                      <a:tailEnd type="none" w="med" len="med"/>
+                    </a:lnB>
+                  </a:tcPr>
+                </a:tc>
+                <a:tc>
+                  <a:txBody>
+                    <a:bodyPr/>
+                    <a:lstStyle/>
+                    <a:p>
+                      <a:pPr indent="0" marL="0">
+                        <a:buNone/>
+                      </a:pPr>
+                      <a:r>
+                        <a:rPr lang="en-US" sz="900" b="1" dirty="0">
+                          <a:solidFill>
+                            <a:srgbClr val="1D1B18"/>
+                          </a:solidFill>
+                          <a:latin typeface="Arial" pitchFamily="34" charset="0"/>
+                          <a:ea typeface="Arial" pitchFamily="34" charset="-122"/>
+                          <a:cs typeface="Arial" pitchFamily="34" charset="-120"/>
+                        </a:rPr>
+                        <a:t>Python templates</a:t>
+                      </a:r>
+                      <a:endParaRPr lang="en-US" sz="900" dirty="0">
+                        <a:latin typeface="Arial" charset="0"/>
+                        <a:ea typeface="Arial" charset="0"/>
+                        <a:cs typeface="Arial" charset="0"/>
+                      </a:endParaRPr>
+                    </a:p>
+                  </a:txBody>
+                  <a:tcPr marL="0" marR="50800" marT="25400" marB="25400" anchor="ctr">
+                    <a:lnL w="0" cap="flat" cmpd="sng" algn="ctr">
+                      <a:noFill/>
+                    </a:lnL>
+                    <a:lnR w="0" cap="flat" cmpd="sng" algn="ctr">
+                      <a:noFill/>
+                    </a:lnR>
+                    <a:lnT w="0" cap="flat" cmpd="sng" algn="ctr">
+                      <a:noFill/>
+                    </a:lnT>
+                    <a:lnB w="9525" cap="flat" cmpd="sng" algn="ctr">
+                      <a:solidFill>
+                        <a:srgbClr val="E4DDD0"/>
+                      </a:solidFill>
+                      <a:prstDash val="solid"/>
+                      <a:round/>
+                      <a:headEnd type="none" w="med" len="med"/>
+                      <a:tailEnd type="none" w="med" len="med"/>
+                    </a:lnB>
+                  </a:tcPr>
+                </a:tc>
+                <a:tc>
+                  <a:txBody>
+                    <a:bodyPr/>
+                    <a:lstStyle/>
+                    <a:p>
+                      <a:pPr indent="0" marL="0">
+                        <a:buNone/>
+                      </a:pPr>
+                      <a:r>
+                        <a:rPr lang="en-US" sz="900" dirty="0">
+                          <a:solidFill>
+                            <a:srgbClr val="6B665D"/>
+                          </a:solidFill>
+                          <a:latin typeface="Arial" pitchFamily="34" charset="0"/>
+                          <a:ea typeface="Arial" pitchFamily="34" charset="-122"/>
+                          <a:cs typeface="Arial" pitchFamily="34" charset="-120"/>
+                        </a:rPr>
+                        <a:t>Model-written replies</a:t>
+                      </a:r>
+                      <a:endParaRPr lang="en-US" sz="900" dirty="0">
+                        <a:latin typeface="Arial" charset="0"/>
+                        <a:ea typeface="Arial" charset="0"/>
+                        <a:cs typeface="Arial" charset="0"/>
+                      </a:endParaRPr>
+                    </a:p>
+                  </a:txBody>
+                  <a:tcPr marL="0" marR="50800" marT="25400" marB="25400" anchor="ctr">
+                    <a:lnL w="0" cap="flat" cmpd="sng" algn="ctr">
+                      <a:noFill/>
+                    </a:lnL>
+                    <a:lnR w="0" cap="flat" cmpd="sng" algn="ctr">
+                      <a:noFill/>
+                    </a:lnR>
+                    <a:lnT w="0" cap="flat" cmpd="sng" algn="ctr">
+                      <a:noFill/>
+                    </a:lnT>
+                    <a:lnB w="9525" cap="flat" cmpd="sng" algn="ctr">
+                      <a:solidFill>
+                        <a:srgbClr val="E4DDD0"/>
+                      </a:solidFill>
+                      <a:prstDash val="solid"/>
+                      <a:round/>
+                      <a:headEnd type="none" w="med" len="med"/>
+                      <a:tailEnd type="none" w="med" len="med"/>
+                    </a:lnB>
+                  </a:tcPr>
+                </a:tc>
+                <a:tc>
+                  <a:txBody>
+                    <a:bodyPr/>
+                    <a:lstStyle/>
+                    <a:p>
+                      <a:pPr indent="0" marL="0">
+                        <a:buNone/>
+                      </a:pPr>
+                      <a:r>
+                        <a:rPr lang="en-US" sz="900" dirty="0">
+                          <a:solidFill>
+                            <a:srgbClr val="4A463F"/>
+                          </a:solidFill>
+                          <a:latin typeface="Arial" pitchFamily="34" charset="0"/>
+                          <a:ea typeface="Arial" pitchFamily="34" charset="-122"/>
+                          <a:cs typeface="Arial" pitchFamily="34" charset="-120"/>
+                        </a:rPr>
+                        <a:t>No model arithmetic: dates and costs are copied from tool outputs</a:t>
+                      </a:r>
+                      <a:endParaRPr lang="en-US" sz="900" dirty="0">
+                        <a:latin typeface="Arial" charset="0"/>
+                        <a:ea typeface="Arial" charset="0"/>
+                        <a:cs typeface="Arial" charset="0"/>
+                      </a:endParaRPr>
+                    </a:p>
+                  </a:txBody>
+                  <a:tcPr marL="0" marR="50800" marT="25400" marB="25400" anchor="ctr">
+                    <a:lnL w="0" cap="flat" cmpd="sng" algn="ctr">
+                      <a:noFill/>
+                    </a:lnL>
+                    <a:lnR w="0" cap="flat" cmpd="sng" algn="ctr">
+                      <a:noFill/>
+                    </a:lnR>
+                    <a:lnT w="0" cap="flat" cmpd="sng" algn="ctr">
+                      <a:noFill/>
+                    </a:lnT>
+                    <a:lnB w="9525" cap="flat" cmpd="sng" algn="ctr">
+                      <a:solidFill>
+                        <a:srgbClr val="E4DDD0"/>
+                      </a:solidFill>
+                      <a:prstDash val="solid"/>
+                      <a:round/>
+                      <a:headEnd type="none" w="med" len="med"/>
+                      <a:tailEnd type="none" w="med" len="med"/>
+                    </a:lnB>
+                  </a:tcPr>
+                </a:tc>
+              </a:tr>
+              <a:tr h="365760">
+                <a:tc>
+                  <a:txBody>
+                    <a:bodyPr/>
+                    <a:lstStyle/>
+                    <a:p>
+                      <a:pPr indent="0" marL="0">
+                        <a:buNone/>
+                      </a:pPr>
+                      <a:r>
+                        <a:rPr lang="en-US" sz="700" b="1" spc="150" kern="0" dirty="0">
+                          <a:solidFill>
+                            <a:srgbClr val="7D5E30"/>
+                          </a:solidFill>
+                          <a:latin typeface="Arial" pitchFamily="34" charset="0"/>
+                          <a:ea typeface="Arial" pitchFamily="34" charset="-122"/>
+                          <a:cs typeface="Arial" pitchFamily="34" charset="-120"/>
+                        </a:rPr>
+                        <a:t>SPEECH</a:t>
+                      </a:r>
+                      <a:endParaRPr lang="en-US" sz="700" dirty="0">
+                        <a:latin typeface="Arial" charset="0"/>
+                        <a:ea typeface="Arial" charset="0"/>
+                        <a:cs typeface="Arial" charset="0"/>
+                      </a:endParaRPr>
+                    </a:p>
+                  </a:txBody>
+                  <a:tcPr marL="0" marR="50800" marT="25400" marB="25400" anchor="ctr">
+                    <a:lnL w="0" cap="flat" cmpd="sng" algn="ctr">
+                      <a:noFill/>
+                    </a:lnL>
+                    <a:lnR w="0" cap="flat" cmpd="sng" algn="ctr">
+                      <a:noFill/>
+                    </a:lnR>
+                    <a:lnT w="0" cap="flat" cmpd="sng" algn="ctr">
+                      <a:noFill/>
+                    </a:lnT>
+                    <a:lnB w="9525" cap="flat" cmpd="sng" algn="ctr">
+                      <a:solidFill>
+                        <a:srgbClr val="E4DDD0"/>
+                      </a:solidFill>
+                      <a:prstDash val="solid"/>
+                      <a:round/>
+                      <a:headEnd type="none" w="med" len="med"/>
+                      <a:tailEnd type="none" w="med" len="med"/>
+                    </a:lnB>
+                  </a:tcPr>
+                </a:tc>
                 <a:tc>
                   <a:txBody>
                     <a:bodyPr/>
@@ -6818,7 +6868,7 @@
                   </a:tcPr>
                 </a:tc>
               </a:tr>
-              <a:tr h="246888">
+              <a:tr h="365760">
                 <a:tc>
                   <a:txBody>
                     <a:bodyPr/>
@@ -6828,17 +6878,17 @@
                         <a:buNone/>
                       </a:pPr>
                       <a:r>
-                        <a:rPr lang="en-US" sz="900" b="1" dirty="0">
+                        <a:rPr lang="en-US" sz="700" b="1" spc="150" kern="0" dirty="0">
                           <a:solidFill>
-                            <a:srgbClr val="1D1B18"/>
+                            <a:srgbClr val="7D5E30"/>
                           </a:solidFill>
                           <a:latin typeface="Arial" pitchFamily="34" charset="0"/>
                           <a:ea typeface="Arial" pitchFamily="34" charset="-122"/>
                           <a:cs typeface="Arial" pitchFamily="34" charset="-120"/>
                         </a:rPr>
-                        <a:t>Python templates for replies</a:t>
+                        <a:t>COMMIT</a:t>
                       </a:r>
-                      <a:endParaRPr lang="en-US" sz="900" dirty="0">
+                      <a:endParaRPr lang="en-US" sz="700" dirty="0">
                         <a:latin typeface="Arial" charset="0"/>
                         <a:ea typeface="Arial" charset="0"/>
                         <a:cs typeface="Arial" charset="0"/>
@@ -6866,245 +6916,6 @@
                     </a:lnB>
                   </a:tcPr>
                 </a:tc>
-                <a:tc>
-                  <a:txBody>
-                    <a:bodyPr/>
-                    <a:lstStyle/>
-                    <a:p>
-                      <a:pPr indent="0" marL="0">
-                        <a:buNone/>
-                      </a:pPr>
-                      <a:r>
-                        <a:rPr lang="en-US" sz="900" dirty="0">
-                          <a:solidFill>
-                            <a:srgbClr val="6B665D"/>
-                          </a:solidFill>
-                          <a:latin typeface="Arial" pitchFamily="34" charset="0"/>
-                          <a:ea typeface="Arial" pitchFamily="34" charset="-122"/>
-                          <a:cs typeface="Arial" pitchFamily="34" charset="-120"/>
-                        </a:rPr>
-                        <a:t>Model-written replies</a:t>
-                      </a:r>
-                      <a:endParaRPr lang="en-US" sz="900" dirty="0">
-                        <a:latin typeface="Arial" charset="0"/>
-                        <a:ea typeface="Arial" charset="0"/>
-                        <a:cs typeface="Arial" charset="0"/>
-                      </a:endParaRPr>
-                    </a:p>
-                  </a:txBody>
-                  <a:tcPr marL="0" marR="50800" marT="25400" marB="25400" anchor="ctr">
-                    <a:lnL w="0" cap="flat" cmpd="sng" algn="ctr">
-                      <a:noFill/>
-                    </a:lnL>
-                    <a:lnR w="0" cap="flat" cmpd="sng" algn="ctr">
-                      <a:noFill/>
-                    </a:lnR>
-                    <a:lnT w="0" cap="flat" cmpd="sng" algn="ctr">
-                      <a:noFill/>
-                    </a:lnT>
-                    <a:lnB w="9525" cap="flat" cmpd="sng" algn="ctr">
-                      <a:solidFill>
-                        <a:srgbClr val="E4DDD0"/>
-                      </a:solidFill>
-                      <a:prstDash val="solid"/>
-                      <a:round/>
-                      <a:headEnd type="none" w="med" len="med"/>
-                      <a:tailEnd type="none" w="med" len="med"/>
-                    </a:lnB>
-                  </a:tcPr>
-                </a:tc>
-                <a:tc>
-                  <a:txBody>
-                    <a:bodyPr/>
-                    <a:lstStyle/>
-                    <a:p>
-                      <a:pPr indent="0" marL="0">
-                        <a:buNone/>
-                      </a:pPr>
-                      <a:r>
-                        <a:rPr lang="en-US" sz="900" dirty="0">
-                          <a:solidFill>
-                            <a:srgbClr val="4A463F"/>
-                          </a:solidFill>
-                          <a:latin typeface="Arial" pitchFamily="34" charset="0"/>
-                          <a:ea typeface="Arial" pitchFamily="34" charset="-122"/>
-                          <a:cs typeface="Arial" pitchFamily="34" charset="-120"/>
-                        </a:rPr>
-                        <a:t>No model arithmetic: dates and costs are copied from tools</a:t>
-                      </a:r>
-                      <a:endParaRPr lang="en-US" sz="900" dirty="0">
-                        <a:latin typeface="Arial" charset="0"/>
-                        <a:ea typeface="Arial" charset="0"/>
-                        <a:cs typeface="Arial" charset="0"/>
-                      </a:endParaRPr>
-                    </a:p>
-                  </a:txBody>
-                  <a:tcPr marL="0" marR="50800" marT="25400" marB="25400" anchor="ctr">
-                    <a:lnL w="0" cap="flat" cmpd="sng" algn="ctr">
-                      <a:noFill/>
-                    </a:lnL>
-                    <a:lnR w="0" cap="flat" cmpd="sng" algn="ctr">
-                      <a:noFill/>
-                    </a:lnR>
-                    <a:lnT w="0" cap="flat" cmpd="sng" algn="ctr">
-                      <a:noFill/>
-                    </a:lnT>
-                    <a:lnB w="9525" cap="flat" cmpd="sng" algn="ctr">
-                      <a:solidFill>
-                        <a:srgbClr val="E4DDD0"/>
-                      </a:solidFill>
-                      <a:prstDash val="solid"/>
-                      <a:round/>
-                      <a:headEnd type="none" w="med" len="med"/>
-                      <a:tailEnd type="none" w="med" len="med"/>
-                    </a:lnB>
-                  </a:tcPr>
-                </a:tc>
-              </a:tr>
-              <a:tr h="246888">
-                <a:tc>
-                  <a:txBody>
-                    <a:bodyPr/>
-                    <a:lstStyle/>
-                    <a:p>
-                      <a:pPr indent="0" marL="0">
-                        <a:buNone/>
-                      </a:pPr>
-                      <a:r>
-                        <a:rPr lang="en-US" sz="900" b="1" dirty="0">
-                          <a:solidFill>
-                            <a:srgbClr val="1D1B18"/>
-                          </a:solidFill>
-                          <a:latin typeface="Arial" pitchFamily="34" charset="0"/>
-                          <a:ea typeface="Arial" pitchFamily="34" charset="-122"/>
-                          <a:cs typeface="Arial" pitchFamily="34" charset="-120"/>
-                        </a:rPr>
-                        <a:t>Exact rules in SQLite</a:t>
-                      </a:r>
-                      <a:endParaRPr lang="en-US" sz="900" dirty="0">
-                        <a:latin typeface="Arial" charset="0"/>
-                        <a:ea typeface="Arial" charset="0"/>
-                        <a:cs typeface="Arial" charset="0"/>
-                      </a:endParaRPr>
-                    </a:p>
-                  </a:txBody>
-                  <a:tcPr marL="0" marR="50800" marT="25400" marB="25400" anchor="ctr">
-                    <a:lnL w="0" cap="flat" cmpd="sng" algn="ctr">
-                      <a:noFill/>
-                    </a:lnL>
-                    <a:lnR w="0" cap="flat" cmpd="sng" algn="ctr">
-                      <a:noFill/>
-                    </a:lnR>
-                    <a:lnT w="0" cap="flat" cmpd="sng" algn="ctr">
-                      <a:noFill/>
-                    </a:lnT>
-                    <a:lnB w="9525" cap="flat" cmpd="sng" algn="ctr">
-                      <a:solidFill>
-                        <a:srgbClr val="E4DDD0"/>
-                      </a:solidFill>
-                      <a:prstDash val="solid"/>
-                      <a:round/>
-                      <a:headEnd type="none" w="med" len="med"/>
-                      <a:tailEnd type="none" w="med" len="med"/>
-                    </a:lnB>
-                  </a:tcPr>
-                </a:tc>
-                <a:tc>
-                  <a:txBody>
-                    <a:bodyPr/>
-                    <a:lstStyle/>
-                    <a:p>
-                      <a:pPr indent="0" marL="0">
-                        <a:buNone/>
-                      </a:pPr>
-                      <a:r>
-                        <a:rPr lang="en-US" sz="900" dirty="0">
-                          <a:solidFill>
-                            <a:srgbClr val="6B665D"/>
-                          </a:solidFill>
-                          <a:latin typeface="Arial" pitchFamily="34" charset="0"/>
-                          <a:ea typeface="Arial" pitchFamily="34" charset="-122"/>
-                          <a:cs typeface="Arial" pitchFamily="34" charset="-120"/>
-                        </a:rPr>
-                        <a:t>A vector-store memory</a:t>
-                      </a:r>
-                      <a:endParaRPr lang="en-US" sz="900" dirty="0">
-                        <a:latin typeface="Arial" charset="0"/>
-                        <a:ea typeface="Arial" charset="0"/>
-                        <a:cs typeface="Arial" charset="0"/>
-                      </a:endParaRPr>
-                    </a:p>
-                  </a:txBody>
-                  <a:tcPr marL="0" marR="50800" marT="25400" marB="25400" anchor="ctr">
-                    <a:lnL w="0" cap="flat" cmpd="sng" algn="ctr">
-                      <a:noFill/>
-                    </a:lnL>
-                    <a:lnR w="0" cap="flat" cmpd="sng" algn="ctr">
-                      <a:noFill/>
-                    </a:lnR>
-                    <a:lnT w="0" cap="flat" cmpd="sng" algn="ctr">
-                      <a:noFill/>
-                    </a:lnT>
-                    <a:lnB w="9525" cap="flat" cmpd="sng" algn="ctr">
-                      <a:solidFill>
-                        <a:srgbClr val="E4DDD0"/>
-                      </a:solidFill>
-                      <a:prstDash val="solid"/>
-                      <a:round/>
-                      <a:headEnd type="none" w="med" len="med"/>
-                      <a:tailEnd type="none" w="med" len="med"/>
-                    </a:lnB>
-                  </a:tcPr>
-                </a:tc>
-                <a:tc>
-                  <a:txBody>
-                    <a:bodyPr/>
-                    <a:lstStyle/>
-                    <a:p>
-                      <a:pPr indent="0" marL="0">
-                        <a:buNone/>
-                      </a:pPr>
-                      <a:r>
-                        <a:rPr lang="en-US" sz="900" dirty="0">
-                          <a:solidFill>
-                            <a:srgbClr val="4A463F"/>
-                          </a:solidFill>
-                          <a:latin typeface="Arial" pitchFamily="34" charset="0"/>
-                          <a:ea typeface="Arial" pitchFamily="34" charset="-122"/>
-                          <a:cs typeface="Arial" pitchFamily="34" charset="-120"/>
-                        </a:rPr>
-                        <a:t>A constraint must apply exactly, with who said it, and be auditable</a:t>
-                      </a:r>
-                      <a:endParaRPr lang="en-US" sz="900" dirty="0">
-                        <a:latin typeface="Arial" charset="0"/>
-                        <a:ea typeface="Arial" charset="0"/>
-                        <a:cs typeface="Arial" charset="0"/>
-                      </a:endParaRPr>
-                    </a:p>
-                  </a:txBody>
-                  <a:tcPr marL="0" marR="50800" marT="25400" marB="25400" anchor="ctr">
-                    <a:lnL w="0" cap="flat" cmpd="sng" algn="ctr">
-                      <a:noFill/>
-                    </a:lnL>
-                    <a:lnR w="0" cap="flat" cmpd="sng" algn="ctr">
-                      <a:noFill/>
-                    </a:lnR>
-                    <a:lnT w="0" cap="flat" cmpd="sng" algn="ctr">
-                      <a:noFill/>
-                    </a:lnT>
-                    <a:lnB w="9525" cap="flat" cmpd="sng" algn="ctr">
-                      <a:solidFill>
-                        <a:srgbClr val="E4DDD0"/>
-                      </a:solidFill>
-                      <a:prstDash val="solid"/>
-                      <a:round/>
-                      <a:headEnd type="none" w="med" len="med"/>
-                      <a:tailEnd type="none" w="med" len="med"/>
-                    </a:lnB>
-                  </a:tcPr>
-                </a:tc>
-              </a:tr>
-              <a:tr h="246888">
                 <a:tc>
                   <a:txBody>
                     <a:bodyPr/>
@@ -7253,6 +7064,45 @@
       </p:graphicFrame>
       <p:sp>
         <p:nvSpPr>
+          <p:cNvPr id="5" name="Text 2"/>
+          <p:cNvSpPr txBox="1"/>
+          <p:nvPr/>
+        </p:nvSpPr>
+        <p:spPr>
+          <a:xfrm>
+            <a:off x="548640" y="4572000"/>
+            <a:ext cx="8046720" cy="182880"/>
+          </a:xfrm>
+          <a:prstGeom prst="rect">
+            <a:avLst/>
+          </a:prstGeom>
+          <a:noFill/>
+          <a:ln/>
+        </p:spPr>
+        <p:txBody>
+          <a:bodyPr wrap="square" lIns="0" tIns="0" rIns="0" bIns="0" rtlCol="0" anchor="t"/>
+          <a:lstStyle/>
+          <a:p>
+            <a:pPr indent="0" marL="0">
+              <a:buNone/>
+            </a:pPr>
+            <a:r>
+              <a:rPr lang="en-US" sz="700" i="1" dirty="0">
+                <a:solidFill>
+                  <a:srgbClr val="6B665D"/>
+                </a:solidFill>
+                <a:latin typeface="Arial" pitchFamily="34" charset="0"/>
+                <a:ea typeface="Arial" pitchFamily="34" charset="-122"/>
+                <a:cs typeface="Arial" pitchFamily="34" charset="-120"/>
+              </a:rPr>
+              <a:t>Trust boundary: the model call is the only thing that leaves the machine. It never sees costs, queues or defect rates.</a:t>
+            </a:r>
+            <a:endParaRPr lang="en-US" sz="700" dirty="0"/>
+          </a:p>
+        </p:txBody>
+      </p:sp>
+      <p:sp>
+        <p:nvSpPr>
           <p:cNvPr id="25" name="Slide Number Placeholder 0"/>
           <p:cNvSpPr>
             <a:spLocks noGrp="1"/>
@@ -7293,7 +7143,7 @@
             <a:pPr algn="r"/>
             <a:fld id="{F7021451-1387-4CA6-816F-3879F97B5CBC}" type="slidenum">
               <a:rPr b="0" lang="en-US"/>
-              <a:t>4</a:t>
+              <a:t>5</a:t>
             </a:fld>
             <a:endParaRPr lang="en-US"/>
           </a:p>
@@ -7307,9 +7157,9 @@
 </p:sld>
 </file>
 
-<file path=ppt/slides/slide5.xml><?xml version="1.0" encoding="utf-8"?>
+<file path=ppt/slides/slide6.xml><?xml version="1.0" encoding="utf-8"?>
 <p:sld xmlns:a="http://schemas.openxmlformats.org/drawingml/2006/main" xmlns:r="http://schemas.openxmlformats.org/officeDocument/2006/relationships" xmlns:p="http://schemas.openxmlformats.org/presentationml/2006/main">
-  <p:cSld name="Slide 5">
+  <p:cSld name="Slide 6">
     <p:spTree>
       <p:nvGrpSpPr>
         <p:cNvPr id="1" name=""/>
@@ -7357,7 +7207,7 @@
                 <a:ea typeface="Arial" pitchFamily="34" charset="-122"/>
                 <a:cs typeface="Arial" pitchFamily="34" charset="-120"/>
               </a:rPr>
-              <a:t>05   </a:t>
+              <a:t>06   </a:t>
             </a:r>
             <a:r>
               <a:rPr lang="en-US" sz="850" b="1" spc="300" kern="0" dirty="0">
@@ -7636,7 +7486,7 @@
       </p:sp>
       <p:graphicFrame>
         <p:nvGraphicFramePr>
-          <p:cNvPr id="6" name="Table 0"/>
+          <p:cNvPr id="7" name="Table 0"/>
           <p:cNvGraphicFramePr>
             <a:graphicFrameLocks noGrp="1"/>
           </p:cNvGraphicFramePr>
@@ -9462,7 +9312,7 @@
             <a:pPr algn="r"/>
             <a:fld id="{F7021451-1387-4CA6-816F-3879F97B5CBC}" type="slidenum">
               <a:rPr b="0" lang="en-US"/>
-              <a:t>5</a:t>
+              <a:t>6</a:t>
             </a:fld>
             <a:endParaRPr lang="en-US"/>
           </a:p>
@@ -9476,9 +9326,9 @@
 </p:sld>
 </file>
 
-<file path=ppt/slides/slide6.xml><?xml version="1.0" encoding="utf-8"?>
+<file path=ppt/slides/slide7.xml><?xml version="1.0" encoding="utf-8"?>
 <p:sld xmlns:a="http://schemas.openxmlformats.org/drawingml/2006/main" xmlns:r="http://schemas.openxmlformats.org/officeDocument/2006/relationships" xmlns:p="http://schemas.openxmlformats.org/presentationml/2006/main">
-  <p:cSld name="Slide 6">
+  <p:cSld name="Slide 7">
     <p:spTree>
       <p:nvGrpSpPr>
         <p:cNvPr id="1" name=""/>
@@ -9526,7 +9376,7 @@
                 <a:ea typeface="Arial" pitchFamily="34" charset="-122"/>
                 <a:cs typeface="Arial" pitchFamily="34" charset="-120"/>
               </a:rPr>
-              <a:t>06   </a:t>
+              <a:t>07   </a:t>
             </a:r>
             <a:r>
               <a:rPr lang="en-US" sz="850" b="1" spc="300" kern="0" dirty="0">
@@ -9857,7 +9707,7 @@
       </p:sp>
       <p:graphicFrame>
         <p:nvGraphicFramePr>
-          <p:cNvPr id="7" name="Table 0"/>
+          <p:cNvPr id="8" name="Table 0"/>
           <p:cNvGraphicFramePr>
             <a:graphicFrameLocks noGrp="1"/>
           </p:cNvGraphicFramePr>
@@ -11297,7 +11147,7 @@
             <a:pPr algn="r"/>
             <a:fld id="{F7021451-1387-4CA6-816F-3879F97B5CBC}" type="slidenum">
               <a:rPr b="0" lang="en-US"/>
-              <a:t>6</a:t>
+              <a:t>7</a:t>
             </a:fld>
             <a:endParaRPr lang="en-US"/>
           </a:p>
@@ -11311,9 +11161,9 @@
 </p:sld>
 </file>
 
-<file path=ppt/slides/slide7.xml><?xml version="1.0" encoding="utf-8"?>
+<file path=ppt/slides/slide8.xml><?xml version="1.0" encoding="utf-8"?>
 <p:sld xmlns:a="http://schemas.openxmlformats.org/drawingml/2006/main" xmlns:r="http://schemas.openxmlformats.org/officeDocument/2006/relationships" xmlns:p="http://schemas.openxmlformats.org/presentationml/2006/main">
-  <p:cSld name="Slide 7">
+  <p:cSld name="Slide 8">
     <p:spTree>
       <p:nvGrpSpPr>
         <p:cNvPr id="1" name=""/>
@@ -11361,7 +11211,7 @@
                 <a:ea typeface="Arial" pitchFamily="34" charset="-122"/>
                 <a:cs typeface="Arial" pitchFamily="34" charset="-120"/>
               </a:rPr>
-              <a:t>07   </a:t>
+              <a:t>08   </a:t>
             </a:r>
             <a:r>
               <a:rPr lang="en-US" sz="850" b="1" spc="300" kern="0" dirty="0">
@@ -12002,9 +11852,9 @@
 </p:sld>
 </file>
 
-<file path=ppt/slides/slide8.xml><?xml version="1.0" encoding="utf-8"?>
+<file path=ppt/slides/slide9.xml><?xml version="1.0" encoding="utf-8"?>
 <p:sld xmlns:a="http://schemas.openxmlformats.org/drawingml/2006/main" xmlns:r="http://schemas.openxmlformats.org/officeDocument/2006/relationships" xmlns:p="http://schemas.openxmlformats.org/presentationml/2006/main">
-  <p:cSld name="Slide 8">
+  <p:cSld name="Slide 9">
     <p:spTree>
       <p:nvGrpSpPr>
         <p:cNvPr id="1" name=""/>

</xml_diff>

<commit_message>
Rewrap two script lines
</commit_message>
<xml_diff>
--- a/docs/slides/Presentation_Group11_Sprint2.pptx
+++ b/docs/slides/Presentation_Group11_Sprint2.pptx
@@ -694,9 +694,10 @@
             <a:r>
               <a:rPr lang="en-US" dirty="0"/>
               <a:t>SLIDE 3 - The user journey (0:45-1:08)  Charles
-"We designed the journey for the floor. The dispatcher holds the mic and says the order. The desk answers
-on screen and out loud: the best workshop, when it arrives, and why. 'Book it' opens a sheet, and
-a slide confirms. It offers to remember the constraint, and uses it on the next order."</a:t>
+"We designed the journey for the floor. The dispatcher holds the mic and says the order. The
+desk answers on screen and out loud: the best workshop, when it arrives, and why. 'Book it' opens
+a sheet, and a slide confirms. It offers to remember the constraint, and uses it on the next
+order."</a:t>
             </a:r>
             <a:endParaRPr lang="en-US" dirty="0"/>
           </a:p>
@@ -1062,10 +1063,9 @@
               <a:rPr lang="en-US" dirty="0"/>
               <a:t>SLIDE 7 - Validation plan (2:13-2:55)  Niyanthri
 "We measure late batches and late days, our primary objective, in the course simulator, with and
-without a closure. Baselines are random, biggest capacity and cheapest, plus earliest
-finish. The minimum is to beat all three
-baselines, and handle all 30 inbox requests. Today: 1.4 percent late against 1.7, and 68 percent
-fewer late days. For language, the 30 inbox requests plus 50 new held-out ones, labelled
+without a closure. Baselines are random, biggest capacity and cheapest, plus earliest finish.
+The minimum is to beat all three baselines, and handle all 30 inbox requests. Today: 1.4 percent
+late against 1.7, and 68 percent fewer late days. For language, the 30 inbox requests plus 50 new held-out ones, labelled
 separately, then agreed. Hard cases: an impossible date, a workshop that can't take it, and a
 misheard order. We give options, refuse with a reason, and read the order back."</a:t>
             </a:r>

</xml_diff>

<commit_message>
Show the 205-request evaluation sets and Joshua's usability test in the deck
</commit_message>
<xml_diff>
--- a/docs/slides/Presentation_Group11_Sprint2.pptx
+++ b/docs/slides/Presentation_Group11_Sprint2.pptx
@@ -969,10 +969,10 @@
           <a:p>
             <a:r>
               <a:rPr lang="en-US" dirty="0"/>
-              <a:t>SLIDE 6 - Progress (1:53-2:13)  Saadhvika
-"Every feature has an owner. Six of eleven are done: the voice assistant, memory, capacity
-questions, the four-objective scorer, the desk redesign and the AWS deployment. In progress:
-clarification fixes, and our evaluation set. Planned: Lynn's live run on the full set, and a
+              <a:t>SLIDE 6 - Progress (1:53-2:11)  Saadhvika
+"Every feature has an owner. Seven of eleven are done, including the voice assistant, memory,
+the four-objective scorer and 205 generated evaluation requests. In progress: clarification
+fixes and independent inbox labels. Planned: Lynn's re-run of the test set, and Joshua's
 usability test."</a:t>
             </a:r>
             <a:endParaRPr lang="en-US" dirty="0"/>
@@ -1061,13 +1061,14 @@
           <a:p>
             <a:r>
               <a:rPr lang="en-US" dirty="0"/>
-              <a:t>SLIDE 7 - Validation plan (2:13-2:55)  Niyanthri
+              <a:t>SLIDE 7 - Validation plan (2:11-2:55)  Niyanthri
 "We measure late batches and late days, our primary objective, in the course simulator, with and
-without a closure. Baselines are random, biggest capacity and cheapest, plus earliest finish.
-The minimum is to beat all three baselines, and handle all 30 inbox requests. Today: 1.4 percent
-late against 1.7, and 68 percent fewer late days. For language, the 30 inbox requests plus 50 new held-out ones, labelled
-separately, then agreed. Hard cases: an impossible date, a workshop that can't take it, and a
-misheard order. We give options, refuse with a reason, and read the order back."</a:t>
+without a closure, against random, biggest capacity, cheapest and earliest finish. The minimum
+is to beat all three baselines and handle all 30 inbox requests. Today: 1.4 percent late against
+1.7, and 68 percent fewer late days. For language: the inbox plus 205 generated requests, 65 held
+out with new wording; 96.9 percent passed on the first live run. Hard cases: an
+impossible date, a workshop that can't take it, and a misheard order. We give options, refuse
+with a reason, and read the order back."</a:t>
             </a:r>
             <a:endParaRPr lang="en-US" dirty="0"/>
           </a:p>
@@ -1287,6 +1288,13 @@
   the dispatcher and says requests from the chat out loud: Mei's R25 and the boss's R14.
 - Why "StitchFlow"? Stitch for garments, flow for orders moving to the right workshop.
   QuickStitch is one of the eight workshops, not us.
+- How was the evaluation set built? 205 requests generated from templates with fixed seeds,
+  across the seven request kinds: 140 train, 65 test, and the test wording never appears in
+  train. Labels come from construction (the generator knows the order, date and constraint it
+  wrote) plus the deterministic dispatch preview, so no model labels them. Results are
+  behaviour-rubric pass rates from one gpt-5.6 run on intake-v2: train 134/140 (95.7%), test
+  63/65 (96.9%). They are not model accuracy. The three original train failures (TR053,
+  TR056, TR059) were an unneeded quantity question blocking a refusal, fixed in intake-v3.
 - Is the demo real time? Yes. It is one take with no cuts; only the start and end are trimmed.
 - Why voice? The track's bonus asks how a dispatcher would really use it: on the floor, on a
   phone. Typing still works everywhere, and the course inbox is still evaluated as text.
@@ -7296,7 +7304,7 @@
                 <a:ea typeface="Georgia" pitchFamily="34" charset="-122"/>
                 <a:cs typeface="Georgia" pitchFamily="34" charset="-120"/>
               </a:rPr>
-              <a:t>6</a:t>
+              <a:t>7</a:t>
             </a:r>
             <a:r>
               <a:rPr lang="en-US" sz="6000" dirty="0">
@@ -7412,7 +7420,7 @@
                 <a:ea typeface="Arial" pitchFamily="34" charset="-122"/>
                 <a:cs typeface="Arial" pitchFamily="34" charset="-120"/>
               </a:rPr>
-              <a:t>3 in progress</a:t>
+              <a:t>2 in progress</a:t>
             </a:r>
             <a:endParaRPr lang="en-US" sz="900" dirty="0"/>
           </a:p>
@@ -8673,7 +8681,7 @@
                           <a:ea typeface="Arial" pitchFamily="34" charset="-122"/>
                           <a:cs typeface="Arial" pitchFamily="34" charset="-120"/>
                         </a:rPr>
-                        <a:t>Evaluation set: 50 new held-out requests, written and labelled</a:t>
+                        <a:t>Evaluation sets: 205 generated requests, 140 train and 65 test</a:t>
                       </a:r>
                       <a:endParaRPr lang="en-US" sz="850" dirty="0">
                         <a:latin typeface="Arial" charset="0"/>
@@ -8761,13 +8769,13 @@
                       <a:r>
                         <a:rPr lang="en-US" sz="850" b="1" dirty="0">
                           <a:solidFill>
-                            <a:srgbClr val="9A6A12"/>
+                            <a:srgbClr val="2F5D46"/>
                           </a:solidFill>
                           <a:latin typeface="Arial" pitchFamily="34" charset="0"/>
                           <a:ea typeface="Arial" pitchFamily="34" charset="-122"/>
                           <a:cs typeface="Arial" pitchFamily="34" charset="-120"/>
                         </a:rPr>
-                        <a:t>In progress</a:t>
+                        <a:t>Done</a:t>
                       </a:r>
                       <a:endParaRPr lang="en-US" sz="850" dirty="0">
                         <a:latin typeface="Arial" charset="0"/>
@@ -8959,7 +8967,7 @@
                           <a:ea typeface="Arial" pitchFamily="34" charset="-122"/>
                           <a:cs typeface="Arial" pitchFamily="34" charset="-120"/>
                         </a:rPr>
-                        <a:t>Live model run on the full evaluation set (30 inbox + 50 new)</a:t>
+                        <a:t>Re-run the 65 test requests on the current intake (v3)</a:t>
                       </a:r>
                       <a:endParaRPr lang="en-US" sz="850" dirty="0">
                         <a:latin typeface="Arial" charset="0"/>
@@ -9143,13 +9151,13 @@
                       <a:r>
                         <a:rPr lang="en-US" sz="850" dirty="0">
                           <a:solidFill>
-                            <a:srgbClr val="8A2C35"/>
+                            <a:srgbClr val="4A463F"/>
                           </a:solidFill>
                           <a:latin typeface="Arial" pitchFamily="34" charset="0"/>
                           <a:ea typeface="Arial" pitchFamily="34" charset="-122"/>
                           <a:cs typeface="Arial" pitchFamily="34" charset="-120"/>
                         </a:rPr>
-                        <a:t>[TBD]</a:t>
+                        <a:t>Joshua Wesley Gloor</a:t>
                       </a:r>
                       <a:endParaRPr lang="en-US" sz="850" dirty="0">
                         <a:latin typeface="Arial" charset="0"/>
@@ -9264,7 +9272,7 @@
                 <a:ea typeface="Arial" pitchFamily="34" charset="-122"/>
                 <a:cs typeface="Arial" pitchFamily="34" charset="-120"/>
               </a:rPr>
-              <a:t>Code: github.com/JoshuaGloor/dss5105-capstone-project (PRs #15 and #18 for this sprint, PR #14 for clarification reliability).</a:t>
+              <a:t>Code: github.com/JoshuaGloor/dss5105-capstone-project. PRs: #15 and #18 this sprint, #16 and #17 evaluation sets, #14 clarification reliability.</a:t>
             </a:r>
             <a:endParaRPr lang="en-US" sz="700" dirty="0"/>
           </a:p>
@@ -9582,7 +9590,7 @@
                 <a:ea typeface="Arial" pitchFamily="34" charset="-122"/>
                 <a:cs typeface="Arial" pitchFamily="34" charset="-120"/>
               </a:rPr>
-              <a:t>All 30 inbox requests, grouped by the 7 kinds in the data dictionary, plus 50 new held-out requests (rewordings, bait items) written and labelled by Saadhvika and Niyanthri. Labels are made separately, then agreed; a model judge counts only where it matches them.</a:t>
+              <a:t>All 30 inbox requests by the 7 kinds in the data dictionary, plus 205 generated by Saadhvika and Niyanthri: 140 to tune on, 65 held out with new wording. Labels come from how each request was built, never from a model. First live run: test 63/65 passed (96.9%), train 134/140 (95.7%).</a:t>
             </a:r>
             <a:endParaRPr lang="en-US" sz="850" dirty="0"/>
           </a:p>
@@ -11099,7 +11107,7 @@
                 <a:ea typeface="Arial" pitchFamily="34" charset="-122"/>
                 <a:cs typeface="Arial" pitchFamily="34" charset="-120"/>
               </a:rPr>
-              <a:t>Presets chosen on development seeds 6000-6029; the course seeds were run twice, as disclosed in docs/OBJECTIVE_STUDY.md.</a:t>
+              <a:t>Allocation: presets chosen on seeds 6000-6029, course seeds run twice (OBJECTIVE_STUDY.md). Language: one gpt-5.6 run; a rubric pass rate, not model accuracy.</a:t>
             </a:r>
             <a:endParaRPr lang="en-US" sz="700" dirty="0"/>
           </a:p>

</xml_diff>

<commit_message>
Script: Charles records the whole demo; slides split among Joshua, Saadhvika and Niyanthri
</commit_message>
<xml_diff>
--- a/docs/slides/Presentation_Group11_Sprint2.pptx
+++ b/docs/slides/Presentation_Group11_Sprint2.pptx
@@ -693,7 +693,7 @@
           <a:p>
             <a:r>
               <a:rPr lang="en-US" dirty="0"/>
-              <a:t>SLIDE 3 - The user journey (0:45-1:08)  Charles
+              <a:t>SLIDE 3 - The user journey (0:45-1:08)  Saadhvika
 "We designed the journey for the floor. The dispatcher holds the mic and says the order. The
 desk answers on screen and out loud: the best workshop, when it arrives, and why. 'Book it' opens
 a sheet, and a slide confirms. It offers to remember the constraint, and uses it on the next
@@ -785,7 +785,7 @@
           <a:p>
             <a:r>
               <a:rPr lang="en-US" dirty="0"/>
-              <a:t>SLIDE 4 - Architecture (1:08-1:35)  Charles
+              <a:t>SLIDE 4 - Architecture (1:08-1:35)  Joshua
 "This is what we built. Speech becomes text in the browser, and Python answers commands like
 'book it' itself. Everything else is one structured-output call, and every field must quote the
 message. Deterministic tools then look up the order, apply remembered rules, check eligibility
@@ -878,7 +878,7 @@
           <a:p>
             <a:r>
               <a:rPr lang="en-US" dirty="0"/>
-              <a:t>SLIDE 5 - Key choices (1:35-1:53)  Charles
+              <a:t>SLIDE 5 - Key choices (1:35-1:53)  Niyanthri
 "We chose a fixed workflow over a ReAct agent, because every request needs the same checks;
 exact lookups over embeddings, so we never fetch the wrong order; exact rules in SQLite over a
 vector store; and a slide, never a spoken yes."</a:t>
@@ -1156,10 +1156,10 @@
           <a:p>
             <a:r>
               <a:rPr lang="en-US" dirty="0"/>
-              <a:t>SLIDE 8 - Demo (2:55-4:50)  Charles, then Lynn
-Take A ends here:
+              <a:t>SLIDE 8 - Demo (2:55-4:50)  Charles
+Take B starts on this slide for two seconds:
   Charles: "Now the demo."
-Take B, in the app. Times are from the start of Take B. Speak only when the app is quiet.
+Then the app. Times are from the start of the app part. Speak only when the app is quiet.
 [0:00] Charles: "I'm Charles, playing the dispatcher. The rings show how busy each workshop is,
        and OldMill is grey because it's suspended."
 [0:08] Hold the mic and say: "ORD-109, 500 vests for Harbor Knits, due April 13. Keep it away
@@ -1176,13 +1176,13 @@
 [0:58] Hold the mic and say: "ORD-081 for Harbor Knits needs to go out, due April 20."
        Let the answer play, then point at the memory note on the card.
        Charles: "Same customer, so the rule is applied, and the card says it came from memory."
-[1:22] Lynn: "Now a hard case, straight from the inbox."
-       Charles holds the mic and says: "QuickStitch for the scarves on ORD-103?"
+[1:22] Charles: "Now a hard case, straight from the inbox."
+       Hold the mic and say: "QuickStitch for the scarves on ORD-103?"
        Let the answer play: QuickStitch cannot make scarves, no workshop meets 4 April, and the
        best alternative is 13.44 days late.
-[1:45] Lynn: "It refuses, gives the earliest option and a two-shop split, and books nothing."
+[1:45] Charles: "It refuses, gives the earliest option and a two-shop split, and books nothing."
 [1:52] Open "Behind the answer". (optional)
-       Lynn: "This panel shows what the model read, with quotes, and what Python computed."
+       Charles: "This panel shows what the model read, with quotes, and what Python computed."
 [1:59] Stop recording.</a:t>
             </a:r>
             <a:endParaRPr lang="en-US" dirty="0"/>

</xml_diff>

<commit_message>
Script: agreed speakers for slides 1-7
</commit_message>
<xml_diff>
--- a/docs/slides/Presentation_Group11_Sprint2.pptx
+++ b/docs/slides/Presentation_Group11_Sprint2.pptx
@@ -693,7 +693,7 @@
           <a:p>
             <a:r>
               <a:rPr lang="en-US" dirty="0"/>
-              <a:t>SLIDE 3 - The user journey (0:45-1:08)  Saadhvika
+              <a:t>SLIDE 3 - The user journey (0:45-1:08)  Joshua
 "We designed the journey for the floor. The dispatcher holds the mic and says the order. The
 desk answers on screen and out loud: the best workshop, when it arrives, and why. 'Book it' opens
 a sheet, and a slide confirms. It offers to remember the constraint, and uses it on the next
@@ -785,7 +785,7 @@
           <a:p>
             <a:r>
               <a:rPr lang="en-US" dirty="0"/>
-              <a:t>SLIDE 4 - Architecture (1:08-1:35)  Joshua
+              <a:t>SLIDE 4 - Architecture (1:08-1:35)  Saadhvika
 "This is what we built. Speech becomes text in the browser, and Python answers commands like
 'book it' itself. Everything else is one structured-output call, and every field must quote the
 message. Deterministic tools then look up the order, apply remembered rules, check eligibility
@@ -878,7 +878,7 @@
           <a:p>
             <a:r>
               <a:rPr lang="en-US" dirty="0"/>
-              <a:t>SLIDE 5 - Key choices (1:35-1:53)  Niyanthri
+              <a:t>SLIDE 5 - Key choices (1:35-1:53)  Saadhvika
 "We chose a fixed workflow over a ReAct agent, because every request needs the same checks;
 exact lookups over embeddings, so we never fetch the wrong order; exact rules in SQLite over a
 vector store; and a slide, never a spoken yes."</a:t>
@@ -969,7 +969,7 @@
           <a:p>
             <a:r>
               <a:rPr lang="en-US" dirty="0"/>
-              <a:t>SLIDE 6 - Progress (1:53-2:11)  Saadhvika
+              <a:t>SLIDE 6 - Progress (1:53-2:11)  Niyanthri
 "Every feature has an owner. Seven of eleven are done, including the voice assistant, memory,
 the four-objective scorer and 205 generated evaluation requests. In progress: clarification
 fixes and independent inbox labels. Planned: Lynn's re-run of the test set, and Joshua's

</xml_diff>

<commit_message>
Full-resolution app screenshots; name Chen Zepeng on the demo slide
</commit_message>
<xml_diff>
--- a/docs/slides/Presentation_Group11_Sprint2.pptx
+++ b/docs/slides/Presentation_Group11_Sprint2.pptx
@@ -1160,8 +1160,8 @@
 Take B starts on this slide for two seconds:
   Charles: "Now the demo."
 Then the app. Times are from the start of the app part. Speak only when the app is quiet.
-[0:00] Charles: "I'm Charles, playing the dispatcher. The rings show how busy each workshop is,
-       and OldMill is grey because it's suspended."
+[0:00] Charles: "I'm Chen Zepeng, Charles in the app, playing the dispatcher. The rings show how
+       busy each workshop is, and OldMill is grey because it's suspended."
 [0:08] Hold the mic and say: "ORD-109, 500 vests for Harbor Knits, due April 13. Keep it away
        from BudgetWorks."
        Let the answer play: "GiantWeave can deliver order 109 by Thursday 9 April, 3.71 days
@@ -2850,8 +2850,8 @@
         </p:blipFill>
         <p:spPr>
           <a:xfrm>
-            <a:off x="6537960" y="411480"/>
-            <a:ext cx="2108934" cy="4343400"/>
+            <a:off x="6368838" y="411480"/>
+            <a:ext cx="2272242" cy="4343400"/>
           </a:xfrm>
           <a:prstGeom prst="rect">
             <a:avLst/>
@@ -4218,7 +4218,7 @@
         <p:spPr>
           <a:xfrm>
             <a:off x="548640" y="1188720"/>
-            <a:ext cx="1331958" cy="2743200"/>
+            <a:ext cx="1435100" cy="2743200"/>
           </a:xfrm>
           <a:prstGeom prst="rect">
             <a:avLst/>
@@ -4280,7 +4280,7 @@
         <p:spPr>
           <a:xfrm>
             <a:off x="795528" y="4005072"/>
-            <a:ext cx="1331958" cy="219456"/>
+            <a:ext cx="1435100" cy="219456"/>
           </a:xfrm>
           <a:prstGeom prst="rect">
             <a:avLst/>
@@ -4319,7 +4319,7 @@
         <p:spPr>
           <a:xfrm>
             <a:off x="530352" y="4261104"/>
-            <a:ext cx="1514838" cy="329184"/>
+            <a:ext cx="1617980" cy="329184"/>
           </a:xfrm>
           <a:prstGeom prst="rect">
             <a:avLst/>
@@ -4365,8 +4365,8 @@
         </p:blipFill>
         <p:spPr>
           <a:xfrm>
-            <a:off x="2227330" y="1188720"/>
-            <a:ext cx="1331958" cy="2743200"/>
+            <a:off x="2201545" y="1188720"/>
+            <a:ext cx="1435100" cy="2743200"/>
           </a:xfrm>
           <a:prstGeom prst="rect">
             <a:avLst/>
@@ -4388,7 +4388,7 @@
         </p:nvSpPr>
         <p:spPr>
           <a:xfrm>
-            <a:off x="2209042" y="3986784"/>
+            <a:off x="2183257" y="3986784"/>
             <a:ext cx="274320" cy="292608"/>
           </a:xfrm>
           <a:prstGeom prst="rect">
@@ -4427,8 +4427,8 @@
         </p:nvSpPr>
         <p:spPr>
           <a:xfrm>
-            <a:off x="2474218" y="4005072"/>
-            <a:ext cx="1331958" cy="219456"/>
+            <a:off x="2448433" y="4005072"/>
+            <a:ext cx="1435100" cy="219456"/>
           </a:xfrm>
           <a:prstGeom prst="rect">
             <a:avLst/>
@@ -4466,8 +4466,8 @@
         </p:nvSpPr>
         <p:spPr>
           <a:xfrm>
-            <a:off x="2209042" y="4261104"/>
-            <a:ext cx="1514838" cy="329184"/>
+            <a:off x="2183257" y="4261104"/>
+            <a:ext cx="1617980" cy="329184"/>
           </a:xfrm>
           <a:prstGeom prst="rect">
             <a:avLst/>
@@ -4513,8 +4513,8 @@
         </p:blipFill>
         <p:spPr>
           <a:xfrm>
-            <a:off x="3906021" y="1188720"/>
-            <a:ext cx="1331958" cy="2743200"/>
+            <a:off x="3854450" y="1188720"/>
+            <a:ext cx="1435100" cy="2743200"/>
           </a:xfrm>
           <a:prstGeom prst="rect">
             <a:avLst/>
@@ -4536,7 +4536,7 @@
         </p:nvSpPr>
         <p:spPr>
           <a:xfrm>
-            <a:off x="3887733" y="3986784"/>
+            <a:off x="3836162" y="3986784"/>
             <a:ext cx="274320" cy="292608"/>
           </a:xfrm>
           <a:prstGeom prst="rect">
@@ -4575,8 +4575,8 @@
         </p:nvSpPr>
         <p:spPr>
           <a:xfrm>
-            <a:off x="4152909" y="4005072"/>
-            <a:ext cx="1331958" cy="219456"/>
+            <a:off x="4101338" y="4005072"/>
+            <a:ext cx="1435100" cy="219456"/>
           </a:xfrm>
           <a:prstGeom prst="rect">
             <a:avLst/>
@@ -4614,8 +4614,8 @@
         </p:nvSpPr>
         <p:spPr>
           <a:xfrm>
-            <a:off x="3887733" y="4261104"/>
-            <a:ext cx="1514838" cy="329184"/>
+            <a:off x="3836162" y="4261104"/>
+            <a:ext cx="1617980" cy="329184"/>
           </a:xfrm>
           <a:prstGeom prst="rect">
             <a:avLst/>
@@ -4661,8 +4661,8 @@
         </p:blipFill>
         <p:spPr>
           <a:xfrm>
-            <a:off x="5584711" y="1188720"/>
-            <a:ext cx="1331958" cy="2743200"/>
+            <a:off x="5507355" y="1188720"/>
+            <a:ext cx="1435100" cy="2743200"/>
           </a:xfrm>
           <a:prstGeom prst="rect">
             <a:avLst/>
@@ -4684,7 +4684,7 @@
         </p:nvSpPr>
         <p:spPr>
           <a:xfrm>
-            <a:off x="5566423" y="3986784"/>
+            <a:off x="5489067" y="3986784"/>
             <a:ext cx="274320" cy="292608"/>
           </a:xfrm>
           <a:prstGeom prst="rect">
@@ -4723,8 +4723,8 @@
         </p:nvSpPr>
         <p:spPr>
           <a:xfrm>
-            <a:off x="5831599" y="4005072"/>
-            <a:ext cx="1331958" cy="219456"/>
+            <a:off x="5754243" y="4005072"/>
+            <a:ext cx="1435100" cy="219456"/>
           </a:xfrm>
           <a:prstGeom prst="rect">
             <a:avLst/>
@@ -4762,8 +4762,8 @@
         </p:nvSpPr>
         <p:spPr>
           <a:xfrm>
-            <a:off x="5566423" y="4261104"/>
-            <a:ext cx="1514838" cy="329184"/>
+            <a:off x="5489067" y="4261104"/>
+            <a:ext cx="1617980" cy="329184"/>
           </a:xfrm>
           <a:prstGeom prst="rect">
             <a:avLst/>
@@ -4809,8 +4809,8 @@
         </p:blipFill>
         <p:spPr>
           <a:xfrm>
-            <a:off x="7263402" y="1188720"/>
-            <a:ext cx="1331958" cy="2743200"/>
+            <a:off x="7160260" y="1188720"/>
+            <a:ext cx="1435100" cy="2743200"/>
           </a:xfrm>
           <a:prstGeom prst="rect">
             <a:avLst/>
@@ -4832,7 +4832,7 @@
         </p:nvSpPr>
         <p:spPr>
           <a:xfrm>
-            <a:off x="7245114" y="3986784"/>
+            <a:off x="7141972" y="3986784"/>
             <a:ext cx="274320" cy="292608"/>
           </a:xfrm>
           <a:prstGeom prst="rect">
@@ -4871,8 +4871,8 @@
         </p:nvSpPr>
         <p:spPr>
           <a:xfrm>
-            <a:off x="7510290" y="4005072"/>
-            <a:ext cx="1331958" cy="219456"/>
+            <a:off x="7407148" y="4005072"/>
+            <a:ext cx="1435100" cy="219456"/>
           </a:xfrm>
           <a:prstGeom prst="rect">
             <a:avLst/>
@@ -4910,8 +4910,8 @@
         </p:nvSpPr>
         <p:spPr>
           <a:xfrm>
-            <a:off x="7245114" y="4261104"/>
-            <a:ext cx="1514838" cy="329184"/>
+            <a:off x="7141972" y="4261104"/>
+            <a:ext cx="1617980" cy="329184"/>
           </a:xfrm>
           <a:prstGeom prst="rect">
             <a:avLst/>
@@ -11283,6 +11283,45 @@
         </p:nvSpPr>
         <p:spPr>
           <a:xfrm>
+            <a:off x="548640" y="1243584"/>
+            <a:ext cx="4572000" cy="201168"/>
+          </a:xfrm>
+          <a:prstGeom prst="rect">
+            <a:avLst/>
+          </a:prstGeom>
+          <a:noFill/>
+          <a:ln/>
+        </p:spPr>
+        <p:txBody>
+          <a:bodyPr wrap="square" lIns="0" tIns="0" rIns="0" bIns="0" rtlCol="0" anchor="t"/>
+          <a:lstStyle/>
+          <a:p>
+            <a:pPr indent="0" marL="0">
+              <a:buNone/>
+            </a:pPr>
+            <a:r>
+              <a:rPr lang="en-US" sz="950" dirty="0">
+                <a:solidFill>
+                  <a:srgbClr val="B9AF9F"/>
+                </a:solidFill>
+                <a:latin typeface="Arial" pitchFamily="34" charset="0"/>
+                <a:ea typeface="Arial" pitchFamily="34" charset="-122"/>
+                <a:cs typeface="Arial" pitchFamily="34" charset="-120"/>
+              </a:rPr>
+              <a:t>Presented by Chen Zepeng (A0156784N), who goes by Charles</a:t>
+            </a:r>
+            <a:endParaRPr lang="en-US" sz="950" dirty="0"/>
+          </a:p>
+        </p:txBody>
+      </p:sp>
+      <p:sp>
+        <p:nvSpPr>
+          <p:cNvPr id="5" name="Text 3"/>
+          <p:cNvSpPr txBox="1"/>
+          <p:nvPr/>
+        </p:nvSpPr>
+        <p:spPr>
+          <a:xfrm>
             <a:off x="548640" y="1508760"/>
             <a:ext cx="274320" cy="292608"/>
           </a:xfrm>
@@ -11316,7 +11355,7 @@
       </p:sp>
       <p:sp>
         <p:nvSpPr>
-          <p:cNvPr id="5" name="Text 3"/>
+          <p:cNvPr id="6" name="Text 4"/>
           <p:cNvSpPr txBox="1"/>
           <p:nvPr/>
         </p:nvSpPr>
@@ -11355,7 +11394,7 @@
       </p:sp>
       <p:sp>
         <p:nvSpPr>
-          <p:cNvPr id="6" name="Text 4"/>
+          <p:cNvPr id="7" name="Text 5"/>
           <p:cNvSpPr txBox="1"/>
           <p:nvPr/>
         </p:nvSpPr>
@@ -11394,7 +11433,7 @@
       </p:sp>
       <p:sp>
         <p:nvSpPr>
-          <p:cNvPr id="7" name="Text 5"/>
+          <p:cNvPr id="8" name="Text 6"/>
           <p:cNvSpPr txBox="1"/>
           <p:nvPr/>
         </p:nvSpPr>
@@ -11433,7 +11472,7 @@
       </p:sp>
       <p:sp>
         <p:nvSpPr>
-          <p:cNvPr id="8" name="Text 6"/>
+          <p:cNvPr id="9" name="Text 7"/>
           <p:cNvSpPr txBox="1"/>
           <p:nvPr/>
         </p:nvSpPr>
@@ -11472,7 +11511,7 @@
       </p:sp>
       <p:sp>
         <p:nvSpPr>
-          <p:cNvPr id="9" name="Text 7"/>
+          <p:cNvPr id="10" name="Text 8"/>
           <p:cNvSpPr txBox="1"/>
           <p:nvPr/>
         </p:nvSpPr>
@@ -11511,7 +11550,7 @@
       </p:sp>
       <p:sp>
         <p:nvSpPr>
-          <p:cNvPr id="10" name="Text 8"/>
+          <p:cNvPr id="11" name="Text 9"/>
           <p:cNvSpPr txBox="1"/>
           <p:nvPr/>
         </p:nvSpPr>
@@ -11550,7 +11589,7 @@
       </p:sp>
       <p:sp>
         <p:nvSpPr>
-          <p:cNvPr id="11" name="Text 9"/>
+          <p:cNvPr id="12" name="Text 10"/>
           <p:cNvSpPr txBox="1"/>
           <p:nvPr/>
         </p:nvSpPr>
@@ -11589,7 +11628,7 @@
       </p:sp>
       <p:sp>
         <p:nvSpPr>
-          <p:cNvPr id="12" name="Text 10"/>
+          <p:cNvPr id="13" name="Text 11"/>
           <p:cNvSpPr txBox="1"/>
           <p:nvPr/>
         </p:nvSpPr>
@@ -11628,7 +11667,7 @@
       </p:sp>
       <p:sp>
         <p:nvSpPr>
-          <p:cNvPr id="13" name="Text 11"/>
+          <p:cNvPr id="14" name="Text 12"/>
           <p:cNvSpPr txBox="1"/>
           <p:nvPr/>
         </p:nvSpPr>
@@ -11667,7 +11706,7 @@
       </p:sp>
       <p:sp>
         <p:nvSpPr>
-          <p:cNvPr id="14" name="Text 12"/>
+          <p:cNvPr id="15" name="Text 13"/>
           <p:cNvSpPr txBox="1"/>
           <p:nvPr/>
         </p:nvSpPr>
@@ -11706,7 +11745,7 @@
       </p:sp>
       <p:sp>
         <p:nvSpPr>
-          <p:cNvPr id="15" name="Text 13"/>
+          <p:cNvPr id="16" name="Text 14"/>
           <p:cNvSpPr txBox="1"/>
           <p:nvPr/>
         </p:nvSpPr>
@@ -11745,7 +11784,7 @@
       </p:sp>
       <p:sp>
         <p:nvSpPr>
-          <p:cNvPr id="16" name="Text 14"/>
+          <p:cNvPr id="17" name="Text 15"/>
           <p:cNvSpPr txBox="1"/>
           <p:nvPr/>
         </p:nvSpPr>
@@ -11784,7 +11823,7 @@
       </p:sp>
       <p:sp>
         <p:nvSpPr>
-          <p:cNvPr id="17" name="Text 15"/>
+          <p:cNvPr id="18" name="Text 16"/>
           <p:cNvSpPr txBox="1"/>
           <p:nvPr/>
         </p:nvSpPr>
@@ -11823,7 +11862,7 @@
       </p:sp>
       <p:pic>
         <p:nvPicPr>
-          <p:cNvPr id="18" name="Image 0" descr="The assistant beside its Behind the answer panel, showing a remembered rule applied to a new order">    </p:cNvPr>
+          <p:cNvPr id="19" name="Image 0" descr="The assistant beside its Behind the answer panel, showing a remembered rule applied to a new order">    </p:cNvPr>
           <p:cNvPicPr>
             <a:picLocks noChangeAspect="1"/>
           </p:cNvPicPr>
@@ -11837,8 +11876,8 @@
         </p:blipFill>
         <p:spPr>
           <a:xfrm>
-            <a:off x="5029200" y="658368"/>
-            <a:ext cx="3802598" cy="3749040"/>
+            <a:off x="5029200" y="860663"/>
+            <a:ext cx="3611880" cy="3344450"/>
           </a:xfrm>
           <a:prstGeom prst="rect">
             <a:avLst/>

</xml_diff>

<commit_message>
Show the demo link only once it exists
</commit_message>
<xml_diff>
--- a/docs/slides/Presentation_Group11_Sprint2.pptx
+++ b/docs/slides/Presentation_Group11_Sprint2.pptx
@@ -1275,7 +1275,7 @@
 The video ends on the demo, so this slide stays in the deck for the Q&amp;A only.
 AFTER RECORDING
 - Upload the .mp4 to YouTube as unlisted, then open the link in a private window.
-- Put the link on slides 1 and 9:
+- The recorded deck has no demo link line. The submitted deck must have it, so add it to slides 1 and 9:
     DEMO_LINK=https://youtu.be/... node scripts/build_sprint2_deck.mjs
   then export the PDF again, and open the GitHub link in a private window too.
 - One member uploads the .mp4 and the .pptx (or .pdf) to Canvas by 15:00.
@@ -2753,56 +2753,6 @@
         </p:nvSpPr>
         <p:spPr>
           <a:xfrm>
-            <a:off x="548640" y="4425696"/>
-            <a:ext cx="5669280" cy="182880"/>
-          </a:xfrm>
-          <a:prstGeom prst="rect">
-            <a:avLst/>
-          </a:prstGeom>
-          <a:noFill/>
-          <a:ln/>
-        </p:spPr>
-        <p:txBody>
-          <a:bodyPr wrap="square" lIns="0" tIns="0" rIns="0" bIns="0" rtlCol="0" anchor="t"/>
-          <a:lstStyle/>
-          <a:p>
-            <a:pPr indent="0" marL="0">
-              <a:buNone/>
-            </a:pPr>
-            <a:r>
-              <a:rPr lang="en-US" sz="850" b="1" spc="50" kern="0" dirty="0">
-                <a:solidFill>
-                  <a:srgbClr val="A3804C"/>
-                </a:solidFill>
-                <a:latin typeface="Arial" pitchFamily="34" charset="0"/>
-                <a:ea typeface="Arial" pitchFamily="34" charset="-122"/>
-                <a:cs typeface="Arial" pitchFamily="34" charset="-120"/>
-              </a:rPr>
-              <a:t>DEMO VIDEO  </a:t>
-            </a:r>
-            <a:r>
-              <a:rPr lang="en-US" sz="850" spc="50" kern="0" dirty="0">
-                <a:solidFill>
-                  <a:srgbClr val="F4EFE6"/>
-                </a:solidFill>
-                <a:latin typeface="Arial" pitchFamily="34" charset="0"/>
-                <a:ea typeface="Arial" pitchFamily="34" charset="-122"/>
-                <a:cs typeface="Arial" pitchFamily="34" charset="-120"/>
-              </a:rPr>
-              <a:t>[YouTube link: add after upload]</a:t>
-            </a:r>
-            <a:endParaRPr lang="en-US" sz="850" dirty="0"/>
-          </a:p>
-        </p:txBody>
-      </p:sp>
-      <p:sp>
-        <p:nvSpPr>
-          <p:cNvPr id="25" name="Text 23"/>
-          <p:cNvSpPr txBox="1"/>
-          <p:nvPr/>
-        </p:nvSpPr>
-        <p:spPr>
-          <a:xfrm>
             <a:off x="548640" y="4754880"/>
             <a:ext cx="5486400" cy="182880"/>
           </a:xfrm>
@@ -2836,7 +2786,7 @@
       </p:sp>
       <p:pic>
         <p:nvPicPr>
-          <p:cNvPr id="26" name="Image 0" descr="The dispatch assistant on a phone: a greeting, the eight workshops with their queue rings, and example requests">    </p:cNvPr>
+          <p:cNvPr id="25" name="Image 0" descr="The dispatch assistant on a phone: a greeting, the eight workshops with their queue rings, and example requests">    </p:cNvPr>
           <p:cNvPicPr>
             <a:picLocks noChangeAspect="1"/>
           </p:cNvPicPr>
@@ -12091,56 +12041,6 @@
         </p:nvSpPr>
         <p:spPr>
           <a:xfrm>
-            <a:off x="548640" y="3520440"/>
-            <a:ext cx="8046720" cy="201168"/>
-          </a:xfrm>
-          <a:prstGeom prst="rect">
-            <a:avLst/>
-          </a:prstGeom>
-          <a:noFill/>
-          <a:ln/>
-        </p:spPr>
-        <p:txBody>
-          <a:bodyPr wrap="square" lIns="0" tIns="0" rIns="0" bIns="0" rtlCol="0" anchor="t"/>
-          <a:lstStyle/>
-          <a:p>
-            <a:pPr indent="0" marL="0">
-              <a:buNone/>
-            </a:pPr>
-            <a:r>
-              <a:rPr lang="en-US" sz="1000" b="1" dirty="0">
-                <a:solidFill>
-                  <a:srgbClr val="A3804C"/>
-                </a:solidFill>
-                <a:latin typeface="Arial" pitchFamily="34" charset="0"/>
-                <a:ea typeface="Arial" pitchFamily="34" charset="-122"/>
-                <a:cs typeface="Arial" pitchFamily="34" charset="-120"/>
-              </a:rPr>
-              <a:t>DEMO VIDEO  </a:t>
-            </a:r>
-            <a:r>
-              <a:rPr lang="en-US" sz="1000" dirty="0">
-                <a:solidFill>
-                  <a:srgbClr val="F4EFE6"/>
-                </a:solidFill>
-                <a:latin typeface="Arial" pitchFamily="34" charset="0"/>
-                <a:ea typeface="Arial" pitchFamily="34" charset="-122"/>
-                <a:cs typeface="Arial" pitchFamily="34" charset="-120"/>
-              </a:rPr>
-              <a:t>[YouTube link: add after upload]</a:t>
-            </a:r>
-            <a:endParaRPr lang="en-US" sz="1000" dirty="0"/>
-          </a:p>
-        </p:txBody>
-      </p:sp>
-      <p:sp>
-        <p:nvSpPr>
-          <p:cNvPr id="7" name="Text 5"/>
-          <p:cNvSpPr txBox="1"/>
-          <p:nvPr/>
-        </p:nvSpPr>
-        <p:spPr>
-          <a:xfrm>
             <a:off x="548640" y="4114800"/>
             <a:ext cx="8046720" cy="201168"/>
           </a:xfrm>
@@ -12174,7 +12074,7 @@
       </p:sp>
       <p:sp>
         <p:nvSpPr>
-          <p:cNvPr id="8" name="Text 6"/>
+          <p:cNvPr id="7" name="Text 5"/>
           <p:cNvSpPr txBox="1"/>
           <p:nvPr/>
         </p:nvSpPr>

</xml_diff>

<commit_message>
Soften the dark slides to espresso and the emphasis cards to sand
</commit_message>
<xml_diff>
--- a/docs/slides/Presentation_Group11_Sprint2.pptx
+++ b/docs/slides/Presentation_Group11_Sprint2.pptx
@@ -1508,7 +1508,7 @@
     <p:bg>
       <p:bgPr>
         <a:solidFill>
-          <a:srgbClr val="1D1B18"/>
+          <a:srgbClr val="3E342B"/>
         </a:solidFill>
       </p:bgPr>
     </p:bg>
@@ -2061,7 +2061,7 @@
             <a:r>
               <a:rPr lang="en-US" sz="1300" i="1" dirty="0">
                 <a:solidFill>
-                  <a:srgbClr val="B9AF9F"/>
+                  <a:srgbClr val="C9BEAD"/>
                 </a:solidFill>
                 <a:latin typeface="Georgia" pitchFamily="34" charset="0"/>
                 <a:ea typeface="Georgia" pitchFamily="34" charset="-122"/>
@@ -2090,7 +2090,7 @@
             </a:avLst>
           </a:prstGeom>
           <a:solidFill>
-            <a:srgbClr val="1D1B18"/>
+            <a:srgbClr val="3E342B"/>
           </a:solidFill>
           <a:ln w="12700">
             <a:solidFill>
@@ -2167,7 +2167,7 @@
             </a:avLst>
           </a:prstGeom>
           <a:solidFill>
-            <a:srgbClr val="1D1B18"/>
+            <a:srgbClr val="3E342B"/>
           </a:solidFill>
           <a:ln w="12700">
             <a:solidFill>
@@ -2293,7 +2293,7 @@
             <a:r>
               <a:rPr lang="en-US" sz="700" dirty="0">
                 <a:solidFill>
-                  <a:srgbClr val="B9AF9F"/>
+                  <a:srgbClr val="C9BEAD"/>
                 </a:solidFill>
                 <a:latin typeface="Arial" pitchFamily="34" charset="0"/>
                 <a:ea typeface="Arial" pitchFamily="34" charset="-122"/>
@@ -2371,7 +2371,7 @@
             <a:r>
               <a:rPr lang="en-US" sz="700" dirty="0">
                 <a:solidFill>
-                  <a:srgbClr val="B9AF9F"/>
+                  <a:srgbClr val="C9BEAD"/>
                 </a:solidFill>
                 <a:latin typeface="Arial" pitchFamily="34" charset="0"/>
                 <a:ea typeface="Arial" pitchFamily="34" charset="-122"/>
@@ -2449,7 +2449,7 @@
             <a:r>
               <a:rPr lang="en-US" sz="700" dirty="0">
                 <a:solidFill>
-                  <a:srgbClr val="B9AF9F"/>
+                  <a:srgbClr val="C9BEAD"/>
                 </a:solidFill>
                 <a:latin typeface="Arial" pitchFamily="34" charset="0"/>
                 <a:ea typeface="Arial" pitchFamily="34" charset="-122"/>
@@ -2527,7 +2527,7 @@
             <a:r>
               <a:rPr lang="en-US" sz="700" dirty="0">
                 <a:solidFill>
-                  <a:srgbClr val="B9AF9F"/>
+                  <a:srgbClr val="C9BEAD"/>
                 </a:solidFill>
                 <a:latin typeface="Arial" pitchFamily="34" charset="0"/>
                 <a:ea typeface="Arial" pitchFamily="34" charset="-122"/>
@@ -2605,7 +2605,7 @@
             <a:r>
               <a:rPr lang="en-US" sz="700" dirty="0">
                 <a:solidFill>
-                  <a:srgbClr val="B9AF9F"/>
+                  <a:srgbClr val="C9BEAD"/>
                 </a:solidFill>
                 <a:latin typeface="Arial" pitchFamily="34" charset="0"/>
                 <a:ea typeface="Arial" pitchFamily="34" charset="-122"/>
@@ -2683,7 +2683,7 @@
             <a:r>
               <a:rPr lang="en-US" sz="700" dirty="0">
                 <a:solidFill>
-                  <a:srgbClr val="B9AF9F"/>
+                  <a:srgbClr val="C9BEAD"/>
                 </a:solidFill>
                 <a:latin typeface="Arial" pitchFamily="34" charset="0"/>
                 <a:ea typeface="Arial" pitchFamily="34" charset="-122"/>
@@ -2772,7 +2772,7 @@
             <a:r>
               <a:rPr lang="en-US" sz="700" spc="200" kern="0" dirty="0">
                 <a:solidFill>
-                  <a:srgbClr val="B9AF9F"/>
+                  <a:srgbClr val="C9BEAD"/>
                 </a:solidFill>
                 <a:latin typeface="Arial" pitchFamily="34" charset="0"/>
                 <a:ea typeface="Arial" pitchFamily="34" charset="-122"/>
@@ -2946,11 +2946,11 @@
             </a:avLst>
           </a:prstGeom>
           <a:solidFill>
-            <a:srgbClr val="1D1B18"/>
+            <a:srgbClr val="F1E7D6"/>
           </a:solidFill>
           <a:ln w="9525">
             <a:solidFill>
-              <a:srgbClr val="1D1B18"/>
+              <a:srgbClr val="E2D3B9"/>
             </a:solidFill>
             <a:prstDash val="solid"/>
           </a:ln>
@@ -2958,7 +2958,32 @@
       </p:sp>
       <p:sp>
         <p:nvSpPr>
-          <p:cNvPr id="5" name="Text 3"/>
+          <p:cNvPr id="5" name="Shape 3"/>
+          <p:cNvSpPr/>
+          <p:nvPr/>
+        </p:nvSpPr>
+        <p:spPr>
+          <a:xfrm>
+            <a:off x="548640" y="1188720"/>
+            <a:ext cx="54864" cy="1417320"/>
+          </a:xfrm>
+          <a:prstGeom prst="rect">
+            <a:avLst/>
+          </a:prstGeom>
+          <a:solidFill>
+            <a:srgbClr val="A3804C"/>
+          </a:solidFill>
+          <a:ln w="12700">
+            <a:solidFill>
+              <a:srgbClr val="A3804C"/>
+            </a:solidFill>
+            <a:prstDash val="solid"/>
+          </a:ln>
+        </p:spPr>
+      </p:sp>
+      <p:sp>
+        <p:nvSpPr>
+          <p:cNvPr id="6" name="Text 4"/>
           <p:cNvSpPr txBox="1"/>
           <p:nvPr/>
         </p:nvSpPr>
@@ -2983,7 +3008,7 @@
             <a:r>
               <a:rPr lang="en-US" sz="750" b="1" spc="180" kern="0" dirty="0">
                 <a:solidFill>
-                  <a:srgbClr val="CDB78F"/>
+                  <a:srgbClr val="7D5E30"/>
                 </a:solidFill>
                 <a:latin typeface="Arial" pitchFamily="34" charset="0"/>
                 <a:ea typeface="Arial" pitchFamily="34" charset="-122"/>
@@ -2997,7 +3022,7 @@
       </p:sp>
       <p:sp>
         <p:nvSpPr>
-          <p:cNvPr id="6" name="Text 4"/>
+          <p:cNvPr id="7" name="Text 5"/>
           <p:cNvSpPr txBox="1"/>
           <p:nvPr/>
         </p:nvSpPr>
@@ -3022,7 +3047,7 @@
             <a:r>
               <a:rPr lang="en-US" sz="1350" i="1" dirty="0">
                 <a:solidFill>
-                  <a:srgbClr val="F4EFE6"/>
+                  <a:srgbClr val="1D1B18"/>
                 </a:solidFill>
                 <a:latin typeface="Georgia" pitchFamily="34" charset="0"/>
                 <a:ea typeface="Georgia" pitchFamily="34" charset="-122"/>
@@ -3036,7 +3061,7 @@
       </p:sp>
       <p:sp>
         <p:nvSpPr>
-          <p:cNvPr id="7" name="Text 5"/>
+          <p:cNvPr id="8" name="Text 6"/>
           <p:cNvSpPr txBox="1"/>
           <p:nvPr/>
         </p:nvSpPr>
@@ -3061,7 +3086,7 @@
             <a:r>
               <a:rPr lang="en-US" sz="800" dirty="0">
                 <a:solidFill>
-                  <a:srgbClr val="B9AF9F"/>
+                  <a:srgbClr val="6B665D"/>
                 </a:solidFill>
                 <a:latin typeface="Arial" pitchFamily="34" charset="0"/>
                 <a:ea typeface="Arial" pitchFamily="34" charset="-122"/>
@@ -3075,7 +3100,7 @@
       </p:sp>
       <p:sp>
         <p:nvSpPr>
-          <p:cNvPr id="8" name="Text 6"/>
+          <p:cNvPr id="9" name="Text 7"/>
           <p:cNvSpPr txBox="1"/>
           <p:nvPr/>
         </p:nvSpPr>
@@ -3114,7 +3139,7 @@
       </p:sp>
       <p:sp>
         <p:nvSpPr>
-          <p:cNvPr id="9" name="Text 7"/>
+          <p:cNvPr id="10" name="Text 8"/>
           <p:cNvSpPr txBox="1"/>
           <p:nvPr/>
         </p:nvSpPr>
@@ -3153,7 +3178,7 @@
       </p:sp>
       <p:sp>
         <p:nvSpPr>
-          <p:cNvPr id="10" name="Text 8"/>
+          <p:cNvPr id="11" name="Text 9"/>
           <p:cNvSpPr txBox="1"/>
           <p:nvPr/>
         </p:nvSpPr>
@@ -3192,7 +3217,7 @@
       </p:sp>
       <p:sp>
         <p:nvSpPr>
-          <p:cNvPr id="11" name="Shape 9"/>
+          <p:cNvPr id="12" name="Shape 10"/>
           <p:cNvSpPr/>
           <p:nvPr/>
         </p:nvSpPr>
@@ -3219,7 +3244,7 @@
       </p:sp>
       <p:sp>
         <p:nvSpPr>
-          <p:cNvPr id="12" name="Text 10"/>
+          <p:cNvPr id="13" name="Text 11"/>
           <p:cNvSpPr txBox="1"/>
           <p:nvPr/>
         </p:nvSpPr>
@@ -3258,7 +3283,7 @@
       </p:sp>
       <p:sp>
         <p:nvSpPr>
-          <p:cNvPr id="13" name="Text 11"/>
+          <p:cNvPr id="14" name="Text 12"/>
           <p:cNvSpPr txBox="1"/>
           <p:nvPr/>
         </p:nvSpPr>
@@ -3297,7 +3322,7 @@
       </p:sp>
       <p:sp>
         <p:nvSpPr>
-          <p:cNvPr id="14" name="Shape 12"/>
+          <p:cNvPr id="15" name="Shape 13"/>
           <p:cNvSpPr/>
           <p:nvPr/>
         </p:nvSpPr>
@@ -3324,7 +3349,7 @@
       </p:sp>
       <p:sp>
         <p:nvSpPr>
-          <p:cNvPr id="15" name="Text 13"/>
+          <p:cNvPr id="16" name="Text 14"/>
           <p:cNvSpPr txBox="1"/>
           <p:nvPr/>
         </p:nvSpPr>
@@ -3363,7 +3388,7 @@
       </p:sp>
       <p:sp>
         <p:nvSpPr>
-          <p:cNvPr id="16" name="Text 14"/>
+          <p:cNvPr id="17" name="Text 15"/>
           <p:cNvSpPr txBox="1"/>
           <p:nvPr/>
         </p:nvSpPr>
@@ -3402,7 +3427,7 @@
       </p:sp>
       <p:sp>
         <p:nvSpPr>
-          <p:cNvPr id="17" name="Shape 15"/>
+          <p:cNvPr id="18" name="Shape 16"/>
           <p:cNvSpPr/>
           <p:nvPr/>
         </p:nvSpPr>
@@ -3429,7 +3454,7 @@
       </p:sp>
       <p:sp>
         <p:nvSpPr>
-          <p:cNvPr id="18" name="Text 16"/>
+          <p:cNvPr id="19" name="Text 17"/>
           <p:cNvSpPr txBox="1"/>
           <p:nvPr/>
         </p:nvSpPr>
@@ -3468,7 +3493,7 @@
       </p:sp>
       <p:sp>
         <p:nvSpPr>
-          <p:cNvPr id="19" name="Text 17"/>
+          <p:cNvPr id="20" name="Text 18"/>
           <p:cNvSpPr txBox="1"/>
           <p:nvPr/>
         </p:nvSpPr>
@@ -3507,7 +3532,7 @@
       </p:sp>
       <p:sp>
         <p:nvSpPr>
-          <p:cNvPr id="20" name="Text 18"/>
+          <p:cNvPr id="21" name="Text 19"/>
           <p:cNvSpPr txBox="1"/>
           <p:nvPr/>
         </p:nvSpPr>
@@ -3546,7 +3571,7 @@
       </p:sp>
       <p:sp>
         <p:nvSpPr>
-          <p:cNvPr id="21" name="Shape 19"/>
+          <p:cNvPr id="22" name="Shape 20"/>
           <p:cNvSpPr/>
           <p:nvPr/>
         </p:nvSpPr>
@@ -3573,7 +3598,7 @@
       </p:sp>
       <p:sp>
         <p:nvSpPr>
-          <p:cNvPr id="22" name="Text 20"/>
+          <p:cNvPr id="23" name="Text 21"/>
           <p:cNvSpPr txBox="1"/>
           <p:nvPr/>
         </p:nvSpPr>
@@ -3612,7 +3637,7 @@
       </p:sp>
       <p:sp>
         <p:nvSpPr>
-          <p:cNvPr id="23" name="Text 21"/>
+          <p:cNvPr id="24" name="Text 22"/>
           <p:cNvSpPr txBox="1"/>
           <p:nvPr/>
         </p:nvSpPr>
@@ -3651,7 +3676,7 @@
       </p:sp>
       <p:sp>
         <p:nvSpPr>
-          <p:cNvPr id="24" name="Shape 22"/>
+          <p:cNvPr id="25" name="Shape 23"/>
           <p:cNvSpPr/>
           <p:nvPr/>
         </p:nvSpPr>
@@ -3678,7 +3703,7 @@
       </p:sp>
       <p:sp>
         <p:nvSpPr>
-          <p:cNvPr id="25" name="Text 23"/>
+          <p:cNvPr id="26" name="Text 24"/>
           <p:cNvSpPr txBox="1"/>
           <p:nvPr/>
         </p:nvSpPr>
@@ -3717,7 +3742,7 @@
       </p:sp>
       <p:sp>
         <p:nvSpPr>
-          <p:cNvPr id="26" name="Text 24"/>
+          <p:cNvPr id="27" name="Text 25"/>
           <p:cNvSpPr txBox="1"/>
           <p:nvPr/>
         </p:nvSpPr>
@@ -3756,7 +3781,7 @@
       </p:sp>
       <p:sp>
         <p:nvSpPr>
-          <p:cNvPr id="27" name="Shape 25"/>
+          <p:cNvPr id="28" name="Shape 26"/>
           <p:cNvSpPr/>
           <p:nvPr/>
         </p:nvSpPr>
@@ -3783,7 +3808,7 @@
       </p:sp>
       <p:sp>
         <p:nvSpPr>
-          <p:cNvPr id="28" name="Text 26"/>
+          <p:cNvPr id="29" name="Text 27"/>
           <p:cNvSpPr txBox="1"/>
           <p:nvPr/>
         </p:nvSpPr>
@@ -3822,7 +3847,7 @@
       </p:sp>
       <p:sp>
         <p:nvSpPr>
-          <p:cNvPr id="29" name="Text 27"/>
+          <p:cNvPr id="30" name="Text 28"/>
           <p:cNvSpPr txBox="1"/>
           <p:nvPr/>
         </p:nvSpPr>
@@ -3861,7 +3886,7 @@
       </p:sp>
       <p:sp>
         <p:nvSpPr>
-          <p:cNvPr id="30" name="Shape 28"/>
+          <p:cNvPr id="31" name="Shape 29"/>
           <p:cNvSpPr/>
           <p:nvPr/>
         </p:nvSpPr>
@@ -3888,7 +3913,7 @@
       </p:sp>
       <p:sp>
         <p:nvSpPr>
-          <p:cNvPr id="31" name="Shape 29"/>
+          <p:cNvPr id="32" name="Shape 30"/>
           <p:cNvSpPr/>
           <p:nvPr/>
         </p:nvSpPr>
@@ -3913,7 +3938,7 @@
       </p:sp>
       <p:sp>
         <p:nvSpPr>
-          <p:cNvPr id="32" name="Text 30"/>
+          <p:cNvPr id="33" name="Text 31"/>
           <p:cNvSpPr txBox="1"/>
           <p:nvPr/>
         </p:nvSpPr>
@@ -3952,7 +3977,7 @@
       </p:sp>
       <p:sp>
         <p:nvSpPr>
-          <p:cNvPr id="33" name="Text 31"/>
+          <p:cNvPr id="34" name="Text 32"/>
           <p:cNvSpPr txBox="1"/>
           <p:nvPr/>
         </p:nvSpPr>
@@ -3991,7 +4016,7 @@
       </p:sp>
       <p:sp>
         <p:nvSpPr>
-          <p:cNvPr id="34" name="Shape 32"/>
+          <p:cNvPr id="35" name="Shape 33"/>
           <p:cNvSpPr/>
           <p:nvPr/>
         </p:nvSpPr>
@@ -4018,7 +4043,7 @@
       </p:sp>
       <p:sp>
         <p:nvSpPr>
-          <p:cNvPr id="35" name="Shape 33"/>
+          <p:cNvPr id="36" name="Shape 34"/>
           <p:cNvSpPr/>
           <p:nvPr/>
         </p:nvSpPr>
@@ -4043,7 +4068,7 @@
       </p:sp>
       <p:sp>
         <p:nvSpPr>
-          <p:cNvPr id="36" name="Text 34"/>
+          <p:cNvPr id="37" name="Text 35"/>
           <p:cNvSpPr txBox="1"/>
           <p:nvPr/>
         </p:nvSpPr>
@@ -4082,7 +4107,7 @@
       </p:sp>
       <p:sp>
         <p:nvSpPr>
-          <p:cNvPr id="37" name="Text 35"/>
+          <p:cNvPr id="38" name="Text 36"/>
           <p:cNvSpPr txBox="1"/>
           <p:nvPr/>
         </p:nvSpPr>
@@ -4121,7 +4146,7 @@
       </p:sp>
       <p:sp>
         <p:nvSpPr>
-          <p:cNvPr id="38" name="Text 36"/>
+          <p:cNvPr id="39" name="Text 37"/>
           <p:cNvSpPr txBox="1"/>
           <p:nvPr/>
         </p:nvSpPr>
@@ -5464,11 +5489,11 @@
             </a:avLst>
           </a:prstGeom>
           <a:solidFill>
-            <a:srgbClr val="1D1B18"/>
+            <a:srgbClr val="F1E7D6"/>
           </a:solidFill>
           <a:ln w="9525">
             <a:solidFill>
-              <a:srgbClr val="1D1B18"/>
+              <a:srgbClr val="E2D3B9"/>
             </a:solidFill>
             <a:prstDash val="solid"/>
           </a:ln>
@@ -5476,7 +5501,32 @@
       </p:sp>
       <p:sp>
         <p:nvSpPr>
-          <p:cNvPr id="5" name="Text 3"/>
+          <p:cNvPr id="5" name="Shape 3"/>
+          <p:cNvSpPr/>
+          <p:nvPr/>
+        </p:nvSpPr>
+        <p:spPr>
+          <a:xfrm>
+            <a:off x="548640" y="1188720"/>
+            <a:ext cx="54864" cy="1536192"/>
+          </a:xfrm>
+          <a:prstGeom prst="rect">
+            <a:avLst/>
+          </a:prstGeom>
+          <a:solidFill>
+            <a:srgbClr val="A3804C"/>
+          </a:solidFill>
+          <a:ln w="12700">
+            <a:solidFill>
+              <a:srgbClr val="A3804C"/>
+            </a:solidFill>
+            <a:prstDash val="solid"/>
+          </a:ln>
+        </p:spPr>
+      </p:sp>
+      <p:sp>
+        <p:nvSpPr>
+          <p:cNvPr id="6" name="Text 4"/>
           <p:cNvSpPr txBox="1"/>
           <p:nvPr/>
         </p:nvSpPr>
@@ -5501,7 +5551,7 @@
             <a:r>
               <a:rPr lang="en-US" sz="750" b="1" spc="180" kern="0" dirty="0">
                 <a:solidFill>
-                  <a:srgbClr val="CDB78F"/>
+                  <a:srgbClr val="7D5E30"/>
                 </a:solidFill>
                 <a:latin typeface="Arial" pitchFamily="34" charset="0"/>
                 <a:ea typeface="Arial" pitchFamily="34" charset="-122"/>
@@ -5515,7 +5565,7 @@
       </p:sp>
       <p:sp>
         <p:nvSpPr>
-          <p:cNvPr id="6" name="Text 4"/>
+          <p:cNvPr id="7" name="Text 5"/>
           <p:cNvSpPr txBox="1"/>
           <p:nvPr/>
         </p:nvSpPr>
@@ -5540,7 +5590,7 @@
             <a:r>
               <a:rPr lang="en-US" sz="1250" dirty="0">
                 <a:solidFill>
-                  <a:srgbClr val="F4EFE6"/>
+                  <a:srgbClr val="1D1B18"/>
                 </a:solidFill>
                 <a:latin typeface="Georgia" pitchFamily="34" charset="0"/>
                 <a:ea typeface="Georgia" pitchFamily="34" charset="-122"/>
@@ -5554,7 +5604,7 @@
       </p:sp>
       <p:sp>
         <p:nvSpPr>
-          <p:cNvPr id="7" name="Text 5"/>
+          <p:cNvPr id="8" name="Text 6"/>
           <p:cNvSpPr txBox="1"/>
           <p:nvPr/>
         </p:nvSpPr>
@@ -5579,7 +5629,7 @@
             <a:r>
               <a:rPr lang="en-US" sz="800" i="1" dirty="0">
                 <a:solidFill>
-                  <a:srgbClr val="B9AF9F"/>
+                  <a:srgbClr val="6B665D"/>
                 </a:solidFill>
                 <a:latin typeface="Arial" pitchFamily="34" charset="0"/>
                 <a:ea typeface="Arial" pitchFamily="34" charset="-122"/>
@@ -5593,7 +5643,7 @@
       </p:sp>
       <p:sp>
         <p:nvSpPr>
-          <p:cNvPr id="8" name="Text 6"/>
+          <p:cNvPr id="9" name="Text 7"/>
           <p:cNvSpPr txBox="1"/>
           <p:nvPr/>
         </p:nvSpPr>
@@ -5618,7 +5668,7 @@
             <a:r>
               <a:rPr lang="en-US" sz="800" dirty="0">
                 <a:solidFill>
-                  <a:srgbClr val="F4EFE6"/>
+                  <a:srgbClr val="4A463F"/>
                 </a:solidFill>
                 <a:latin typeface="Arial" pitchFamily="34" charset="0"/>
                 <a:ea typeface="Arial" pitchFamily="34" charset="-122"/>
@@ -5632,7 +5682,7 @@
       </p:sp>
       <p:sp>
         <p:nvSpPr>
-          <p:cNvPr id="9" name="Shape 7"/>
+          <p:cNvPr id="10" name="Shape 8"/>
           <p:cNvSpPr/>
           <p:nvPr/>
         </p:nvSpPr>
@@ -5647,11 +5697,11 @@
             </a:avLst>
           </a:prstGeom>
           <a:solidFill>
-            <a:srgbClr val="1D1B18"/>
+            <a:srgbClr val="F1E7D6"/>
           </a:solidFill>
           <a:ln w="9525">
             <a:solidFill>
-              <a:srgbClr val="1D1B18"/>
+              <a:srgbClr val="E2D3B9"/>
             </a:solidFill>
             <a:prstDash val="solid"/>
           </a:ln>
@@ -5659,7 +5709,32 @@
       </p:sp>
       <p:sp>
         <p:nvSpPr>
-          <p:cNvPr id="10" name="Text 8"/>
+          <p:cNvPr id="11" name="Shape 9"/>
+          <p:cNvSpPr/>
+          <p:nvPr/>
+        </p:nvSpPr>
+        <p:spPr>
+          <a:xfrm>
+            <a:off x="2587752" y="1188720"/>
+            <a:ext cx="54864" cy="1536192"/>
+          </a:xfrm>
+          <a:prstGeom prst="rect">
+            <a:avLst/>
+          </a:prstGeom>
+          <a:solidFill>
+            <a:srgbClr val="A3804C"/>
+          </a:solidFill>
+          <a:ln w="12700">
+            <a:solidFill>
+              <a:srgbClr val="A3804C"/>
+            </a:solidFill>
+            <a:prstDash val="solid"/>
+          </a:ln>
+        </p:spPr>
+      </p:sp>
+      <p:sp>
+        <p:nvSpPr>
+          <p:cNvPr id="12" name="Text 10"/>
           <p:cNvSpPr txBox="1"/>
           <p:nvPr/>
         </p:nvSpPr>
@@ -5684,7 +5759,7 @@
             <a:r>
               <a:rPr lang="en-US" sz="750" b="1" spc="180" kern="0" dirty="0">
                 <a:solidFill>
-                  <a:srgbClr val="CDB78F"/>
+                  <a:srgbClr val="7D5E30"/>
                 </a:solidFill>
                 <a:latin typeface="Arial" pitchFamily="34" charset="0"/>
                 <a:ea typeface="Arial" pitchFamily="34" charset="-122"/>
@@ -5698,7 +5773,7 @@
       </p:sp>
       <p:sp>
         <p:nvSpPr>
-          <p:cNvPr id="11" name="Text 9"/>
+          <p:cNvPr id="13" name="Text 11"/>
           <p:cNvSpPr txBox="1"/>
           <p:nvPr/>
         </p:nvSpPr>
@@ -5723,7 +5798,7 @@
             <a:r>
               <a:rPr lang="en-US" sz="1250" dirty="0">
                 <a:solidFill>
-                  <a:srgbClr val="F4EFE6"/>
+                  <a:srgbClr val="1D1B18"/>
                 </a:solidFill>
                 <a:latin typeface="Georgia" pitchFamily="34" charset="0"/>
                 <a:ea typeface="Georgia" pitchFamily="34" charset="-122"/>
@@ -5737,7 +5812,7 @@
       </p:sp>
       <p:sp>
         <p:nvSpPr>
-          <p:cNvPr id="12" name="Text 10"/>
+          <p:cNvPr id="14" name="Text 12"/>
           <p:cNvSpPr txBox="1"/>
           <p:nvPr/>
         </p:nvSpPr>
@@ -5762,7 +5837,7 @@
             <a:r>
               <a:rPr lang="en-US" sz="800" i="1" dirty="0">
                 <a:solidFill>
-                  <a:srgbClr val="B9AF9F"/>
+                  <a:srgbClr val="6B665D"/>
                 </a:solidFill>
                 <a:latin typeface="Arial" pitchFamily="34" charset="0"/>
                 <a:ea typeface="Arial" pitchFamily="34" charset="-122"/>
@@ -5776,7 +5851,7 @@
       </p:sp>
       <p:sp>
         <p:nvSpPr>
-          <p:cNvPr id="13" name="Text 11"/>
+          <p:cNvPr id="15" name="Text 13"/>
           <p:cNvSpPr txBox="1"/>
           <p:nvPr/>
         </p:nvSpPr>
@@ -5801,7 +5876,7 @@
             <a:r>
               <a:rPr lang="en-US" sz="800" dirty="0">
                 <a:solidFill>
-                  <a:srgbClr val="F4EFE6"/>
+                  <a:srgbClr val="4A463F"/>
                 </a:solidFill>
                 <a:latin typeface="Arial" pitchFamily="34" charset="0"/>
                 <a:ea typeface="Arial" pitchFamily="34" charset="-122"/>
@@ -5815,7 +5890,7 @@
       </p:sp>
       <p:sp>
         <p:nvSpPr>
-          <p:cNvPr id="14" name="Shape 12"/>
+          <p:cNvPr id="16" name="Shape 14"/>
           <p:cNvSpPr/>
           <p:nvPr/>
         </p:nvSpPr>
@@ -5830,11 +5905,11 @@
             </a:avLst>
           </a:prstGeom>
           <a:solidFill>
-            <a:srgbClr val="1D1B18"/>
+            <a:srgbClr val="F1E7D6"/>
           </a:solidFill>
           <a:ln w="9525">
             <a:solidFill>
-              <a:srgbClr val="1D1B18"/>
+              <a:srgbClr val="E2D3B9"/>
             </a:solidFill>
             <a:prstDash val="solid"/>
           </a:ln>
@@ -5842,7 +5917,32 @@
       </p:sp>
       <p:sp>
         <p:nvSpPr>
-          <p:cNvPr id="15" name="Text 13"/>
+          <p:cNvPr id="17" name="Shape 15"/>
+          <p:cNvSpPr/>
+          <p:nvPr/>
+        </p:nvSpPr>
+        <p:spPr>
+          <a:xfrm>
+            <a:off x="4626864" y="1188720"/>
+            <a:ext cx="54864" cy="1536192"/>
+          </a:xfrm>
+          <a:prstGeom prst="rect">
+            <a:avLst/>
+          </a:prstGeom>
+          <a:solidFill>
+            <a:srgbClr val="A3804C"/>
+          </a:solidFill>
+          <a:ln w="12700">
+            <a:solidFill>
+              <a:srgbClr val="A3804C"/>
+            </a:solidFill>
+            <a:prstDash val="solid"/>
+          </a:ln>
+        </p:spPr>
+      </p:sp>
+      <p:sp>
+        <p:nvSpPr>
+          <p:cNvPr id="18" name="Text 16"/>
           <p:cNvSpPr txBox="1"/>
           <p:nvPr/>
         </p:nvSpPr>
@@ -5867,7 +5967,7 @@
             <a:r>
               <a:rPr lang="en-US" sz="750" b="1" spc="180" kern="0" dirty="0">
                 <a:solidFill>
-                  <a:srgbClr val="CDB78F"/>
+                  <a:srgbClr val="7D5E30"/>
                 </a:solidFill>
                 <a:latin typeface="Arial" pitchFamily="34" charset="0"/>
                 <a:ea typeface="Arial" pitchFamily="34" charset="-122"/>
@@ -5881,7 +5981,7 @@
       </p:sp>
       <p:sp>
         <p:nvSpPr>
-          <p:cNvPr id="16" name="Text 14"/>
+          <p:cNvPr id="19" name="Text 17"/>
           <p:cNvSpPr txBox="1"/>
           <p:nvPr/>
         </p:nvSpPr>
@@ -5906,7 +6006,7 @@
             <a:r>
               <a:rPr lang="en-US" sz="1250" dirty="0">
                 <a:solidFill>
-                  <a:srgbClr val="F4EFE6"/>
+                  <a:srgbClr val="1D1B18"/>
                 </a:solidFill>
                 <a:latin typeface="Georgia" pitchFamily="34" charset="0"/>
                 <a:ea typeface="Georgia" pitchFamily="34" charset="-122"/>
@@ -5920,7 +6020,7 @@
       </p:sp>
       <p:sp>
         <p:nvSpPr>
-          <p:cNvPr id="17" name="Text 15"/>
+          <p:cNvPr id="20" name="Text 18"/>
           <p:cNvSpPr txBox="1"/>
           <p:nvPr/>
         </p:nvSpPr>
@@ -5945,7 +6045,7 @@
             <a:r>
               <a:rPr lang="en-US" sz="800" i="1" dirty="0">
                 <a:solidFill>
-                  <a:srgbClr val="B9AF9F"/>
+                  <a:srgbClr val="6B665D"/>
                 </a:solidFill>
                 <a:latin typeface="Arial" pitchFamily="34" charset="0"/>
                 <a:ea typeface="Arial" pitchFamily="34" charset="-122"/>
@@ -5959,7 +6059,7 @@
       </p:sp>
       <p:sp>
         <p:nvSpPr>
-          <p:cNvPr id="18" name="Text 16"/>
+          <p:cNvPr id="21" name="Text 19"/>
           <p:cNvSpPr txBox="1"/>
           <p:nvPr/>
         </p:nvSpPr>
@@ -5984,7 +6084,7 @@
             <a:r>
               <a:rPr lang="en-US" sz="800" dirty="0">
                 <a:solidFill>
-                  <a:srgbClr val="F4EFE6"/>
+                  <a:srgbClr val="4A463F"/>
                 </a:solidFill>
                 <a:latin typeface="Arial" pitchFamily="34" charset="0"/>
                 <a:ea typeface="Arial" pitchFamily="34" charset="-122"/>
@@ -5998,7 +6098,7 @@
       </p:sp>
       <p:sp>
         <p:nvSpPr>
-          <p:cNvPr id="19" name="Shape 17"/>
+          <p:cNvPr id="22" name="Shape 20"/>
           <p:cNvSpPr/>
           <p:nvPr/>
         </p:nvSpPr>
@@ -6013,11 +6113,11 @@
             </a:avLst>
           </a:prstGeom>
           <a:solidFill>
-            <a:srgbClr val="1D1B18"/>
+            <a:srgbClr val="F1E7D6"/>
           </a:solidFill>
           <a:ln w="9525">
             <a:solidFill>
-              <a:srgbClr val="1D1B18"/>
+              <a:srgbClr val="E2D3B9"/>
             </a:solidFill>
             <a:prstDash val="solid"/>
           </a:ln>
@@ -6025,7 +6125,32 @@
       </p:sp>
       <p:sp>
         <p:nvSpPr>
-          <p:cNvPr id="20" name="Text 18"/>
+          <p:cNvPr id="23" name="Shape 21"/>
+          <p:cNvSpPr/>
+          <p:nvPr/>
+        </p:nvSpPr>
+        <p:spPr>
+          <a:xfrm>
+            <a:off x="6665976" y="1188720"/>
+            <a:ext cx="54864" cy="1536192"/>
+          </a:xfrm>
+          <a:prstGeom prst="rect">
+            <a:avLst/>
+          </a:prstGeom>
+          <a:solidFill>
+            <a:srgbClr val="A3804C"/>
+          </a:solidFill>
+          <a:ln w="12700">
+            <a:solidFill>
+              <a:srgbClr val="A3804C"/>
+            </a:solidFill>
+            <a:prstDash val="solid"/>
+          </a:ln>
+        </p:spPr>
+      </p:sp>
+      <p:sp>
+        <p:nvSpPr>
+          <p:cNvPr id="24" name="Text 22"/>
           <p:cNvSpPr txBox="1"/>
           <p:nvPr/>
         </p:nvSpPr>
@@ -6050,7 +6175,7 @@
             <a:r>
               <a:rPr lang="en-US" sz="750" b="1" spc="180" kern="0" dirty="0">
                 <a:solidFill>
-                  <a:srgbClr val="CDB78F"/>
+                  <a:srgbClr val="7D5E30"/>
                 </a:solidFill>
                 <a:latin typeface="Arial" pitchFamily="34" charset="0"/>
                 <a:ea typeface="Arial" pitchFamily="34" charset="-122"/>
@@ -6064,7 +6189,7 @@
       </p:sp>
       <p:sp>
         <p:nvSpPr>
-          <p:cNvPr id="21" name="Text 19"/>
+          <p:cNvPr id="25" name="Text 23"/>
           <p:cNvSpPr txBox="1"/>
           <p:nvPr/>
         </p:nvSpPr>
@@ -6089,7 +6214,7 @@
             <a:r>
               <a:rPr lang="en-US" sz="1250" dirty="0">
                 <a:solidFill>
-                  <a:srgbClr val="F4EFE6"/>
+                  <a:srgbClr val="1D1B18"/>
                 </a:solidFill>
                 <a:latin typeface="Georgia" pitchFamily="34" charset="0"/>
                 <a:ea typeface="Georgia" pitchFamily="34" charset="-122"/>
@@ -6103,7 +6228,7 @@
       </p:sp>
       <p:sp>
         <p:nvSpPr>
-          <p:cNvPr id="22" name="Text 20"/>
+          <p:cNvPr id="26" name="Text 24"/>
           <p:cNvSpPr txBox="1"/>
           <p:nvPr/>
         </p:nvSpPr>
@@ -6128,7 +6253,7 @@
             <a:r>
               <a:rPr lang="en-US" sz="800" i="1" dirty="0">
                 <a:solidFill>
-                  <a:srgbClr val="B9AF9F"/>
+                  <a:srgbClr val="6B665D"/>
                 </a:solidFill>
                 <a:latin typeface="Arial" pitchFamily="34" charset="0"/>
                 <a:ea typeface="Arial" pitchFamily="34" charset="-122"/>
@@ -6142,7 +6267,7 @@
       </p:sp>
       <p:sp>
         <p:nvSpPr>
-          <p:cNvPr id="23" name="Text 21"/>
+          <p:cNvPr id="27" name="Text 25"/>
           <p:cNvSpPr txBox="1"/>
           <p:nvPr/>
         </p:nvSpPr>
@@ -6167,7 +6292,7 @@
             <a:r>
               <a:rPr lang="en-US" sz="800" dirty="0">
                 <a:solidFill>
-                  <a:srgbClr val="F4EFE6"/>
+                  <a:srgbClr val="4A463F"/>
                 </a:solidFill>
                 <a:latin typeface="Arial" pitchFamily="34" charset="0"/>
                 <a:ea typeface="Arial" pitchFamily="34" charset="-122"/>
@@ -6181,7 +6306,7 @@
       </p:sp>
       <p:sp>
         <p:nvSpPr>
-          <p:cNvPr id="24" name="Shape 22"/>
+          <p:cNvPr id="28" name="Shape 26"/>
           <p:cNvSpPr/>
           <p:nvPr/>
         </p:nvSpPr>
@@ -6208,7 +6333,7 @@
       </p:sp>
       <p:sp>
         <p:nvSpPr>
-          <p:cNvPr id="25" name="Text 23"/>
+          <p:cNvPr id="29" name="Text 27"/>
           <p:cNvSpPr txBox="1"/>
           <p:nvPr/>
         </p:nvSpPr>
@@ -6247,7 +6372,7 @@
       </p:sp>
       <p:sp>
         <p:nvSpPr>
-          <p:cNvPr id="26" name="Text 24"/>
+          <p:cNvPr id="30" name="Text 28"/>
           <p:cNvSpPr txBox="1"/>
           <p:nvPr/>
         </p:nvSpPr>
@@ -6286,7 +6411,7 @@
       </p:sp>
       <p:sp>
         <p:nvSpPr>
-          <p:cNvPr id="27" name="Text 25"/>
+          <p:cNvPr id="31" name="Text 29"/>
           <p:cNvSpPr txBox="1"/>
           <p:nvPr/>
         </p:nvSpPr>
@@ -6325,7 +6450,7 @@
       </p:sp>
       <p:sp>
         <p:nvSpPr>
-          <p:cNvPr id="28" name="Text 26"/>
+          <p:cNvPr id="32" name="Text 30"/>
           <p:cNvSpPr txBox="1"/>
           <p:nvPr/>
         </p:nvSpPr>
@@ -6364,7 +6489,7 @@
       </p:sp>
       <p:sp>
         <p:nvSpPr>
-          <p:cNvPr id="29" name="Shape 27"/>
+          <p:cNvPr id="33" name="Shape 31"/>
           <p:cNvSpPr/>
           <p:nvPr/>
         </p:nvSpPr>
@@ -6391,7 +6516,7 @@
       </p:sp>
       <p:sp>
         <p:nvSpPr>
-          <p:cNvPr id="30" name="Text 28"/>
+          <p:cNvPr id="34" name="Text 32"/>
           <p:cNvSpPr txBox="1"/>
           <p:nvPr/>
         </p:nvSpPr>
@@ -6430,7 +6555,7 @@
       </p:sp>
       <p:sp>
         <p:nvSpPr>
-          <p:cNvPr id="31" name="Text 29"/>
+          <p:cNvPr id="35" name="Text 33"/>
           <p:cNvSpPr txBox="1"/>
           <p:nvPr/>
         </p:nvSpPr>
@@ -6469,7 +6594,7 @@
       </p:sp>
       <p:sp>
         <p:nvSpPr>
-          <p:cNvPr id="32" name="Text 30"/>
+          <p:cNvPr id="36" name="Text 34"/>
           <p:cNvSpPr txBox="1"/>
           <p:nvPr/>
         </p:nvSpPr>
@@ -6508,7 +6633,7 @@
       </p:sp>
       <p:sp>
         <p:nvSpPr>
-          <p:cNvPr id="33" name="Text 31"/>
+          <p:cNvPr id="37" name="Text 35"/>
           <p:cNvSpPr txBox="1"/>
           <p:nvPr/>
         </p:nvSpPr>
@@ -6547,7 +6672,7 @@
       </p:sp>
       <p:sp>
         <p:nvSpPr>
-          <p:cNvPr id="34" name="Shape 32"/>
+          <p:cNvPr id="38" name="Shape 36"/>
           <p:cNvSpPr/>
           <p:nvPr/>
         </p:nvSpPr>
@@ -6574,7 +6699,7 @@
       </p:sp>
       <p:sp>
         <p:nvSpPr>
-          <p:cNvPr id="35" name="Text 33"/>
+          <p:cNvPr id="39" name="Text 37"/>
           <p:cNvSpPr txBox="1"/>
           <p:nvPr/>
         </p:nvSpPr>
@@ -6613,7 +6738,7 @@
       </p:sp>
       <p:sp>
         <p:nvSpPr>
-          <p:cNvPr id="36" name="Text 34"/>
+          <p:cNvPr id="40" name="Text 38"/>
           <p:cNvSpPr txBox="1"/>
           <p:nvPr/>
         </p:nvSpPr>
@@ -6652,7 +6777,7 @@
       </p:sp>
       <p:sp>
         <p:nvSpPr>
-          <p:cNvPr id="37" name="Text 35"/>
+          <p:cNvPr id="41" name="Text 39"/>
           <p:cNvSpPr txBox="1"/>
           <p:nvPr/>
         </p:nvSpPr>
@@ -6691,7 +6816,7 @@
       </p:sp>
       <p:sp>
         <p:nvSpPr>
-          <p:cNvPr id="38" name="Text 36"/>
+          <p:cNvPr id="42" name="Text 40"/>
           <p:cNvSpPr txBox="1"/>
           <p:nvPr/>
         </p:nvSpPr>
@@ -6730,7 +6855,7 @@
       </p:sp>
       <p:sp>
         <p:nvSpPr>
-          <p:cNvPr id="39" name="Shape 37"/>
+          <p:cNvPr id="43" name="Shape 41"/>
           <p:cNvSpPr/>
           <p:nvPr/>
         </p:nvSpPr>
@@ -6757,7 +6882,7 @@
       </p:sp>
       <p:sp>
         <p:nvSpPr>
-          <p:cNvPr id="40" name="Text 38"/>
+          <p:cNvPr id="44" name="Text 42"/>
           <p:cNvSpPr txBox="1"/>
           <p:nvPr/>
         </p:nvSpPr>
@@ -6796,7 +6921,7 @@
       </p:sp>
       <p:sp>
         <p:nvSpPr>
-          <p:cNvPr id="41" name="Text 39"/>
+          <p:cNvPr id="45" name="Text 43"/>
           <p:cNvSpPr txBox="1"/>
           <p:nvPr/>
         </p:nvSpPr>
@@ -6835,7 +6960,7 @@
       </p:sp>
       <p:sp>
         <p:nvSpPr>
-          <p:cNvPr id="42" name="Text 40"/>
+          <p:cNvPr id="46" name="Text 44"/>
           <p:cNvSpPr txBox="1"/>
           <p:nvPr/>
         </p:nvSpPr>
@@ -6874,7 +6999,7 @@
       </p:sp>
       <p:sp>
         <p:nvSpPr>
-          <p:cNvPr id="43" name="Text 41"/>
+          <p:cNvPr id="47" name="Text 45"/>
           <p:cNvSpPr txBox="1"/>
           <p:nvPr/>
         </p:nvSpPr>
@@ -6913,7 +7038,7 @@
       </p:sp>
       <p:sp>
         <p:nvSpPr>
-          <p:cNvPr id="44" name="Text 42"/>
+          <p:cNvPr id="48" name="Text 46"/>
           <p:cNvSpPr txBox="1"/>
           <p:nvPr/>
         </p:nvSpPr>
@@ -6944,7 +7069,7 @@
                 <a:ea typeface="Arial" pitchFamily="34" charset="-122"/>
                 <a:cs typeface="Arial" pitchFamily="34" charset="-120"/>
               </a:rPr>
-              <a:t>Dark: the four choices the brief asks us to justify. The model call is the only thing that leaves the machine; it never sees costs, queues or defect rates.</a:t>
+              <a:t>Highlighted: the four choices the brief asks us to justify. The model call is the only thing that leaves the machine; it never sees costs, queues or defect rates.</a:t>
             </a:r>
             <a:endParaRPr lang="en-US" sz="700" dirty="0"/>
           </a:p>
@@ -9401,11 +9526,11 @@
             </a:avLst>
           </a:prstGeom>
           <a:solidFill>
-            <a:srgbClr val="1D1B18"/>
+            <a:srgbClr val="F1E7D6"/>
           </a:solidFill>
           <a:ln w="9525">
             <a:solidFill>
-              <a:srgbClr val="1D1B18"/>
+              <a:srgbClr val="E2D3B9"/>
             </a:solidFill>
             <a:prstDash val="solid"/>
           </a:ln>
@@ -9413,7 +9538,32 @@
       </p:sp>
       <p:sp>
         <p:nvSpPr>
-          <p:cNvPr id="14" name="Text 12"/>
+          <p:cNvPr id="14" name="Shape 12"/>
+          <p:cNvSpPr/>
+          <p:nvPr/>
+        </p:nvSpPr>
+        <p:spPr>
+          <a:xfrm>
+            <a:off x="6665976" y="1170432"/>
+            <a:ext cx="54864" cy="1024128"/>
+          </a:xfrm>
+          <a:prstGeom prst="rect">
+            <a:avLst/>
+          </a:prstGeom>
+          <a:solidFill>
+            <a:srgbClr val="A3804C"/>
+          </a:solidFill>
+          <a:ln w="12700">
+            <a:solidFill>
+              <a:srgbClr val="A3804C"/>
+            </a:solidFill>
+            <a:prstDash val="solid"/>
+          </a:ln>
+        </p:spPr>
+      </p:sp>
+      <p:sp>
+        <p:nvSpPr>
+          <p:cNvPr id="15" name="Text 13"/>
           <p:cNvSpPr txBox="1"/>
           <p:nvPr/>
         </p:nvSpPr>
@@ -9438,7 +9588,7 @@
             <a:r>
               <a:rPr lang="en-US" sz="2800" dirty="0">
                 <a:solidFill>
-                  <a:srgbClr val="F4EFE6"/>
+                  <a:srgbClr val="2F5D46"/>
                 </a:solidFill>
                 <a:latin typeface="Georgia" pitchFamily="34" charset="0"/>
                 <a:ea typeface="Georgia" pitchFamily="34" charset="-122"/>
@@ -9452,7 +9602,7 @@
       </p:sp>
       <p:sp>
         <p:nvSpPr>
-          <p:cNvPr id="15" name="Text 13"/>
+          <p:cNvPr id="16" name="Text 14"/>
           <p:cNvSpPr txBox="1"/>
           <p:nvPr/>
         </p:nvSpPr>
@@ -9477,7 +9627,7 @@
             <a:r>
               <a:rPr lang="en-US" sz="850" dirty="0">
                 <a:solidFill>
-                  <a:srgbClr val="B9AF9F"/>
+                  <a:srgbClr val="4A463F"/>
                 </a:solidFill>
                 <a:latin typeface="Arial" pitchFamily="34" charset="0"/>
                 <a:ea typeface="Arial" pitchFamily="34" charset="-122"/>
@@ -9491,7 +9641,7 @@
       </p:sp>
       <p:sp>
         <p:nvSpPr>
-          <p:cNvPr id="16" name="Shape 14"/>
+          <p:cNvPr id="17" name="Shape 15"/>
           <p:cNvSpPr/>
           <p:nvPr/>
         </p:nvSpPr>
@@ -9518,7 +9668,7 @@
       </p:sp>
       <p:sp>
         <p:nvSpPr>
-          <p:cNvPr id="17" name="Text 15"/>
+          <p:cNvPr id="18" name="Text 16"/>
           <p:cNvSpPr txBox="1"/>
           <p:nvPr/>
         </p:nvSpPr>
@@ -9557,7 +9707,7 @@
       </p:sp>
       <p:sp>
         <p:nvSpPr>
-          <p:cNvPr id="18" name="Text 16"/>
+          <p:cNvPr id="19" name="Text 17"/>
           <p:cNvSpPr txBox="1"/>
           <p:nvPr/>
         </p:nvSpPr>
@@ -9596,7 +9746,7 @@
       </p:sp>
       <p:sp>
         <p:nvSpPr>
-          <p:cNvPr id="19" name="Shape 17"/>
+          <p:cNvPr id="20" name="Shape 18"/>
           <p:cNvSpPr/>
           <p:nvPr/>
         </p:nvSpPr>
@@ -9623,7 +9773,7 @@
       </p:sp>
       <p:sp>
         <p:nvSpPr>
-          <p:cNvPr id="20" name="Text 18"/>
+          <p:cNvPr id="21" name="Text 19"/>
           <p:cNvSpPr txBox="1"/>
           <p:nvPr/>
         </p:nvSpPr>
@@ -9662,7 +9812,7 @@
       </p:sp>
       <p:sp>
         <p:nvSpPr>
-          <p:cNvPr id="21" name="Text 19"/>
+          <p:cNvPr id="22" name="Text 20"/>
           <p:cNvSpPr txBox="1"/>
           <p:nvPr/>
         </p:nvSpPr>
@@ -9701,7 +9851,7 @@
       </p:sp>
       <p:sp>
         <p:nvSpPr>
-          <p:cNvPr id="22" name="Shape 20"/>
+          <p:cNvPr id="23" name="Shape 21"/>
           <p:cNvSpPr/>
           <p:nvPr/>
         </p:nvSpPr>
@@ -9728,7 +9878,7 @@
       </p:sp>
       <p:sp>
         <p:nvSpPr>
-          <p:cNvPr id="23" name="Text 21"/>
+          <p:cNvPr id="24" name="Text 22"/>
           <p:cNvSpPr txBox="1"/>
           <p:nvPr/>
         </p:nvSpPr>
@@ -9767,7 +9917,7 @@
       </p:sp>
       <p:sp>
         <p:nvSpPr>
-          <p:cNvPr id="24" name="Text 22"/>
+          <p:cNvPr id="25" name="Text 23"/>
           <p:cNvSpPr txBox="1"/>
           <p:nvPr/>
         </p:nvSpPr>
@@ -9806,7 +9956,7 @@
       </p:sp>
       <p:sp>
         <p:nvSpPr>
-          <p:cNvPr id="25" name="Text 23"/>
+          <p:cNvPr id="26" name="Text 24"/>
           <p:cNvSpPr txBox="1"/>
           <p:nvPr/>
         </p:nvSpPr>
@@ -9845,7 +9995,7 @@
       </p:sp>
       <p:sp>
         <p:nvSpPr>
-          <p:cNvPr id="26" name="Shape 24"/>
+          <p:cNvPr id="27" name="Shape 25"/>
           <p:cNvSpPr/>
           <p:nvPr/>
         </p:nvSpPr>
@@ -9872,7 +10022,7 @@
       </p:sp>
       <p:sp>
         <p:nvSpPr>
-          <p:cNvPr id="27" name="Text 25"/>
+          <p:cNvPr id="28" name="Text 26"/>
           <p:cNvSpPr txBox="1"/>
           <p:nvPr/>
         </p:nvSpPr>
@@ -9911,7 +10061,7 @@
       </p:sp>
       <p:sp>
         <p:nvSpPr>
-          <p:cNvPr id="28" name="Text 26"/>
+          <p:cNvPr id="29" name="Text 27"/>
           <p:cNvSpPr txBox="1"/>
           <p:nvPr/>
         </p:nvSpPr>
@@ -9950,7 +10100,7 @@
       </p:sp>
       <p:sp>
         <p:nvSpPr>
-          <p:cNvPr id="29" name="Text 27"/>
+          <p:cNvPr id="30" name="Text 28"/>
           <p:cNvSpPr txBox="1"/>
           <p:nvPr/>
         </p:nvSpPr>
@@ -9989,7 +10139,7 @@
       </p:sp>
       <p:sp>
         <p:nvSpPr>
-          <p:cNvPr id="30" name="Shape 28"/>
+          <p:cNvPr id="31" name="Shape 29"/>
           <p:cNvSpPr/>
           <p:nvPr/>
         </p:nvSpPr>
@@ -10016,7 +10166,7 @@
       </p:sp>
       <p:sp>
         <p:nvSpPr>
-          <p:cNvPr id="31" name="Text 29"/>
+          <p:cNvPr id="32" name="Text 30"/>
           <p:cNvSpPr txBox="1"/>
           <p:nvPr/>
         </p:nvSpPr>
@@ -10055,7 +10205,7 @@
       </p:sp>
       <p:sp>
         <p:nvSpPr>
-          <p:cNvPr id="32" name="Text 30"/>
+          <p:cNvPr id="33" name="Text 31"/>
           <p:cNvSpPr txBox="1"/>
           <p:nvPr/>
         </p:nvSpPr>
@@ -10094,7 +10244,7 @@
       </p:sp>
       <p:sp>
         <p:nvSpPr>
-          <p:cNvPr id="33" name="Text 31"/>
+          <p:cNvPr id="34" name="Text 32"/>
           <p:cNvSpPr txBox="1"/>
           <p:nvPr/>
         </p:nvSpPr>
@@ -10133,7 +10283,7 @@
       </p:sp>
       <p:sp>
         <p:nvSpPr>
-          <p:cNvPr id="34" name="Shape 32"/>
+          <p:cNvPr id="35" name="Shape 33"/>
           <p:cNvSpPr/>
           <p:nvPr/>
         </p:nvSpPr>
@@ -10160,7 +10310,7 @@
       </p:sp>
       <p:sp>
         <p:nvSpPr>
-          <p:cNvPr id="35" name="Text 33"/>
+          <p:cNvPr id="36" name="Text 34"/>
           <p:cNvSpPr txBox="1"/>
           <p:nvPr/>
         </p:nvSpPr>
@@ -10199,7 +10349,7 @@
       </p:sp>
       <p:sp>
         <p:nvSpPr>
-          <p:cNvPr id="36" name="Text 34"/>
+          <p:cNvPr id="37" name="Text 35"/>
           <p:cNvSpPr txBox="1"/>
           <p:nvPr/>
         </p:nvSpPr>
@@ -10238,7 +10388,7 @@
       </p:sp>
       <p:sp>
         <p:nvSpPr>
-          <p:cNvPr id="37" name="Text 35"/>
+          <p:cNvPr id="38" name="Text 36"/>
           <p:cNvSpPr txBox="1"/>
           <p:nvPr/>
         </p:nvSpPr>
@@ -10277,7 +10427,7 @@
       </p:sp>
       <p:sp>
         <p:nvSpPr>
-          <p:cNvPr id="38" name="Text 36"/>
+          <p:cNvPr id="39" name="Text 37"/>
           <p:cNvSpPr txBox="1"/>
           <p:nvPr/>
         </p:nvSpPr>
@@ -10503,7 +10653,7 @@
             <a:r>
               <a:rPr lang="en-US" sz="950" dirty="0">
                 <a:solidFill>
-                  <a:srgbClr val="B9AF9F"/>
+                  <a:srgbClr val="C9BEAD"/>
                 </a:solidFill>
                 <a:latin typeface="Arial" pitchFamily="34" charset="0"/>
                 <a:ea typeface="Arial" pitchFamily="34" charset="-122"/>
@@ -11222,7 +11372,7 @@
             <a:r>
               <a:rPr lang="en-US" sz="1800" i="1" dirty="0">
                 <a:solidFill>
-                  <a:srgbClr val="B9AF9F"/>
+                  <a:srgbClr val="C9BEAD"/>
                 </a:solidFill>
                 <a:latin typeface="Georgia" pitchFamily="34" charset="0"/>
                 <a:ea typeface="Georgia" pitchFamily="34" charset="-122"/>
@@ -11350,7 +11500,7 @@
             <a:r>
               <a:rPr lang="en-US" sz="750" spc="200" kern="0" dirty="0">
                 <a:solidFill>
-                  <a:srgbClr val="B9AF9F"/>
+                  <a:srgbClr val="C9BEAD"/>
                 </a:solidFill>
                 <a:latin typeface="Arial" pitchFamily="34" charset="0"/>
                 <a:ea typeface="Arial" pitchFamily="34" charset="-122"/>

</xml_diff>

<commit_message>
Script: slides team ends on slide 8; the demo recording starts in the app
</commit_message>
<xml_diff>
--- a/docs/slides/Presentation_Group11_Sprint2.pptx
+++ b/docs/slides/Presentation_Group11_Sprint2.pptx
@@ -1157,9 +1157,9 @@
             <a:r>
               <a:rPr lang="en-US" dirty="0"/>
               <a:t>SLIDE 8 - Demo (2:55-4:50)  Charles
-Take B starts on this slide for two seconds:
-  Charles: "Now the demo."
-Then the app. Times are from the start of the app part. Speak only when the app is quiet.
+The slides recording ends on this slide for two seconds:
+  Niyanthri: "Now, the demo."
+Charles's recording starts straight in the app. Times are from the start of the app part. Speak only when the app is quiet.
 [0:00] Charles: "I'm Chen Zepeng, Charles in the app, playing the dispatcher. The rings show how
        busy each workshop is, and OldMill is grey because it's suspended."
 [0:08] Hold the mic and say: "ORD-109, 500 vests for Harbor Knits, due April 13. Keep it away

</xml_diff>

<commit_message>
Understand spoken order numbers and spaced workshop names; natural demo lines
</commit_message>
<xml_diff>
--- a/docs/slides/Presentation_Group11_Sprint2.pptx
+++ b/docs/slides/Presentation_Group11_Sprint2.pptx
@@ -1162,22 +1162,23 @@
 Charles's recording starts straight in the app. Times are from the start of the app part. Speak only when the app is quiet.
 [0:00] Charles: "I'm Chen Zepeng, Charles in the app, playing the dispatcher. The rings show how
        busy each workshop is, and OldMill is grey because it's suspended."
-[0:08] Hold the mic and say: "ORD-109, 500 vests for Harbor Knits, due April 13. Keep it away
-       from BudgetWorks."
+[0:08] Hold the mic and say: "Hi, I've got order 109 for Harbor Knits, 500 vests, due April
+       13th. And keep it away from BudgetWorks, their last batch came back rough."
        Let the answer play: "GiantWeave can deliver order 109 by Thursday 9 April, 3.71 days
        early. Cost 550, defect risk 6.0%. Say book it, or tap book, to confirm."
 [0:30] Tap "Compare 4 workshops", then "Can't take it", then close them. (optional)
        Charles: "Here are the other options, and why the rest can't take it. BudgetWorks is out
        because I asked."
-[0:40] Hold the mic and say: "Book it." The sheet opens.
+[0:40] Hold the mic and say: "Okay, book it." The sheet opens.
        Charles: "Nothing is saved until I slide." Slide to confirm.
 [0:52] On the receipt, tap "Remember".
        Charles: "And it offers to remember that rule."
-[0:58] Hold the mic and say: "ORD-081 for Harbor Knits needs to go out, due April 20."
+[0:58] Hold the mic and say: "Next one: order 81 for Harbor Knits, due April 20th."
+       (Say "due", not "go out by": "go out by" is a ship date, and the desk would ask which.)
        Let the answer play, then point at the memory note on the card.
        Charles: "Same customer, so the rule is applied, and the card says it came from memory."
 [1:22] Charles: "Now a hard case, straight from the inbox."
-       Hold the mic and say: "QuickStitch for the scarves on ORD-103?"
+       Hold the mic and say: "QuickStitch for the scarves on order 103?"
        Let the answer play: QuickStitch cannot make scarves, no workshop meets 4 April, and the
        best alternative is 13.44 days late.
 [1:45] Charles: "It refuses, gives the earliest option and a two-shop split, and books nothing."

</xml_diff>

<commit_message>
Script: Charles's own opening line for the demo
</commit_message>
<xml_diff>
--- a/docs/slides/Presentation_Group11_Sprint2.pptx
+++ b/docs/slides/Presentation_Group11_Sprint2.pptx
@@ -1160,8 +1160,9 @@
 The slides recording ends on this slide for two seconds:
   Niyanthri: "Now, the demo."
 Charles's recording starts straight in the app. Times are from the start of the app part. Speak only when the app is quiet.
-[0:00] Charles: "I'm Chen Zepeng, Charles in the app, playing the dispatcher. The rings show how
-       busy each workshop is, and OldMill is grey because it's suspended."
+[0:00] Charles: "Hi everyone, I'm Charles, that's Chen Zepeng. In this demo I'll play the
+       dispatcher, using our app, StitchFlow. The rings show how busy each workshop is, and
+       OldMill is grey because it's suspended."
 [0:08] Hold the mic and say: "Hi, I've got order 109 for Harbor Knits, 500 vests, due April
        13th. And keep it away from BudgetWorks, their last batch came back rough."
        Let the answer play: "GiantWeave can deliver order 109 by Thursday 9 April, 3.71 days

</xml_diff>

<commit_message>
Script: open the demo with Zepeng, or Charles
</commit_message>
<xml_diff>
--- a/docs/slides/Presentation_Group11_Sprint2.pptx
+++ b/docs/slides/Presentation_Group11_Sprint2.pptx
@@ -1160,8 +1160,8 @@
 The slides recording ends on this slide for two seconds:
   Niyanthri: "Now, the demo."
 Charles's recording starts straight in the app. Times are from the start of the app part. Speak only when the app is quiet.
-[0:00] Charles: "Hi everyone, I'm Charles, that's Chen Zepeng. In this demo I'll play the
-       dispatcher, using our app, StitchFlow. The rings show how busy each workshop is, and
+[0:00] Charles: "Hi everyone, I'm Zepeng, or Charles, as the app calls me. In this demo I'll
+       play the dispatcher, using our app, StitchFlow. The rings show how busy each workshop is, and
        OldMill is grey because it's suspended."
 [0:08] Hold the mic and say: "Hi, I've got order 109 for Harbor Knits, 500 vests, due April
        13th. And keep it away from BudgetWorks, their last batch came back rough."

</xml_diff>

<commit_message>
Script: demo narration in a product-pitch voice
</commit_message>
<xml_diff>
--- a/docs/slides/Presentation_Group11_Sprint2.pptx
+++ b/docs/slides/Presentation_Group11_Sprint2.pptx
@@ -1160,31 +1160,34 @@
 The slides recording ends on this slide for two seconds:
   Niyanthri: "Now, the demo."
 Charles's recording starts straight in the app. Times are from the start of the app part. Speak only when the app is quiet.
-[0:00] Charles: "Hi everyone, I'm Zepeng, or Charles, as the app calls me. In this demo I'll
-       play the dispatcher, using our app, StitchFlow. The rings show how busy each workshop is, and
-       OldMill is grey because it's suspended."
-[0:08] Hold the mic and say: "Hi, I've got order 109 for Harbor Knits, 500 vests, due April
+[0:00] Charles: "Hi everyone, I'm Zepeng, or Charles, as the app calls me. Today I'm a
+       dispatcher, and this phone is my whole desk. The rings show who's busy; OldMill is
+       suspended."
+[0:10] Hold the mic and say: "Hi, I've got order 109 for Harbor Knits, 500 vests, due April
        13th. And keep it away from BudgetWorks, their last batch came back rough."
        Let the answer play: "GiantWeave can deliver order 109 by Thursday 9 April, 3.71 days
        early. Cost 550, defect risk 6.0%. Say book it, or tap book, to confirm."
-[0:30] Tap "Compare 4 workshops", then "Can't take it", then close them. (optional)
-       Charles: "Here are the other options, and why the rest can't take it. BudgetWorks is out
-       because I asked."
+[0:32] Tap "Compare 4 workshops", then "Can't take it", then close them. (optional)
+       Charles: "No typing. It picked GiantWeave, told me when it lands, and kept BudgetWorks
+       out, because I asked."
 [0:40] Hold the mic and say: "Okay, book it." The sheet opens.
-       Charles: "Nothing is saved until I slide." Slide to confirm.
-[0:52] On the receipt, tap "Remember".
-       Charles: "And it offers to remember that rule."
-[0:58] Hold the mic and say: "Next one: order 81 for Harbor Knits, due April 20th."
+       Charles: "Nothing goes out until I slide." Slide to confirm.
+[0:50] On the receipt, tap "Remember".
+       Charles: "And it offers to remember that, for next time."
+[0:56] Hold the mic and say: "Next one: order 81 for Harbor Knits, due April 20th."
        (Say "due", not "go out by": "go out by" is a ship date, and the desk would ask which.)
-       Let the answer play, then point at the memory note on the card.
-       Charles: "Same customer, so the rule is applied, and the card says it came from memory."
-[1:22] Charles: "Now a hard case, straight from the inbox."
+       Let the answer play, then point at the "From memory" note on the card.
+       Charles: "Same customer, and I didn't repeat myself: the rule came back from memory."
+[1:20] Charles: "Now let's try to break it, with a real message from the boss."
        Hold the mic and say: "QuickStitch for the scarves on order 103?"
        Let the answer play: QuickStitch cannot make scarves, no workshop meets 4 April, and the
        best alternative is 13.44 days late.
-[1:45] Charles: "It refuses, gives the earliest option and a two-shop split, and books nothing."
-[1:52] Open "Behind the answer". (optional)
-       Charles: "This panel shows what the model read, with quotes, and what Python computed."
+[1:42] Charles: "It doesn't just say yes. It says no, explains why, offers the earliest option
+       and a split, and books nothing."
+[1:50] Point at the "Behind the answer" panel on the right. (optional)
+       Charles: "And every answer shows its working: what the AI heard, and what our code
+       calculated."
+[1:56] Charles: "That's StitchFlow: say it, see why, slide to book."
 [1:59] Stop recording.</a:t>
             </a:r>
             <a:endParaRPr lang="en-US" dirty="0"/>

</xml_diff>

<commit_message>
Script: name StitchFlow in the demo opening
</commit_message>
<xml_diff>
--- a/docs/slides/Presentation_Group11_Sprint2.pptx
+++ b/docs/slides/Presentation_Group11_Sprint2.pptx
@@ -1161,8 +1161,8 @@
   Niyanthri: "Now, the demo."
 Charles's recording starts straight in the app. Times are from the start of the app part. Speak only when the app is quiet.
 [0:00] Charles: "Hi everyone, I'm Zepeng, or Charles, as the app calls me. Today I'm a
-       dispatcher, and this phone is my whole desk. The rings show who's busy; OldMill is
-       suspended."
+       dispatcher, and with StitchFlow, this phone is my whole desk. The rings show who's
+       busy; OldMill is suspended."
 [0:10] Hold the mic and say: "Hi, I've got order 109 for Harbor Knits, 500 vests, due April
        13th. And keep it away from BudgetWorks, their last batch came back rough."
        Let the answer play: "GiantWeave can deliver order 109 by Thursday 9 April, 3.71 days

</xml_diff>

<commit_message>
Script: back to the plain demo narration
</commit_message>
<xml_diff>
--- a/docs/slides/Presentation_Group11_Sprint2.pptx
+++ b/docs/slides/Presentation_Group11_Sprint2.pptx
@@ -1160,34 +1160,31 @@
 The slides recording ends on this slide for two seconds:
   Niyanthri: "Now, the demo."
 Charles's recording starts straight in the app. Times are from the start of the app part. Speak only when the app is quiet.
-[0:00] Charles: "Hi everyone, I'm Zepeng, or Charles, as the app calls me. Today I'm a
-       dispatcher, and with StitchFlow, this phone is my whole desk. The rings show who's
-       busy; OldMill is suspended."
-[0:10] Hold the mic and say: "Hi, I've got order 109 for Harbor Knits, 500 vests, due April
+[0:00] Charles: "Hi everyone, I'm Zepeng, or Charles, as the app calls me. In this demo I'll
+       play the dispatcher, using our app, StitchFlow. The rings show how busy each workshop
+       is, and OldMill is grey because it's suspended."
+[0:08] Hold the mic and say: "Hi, I've got order 109 for Harbor Knits, 500 vests, due April
        13th. And keep it away from BudgetWorks, their last batch came back rough."
        Let the answer play: "GiantWeave can deliver order 109 by Thursday 9 April, 3.71 days
        early. Cost 550, defect risk 6.0%. Say book it, or tap book, to confirm."
-[0:32] Tap "Compare 4 workshops", then "Can't take it", then close them. (optional)
-       Charles: "No typing. It picked GiantWeave, told me when it lands, and kept BudgetWorks
-       out, because I asked."
+[0:30] Tap "Compare 4 workshops", then "Can't take it", then close them. (optional)
+       Charles: "Here are the other options, and why the rest can't take it. BudgetWorks is out
+       because I asked."
 [0:40] Hold the mic and say: "Okay, book it." The sheet opens.
-       Charles: "Nothing goes out until I slide." Slide to confirm.
-[0:50] On the receipt, tap "Remember".
-       Charles: "And it offers to remember that, for next time."
-[0:56] Hold the mic and say: "Next one: order 81 for Harbor Knits, due April 20th."
+       Charles: "Nothing is saved until I slide." Slide to confirm.
+[0:52] On the receipt, tap "Remember".
+       Charles: "And it offers to remember that rule."
+[0:58] Hold the mic and say: "Next one: order 81 for Harbor Knits, due April 20th."
        (Say "due", not "go out by": "go out by" is a ship date, and the desk would ask which.)
-       Let the answer play, then point at the "From memory" note on the card.
-       Charles: "Same customer, and I didn't repeat myself: the rule came back from memory."
-[1:20] Charles: "Now let's try to break it, with a real message from the boss."
+       Let the answer play, then point at the memory note on the card.
+       Charles: "Same customer, so the rule is applied, and the card says it came from memory."
+[1:22] Charles: "Now a hard case, straight from the inbox."
        Hold the mic and say: "QuickStitch for the scarves on order 103?"
        Let the answer play: QuickStitch cannot make scarves, no workshop meets 4 April, and the
        best alternative is 13.44 days late.
-[1:42] Charles: "It doesn't just say yes. It says no, explains why, offers the earliest option
-       and a split, and books nothing."
-[1:50] Point at the "Behind the answer" panel on the right. (optional)
-       Charles: "And every answer shows its working: what the AI heard, and what our code
-       calculated."
-[1:56] Charles: "That's StitchFlow: say it, see why, slide to book."
+[1:45] Charles: "It refuses, gives the earliest option and a two-shop split, and books nothing."
+[1:52] Point at the "Behind the answer" panel on the right. (optional)
+       Charles: "This panel shows what the model read, with quotes, and what Python computed."
 [1:59] Stop recording.</a:t>
             </a:r>
             <a:endParaRPr lang="en-US" dirty="0"/>

</xml_diff>

<commit_message>
Script: demo narration in a calm keynote voice
</commit_message>
<xml_diff>
--- a/docs/slides/Presentation_Group11_Sprint2.pptx
+++ b/docs/slides/Presentation_Group11_Sprint2.pptx
@@ -1160,31 +1160,34 @@
 The slides recording ends on this slide for two seconds:
   Niyanthri: "Now, the demo."
 Charles's recording starts straight in the app. Times are from the start of the app part. Speak only when the app is quiet.
-[0:00] Charles: "Hi everyone, I'm Zepeng, or Charles, as the app calls me. In this demo I'll
-       play the dispatcher, using our app, StitchFlow. The rings show how busy each workshop
-       is, and OldMill is grey because it's suspended."
-[0:08] Hold the mic and say: "Hi, I've got order 109 for Harbor Knits, 500 vests, due April
+[0:00] Charles: "Hi everyone, I'm Zepeng, or Charles, as the app calls me. Today I'm a
+       dispatcher. No desk. Just my phone, and StitchFlow. The rings show how busy each
+       workshop is; OldMill is grey, it's suspended."
+[0:10] Hold the mic and say: "Hi, I've got order 109 for Harbor Knits, 500 vests, due April
        13th. And keep it away from BudgetWorks, their last batch came back rough."
        Let the answer play: "GiantWeave can deliver order 109 by Thursday 9 April, 3.71 days
        early. Cost 550, defect risk 6.0%. Say book it, or tap book, to confirm."
-[0:30] Tap "Compare 4 workshops", then "Can't take it", then close them. (optional)
-       Charles: "Here are the other options, and why the rest can't take it. BudgetWorks is out
-       because I asked."
+[0:32] Tap "Compare 4 workshops", then "Can't take it", then close them. (optional)
+       Charles: "I just said it. It found a workshop, told me when it'll arrive, and kept
+       BudgetWorks out, because I asked."
 [0:40] Hold the mic and say: "Okay, book it." The sheet opens.
-       Charles: "Nothing is saved until I slide." Slide to confirm.
-[0:52] On the receipt, tap "Remember".
-       Charles: "And it offers to remember that rule."
-[0:58] Hold the mic and say: "Next one: order 81 for Harbor Knits, due April 20th."
+       Charles: "Nothing happens until I slide." Slide to confirm.
+[0:50] On the receipt, tap "Remember".
+       Charles: "And it offers to remember that."
+[0:55] Hold the mic and say: "Next one: order 81 for Harbor Knits, due April 20th."
        (Say "due", not "go out by": "go out by" is a ship date, and the desk would ask which.)
-       Let the answer play, then point at the memory note on the card.
-       Charles: "Same customer, so the rule is applied, and the card says it came from memory."
-[1:22] Charles: "Now a hard case, straight from the inbox."
+       Let the answer play, then point at the "From memory" note on the card.
+       Charles: "Same customer, new order. I don't repeat myself; it remembers."
+[1:18] Charles: "Now, something hard. A real message from the boss."
        Hold the mic and say: "QuickStitch for the scarves on order 103?"
        Let the answer play: QuickStitch cannot make scarves, no workshop meets 4 April, and the
        best alternative is 13.44 days late.
-[1:45] Charles: "It refuses, gives the earliest option and a two-shop split, and books nothing."
-[1:52] Point at the "Behind the answer" panel on the right. (optional)
-       Charles: "This panel shows what the model read, with quotes, and what Python computed."
+[1:40] Charles: "It doesn't guess. It says no, tells me why, and shows the earliest option and a
+       split. Nothing is booked."
+[1:48] Point at the "Behind the answer" panel on the right.
+       Charles: "One more thing. Every answer shows its working: what the AI heard, and what our
+       code calculated."
+[1:56] Charles: "That's StitchFlow."
 [1:59] Stop recording.</a:t>
             </a:r>
             <a:endParaRPr lang="en-US" dirty="0"/>

</xml_diff>

<commit_message>
Script: back to the plain demo narration again
</commit_message>
<xml_diff>
--- a/docs/slides/Presentation_Group11_Sprint2.pptx
+++ b/docs/slides/Presentation_Group11_Sprint2.pptx
@@ -1160,34 +1160,31 @@
 The slides recording ends on this slide for two seconds:
   Niyanthri: "Now, the demo."
 Charles's recording starts straight in the app. Times are from the start of the app part. Speak only when the app is quiet.
-[0:00] Charles: "Hi everyone, I'm Zepeng, or Charles, as the app calls me. Today I'm a
-       dispatcher. No desk. Just my phone, and StitchFlow. The rings show how busy each
-       workshop is; OldMill is grey, it's suspended."
-[0:10] Hold the mic and say: "Hi, I've got order 109 for Harbor Knits, 500 vests, due April
+[0:00] Charles: "Hi everyone, I'm Zepeng, or Charles, as the app calls me. In this demo I'll
+       play the dispatcher, using our app, StitchFlow. The rings show how busy each workshop
+       is, and OldMill is grey because it's suspended."
+[0:08] Hold the mic and say: "Hi, I've got order 109 for Harbor Knits, 500 vests, due April
        13th. And keep it away from BudgetWorks, their last batch came back rough."
        Let the answer play: "GiantWeave can deliver order 109 by Thursday 9 April, 3.71 days
        early. Cost 550, defect risk 6.0%. Say book it, or tap book, to confirm."
-[0:32] Tap "Compare 4 workshops", then "Can't take it", then close them. (optional)
-       Charles: "I just said it. It found a workshop, told me when it'll arrive, and kept
-       BudgetWorks out, because I asked."
+[0:30] Tap "Compare 4 workshops", then "Can't take it", then close them. (optional)
+       Charles: "Here are the other options, and why the rest can't take it. BudgetWorks is out
+       because I asked."
 [0:40] Hold the mic and say: "Okay, book it." The sheet opens.
-       Charles: "Nothing happens until I slide." Slide to confirm.
-[0:50] On the receipt, tap "Remember".
-       Charles: "And it offers to remember that."
-[0:55] Hold the mic and say: "Next one: order 81 for Harbor Knits, due April 20th."
+       Charles: "Nothing is saved until I slide." Slide to confirm.
+[0:52] On the receipt, tap "Remember".
+       Charles: "And it offers to remember that rule."
+[0:58] Hold the mic and say: "Next one: order 81 for Harbor Knits, due April 20th."
        (Say "due", not "go out by": "go out by" is a ship date, and the desk would ask which.)
-       Let the answer play, then point at the "From memory" note on the card.
-       Charles: "Same customer, new order. I don't repeat myself; it remembers."
-[1:18] Charles: "Now, something hard. A real message from the boss."
+       Let the answer play, then point at the memory note on the card.
+       Charles: "Same customer, so the rule is applied, and the card says it came from memory."
+[1:22] Charles: "Now a hard case, straight from the inbox."
        Hold the mic and say: "QuickStitch for the scarves on order 103?"
        Let the answer play: QuickStitch cannot make scarves, no workshop meets 4 April, and the
        best alternative is 13.44 days late.
-[1:40] Charles: "It doesn't guess. It says no, tells me why, and shows the earliest option and a
-       split. Nothing is booked."
-[1:48] Point at the "Behind the answer" panel on the right.
-       Charles: "One more thing. Every answer shows its working: what the AI heard, and what our
-       code calculated."
-[1:56] Charles: "That's StitchFlow."
+[1:45] Charles: "It refuses, gives the earliest option and a two-shop split, and books nothing."
+[1:52] Point at the "Behind the answer" panel on the right. (optional)
+       Charles: "This panel shows what the model read, with quotes, and what Python computed."
 [1:59] Stop recording.</a:t>
             </a:r>
             <a:endParaRPr lang="en-US" dirty="0"/>

</xml_diff>

<commit_message>
Shorter spoken demo lines; say how to fix a misheard order number
</commit_message>
<xml_diff>
--- a/docs/slides/Presentation_Group11_Sprint2.pptx
+++ b/docs/slides/Presentation_Group11_Sprint2.pptx
@@ -1159,12 +1159,16 @@
               <a:t>SLIDE 8 - Demo (2:55-4:50)  Charles
 The slides recording ends on this slide for two seconds:
   Niyanthri: "Now, the demo."
-Charles's recording starts straight in the app. Times are from the start of the app part. Speak only when the app is quiet.
-[0:00] Charles: "Hi everyone, I'm Zepeng, or Charles, as the app calls me. In this demo I'll
-       play the dispatcher, using our app, StitchFlow. The rings show how busy each workshop
+Charles's recording starts straight in the app. Times are from the start of the app part.
+Speak only when the app is quiet. If speech mishears a request, the transcript shows it: hold
+the mic and say it again, slowly.
+[0:00] Charles: "Hi everyone, I'm Zepeng, or Charles. In this demo I'll
+       play as the dispatcher, using our app, StitchFlow. The rings show how busy each workshop
        is, and OldMill is grey because it's suspended."
-[0:08] Hold the mic and say: "Hi, I've got order 109 for Harbor Knits, 500 vests, due April
-       13th. And keep it away from BudgetWorks, their last batch came back rough."
+[0:08] Hold the mic and say: "Hi, I've got order number 109, due April 13th. Keep it away from
+       BudgetWorks, their last batch came back rough."
+       (No customer or product names: speech often mishears them, and the order book supplies
+       both. Say "order number" clearly, so it is not heard as "other".)
        Let the answer play: "GiantWeave can deliver order 109 by Thursday 9 April, 3.71 days
        early. Cost 550, defect risk 6.0%. Say book it, or tap book, to confirm."
 [0:30] Tap "Compare 4 workshops", then "Can't take it", then close them. (optional)
@@ -1174,18 +1178,18 @@
        Charles: "Nothing is saved until I slide." Slide to confirm.
 [0:52] On the receipt, tap "Remember".
        Charles: "And it offers to remember that rule."
-[0:58] Hold the mic and say: "Next one: order 81 for Harbor Knits, due April 20th."
+[0:58] Hold the mic and say: "Next one: order number 81, due April 20th."
        (Say "due", not "go out by": "go out by" is a ship date, and the desk would ask which.)
        Let the answer play, then point at the memory note on the card.
        Charles: "Same customer, so the rule is applied, and the card says it came from memory."
-[1:22] Charles: "Now a hard case, straight from the inbox."
-       Hold the mic and say: "QuickStitch for the scarves on order 103?"
+[1:22] Charles: "Now a hard case, like the boss's message in the inbox."
+       Hold the mic and say: "Can QuickStitch take order number 103?"
        Let the answer play: QuickStitch cannot make scarves, no workshop meets 4 April, and the
        best alternative is 13.44 days late.
 [1:45] Charles: "It refuses, gives the earliest option and a two-shop split, and books nothing."
 [1:52] Point at the "Behind the answer" panel on the right. (optional)
        Charles: "This panel shows what the model read, with quotes, and what Python computed."
-[1:57] Charles: "That's StitchFlow." Pause for two seconds.
+[1:57] Charles: "And That is StitchFlow." Pause for two seconds.
 [2:00] Stop recording.</a:t>
             </a:r>
             <a:endParaRPr lang="en-US" dirty="0"/>

</xml_diff>

<commit_message>
Voice commands for remember and the other options; an all-voice demo script
</commit_message>
<xml_diff>
--- a/docs/slides/Presentation_Group11_Sprint2.pptx
+++ b/docs/slides/Presentation_Group11_Sprint2.pptx
@@ -1162,35 +1162,43 @@
 Charles's recording starts straight in the app. Times are from the start of the app part.
 Speak only when the app is quiet. If speech mishears a request, the transcript shows it: hold
 the mic and say it again, slowly.
-[0:00] Charles: "Hi everyone, I'm Zepeng, or Charles. In this demo I'll
-       play as the dispatcher, using our app, StitchFlow. The rings show how busy each workshop
-       is, and OldMill is grey because it's suspended."
-[0:08] Hold the mic and say: "Hi, I've got order number 109, due April 13th. Keep it away from
+[0:00] Charles: "Hi everyone, I'm Zepeng, or Charles, as the app calls me. In this demo I'll
+       play the dispatcher, using our app, StitchFlow, and I'll run it all by voice. The rings
+       show how busy each workshop is, and OldMill is grey because it's suspended."
+[0:10] Hold the mic and say: "Hi, I've got order number 109, due April 13th. Keep it away from
        BudgetWorks, their last batch came back rough."
        (No customer or product names: speech often mishears them, and the order book supplies
        both. Say "order number" clearly, so it is not heard as "other".)
        Let the answer play: "GiantWeave can deliver order 109 by Thursday 9 April, 3.71 days
        early. Cost 550, defect risk 6.0%. Say book it, or tap book, to confirm."
-[0:30] Tap "Compare 4 workshops", then "Can't take it", then close them. (optional)
-       Charles: "Here are the other options, and why the rest can't take it. BudgetWorks is out
-       because I asked."
-[0:40] Hold the mic and say: "Okay, book it." The sheet opens.
-       Charles: "Nothing is saved until I slide." Slide to confirm.
-[0:52] On the receipt, tap "Remember".
-       Charles: "And it offers to remember that rule."
-[0:58] Hold the mic and say: "Next one: order number 81, due April 20th."
+       Charles: "I only gave the order number. The customer and the quantity come from the
+       order book, and BudgetWorks is out because I asked."
+[0:35] Hold the mic and say: "Show me the other options." (optional if the video runs long)
+       Let it answer: "Here are the 4 workshops that can take it, ranked, and why the other 4
+       cannot."
+       Charles: "Every workshop that can take it, ranked, and the reason behind each no:
+       excluded by me, can't make tops, suspended, or over its batch limit."
+[0:50] Hold the mic and say: "Okay, book it." The sheet opens.
+       Charles: "This is the only thing I touch. One slide, so a misheard yes on a noisy floor
+       can never send work out." Slide to confirm.
+[1:03] Hold the mic and say: "Remember that."
+       Let it answer: "Remembered: Avoid BudgetWorks for Harbor Knits."
+       Charles: "Now it's a standing rule for this customer, with who said it and my words."
+[1:12] Hold the mic and say: "Next one: order number 81, due April 20th."
        (Say "due", not "go out by": "go out by" is a ship date, and the desk would ask which.)
-       Let the answer play, then point at the memory note on the card.
-       Charles: "Same customer, so the rule is applied, and the card says it came from memory."
-[1:22] Charles: "Now a hard case, like the boss's message in the inbox."
+       Let the answer play, then point at the "From memory" note on the card.
+       Charles: "Same customer, so the rule is applied without me repeating it, and the card
+       says it came from memory."
+[1:33] Charles: "Now a hard case, like the boss's message in the inbox."
        Hold the mic and say: "Can QuickStitch take order number 103?"
        Let the answer play: QuickStitch cannot make scarves, no workshop meets 4 April, and the
        best alternative is 13.44 days late.
-[1:45] Charles: "It refuses, gives the earliest option and a two-shop split, and books nothing."
-[1:52] Point at the "Behind the answer" panel on the right. (optional)
-       Charles: "This panel shows what the model read, with quotes, and what Python computed."
-[1:57] Charles: "And That is StitchFlow." Pause for two seconds.
-[2:00] Stop recording.</a:t>
+[1:50] Charles: "It refuses, gives the earliest option and a two-shop split, and books nothing.
+       And on the right, every answer shows its working: what the model heard, and what
+       Python computed."
+[1:59] Charles: "That's StitchFlow." Pause for two seconds.
+[2:02] Stop recording. The whole video must stay under 4:55; if it runs long, drop the
+       "other options" step.</a:t>
             </a:r>
             <a:endParaRPr lang="en-US" dirty="0"/>
           </a:p>

</xml_diff>

<commit_message>
Shorter spoken replies; a compact all-voice demo script
</commit_message>
<xml_diff>
--- a/docs/slides/Presentation_Group11_Sprint2.pptx
+++ b/docs/slides/Presentation_Group11_Sprint2.pptx
@@ -1159,46 +1159,36 @@
               <a:t>SLIDE 8 - Demo (2:55-4:50)  Charles
 The slides recording ends on this slide for two seconds:
   Niyanthri: "Now, the demo."
-Charles's recording starts straight in the app. Times are from the start of the app part.
-Speak only when the app is quiet. If speech mishears a request, the transcript shows it: hold
-the mic and say it again, slowly.
-[0:00] Charles: "Hi everyone, I'm Zepeng, or Charles, as the app calls me. In this demo I'll
-       play the dispatcher, using our app, StitchFlow, and I'll run it all by voice. The rings
-       show how busy each workshop is, and OldMill is grey because it's suspended."
-[0:10] Hold the mic and say: "Hi, I've got order number 109, due April 13th. Keep it away from
+Charles's recording starts straight in the app, all by voice; the slide to confirm is the only
+touch. Times are from the start of the app part, about 1:30 when nothing goes wrong. Speak only
+when the app is quiet. If speech mishears a request, the transcript shows it: say it again,
+slowly. In the edit you may cut silences and any misheard retry, but never cut or change an
+answer.
+[0:00] Charles: "Hi everyone, I'm Zepeng, or Charles. I'll play the dispatcher, using StitchFlow
+       by voice."
+[0:06] Hold the mic and say: "Hi, I've got order number 109, due April 13th. Keep it away from
        BudgetWorks, their last batch came back rough."
-       (No customer or product names: speech often mishears them, and the order book supplies
-       both. Say "order number" clearly, so it is not heard as "other".)
-       Let the answer play: "GiantWeave can deliver order 109 by Thursday 9 April, 3.71 days
-       early. Cost 550, defect risk 6.0%. Say book it, or tap book, to confirm."
-       Charles: "I only gave the order number. The customer and the quantity come from the
-       order book, and BudgetWorks is out because I asked."
-[0:35] Hold the mic and say: "Show me the other options." (optional if the video runs long)
-       Let it answer: "Here are the 4 workshops that can take it, ranked, and why the other 4
-       cannot."
-       Charles: "Every workshop that can take it, ranked, and the reason behind each no:
-       excluded by me, can't make tops, suspended, or over its batch limit."
-[0:50] Hold the mic and say: "Okay, book it." The sheet opens.
-       Charles: "This is the only thing I touch. One slide, so a misheard yes on a noisy floor
-       can never send work out." Slide to confirm.
-[1:03] Hold the mic and say: "Remember that."
-       Let it answer: "Remembered: Avoid BudgetWorks for Harbor Knits."
-       Charles: "Now it's a standing rule for this customer, with who said it and my words."
-[1:12] Hold the mic and say: "Next one: order number 81, due April 20th."
+       (No customer or product names: the order book supplies both. Say "order number"
+       clearly, so it is not heard as "other".)
+       Let the answer play: "GiantWeave, by Thursday 9 April, 3.71 days early. Say book it to
+       confirm."
+[0:20] Charles: "It found the order, kept BudgetWorks out because I asked, and shows why."
+[0:25] Hold the mic and say: "Okay, book it." The sheet opens: "Slide to confirm."
+       Charles: "Only a slide books it." Slide to confirm.
+       It says: "Booked with GiantWeave, arriving Thursday 9 April."
+[0:36] Hold the mic and say: "Remember that."
+       It says: "Remembered: Avoid BudgetWorks for Harbor Knits."
+[0:41] Hold the mic and say: "Next one: order number 81, due April 20th."
        (Say "due", not "go out by": "go out by" is a ship date, and the desk would ask which.)
        Let the answer play, then point at the "From memory" note on the card.
-       Charles: "Same customer, so the rule is applied without me repeating it, and the card
-       says it came from memory."
-[1:33] Charles: "Now a hard case, like the boss's message in the inbox."
-       Hold the mic and say: "Can QuickStitch take order number 103?"
-       Let the answer play: QuickStitch cannot make scarves, no workshop meets 4 April, and the
-       best alternative is 13.44 days late.
-[1:50] Charles: "It refuses, gives the earliest option and a two-shop split, and books nothing.
-       And on the right, every answer shows its working: what the model heard, and what
-       Python computed."
-[1:59] Charles: "That's StitchFlow." Pause for two seconds.
-[2:02] Stop recording. The whole video must stay under 4:55; if it runs long, drop the
-       "other options" step.</a:t>
+[0:52] Charles: "Same customer, and the rule came back from memory."
+[0:56] Charles: "Now a hard case." Hold the mic and say: "Can QuickStitch take order number 103?"
+       Let the answer play: "QuickStitch cannot take order 103. Cannot make ACCESSORIES. Best
+       alternative: SteadyHands, 13.44 days late."
+[1:10] Charles: "It refuses, says why, and books nothing. And every answer shows its working,
+       here on the right."
+[1:18] Charles: "That's StitchFlow." Pause for two seconds.
+[1:22] Stop recording. With natural pauses this runs about 1:30 to 1:50.</a:t>
             </a:r>
             <a:endParaRPr lang="en-US" dirty="0"/>
           </a:p>

</xml_diff>

<commit_message>
Q&A: the demo is trimmed and slightly sped up
</commit_message>
<xml_diff>
--- a/docs/slides/Presentation_Group11_Sprint2.pptx
+++ b/docs/slides/Presentation_Group11_Sprint2.pptx
@@ -1300,7 +1300,9 @@
   behaviour-rubric pass rates from one gpt-5.6 run on intake-v2: train 134/140 (95.7%), test
   63/65 (96.9%). They are not model accuracy. The three original train failures (TR053,
   TR056, TR059) were an unneeded quantity question blocking a refusal, fixed in intake-v3.
-- Is the demo real time? Yes. It is one take with no cuts; only the start and end are trimmed.
+- Is the demo real time? It is one take. Silences, waits and a misheard retry were cut, and it
+  plays slightly faster than real time, as the caption says. Every answer is shown in full and
+  unchanged; a model call takes about 2-3 seconds live.
 - Why voice? The track's bonus asks how a dispatcher would really use it: on the floor, on a
   phone. Typing still works everywhere, and the course inbox is still evaluated as text.
 - Can a misheard "yes" book something? No. "Book it" only opens the sheet. Saving needs a

</xml_diff>